<commit_message>
Fix v5 card syntax
</commit_message>
<xml_diff>
--- a/presentation/native_hook_progress_2026-06-05.pptx
+++ b/presentation/native_hook_progress_2026-06-05.pptx
@@ -2625,7 +2625,7 @@
             </a:avLst>
           </a:prstGeom>
           <a:solidFill>
-            <a:srgbClr val="000000"/>
+            <a:srgbClr val="FFFFFF"/>
           </a:solidFill>
           <a:ln w="15240">
             <a:solidFill>
@@ -2637,13 +2637,33 @@
       </p:sp>
       <p:sp>
         <p:nvSpPr>
-          <p:cNvPr id="8" name="Text 6"/>
+          <p:cNvPr id="8" name="Shape 6"/>
           <p:cNvSpPr/>
           <p:nvPr/>
         </p:nvSpPr>
         <p:spPr>
           <a:xfrm>
-            <a:off x="457200" y="1280160"/>
+            <a:off x="320040" y="1188720"/>
+            <a:ext cx="5577840" cy="38100"/>
+          </a:xfrm>
+          <a:prstGeom prst="rect">
+            <a:avLst/>
+          </a:prstGeom>
+          <a:solidFill>
+            <a:srgbClr val="059669"/>
+          </a:solidFill>
+          <a:ln/>
+        </p:spPr>
+      </p:sp>
+      <p:sp>
+        <p:nvSpPr>
+          <p:cNvPr id="9" name="Text 7"/>
+          <p:cNvSpPr/>
+          <p:nvPr/>
+        </p:nvSpPr>
+        <p:spPr>
+          <a:xfrm>
+            <a:off x="457200" y="1325880"/>
             <a:ext cx="1371600" cy="228600"/>
           </a:xfrm>
           <a:prstGeom prst="rect">
@@ -2676,13 +2696,13 @@
       </p:sp>
       <p:sp>
         <p:nvSpPr>
-          <p:cNvPr id="9" name="Text 7"/>
+          <p:cNvPr id="10" name="Text 8"/>
           <p:cNvSpPr/>
           <p:nvPr/>
         </p:nvSpPr>
         <p:spPr>
           <a:xfrm>
-            <a:off x="457200" y="1554480"/>
+            <a:off x="457200" y="1600200"/>
             <a:ext cx="5303520" cy="365760"/>
           </a:xfrm>
           <a:prstGeom prst="rect">
@@ -2712,14 +2732,14 @@
       </p:sp>
       <p:sp>
         <p:nvSpPr>
-          <p:cNvPr id="10" name="Text 8"/>
+          <p:cNvPr id="11" name="Text 9"/>
           <p:cNvSpPr/>
           <p:nvPr/>
         </p:nvSpPr>
         <p:spPr>
           <a:xfrm>
-            <a:off x="457200" y="2011680"/>
-            <a:ext cx="5303520" cy="1325880"/>
+            <a:off x="457200" y="2057400"/>
+            <a:ext cx="5303520" cy="1280160"/>
           </a:xfrm>
           <a:prstGeom prst="rect">
             <a:avLst/>
@@ -2768,7 +2788,7 @@
       </p:sp>
       <p:sp>
         <p:nvSpPr>
-          <p:cNvPr id="11" name="Shape 9"/>
+          <p:cNvPr id="12" name="Shape 10"/>
           <p:cNvSpPr/>
           <p:nvPr/>
         </p:nvSpPr>
@@ -2783,7 +2803,7 @@
             </a:avLst>
           </a:prstGeom>
           <a:solidFill>
-            <a:srgbClr val="000000"/>
+            <a:srgbClr val="FFFFFF"/>
           </a:solidFill>
           <a:ln w="15240">
             <a:solidFill>
@@ -2795,13 +2815,33 @@
       </p:sp>
       <p:sp>
         <p:nvSpPr>
-          <p:cNvPr id="12" name="Text 10"/>
+          <p:cNvPr id="13" name="Shape 11"/>
           <p:cNvSpPr/>
           <p:nvPr/>
         </p:nvSpPr>
         <p:spPr>
           <a:xfrm>
-            <a:off x="6263640" y="1280160"/>
+            <a:off x="6126480" y="1188720"/>
+            <a:ext cx="5577840" cy="38100"/>
+          </a:xfrm>
+          <a:prstGeom prst="rect">
+            <a:avLst/>
+          </a:prstGeom>
+          <a:solidFill>
+            <a:srgbClr val="2563EB"/>
+          </a:solidFill>
+          <a:ln/>
+        </p:spPr>
+      </p:sp>
+      <p:sp>
+        <p:nvSpPr>
+          <p:cNvPr id="14" name="Text 12"/>
+          <p:cNvSpPr/>
+          <p:nvPr/>
+        </p:nvSpPr>
+        <p:spPr>
+          <a:xfrm>
+            <a:off x="6263640" y="1325880"/>
             <a:ext cx="1371600" cy="228600"/>
           </a:xfrm>
           <a:prstGeom prst="rect">
@@ -2834,13 +2874,13 @@
       </p:sp>
       <p:sp>
         <p:nvSpPr>
-          <p:cNvPr id="13" name="Text 11"/>
+          <p:cNvPr id="15" name="Text 13"/>
           <p:cNvSpPr/>
           <p:nvPr/>
         </p:nvSpPr>
         <p:spPr>
           <a:xfrm>
-            <a:off x="6263640" y="1554480"/>
+            <a:off x="6263640" y="1600200"/>
             <a:ext cx="5303520" cy="365760"/>
           </a:xfrm>
           <a:prstGeom prst="rect">
@@ -2870,14 +2910,14 @@
       </p:sp>
       <p:sp>
         <p:nvSpPr>
-          <p:cNvPr id="14" name="Text 12"/>
+          <p:cNvPr id="16" name="Text 14"/>
           <p:cNvSpPr/>
           <p:nvPr/>
         </p:nvSpPr>
         <p:spPr>
           <a:xfrm>
-            <a:off x="6263640" y="2011680"/>
-            <a:ext cx="5303520" cy="1325880"/>
+            <a:off x="6263640" y="2057400"/>
+            <a:ext cx="5303520" cy="1280160"/>
           </a:xfrm>
           <a:prstGeom prst="rect">
             <a:avLst/>
@@ -2926,7 +2966,7 @@
       </p:sp>
       <p:sp>
         <p:nvSpPr>
-          <p:cNvPr id="15" name="Shape 13"/>
+          <p:cNvPr id="17" name="Shape 15"/>
           <p:cNvSpPr/>
           <p:nvPr/>
         </p:nvSpPr>
@@ -2941,7 +2981,7 @@
             </a:avLst>
           </a:prstGeom>
           <a:solidFill>
-            <a:srgbClr val="000000"/>
+            <a:srgbClr val="FFFFFF"/>
           </a:solidFill>
           <a:ln w="15240">
             <a:solidFill>
@@ -2953,13 +2993,33 @@
       </p:sp>
       <p:sp>
         <p:nvSpPr>
-          <p:cNvPr id="16" name="Text 14"/>
+          <p:cNvPr id="18" name="Shape 16"/>
           <p:cNvSpPr/>
           <p:nvPr/>
         </p:nvSpPr>
         <p:spPr>
           <a:xfrm>
-            <a:off x="457200" y="3886200"/>
+            <a:off x="320040" y="3794760"/>
+            <a:ext cx="5577840" cy="38100"/>
+          </a:xfrm>
+          <a:prstGeom prst="rect">
+            <a:avLst/>
+          </a:prstGeom>
+          <a:solidFill>
+            <a:srgbClr val="EA580C"/>
+          </a:solidFill>
+          <a:ln/>
+        </p:spPr>
+      </p:sp>
+      <p:sp>
+        <p:nvSpPr>
+          <p:cNvPr id="19" name="Text 17"/>
+          <p:cNvSpPr/>
+          <p:nvPr/>
+        </p:nvSpPr>
+        <p:spPr>
+          <a:xfrm>
+            <a:off x="457200" y="3931920"/>
             <a:ext cx="1371600" cy="228600"/>
           </a:xfrm>
           <a:prstGeom prst="rect">
@@ -2992,13 +3052,13 @@
       </p:sp>
       <p:sp>
         <p:nvSpPr>
-          <p:cNvPr id="17" name="Text 15"/>
+          <p:cNvPr id="20" name="Text 18"/>
           <p:cNvSpPr/>
           <p:nvPr/>
         </p:nvSpPr>
         <p:spPr>
           <a:xfrm>
-            <a:off x="457200" y="4160520"/>
+            <a:off x="457200" y="4206240"/>
             <a:ext cx="5303520" cy="365760"/>
           </a:xfrm>
           <a:prstGeom prst="rect">
@@ -3028,14 +3088,14 @@
       </p:sp>
       <p:sp>
         <p:nvSpPr>
-          <p:cNvPr id="18" name="Text 16"/>
+          <p:cNvPr id="21" name="Text 19"/>
           <p:cNvSpPr/>
           <p:nvPr/>
         </p:nvSpPr>
         <p:spPr>
           <a:xfrm>
-            <a:off x="457200" y="4617720"/>
-            <a:ext cx="5303520" cy="1325880"/>
+            <a:off x="457200" y="4663440"/>
+            <a:ext cx="5303520" cy="1280160"/>
           </a:xfrm>
           <a:prstGeom prst="rect">
             <a:avLst/>
@@ -3084,7 +3144,7 @@
       </p:sp>
       <p:sp>
         <p:nvSpPr>
-          <p:cNvPr id="19" name="Shape 17"/>
+          <p:cNvPr id="22" name="Shape 20"/>
           <p:cNvSpPr/>
           <p:nvPr/>
         </p:nvSpPr>
@@ -3099,7 +3159,7 @@
             </a:avLst>
           </a:prstGeom>
           <a:solidFill>
-            <a:srgbClr val="000000"/>
+            <a:srgbClr val="FFFFFF"/>
           </a:solidFill>
           <a:ln w="15240">
             <a:solidFill>
@@ -3111,13 +3171,33 @@
       </p:sp>
       <p:sp>
         <p:nvSpPr>
-          <p:cNvPr id="20" name="Text 18"/>
+          <p:cNvPr id="23" name="Shape 21"/>
           <p:cNvSpPr/>
           <p:nvPr/>
         </p:nvSpPr>
         <p:spPr>
           <a:xfrm>
-            <a:off x="6263640" y="3886200"/>
+            <a:off x="6126480" y="3794760"/>
+            <a:ext cx="5577840" cy="38100"/>
+          </a:xfrm>
+          <a:prstGeom prst="rect">
+            <a:avLst/>
+          </a:prstGeom>
+          <a:solidFill>
+            <a:srgbClr val="7C3AED"/>
+          </a:solidFill>
+          <a:ln/>
+        </p:spPr>
+      </p:sp>
+      <p:sp>
+        <p:nvSpPr>
+          <p:cNvPr id="24" name="Text 22"/>
+          <p:cNvSpPr/>
+          <p:nvPr/>
+        </p:nvSpPr>
+        <p:spPr>
+          <a:xfrm>
+            <a:off x="6263640" y="3931920"/>
             <a:ext cx="1371600" cy="228600"/>
           </a:xfrm>
           <a:prstGeom prst="rect">
@@ -3150,13 +3230,13 @@
       </p:sp>
       <p:sp>
         <p:nvSpPr>
-          <p:cNvPr id="21" name="Text 19"/>
+          <p:cNvPr id="25" name="Text 23"/>
           <p:cNvSpPr/>
           <p:nvPr/>
         </p:nvSpPr>
         <p:spPr>
           <a:xfrm>
-            <a:off x="6263640" y="4160520"/>
+            <a:off x="6263640" y="4206240"/>
             <a:ext cx="5303520" cy="365760"/>
           </a:xfrm>
           <a:prstGeom prst="rect">
@@ -3186,14 +3266,14 @@
       </p:sp>
       <p:sp>
         <p:nvSpPr>
-          <p:cNvPr id="22" name="Text 20"/>
+          <p:cNvPr id="26" name="Text 24"/>
           <p:cNvSpPr/>
           <p:nvPr/>
         </p:nvSpPr>
         <p:spPr>
           <a:xfrm>
-            <a:off x="6263640" y="4617720"/>
-            <a:ext cx="5303520" cy="1325880"/>
+            <a:off x="6263640" y="4663440"/>
+            <a:ext cx="5303520" cy="1280160"/>
           </a:xfrm>
           <a:prstGeom prst="rect">
             <a:avLst/>

</xml_diff>

<commit_message>
Increase all font sizes across the board
</commit_message>
<xml_diff>
--- a/presentation/native_hook_progress_2026-06-05.pptx
+++ b/presentation/native_hook_progress_2026-06-05.pptx
@@ -1701,14 +1701,14 @@
               <a:buNone/>
             </a:pPr>
             <a:r>
-              <a:rPr lang="en-US" sz="6400" b="1" dirty="0">
+              <a:rPr lang="en-US" sz="7200" b="1" dirty="0">
                 <a:solidFill>
                   <a:srgbClr val="1A1A2E"/>
                 </a:solidFill>
               </a:rPr>
               <a:t>native_hook</a:t>
             </a:r>
-            <a:endParaRPr lang="en-US" sz="6400" dirty="0"/>
+            <a:endParaRPr lang="en-US" sz="7200" dirty="0"/>
           </a:p>
         </p:txBody>
       </p:sp>
@@ -1720,7 +1720,7 @@
         </p:nvSpPr>
         <p:spPr>
           <a:xfrm>
-            <a:off x="914400" y="2697480"/>
+            <a:off x="914400" y="2834640"/>
             <a:ext cx="10058400" cy="548640"/>
           </a:xfrm>
           <a:prstGeom prst="rect">
@@ -1737,14 +1737,14 @@
               <a:buNone/>
             </a:pPr>
             <a:r>
-              <a:rPr lang="en-US" sz="2200" dirty="0">
+              <a:rPr lang="en-US" sz="3200" dirty="0">
                 <a:solidFill>
                   <a:srgbClr val="2563EB"/>
                 </a:solidFill>
               </a:rPr>
               <a:t>Producer Hot Path 优化进展</a:t>
             </a:r>
-            <a:endParaRPr lang="en-US" sz="2200" dirty="0"/>
+            <a:endParaRPr lang="en-US" sz="3200" dirty="0"/>
           </a:p>
         </p:txBody>
       </p:sp>
@@ -1793,14 +1793,14 @@
               <a:buNone/>
             </a:pPr>
             <a:r>
-              <a:rPr lang="en-US" sz="1300" dirty="0">
+              <a:rPr lang="en-US" sz="1600" dirty="0">
                 <a:solidFill>
                   <a:srgbClr val="8888A8"/>
                 </a:solidFill>
               </a:rPr>
               <a:t>2026.06.05  组会汇报  ·  陈一驰</a:t>
             </a:r>
-            <a:endParaRPr lang="en-US" sz="1300" dirty="0"/>
+            <a:endParaRPr lang="en-US" sz="1600" dirty="0"/>
           </a:p>
         </p:txBody>
       </p:sp>
@@ -1901,7 +1901,7 @@
               <a:buNone/>
             </a:pPr>
             <a:r>
-              <a:rPr lang="en-US" sz="2400" b="1" dirty="0">
+              <a:rPr lang="en-US" sz="2800" b="1" dirty="0">
                 <a:solidFill>
                   <a:srgbClr val="2563EB"/>
                 </a:solidFill>
@@ -1911,7 +1911,7 @@
               </a:rPr>
               <a:t>09</a:t>
             </a:r>
-            <a:endParaRPr lang="en-US" sz="2400" dirty="0"/>
+            <a:endParaRPr lang="en-US" sz="2800" dirty="0"/>
           </a:p>
         </p:txBody>
       </p:sp>
@@ -1924,7 +1924,7 @@
         <p:spPr>
           <a:xfrm>
             <a:off x="1280160" y="137160"/>
-            <a:ext cx="9144000" cy="411480"/>
+            <a:ext cx="9144000" cy="502920"/>
           </a:xfrm>
           <a:prstGeom prst="rect">
             <a:avLst/>
@@ -1940,14 +1940,14 @@
               <a:buNone/>
             </a:pPr>
             <a:r>
-              <a:rPr lang="en-US" sz="2000" b="1" dirty="0">
+              <a:rPr lang="en-US" sz="2400" b="1" dirty="0">
                 <a:solidFill>
                   <a:srgbClr val="1A1A2E"/>
                 </a:solidFill>
               </a:rPr>
               <a:t>Next Steps</a:t>
             </a:r>
-            <a:endParaRPr lang="en-US" sz="2000" dirty="0"/>
+            <a:endParaRPr lang="en-US" sz="2400" dirty="0"/>
           </a:p>
         </p:txBody>
       </p:sp>
@@ -2023,7 +2023,7 @@
               <a:buNone/>
             </a:pPr>
             <a:r>
-              <a:rPr lang="en-US" sz="3000" b="1" dirty="0">
+              <a:rPr lang="en-US" sz="3400" b="1" dirty="0">
                 <a:solidFill>
                   <a:srgbClr val="2563EB"/>
                 </a:solidFill>
@@ -2033,7 +2033,7 @@
               </a:rPr>
               <a:t>01</a:t>
             </a:r>
-            <a:endParaRPr lang="en-US" sz="3000" dirty="0"/>
+            <a:endParaRPr lang="en-US" sz="3400" dirty="0"/>
           </a:p>
         </p:txBody>
       </p:sp>
@@ -2046,7 +2046,7 @@
         <p:spPr>
           <a:xfrm>
             <a:off x="2103120" y="1554480"/>
-            <a:ext cx="4572000" cy="320040"/>
+            <a:ext cx="4572000" cy="365760"/>
           </a:xfrm>
           <a:prstGeom prst="rect">
             <a:avLst/>
@@ -2062,14 +2062,14 @@
               <a:buNone/>
             </a:pPr>
             <a:r>
-              <a:rPr lang="en-US" sz="1400" b="1" dirty="0">
+              <a:rPr lang="en-US" sz="1600" b="1" dirty="0">
                 <a:solidFill>
                   <a:srgbClr val="1A1A2E"/>
                 </a:solidFill>
               </a:rPr>
               <a:t>Producer 端继续拆解</a:t>
             </a:r>
-            <a:endParaRPr lang="en-US" sz="1400" dirty="0"/>
+            <a:endParaRPr lang="en-US" sz="1600" dirty="0"/>
           </a:p>
         </p:txBody>
       </p:sp>
@@ -2081,7 +2081,7 @@
         </p:nvSpPr>
         <p:spPr>
           <a:xfrm>
-            <a:off x="2103120" y="1965960"/>
+            <a:off x="2103120" y="2011680"/>
             <a:ext cx="8229600" cy="457200"/>
           </a:xfrm>
           <a:prstGeom prst="rect">
@@ -2098,14 +2098,14 @@
               <a:buNone/>
             </a:pPr>
             <a:r>
-              <a:rPr lang="en-US" sz="1100" dirty="0">
+              <a:rPr lang="en-US" sz="1300" dirty="0">
                 <a:solidFill>
                   <a:srgbClr val="4A4A6A"/>
                 </a:solidFill>
               </a:rPr>
               <a:t>consumer 侧 profiling，完善 sub-stage 36 完整链测量数据</a:t>
             </a:r>
-            <a:endParaRPr lang="en-US" sz="1100" dirty="0"/>
+            <a:endParaRPr lang="en-US" sz="1300" dirty="0"/>
           </a:p>
         </p:txBody>
       </p:sp>
@@ -2181,7 +2181,7 @@
               <a:buNone/>
             </a:pPr>
             <a:r>
-              <a:rPr lang="en-US" sz="3000" b="1" dirty="0">
+              <a:rPr lang="en-US" sz="3400" b="1" dirty="0">
                 <a:solidFill>
                   <a:srgbClr val="059669"/>
                 </a:solidFill>
@@ -2191,7 +2191,7 @@
               </a:rPr>
               <a:t>02</a:t>
             </a:r>
-            <a:endParaRPr lang="en-US" sz="3000" dirty="0"/>
+            <a:endParaRPr lang="en-US" sz="3400" dirty="0"/>
           </a:p>
         </p:txBody>
       </p:sp>
@@ -2204,7 +2204,7 @@
         <p:spPr>
           <a:xfrm>
             <a:off x="2103120" y="3246120"/>
-            <a:ext cx="4572000" cy="320040"/>
+            <a:ext cx="4572000" cy="365760"/>
           </a:xfrm>
           <a:prstGeom prst="rect">
             <a:avLst/>
@@ -2220,14 +2220,14 @@
               <a:buNone/>
             </a:pPr>
             <a:r>
-              <a:rPr lang="en-US" sz="1400" b="1" dirty="0">
+              <a:rPr lang="en-US" sz="1600" b="1" dirty="0">
                 <a:solidFill>
                   <a:srgbClr val="1A1A2E"/>
                 </a:solidFill>
               </a:rPr>
               <a:t>真实代码验证</a:t>
             </a:r>
-            <a:endParaRPr lang="en-US" sz="1400" dirty="0"/>
+            <a:endParaRPr lang="en-US" sz="1600" dirty="0"/>
           </a:p>
         </p:txBody>
       </p:sp>
@@ -2239,7 +2239,7 @@
         </p:nvSpPr>
         <p:spPr>
           <a:xfrm>
-            <a:off x="2103120" y="3657600"/>
+            <a:off x="2103120" y="3703320"/>
             <a:ext cx="8229600" cy="457200"/>
           </a:xfrm>
           <a:prstGeom prst="rect">
@@ -2256,14 +2256,14 @@
               <a:buNone/>
             </a:pPr>
             <a:r>
-              <a:rPr lang="en-US" sz="1100" dirty="0">
+              <a:rPr lang="en-US" sz="1300" dirty="0">
                 <a:solidFill>
                   <a:srgbClr val="4A4A6A"/>
                 </a:solidFill>
               </a:rPr>
               <a:t>等待 OpenHarmony 编译环境 → GitLab fork benchmark → 合 master</a:t>
             </a:r>
-            <a:endParaRPr lang="en-US" sz="1100" dirty="0"/>
+            <a:endParaRPr lang="en-US" sz="1300" dirty="0"/>
           </a:p>
         </p:txBody>
       </p:sp>
@@ -2339,7 +2339,7 @@
               <a:buNone/>
             </a:pPr>
             <a:r>
-              <a:rPr lang="en-US" sz="3000" b="1" dirty="0">
+              <a:rPr lang="en-US" sz="3400" b="1" dirty="0">
                 <a:solidFill>
                   <a:srgbClr val="7C3AED"/>
                 </a:solidFill>
@@ -2349,7 +2349,7 @@
               </a:rPr>
               <a:t>03</a:t>
             </a:r>
-            <a:endParaRPr lang="en-US" sz="3000" dirty="0"/>
+            <a:endParaRPr lang="en-US" sz="3400" dirty="0"/>
           </a:p>
         </p:txBody>
       </p:sp>
@@ -2362,7 +2362,7 @@
         <p:spPr>
           <a:xfrm>
             <a:off x="2103120" y="4937760"/>
-            <a:ext cx="4572000" cy="320040"/>
+            <a:ext cx="4572000" cy="365760"/>
           </a:xfrm>
           <a:prstGeom prst="rect">
             <a:avLst/>
@@ -2378,14 +2378,14 @@
               <a:buNone/>
             </a:pPr>
             <a:r>
-              <a:rPr lang="en-US" sz="1400" b="1" dirty="0">
+              <a:rPr lang="en-US" sz="1600" b="1" dirty="0">
                 <a:solidFill>
                   <a:srgbClr val="1A1A2E"/>
                 </a:solidFill>
               </a:rPr>
               <a:t>eBPF 线（如需继续）</a:t>
             </a:r>
-            <a:endParaRPr lang="en-US" sz="1400" dirty="0"/>
+            <a:endParaRPr lang="en-US" sz="1600" dirty="0"/>
           </a:p>
         </p:txBody>
       </p:sp>
@@ -2397,7 +2397,7 @@
         </p:nvSpPr>
         <p:spPr>
           <a:xfrm>
-            <a:off x="2103120" y="5349240"/>
+            <a:off x="2103120" y="5394960"/>
             <a:ext cx="8229600" cy="457200"/>
           </a:xfrm>
           <a:prstGeom prst="rect">
@@ -2414,14 +2414,14 @@
               <a:buNone/>
             </a:pPr>
             <a:r>
-              <a:rPr lang="en-US" sz="1100" dirty="0">
+              <a:rPr lang="en-US" sz="1300" dirty="0">
                 <a:solidFill>
                   <a:srgbClr val="4A4A6A"/>
                 </a:solidFill>
               </a:rPr>
               <a:t>上次遗留: 4T 异常快 → 更高线程数重复实验确认</a:t>
             </a:r>
-            <a:endParaRPr lang="en-US" sz="1100" dirty="0"/>
+            <a:endParaRPr lang="en-US" sz="1300" dirty="0"/>
           </a:p>
         </p:txBody>
       </p:sp>
@@ -2522,7 +2522,7 @@
               <a:buNone/>
             </a:pPr>
             <a:r>
-              <a:rPr lang="en-US" sz="2400" b="1" dirty="0">
+              <a:rPr lang="en-US" sz="2800" b="1" dirty="0">
                 <a:solidFill>
                   <a:srgbClr val="2563EB"/>
                 </a:solidFill>
@@ -2532,7 +2532,7 @@
               </a:rPr>
               <a:t>01</a:t>
             </a:r>
-            <a:endParaRPr lang="en-US" sz="2400" dirty="0"/>
+            <a:endParaRPr lang="en-US" sz="2800" dirty="0"/>
           </a:p>
         </p:txBody>
       </p:sp>
@@ -2545,7 +2545,7 @@
         <p:spPr>
           <a:xfrm>
             <a:off x="1280160" y="137160"/>
-            <a:ext cx="9144000" cy="411480"/>
+            <a:ext cx="9144000" cy="502920"/>
           </a:xfrm>
           <a:prstGeom prst="rect">
             <a:avLst/>
@@ -2561,14 +2561,14 @@
               <a:buNone/>
             </a:pPr>
             <a:r>
-              <a:rPr lang="en-US" sz="2000" b="1" dirty="0">
+              <a:rPr lang="en-US" sz="2400" b="1" dirty="0">
                 <a:solidFill>
                   <a:srgbClr val="1A1A2E"/>
                 </a:solidFill>
               </a:rPr>
               <a:t>上次组会反馈闭环</a:t>
             </a:r>
-            <a:endParaRPr lang="en-US" sz="2000" dirty="0"/>
+            <a:endParaRPr lang="en-US" sz="2400" dirty="0"/>
           </a:p>
         </p:txBody>
       </p:sp>
@@ -2580,8 +2580,8 @@
         </p:nvSpPr>
         <p:spPr>
           <a:xfrm>
-            <a:off x="1280160" y="530352"/>
-            <a:ext cx="9144000" cy="228600"/>
+            <a:off x="1280160" y="566928"/>
+            <a:ext cx="9144000" cy="274320"/>
           </a:xfrm>
           <a:prstGeom prst="rect">
             <a:avLst/>
@@ -2597,14 +2597,14 @@
               <a:buNone/>
             </a:pPr>
             <a:r>
-              <a:rPr lang="en-US" sz="1000" dirty="0">
+              <a:rPr lang="en-US" sz="1200" dirty="0">
                 <a:solidFill>
                   <a:srgbClr val="8888A8"/>
                 </a:solidFill>
               </a:rPr>
               <a:t>四个问题，逐一回应</a:t>
             </a:r>
-            <a:endParaRPr lang="en-US" sz="1000" dirty="0"/>
+            <a:endParaRPr lang="en-US" sz="1200" dirty="0"/>
           </a:p>
         </p:txBody>
       </p:sp>
@@ -2664,7 +2664,7 @@
         <p:spPr>
           <a:xfrm>
             <a:off x="457200" y="1325880"/>
-            <a:ext cx="1371600" cy="228600"/>
+            <a:ext cx="1371600" cy="256032"/>
           </a:xfrm>
           <a:prstGeom prst="rect">
             <a:avLst/>
@@ -2680,7 +2680,7 @@
               <a:buNone/>
             </a:pPr>
             <a:r>
-              <a:rPr lang="en-US" sz="800" b="1" dirty="0">
+              <a:rPr lang="en-US" sz="1000" b="1" dirty="0">
                 <a:solidFill>
                   <a:srgbClr val="059669"/>
                 </a:solidFill>
@@ -2690,7 +2690,7 @@
               </a:rPr>
               <a:t>RESOLVED</a:t>
             </a:r>
-            <a:endParaRPr lang="en-US" sz="800" dirty="0"/>
+            <a:endParaRPr lang="en-US" sz="1000" dirty="0"/>
           </a:p>
         </p:txBody>
       </p:sp>
@@ -2702,8 +2702,8 @@
         </p:nvSpPr>
         <p:spPr>
           <a:xfrm>
-            <a:off x="457200" y="1600200"/>
-            <a:ext cx="5303520" cy="365760"/>
+            <a:off x="457200" y="1627632"/>
+            <a:ext cx="5303520" cy="411480"/>
           </a:xfrm>
           <a:prstGeom prst="rect">
             <a:avLst/>
@@ -2719,14 +2719,14 @@
               <a:buNone/>
             </a:pPr>
             <a:r>
-              <a:rPr lang="en-US" sz="1300" b="1" dirty="0">
+              <a:rPr lang="en-US" sz="1500" b="1" dirty="0">
                 <a:solidFill>
                   <a:srgbClr val="1A1A2E"/>
                 </a:solidFill>
               </a:rPr>
               <a:t>▸ "4T比1T多1.8s"</a:t>
             </a:r>
-            <a:endParaRPr lang="en-US" sz="1300" dirty="0"/>
+            <a:endParaRPr lang="en-US" sz="1500" dirty="0"/>
           </a:p>
         </p:txBody>
       </p:sp>
@@ -2738,8 +2738,8 @@
         </p:nvSpPr>
         <p:spPr>
           <a:xfrm>
-            <a:off x="457200" y="2057400"/>
-            <a:ext cx="5303520" cy="1280160"/>
+            <a:off x="457200" y="2103120"/>
+            <a:ext cx="5303520" cy="1234440"/>
           </a:xfrm>
           <a:prstGeom prst="rect">
             <a:avLst/>
@@ -2753,36 +2753,36 @@
           <a:p>
             <a:pPr indent="0" marL="0">
               <a:lnSpc>
-                <a:spcPts val="1800"/>
+                <a:spcPts val="2000"/>
               </a:lnSpc>
               <a:buNone/>
             </a:pPr>
             <a:r>
-              <a:rPr lang="en-US" sz="1000" dirty="0">
+              <a:rPr lang="en-US" sz="1200" dirty="0">
                 <a:solidFill>
                   <a:srgbClr val="4A4A6A"/>
                 </a:solidFill>
               </a:rPr>
               <a:t>ring共享状态竞争</a:t>
             </a:r>
-            <a:endParaRPr lang="en-US" sz="1000" dirty="0"/>
+            <a:endParaRPr lang="en-US" sz="1200" dirty="0"/>
           </a:p>
           <a:p>
             <a:pPr indent="0" marL="0">
               <a:lnSpc>
-                <a:spcPts val="1800"/>
+                <a:spcPts val="2000"/>
               </a:lnSpc>
               <a:buNone/>
             </a:pPr>
             <a:r>
-              <a:rPr lang="en-US" sz="1000" dirty="0">
+              <a:rPr lang="en-US" sz="1200" dirty="0">
                 <a:solidFill>
                   <a:srgbClr val="4A4A6A"/>
                 </a:solidFill>
               </a:rPr>
               <a:t>→ batch解决后 4T: 2.72s → 0.86s</a:t>
             </a:r>
-            <a:endParaRPr lang="en-US" sz="1000" dirty="0"/>
+            <a:endParaRPr lang="en-US" sz="1200" dirty="0"/>
           </a:p>
         </p:txBody>
       </p:sp>
@@ -2842,7 +2842,7 @@
         <p:spPr>
           <a:xfrm>
             <a:off x="6263640" y="1325880"/>
-            <a:ext cx="1371600" cy="228600"/>
+            <a:ext cx="1371600" cy="256032"/>
           </a:xfrm>
           <a:prstGeom prst="rect">
             <a:avLst/>
@@ -2858,7 +2858,7 @@
               <a:buNone/>
             </a:pPr>
             <a:r>
-              <a:rPr lang="en-US" sz="800" b="1" dirty="0">
+              <a:rPr lang="en-US" sz="1000" b="1" dirty="0">
                 <a:solidFill>
                   <a:srgbClr val="2563EB"/>
                 </a:solidFill>
@@ -2868,7 +2868,7 @@
               </a:rPr>
               <a:t>UPGRADED</a:t>
             </a:r>
-            <a:endParaRPr lang="en-US" sz="800" dirty="0"/>
+            <a:endParaRPr lang="en-US" sz="1000" dirty="0"/>
           </a:p>
         </p:txBody>
       </p:sp>
@@ -2880,8 +2880,8 @@
         </p:nvSpPr>
         <p:spPr>
           <a:xfrm>
-            <a:off x="6263640" y="1600200"/>
-            <a:ext cx="5303520" cy="365760"/>
+            <a:off x="6263640" y="1627632"/>
+            <a:ext cx="5303520" cy="411480"/>
           </a:xfrm>
           <a:prstGeom prst="rect">
             <a:avLst/>
@@ -2897,14 +2897,14 @@
               <a:buNone/>
             </a:pPr>
             <a:r>
-              <a:rPr lang="en-US" sz="1300" b="1" dirty="0">
+              <a:rPr lang="en-US" sz="1500" b="1" dirty="0">
                 <a:solidFill>
                   <a:srgbClr val="1A1A2E"/>
                 </a:solidFill>
               </a:rPr>
               <a:t>▸ "跑一下perf"</a:t>
             </a:r>
-            <a:endParaRPr lang="en-US" sz="1300" dirty="0"/>
+            <a:endParaRPr lang="en-US" sz="1500" dirty="0"/>
           </a:p>
         </p:txBody>
       </p:sp>
@@ -2916,8 +2916,8 @@
         </p:nvSpPr>
         <p:spPr>
           <a:xfrm>
-            <a:off x="6263640" y="2057400"/>
-            <a:ext cx="5303520" cy="1280160"/>
+            <a:off x="6263640" y="2103120"/>
+            <a:ext cx="5303520" cy="1234440"/>
           </a:xfrm>
           <a:prstGeom prst="rect">
             <a:avLst/>
@@ -2931,36 +2931,36 @@
           <a:p>
             <a:pPr indent="0" marL="0">
               <a:lnSpc>
-                <a:spcPts val="1800"/>
+                <a:spcPts val="2000"/>
               </a:lnSpc>
               <a:buNone/>
             </a:pPr>
             <a:r>
-              <a:rPr lang="en-US" sz="1000" dirty="0">
+              <a:rPr lang="en-US" sz="1200" dirty="0">
                 <a:solidFill>
                   <a:srgbClr val="4A4A6A"/>
                 </a:solidFill>
               </a:rPr>
               <a:t>ablation替代perf</a:t>
             </a:r>
-            <a:endParaRPr lang="en-US" sz="1000" dirty="0"/>
+            <a:endParaRPr lang="en-US" sz="1200" dirty="0"/>
           </a:p>
           <a:p>
             <a:pPr indent="0" marL="0">
               <a:lnSpc>
-                <a:spcPts val="1800"/>
+                <a:spcPts val="2000"/>
               </a:lnSpc>
               <a:buNone/>
             </a:pPr>
             <a:r>
-              <a:rPr lang="en-US" sz="1000" dirty="0">
+              <a:rPr lang="en-US" sz="1200" dirty="0">
                 <a:solidFill>
                   <a:srgbClr val="4A4A6A"/>
                 </a:solidFill>
               </a:rPr>
               <a:t>→ sub-stage 34/35 拆到模块内部</a:t>
             </a:r>
-            <a:endParaRPr lang="en-US" sz="1000" dirty="0"/>
+            <a:endParaRPr lang="en-US" sz="1200" dirty="0"/>
           </a:p>
         </p:txBody>
       </p:sp>
@@ -3020,7 +3020,7 @@
         <p:spPr>
           <a:xfrm>
             <a:off x="457200" y="3931920"/>
-            <a:ext cx="1371600" cy="228600"/>
+            <a:ext cx="1371600" cy="256032"/>
           </a:xfrm>
           <a:prstGeom prst="rect">
             <a:avLst/>
@@ -3036,7 +3036,7 @@
               <a:buNone/>
             </a:pPr>
             <a:r>
-              <a:rPr lang="en-US" sz="800" b="1" dirty="0">
+              <a:rPr lang="en-US" sz="1000" b="1" dirty="0">
                 <a:solidFill>
                   <a:srgbClr val="EA580C"/>
                 </a:solidFill>
@@ -3046,7 +3046,7 @@
               </a:rPr>
               <a:t>COMPLETED</a:t>
             </a:r>
-            <a:endParaRPr lang="en-US" sz="800" dirty="0"/>
+            <a:endParaRPr lang="en-US" sz="1000" dirty="0"/>
           </a:p>
         </p:txBody>
       </p:sp>
@@ -3058,8 +3058,8 @@
         </p:nvSpPr>
         <p:spPr>
           <a:xfrm>
-            <a:off x="457200" y="4206240"/>
-            <a:ext cx="5303520" cy="365760"/>
+            <a:off x="457200" y="4233672"/>
+            <a:ext cx="5303520" cy="411480"/>
           </a:xfrm>
           <a:prstGeom prst="rect">
             <a:avLst/>
@@ -3075,14 +3075,14 @@
               <a:buNone/>
             </a:pPr>
             <a:r>
-              <a:rPr lang="en-US" sz="1300" b="1" dirty="0">
+              <a:rPr lang="en-US" sz="1500" b="1" dirty="0">
                 <a:solidFill>
                   <a:srgbClr val="1A1A2E"/>
                 </a:solidFill>
               </a:rPr>
               <a:t>▸ "fork Gitee→GitLab"</a:t>
             </a:r>
-            <a:endParaRPr lang="en-US" sz="1300" dirty="0"/>
+            <a:endParaRPr lang="en-US" sz="1500" dirty="0"/>
           </a:p>
         </p:txBody>
       </p:sp>
@@ -3094,8 +3094,8 @@
         </p:nvSpPr>
         <p:spPr>
           <a:xfrm>
-            <a:off x="457200" y="4663440"/>
-            <a:ext cx="5303520" cy="1280160"/>
+            <a:off x="457200" y="4709160"/>
+            <a:ext cx="5303520" cy="1234440"/>
           </a:xfrm>
           <a:prstGeom prst="rect">
             <a:avLst/>
@@ -3109,36 +3109,36 @@
           <a:p>
             <a:pPr indent="0" marL="0">
               <a:lnSpc>
-                <a:spcPts val="1800"/>
+                <a:spcPts val="2000"/>
               </a:lnSpc>
               <a:buNone/>
             </a:pPr>
             <a:r>
-              <a:rPr lang="en-US" sz="1000" dirty="0">
+              <a:rPr lang="en-US" sz="1200" dirty="0">
                 <a:solidFill>
                   <a:srgbClr val="4A4A6A"/>
                 </a:solidFill>
               </a:rPr>
               <a:t>5个核心函数全加batch</a:t>
             </a:r>
-            <a:endParaRPr lang="en-US" sz="1000" dirty="0"/>
+            <a:endParaRPr lang="en-US" sz="1200" dirty="0"/>
           </a:p>
           <a:p>
             <a:pPr indent="0" marL="0">
               <a:lnSpc>
-                <a:spcPts val="1800"/>
+                <a:spcPts val="2000"/>
               </a:lnSpc>
               <a:buNone/>
             </a:pPr>
             <a:r>
-              <a:rPr lang="en-US" sz="1000" dirty="0">
+              <a:rPr lang="en-US" sz="1200" dirty="0">
                 <a:solidFill>
                   <a:srgbClr val="4A4A6A"/>
                 </a:solidFill>
               </a:rPr>
               <a:t>→ gitlab.youtune.tech/cychi/cyc_nativehook</a:t>
             </a:r>
-            <a:endParaRPr lang="en-US" sz="1000" dirty="0"/>
+            <a:endParaRPr lang="en-US" sz="1200" dirty="0"/>
           </a:p>
         </p:txBody>
       </p:sp>
@@ -3198,7 +3198,7 @@
         <p:spPr>
           <a:xfrm>
             <a:off x="6263640" y="3931920"/>
-            <a:ext cx="1371600" cy="228600"/>
+            <a:ext cx="1371600" cy="256032"/>
           </a:xfrm>
           <a:prstGeom prst="rect">
             <a:avLst/>
@@ -3214,7 +3214,7 @@
               <a:buNone/>
             </a:pPr>
             <a:r>
-              <a:rPr lang="en-US" sz="800" b="1" dirty="0">
+              <a:rPr lang="en-US" sz="1000" b="1" dirty="0">
                 <a:solidFill>
                   <a:srgbClr val="7C3AED"/>
                 </a:solidFill>
@@ -3224,7 +3224,7 @@
               </a:rPr>
               <a:t>PAUSED</a:t>
             </a:r>
-            <a:endParaRPr lang="en-US" sz="800" dirty="0"/>
+            <a:endParaRPr lang="en-US" sz="1000" dirty="0"/>
           </a:p>
         </p:txBody>
       </p:sp>
@@ -3236,8 +3236,8 @@
         </p:nvSpPr>
         <p:spPr>
           <a:xfrm>
-            <a:off x="6263640" y="4206240"/>
-            <a:ext cx="5303520" cy="365760"/>
+            <a:off x="6263640" y="4233672"/>
+            <a:ext cx="5303520" cy="411480"/>
           </a:xfrm>
           <a:prstGeom prst="rect">
             <a:avLst/>
@@ -3253,14 +3253,14 @@
               <a:buNone/>
             </a:pPr>
             <a:r>
-              <a:rPr lang="en-US" sz="1300" b="1" dirty="0">
+              <a:rPr lang="en-US" sz="1500" b="1" dirty="0">
                 <a:solidFill>
                   <a:srgbClr val="1A1A2E"/>
                 </a:solidFill>
               </a:rPr>
               <a:t>▸ "4T eBPF异常快"</a:t>
             </a:r>
-            <a:endParaRPr lang="en-US" sz="1300" dirty="0"/>
+            <a:endParaRPr lang="en-US" sz="1500" dirty="0"/>
           </a:p>
         </p:txBody>
       </p:sp>
@@ -3272,8 +3272,8 @@
         </p:nvSpPr>
         <p:spPr>
           <a:xfrm>
-            <a:off x="6263640" y="4663440"/>
-            <a:ext cx="5303520" cy="1280160"/>
+            <a:off x="6263640" y="4709160"/>
+            <a:ext cx="5303520" cy="1234440"/>
           </a:xfrm>
           <a:prstGeom prst="rect">
             <a:avLst/>
@@ -3287,36 +3287,36 @@
           <a:p>
             <a:pPr indent="0" marL="0">
               <a:lnSpc>
-                <a:spcPts val="1800"/>
+                <a:spcPts val="2000"/>
               </a:lnSpc>
               <a:buNone/>
             </a:pPr>
             <a:r>
-              <a:rPr lang="en-US" sz="1000" dirty="0">
+              <a:rPr lang="en-US" sz="1200" dirty="0">
                 <a:solidFill>
                   <a:srgbClr val="4A4A6A"/>
                 </a:solidFill>
               </a:rPr>
               <a:t>本轮聚焦producer端</a:t>
             </a:r>
-            <a:endParaRPr lang="en-US" sz="1000" dirty="0"/>
+            <a:endParaRPr lang="en-US" sz="1200" dirty="0"/>
           </a:p>
           <a:p>
             <a:pPr indent="0" marL="0">
               <a:lnSpc>
-                <a:spcPts val="1800"/>
+                <a:spcPts val="2000"/>
               </a:lnSpc>
               <a:buNone/>
             </a:pPr>
             <a:r>
-              <a:rPr lang="en-US" sz="1000" dirty="0">
+              <a:rPr lang="en-US" sz="1200" dirty="0">
                 <a:solidFill>
                   <a:srgbClr val="4A4A6A"/>
                 </a:solidFill>
               </a:rPr>
               <a:t>eBPF线暂停，待后续</a:t>
             </a:r>
-            <a:endParaRPr lang="en-US" sz="1000" dirty="0"/>
+            <a:endParaRPr lang="en-US" sz="1200" dirty="0"/>
           </a:p>
         </p:txBody>
       </p:sp>
@@ -3417,7 +3417,7 @@
               <a:buNone/>
             </a:pPr>
             <a:r>
-              <a:rPr lang="en-US" sz="2400" b="1" dirty="0">
+              <a:rPr lang="en-US" sz="2800" b="1" dirty="0">
                 <a:solidFill>
                   <a:srgbClr val="2563EB"/>
                 </a:solidFill>
@@ -3427,7 +3427,7 @@
               </a:rPr>
               <a:t>02</a:t>
             </a:r>
-            <a:endParaRPr lang="en-US" sz="2400" dirty="0"/>
+            <a:endParaRPr lang="en-US" sz="2800" dirty="0"/>
           </a:p>
         </p:txBody>
       </p:sp>
@@ -3440,7 +3440,7 @@
         <p:spPr>
           <a:xfrm>
             <a:off x="1280160" y="137160"/>
-            <a:ext cx="9144000" cy="411480"/>
+            <a:ext cx="9144000" cy="502920"/>
           </a:xfrm>
           <a:prstGeom prst="rect">
             <a:avLst/>
@@ -3456,14 +3456,14 @@
               <a:buNone/>
             </a:pPr>
             <a:r>
-              <a:rPr lang="en-US" sz="2000" b="1" dirty="0">
+              <a:rPr lang="en-US" sz="2400" b="1" dirty="0">
                 <a:solidFill>
                   <a:srgbClr val="1A1A2E"/>
                 </a:solidFill>
               </a:rPr>
               <a:t>Writer/Ring Impact 拆解实验</a:t>
             </a:r>
-            <a:endParaRPr lang="en-US" sz="2000" dirty="0"/>
+            <a:endParaRPr lang="en-US" sz="2400" dirty="0"/>
           </a:p>
         </p:txBody>
       </p:sp>
@@ -3475,8 +3475,8 @@
         </p:nvSpPr>
         <p:spPr>
           <a:xfrm>
-            <a:off x="1280160" y="530352"/>
-            <a:ext cx="9144000" cy="228600"/>
+            <a:off x="1280160" y="566928"/>
+            <a:ext cx="9144000" cy="274320"/>
           </a:xfrm>
           <a:prstGeom prst="rect">
             <a:avLst/>
@@ -3492,14 +3492,14 @@
               <a:buNone/>
             </a:pPr>
             <a:r>
-              <a:rPr lang="en-US" sz="1000" dirty="0">
+              <a:rPr lang="en-US" sz="1200" dirty="0">
                 <a:solidFill>
                   <a:srgbClr val="8888A8"/>
                 </a:solidFill>
               </a:rPr>
               <a:t>sub-stage 28~33 逐段测量，固定100万次malloc/free pair</a:t>
             </a:r>
-            <a:endParaRPr lang="en-US" sz="1000" dirty="0"/>
+            <a:endParaRPr lang="en-US" sz="1200" dirty="0"/>
           </a:p>
         </p:txBody>
       </p:sp>
@@ -3533,7 +3533,7 @@
                 <a:gridCol w="1920240"/>
                 <a:gridCol w="1920240"/>
               </a:tblGrid>
-              <a:tr h="329184">
+              <a:tr h="384048">
                 <a:tc>
                   <a:txBody>
                     <a:bodyPr/>
@@ -3543,14 +3543,14 @@
                         <a:buNone/>
                       </a:pPr>
                       <a:r>
-                        <a:rPr lang="en-US" sz="1000" b="1" dirty="0">
+                        <a:rPr lang="en-US" sz="1200" b="1" dirty="0">
                           <a:solidFill>
                             <a:srgbClr val="2563EB"/>
                           </a:solidFill>
                         </a:rPr>
                         <a:t>Sub-stage</a:t>
                       </a:r>
-                      <a:endParaRPr lang="en-US" sz="1000" dirty="0"/>
+                      <a:endParaRPr lang="en-US" sz="1200" dirty="0"/>
                     </a:p>
                   </a:txBody>
                   <a:tcPr marL="76200" marR="76200" marT="25400" marB="25400">
@@ -3604,14 +3604,14 @@
                         <a:buNone/>
                       </a:pPr>
                       <a:r>
-                        <a:rPr lang="en-US" sz="1000" b="1" dirty="0">
+                        <a:rPr lang="en-US" sz="1200" b="1" dirty="0">
                           <a:solidFill>
                             <a:srgbClr val="2563EB"/>
                           </a:solidFill>
                         </a:rPr>
                         <a:t>测量内容</a:t>
                       </a:r>
-                      <a:endParaRPr lang="en-US" sz="1000" dirty="0"/>
+                      <a:endParaRPr lang="en-US" sz="1200" dirty="0"/>
                     </a:p>
                   </a:txBody>
                   <a:tcPr marL="76200" marR="76200" marT="25400" marB="25400">
@@ -3665,14 +3665,14 @@
                         <a:buNone/>
                       </a:pPr>
                       <a:r>
-                        <a:rPr lang="en-US" sz="1000" b="1" dirty="0">
+                        <a:rPr lang="en-US" sz="1200" b="1" dirty="0">
                           <a:solidFill>
                             <a:srgbClr val="2563EB"/>
                           </a:solidFill>
                         </a:rPr>
                         <a:t>1T</a:t>
                       </a:r>
-                      <a:endParaRPr lang="en-US" sz="1000" dirty="0"/>
+                      <a:endParaRPr lang="en-US" sz="1200" dirty="0"/>
                     </a:p>
                   </a:txBody>
                   <a:tcPr marL="76200" marR="76200" marT="25400" marB="25400">
@@ -3726,14 +3726,14 @@
                         <a:buNone/>
                       </a:pPr>
                       <a:r>
-                        <a:rPr lang="en-US" sz="1000" b="1" dirty="0">
+                        <a:rPr lang="en-US" sz="1200" b="1" dirty="0">
                           <a:solidFill>
                             <a:srgbClr val="2563EB"/>
                           </a:solidFill>
                         </a:rPr>
                         <a:t>4T</a:t>
                       </a:r>
-                      <a:endParaRPr lang="en-US" sz="1000" dirty="0"/>
+                      <a:endParaRPr lang="en-US" sz="1200" dirty="0"/>
                     </a:p>
                   </a:txBody>
                   <a:tcPr marL="76200" marR="76200" marT="25400" marB="25400">
@@ -3787,14 +3787,14 @@
                         <a:buNone/>
                       </a:pPr>
                       <a:r>
-                        <a:rPr lang="en-US" sz="1000" b="1" dirty="0">
+                        <a:rPr lang="en-US" sz="1200" b="1" dirty="0">
                           <a:solidFill>
                             <a:srgbClr val="2563EB"/>
                           </a:solidFill>
                         </a:rPr>
                         <a:t>8T</a:t>
                       </a:r>
-                      <a:endParaRPr lang="en-US" sz="1000" dirty="0"/>
+                      <a:endParaRPr lang="en-US" sz="1200" dirty="0"/>
                     </a:p>
                   </a:txBody>
                   <a:tcPr marL="76200" marR="76200" marT="25400" marB="25400">
@@ -3848,14 +3848,14 @@
                         <a:buNone/>
                       </a:pPr>
                       <a:r>
-                        <a:rPr lang="en-US" sz="1000" b="1" dirty="0">
+                        <a:rPr lang="en-US" sz="1200" b="1" dirty="0">
                           <a:solidFill>
                             <a:srgbClr val="2563EB"/>
                           </a:solidFill>
                         </a:rPr>
                         <a:t>16T</a:t>
                       </a:r>
-                      <a:endParaRPr lang="en-US" sz="1000" dirty="0"/>
+                      <a:endParaRPr lang="en-US" sz="1200" dirty="0"/>
                     </a:p>
                   </a:txBody>
                   <a:tcPr marL="76200" marR="76200" marT="25400" marB="25400">
@@ -3901,7 +3901,7 @@
                   </a:tcPr>
                 </a:tc>
               </a:tr>
-              <a:tr h="329184">
+              <a:tr h="384048">
                 <a:tc>
                   <a:txBody>
                     <a:bodyPr/>
@@ -3911,14 +3911,14 @@
                         <a:buNone/>
                       </a:pPr>
                       <a:r>
-                        <a:rPr lang="en-US" sz="1000" dirty="0">
+                        <a:rPr lang="en-US" sz="1200" dirty="0">
                           <a:solidFill>
                             <a:srgbClr val="4A4A6A"/>
                           </a:solidFill>
                         </a:rPr>
                         <a:t>28 no_ring</a:t>
                       </a:r>
-                      <a:endParaRPr lang="en-US" sz="1000" dirty="0"/>
+                      <a:endParaRPr lang="en-US" sz="1200" dirty="0"/>
                     </a:p>
                   </a:txBody>
                   <a:tcPr marL="76200" marR="76200" marT="25400" marB="25400">
@@ -3972,14 +3972,14 @@
                         <a:buNone/>
                       </a:pPr>
                       <a:r>
-                        <a:rPr lang="en-US" sz="1000" dirty="0">
+                        <a:rPr lang="en-US" sz="1200" dirty="0">
                           <a:solidFill>
                             <a:srgbClr val="4A4A6A"/>
                           </a:solidFill>
                         </a:rPr>
                         <a:t>基线（无ring操作）</a:t>
                       </a:r>
-                      <a:endParaRPr lang="en-US" sz="1000" dirty="0"/>
+                      <a:endParaRPr lang="en-US" sz="1200" dirty="0"/>
                     </a:p>
                   </a:txBody>
                   <a:tcPr marL="76200" marR="76200" marT="25400" marB="25400">
@@ -4033,14 +4033,14 @@
                         <a:buNone/>
                       </a:pPr>
                       <a:r>
-                        <a:rPr lang="en-US" sz="1000" dirty="0">
+                        <a:rPr lang="en-US" sz="1200" dirty="0">
                           <a:solidFill>
                             <a:srgbClr val="4A4A6A"/>
                           </a:solidFill>
                         </a:rPr>
                         <a:t>—</a:t>
                       </a:r>
-                      <a:endParaRPr lang="en-US" sz="1000" dirty="0"/>
+                      <a:endParaRPr lang="en-US" sz="1200" dirty="0"/>
                     </a:p>
                   </a:txBody>
                   <a:tcPr marL="76200" marR="76200" marT="25400" marB="25400">
@@ -4094,14 +4094,14 @@
                         <a:buNone/>
                       </a:pPr>
                       <a:r>
-                        <a:rPr lang="en-US" sz="1000" dirty="0">
+                        <a:rPr lang="en-US" sz="1200" dirty="0">
                           <a:solidFill>
                             <a:srgbClr val="4A4A6A"/>
                           </a:solidFill>
                         </a:rPr>
                         <a:t>—</a:t>
                       </a:r>
-                      <a:endParaRPr lang="en-US" sz="1000" dirty="0"/>
+                      <a:endParaRPr lang="en-US" sz="1200" dirty="0"/>
                     </a:p>
                   </a:txBody>
                   <a:tcPr marL="76200" marR="76200" marT="25400" marB="25400">
@@ -4155,14 +4155,14 @@
                         <a:buNone/>
                       </a:pPr>
                       <a:r>
-                        <a:rPr lang="en-US" sz="1000" dirty="0">
+                        <a:rPr lang="en-US" sz="1200" dirty="0">
                           <a:solidFill>
                             <a:srgbClr val="4A4A6A"/>
                           </a:solidFill>
                         </a:rPr>
                         <a:t>—</a:t>
                       </a:r>
-                      <a:endParaRPr lang="en-US" sz="1000" dirty="0"/>
+                      <a:endParaRPr lang="en-US" sz="1200" dirty="0"/>
                     </a:p>
                   </a:txBody>
                   <a:tcPr marL="76200" marR="76200" marT="25400" marB="25400">
@@ -4216,14 +4216,14 @@
                         <a:buNone/>
                       </a:pPr>
                       <a:r>
-                        <a:rPr lang="en-US" sz="1000" dirty="0">
+                        <a:rPr lang="en-US" sz="1200" dirty="0">
                           <a:solidFill>
                             <a:srgbClr val="059669"/>
                           </a:solidFill>
                         </a:rPr>
                         <a:t>—</a:t>
                       </a:r>
-                      <a:endParaRPr lang="en-US" sz="1000" dirty="0"/>
+                      <a:endParaRPr lang="en-US" sz="1200" dirty="0"/>
                     </a:p>
                   </a:txBody>
                   <a:tcPr marL="76200" marR="76200" marT="25400" marB="25400">
@@ -4269,7 +4269,7 @@
                   </a:tcPr>
                 </a:tc>
               </a:tr>
-              <a:tr h="329184">
+              <a:tr h="384048">
                 <a:tc>
                   <a:txBody>
                     <a:bodyPr/>
@@ -4279,14 +4279,14 @@
                         <a:buNone/>
                       </a:pPr>
                       <a:r>
-                        <a:rPr lang="en-US" sz="1000" dirty="0">
+                        <a:rPr lang="en-US" sz="1200" dirty="0">
                           <a:solidFill>
                             <a:srgbClr val="4A4A6A"/>
                           </a:solidFill>
                         </a:rPr>
                         <a:t>29 mutex_only</a:t>
                       </a:r>
-                      <a:endParaRPr lang="en-US" sz="1000" dirty="0"/>
+                      <a:endParaRPr lang="en-US" sz="1200" dirty="0"/>
                     </a:p>
                   </a:txBody>
                   <a:tcPr marL="76200" marR="76200" marT="25400" marB="25400">
@@ -4340,14 +4340,14 @@
                         <a:buNone/>
                       </a:pPr>
                       <a:r>
-                        <a:rPr lang="en-US" sz="1000" dirty="0">
+                        <a:rPr lang="en-US" sz="1200" dirty="0">
                           <a:solidFill>
                             <a:srgbClr val="4A4A6A"/>
                           </a:solidFill>
                         </a:rPr>
                         <a:t>仅拿锁 + tracking</a:t>
                       </a:r>
-                      <a:endParaRPr lang="en-US" sz="1000" dirty="0"/>
+                      <a:endParaRPr lang="en-US" sz="1200" dirty="0"/>
                     </a:p>
                   </a:txBody>
                   <a:tcPr marL="76200" marR="76200" marT="25400" marB="25400">
@@ -4401,14 +4401,14 @@
                         <a:buNone/>
                       </a:pPr>
                       <a:r>
-                        <a:rPr lang="en-US" sz="1000" dirty="0">
+                        <a:rPr lang="en-US" sz="1200" dirty="0">
                           <a:solidFill>
                             <a:srgbClr val="4A4A6A"/>
                           </a:solidFill>
                         </a:rPr>
                         <a:t>0.28s</a:t>
                       </a:r>
-                      <a:endParaRPr lang="en-US" sz="1000" dirty="0"/>
+                      <a:endParaRPr lang="en-US" sz="1200" dirty="0"/>
                     </a:p>
                   </a:txBody>
                   <a:tcPr marL="76200" marR="76200" marT="25400" marB="25400">
@@ -4462,14 +4462,14 @@
                         <a:buNone/>
                       </a:pPr>
                       <a:r>
-                        <a:rPr lang="en-US" sz="1000" dirty="0">
+                        <a:rPr lang="en-US" sz="1200" dirty="0">
                           <a:solidFill>
                             <a:srgbClr val="4A4A6A"/>
                           </a:solidFill>
                         </a:rPr>
                         <a:t>0.62s</a:t>
                       </a:r>
-                      <a:endParaRPr lang="en-US" sz="1000" dirty="0"/>
+                      <a:endParaRPr lang="en-US" sz="1200" dirty="0"/>
                     </a:p>
                   </a:txBody>
                   <a:tcPr marL="76200" marR="76200" marT="25400" marB="25400">
@@ -4523,14 +4523,14 @@
                         <a:buNone/>
                       </a:pPr>
                       <a:r>
-                        <a:rPr lang="en-US" sz="1000" dirty="0">
+                        <a:rPr lang="en-US" sz="1200" dirty="0">
                           <a:solidFill>
                             <a:srgbClr val="4A4A6A"/>
                           </a:solidFill>
                         </a:rPr>
                         <a:t>0.85s</a:t>
                       </a:r>
-                      <a:endParaRPr lang="en-US" sz="1000" dirty="0"/>
+                      <a:endParaRPr lang="en-US" sz="1200" dirty="0"/>
                     </a:p>
                   </a:txBody>
                   <a:tcPr marL="76200" marR="76200" marT="25400" marB="25400">
@@ -4584,14 +4584,14 @@
                         <a:buNone/>
                       </a:pPr>
                       <a:r>
-                        <a:rPr lang="en-US" sz="1000" dirty="0">
+                        <a:rPr lang="en-US" sz="1200" dirty="0">
                           <a:solidFill>
                             <a:srgbClr val="059669"/>
                           </a:solidFill>
                         </a:rPr>
                         <a:t>1.12s</a:t>
                       </a:r>
-                      <a:endParaRPr lang="en-US" sz="1000" dirty="0"/>
+                      <a:endParaRPr lang="en-US" sz="1200" dirty="0"/>
                     </a:p>
                   </a:txBody>
                   <a:tcPr marL="76200" marR="76200" marT="25400" marB="25400">
@@ -4637,7 +4637,7 @@
                   </a:tcPr>
                 </a:tc>
               </a:tr>
-              <a:tr h="329184">
+              <a:tr h="384048">
                 <a:tc>
                   <a:txBody>
                     <a:bodyPr/>
@@ -4647,14 +4647,14 @@
                         <a:buNone/>
                       </a:pPr>
                       <a:r>
-                        <a:rPr lang="en-US" sz="1000" dirty="0">
+                        <a:rPr lang="en-US" sz="1200" dirty="0">
                           <a:solidFill>
                             <a:srgbClr val="4A4A6A"/>
                           </a:solidFill>
                         </a:rPr>
                         <a:t>30 ring_index</a:t>
                       </a:r>
-                      <a:endParaRPr lang="en-US" sz="1000" dirty="0"/>
+                      <a:endParaRPr lang="en-US" sz="1200" dirty="0"/>
                     </a:p>
                   </a:txBody>
                   <a:tcPr marL="76200" marR="76200" marT="25400" marB="25400">
@@ -4708,14 +4708,14 @@
                         <a:buNone/>
                       </a:pPr>
                       <a:r>
-                        <a:rPr lang="en-US" sz="1000" dirty="0">
+                        <a:rPr lang="en-US" sz="1200" dirty="0">
                           <a:solidFill>
                             <a:srgbClr val="4A4A6A"/>
                           </a:solidFill>
                         </a:rPr>
                         <a:t>+ ring index检查</a:t>
                       </a:r>
-                      <a:endParaRPr lang="en-US" sz="1000" dirty="0"/>
+                      <a:endParaRPr lang="en-US" sz="1200" dirty="0"/>
                     </a:p>
                   </a:txBody>
                   <a:tcPr marL="76200" marR="76200" marT="25400" marB="25400">
@@ -4769,14 +4769,14 @@
                         <a:buNone/>
                       </a:pPr>
                       <a:r>
-                        <a:rPr lang="en-US" sz="1000" dirty="0">
+                        <a:rPr lang="en-US" sz="1200" dirty="0">
                           <a:solidFill>
                             <a:srgbClr val="4A4A6A"/>
                           </a:solidFill>
                         </a:rPr>
                         <a:t>0.45s</a:t>
                       </a:r>
-                      <a:endParaRPr lang="en-US" sz="1000" dirty="0"/>
+                      <a:endParaRPr lang="en-US" sz="1200" dirty="0"/>
                     </a:p>
                   </a:txBody>
                   <a:tcPr marL="76200" marR="76200" marT="25400" marB="25400">
@@ -4830,14 +4830,14 @@
                         <a:buNone/>
                       </a:pPr>
                       <a:r>
-                        <a:rPr lang="en-US" sz="1000" dirty="0">
+                        <a:rPr lang="en-US" sz="1200" dirty="0">
                           <a:solidFill>
                             <a:srgbClr val="4A4A6A"/>
                           </a:solidFill>
                         </a:rPr>
                         <a:t>1.35s</a:t>
                       </a:r>
-                      <a:endParaRPr lang="en-US" sz="1000" dirty="0"/>
+                      <a:endParaRPr lang="en-US" sz="1200" dirty="0"/>
                     </a:p>
                   </a:txBody>
                   <a:tcPr marL="76200" marR="76200" marT="25400" marB="25400">
@@ -4891,14 +4891,14 @@
                         <a:buNone/>
                       </a:pPr>
                       <a:r>
-                        <a:rPr lang="en-US" sz="1000" dirty="0">
+                        <a:rPr lang="en-US" sz="1200" dirty="0">
                           <a:solidFill>
                             <a:srgbClr val="4A4A6A"/>
                           </a:solidFill>
                         </a:rPr>
                         <a:t>1.92s</a:t>
                       </a:r>
-                      <a:endParaRPr lang="en-US" sz="1000" dirty="0"/>
+                      <a:endParaRPr lang="en-US" sz="1200" dirty="0"/>
                     </a:p>
                   </a:txBody>
                   <a:tcPr marL="76200" marR="76200" marT="25400" marB="25400">
@@ -4952,14 +4952,14 @@
                         <a:buNone/>
                       </a:pPr>
                       <a:r>
-                        <a:rPr lang="en-US" sz="1000" dirty="0">
+                        <a:rPr lang="en-US" sz="1200" dirty="0">
                           <a:solidFill>
                             <a:srgbClr val="059669"/>
                           </a:solidFill>
                         </a:rPr>
                         <a:t>2.48s</a:t>
                       </a:r>
-                      <a:endParaRPr lang="en-US" sz="1000" dirty="0"/>
+                      <a:endParaRPr lang="en-US" sz="1200" dirty="0"/>
                     </a:p>
                   </a:txBody>
                   <a:tcPr marL="76200" marR="76200" marT="25400" marB="25400">
@@ -5005,7 +5005,7 @@
                   </a:tcPr>
                 </a:tc>
               </a:tr>
-              <a:tr h="329184">
+              <a:tr h="384048">
                 <a:tc>
                   <a:txBody>
                     <a:bodyPr/>
@@ -5015,14 +5015,14 @@
                         <a:buNone/>
                       </a:pPr>
                       <a:r>
-                        <a:rPr lang="en-US" sz="1000" dirty="0">
+                        <a:rPr lang="en-US" sz="1200" dirty="0">
                           <a:solidFill>
                             <a:srgbClr val="4A4A6A"/>
                           </a:solidFill>
                         </a:rPr>
                         <a:t>31 record_copy</a:t>
                       </a:r>
-                      <a:endParaRPr lang="en-US" sz="1000" dirty="0"/>
+                      <a:endParaRPr lang="en-US" sz="1200" dirty="0"/>
                     </a:p>
                   </a:txBody>
                   <a:tcPr marL="76200" marR="76200" marT="25400" marB="25400">
@@ -5076,14 +5076,14 @@
                         <a:buNone/>
                       </a:pPr>
                       <a:r>
-                        <a:rPr lang="en-US" sz="1000" dirty="0">
+                        <a:rPr lang="en-US" sz="1200" dirty="0">
                           <a:solidFill>
                             <a:srgbClr val="4A4A6A"/>
                           </a:solidFill>
                         </a:rPr>
                         <a:t>+ 记录拷贝到共享内存</a:t>
                       </a:r>
-                      <a:endParaRPr lang="en-US" sz="1000" dirty="0"/>
+                      <a:endParaRPr lang="en-US" sz="1200" dirty="0"/>
                     </a:p>
                   </a:txBody>
                   <a:tcPr marL="76200" marR="76200" marT="25400" marB="25400">
@@ -5137,14 +5137,14 @@
                         <a:buNone/>
                       </a:pPr>
                       <a:r>
-                        <a:rPr lang="en-US" sz="1000" dirty="0">
+                        <a:rPr lang="en-US" sz="1200" dirty="0">
                           <a:solidFill>
                             <a:srgbClr val="4A4A6A"/>
                           </a:solidFill>
                         </a:rPr>
                         <a:t>0.68s</a:t>
                       </a:r>
-                      <a:endParaRPr lang="en-US" sz="1000" dirty="0"/>
+                      <a:endParaRPr lang="en-US" sz="1200" dirty="0"/>
                     </a:p>
                   </a:txBody>
                   <a:tcPr marL="76200" marR="76200" marT="25400" marB="25400">
@@ -5198,14 +5198,14 @@
                         <a:buNone/>
                       </a:pPr>
                       <a:r>
-                        <a:rPr lang="en-US" sz="1000" dirty="0">
+                        <a:rPr lang="en-US" sz="1200" dirty="0">
                           <a:solidFill>
                             <a:srgbClr val="4A4A6A"/>
                           </a:solidFill>
                         </a:rPr>
                         <a:t>2.10s</a:t>
                       </a:r>
-                      <a:endParaRPr lang="en-US" sz="1000" dirty="0"/>
+                      <a:endParaRPr lang="en-US" sz="1200" dirty="0"/>
                     </a:p>
                   </a:txBody>
                   <a:tcPr marL="76200" marR="76200" marT="25400" marB="25400">
@@ -5259,14 +5259,14 @@
                         <a:buNone/>
                       </a:pPr>
                       <a:r>
-                        <a:rPr lang="en-US" sz="1000" dirty="0">
+                        <a:rPr lang="en-US" sz="1200" dirty="0">
                           <a:solidFill>
                             <a:srgbClr val="4A4A6A"/>
                           </a:solidFill>
                         </a:rPr>
                         <a:t>2.85s</a:t>
                       </a:r>
-                      <a:endParaRPr lang="en-US" sz="1000" dirty="0"/>
+                      <a:endParaRPr lang="en-US" sz="1200" dirty="0"/>
                     </a:p>
                   </a:txBody>
                   <a:tcPr marL="76200" marR="76200" marT="25400" marB="25400">
@@ -5320,14 +5320,14 @@
                         <a:buNone/>
                       </a:pPr>
                       <a:r>
-                        <a:rPr lang="en-US" sz="1000" dirty="0">
+                        <a:rPr lang="en-US" sz="1200" dirty="0">
                           <a:solidFill>
                             <a:srgbClr val="059669"/>
                           </a:solidFill>
                         </a:rPr>
                         <a:t>3.52s</a:t>
                       </a:r>
-                      <a:endParaRPr lang="en-US" sz="1000" dirty="0"/>
+                      <a:endParaRPr lang="en-US" sz="1200" dirty="0"/>
                     </a:p>
                   </a:txBody>
                   <a:tcPr marL="76200" marR="76200" marT="25400" marB="25400">
@@ -5373,7 +5373,7 @@
                   </a:tcPr>
                 </a:tc>
               </a:tr>
-              <a:tr h="329184">
+              <a:tr h="384048">
                 <a:tc>
                   <a:txBody>
                     <a:bodyPr/>
@@ -5383,14 +5383,14 @@
                         <a:buNone/>
                       </a:pPr>
                       <a:r>
-                        <a:rPr lang="en-US" sz="1000" dirty="0">
+                        <a:rPr lang="en-US" sz="1200" dirty="0">
                           <a:solidFill>
                             <a:srgbClr val="4A4A6A"/>
                           </a:solidFill>
                         </a:rPr>
                         <a:t>32 atomic_pub</a:t>
                       </a:r>
-                      <a:endParaRPr lang="en-US" sz="1000" dirty="0"/>
+                      <a:endParaRPr lang="en-US" sz="1200" dirty="0"/>
                     </a:p>
                   </a:txBody>
                   <a:tcPr marL="76200" marR="76200" marT="25400" marB="25400">
@@ -5444,14 +5444,14 @@
                         <a:buNone/>
                       </a:pPr>
                       <a:r>
-                        <a:rPr lang="en-US" sz="1000" dirty="0">
+                        <a:rPr lang="en-US" sz="1200" dirty="0">
                           <a:solidFill>
                             <a:srgbClr val="4A4A6A"/>
                           </a:solidFill>
                         </a:rPr>
                         <a:t>+ atomic write_index发布</a:t>
                       </a:r>
-                      <a:endParaRPr lang="en-US" sz="1000" dirty="0"/>
+                      <a:endParaRPr lang="en-US" sz="1200" dirty="0"/>
                     </a:p>
                   </a:txBody>
                   <a:tcPr marL="76200" marR="76200" marT="25400" marB="25400">
@@ -5505,14 +5505,14 @@
                         <a:buNone/>
                       </a:pPr>
                       <a:r>
-                        <a:rPr lang="en-US" sz="1000" dirty="0">
+                        <a:rPr lang="en-US" sz="1200" dirty="0">
                           <a:solidFill>
                             <a:srgbClr val="4A4A6A"/>
                           </a:solidFill>
                         </a:rPr>
                         <a:t>0.75s</a:t>
                       </a:r>
-                      <a:endParaRPr lang="en-US" sz="1000" dirty="0"/>
+                      <a:endParaRPr lang="en-US" sz="1200" dirty="0"/>
                     </a:p>
                   </a:txBody>
                   <a:tcPr marL="76200" marR="76200" marT="25400" marB="25400">
@@ -5566,14 +5566,14 @@
                         <a:buNone/>
                       </a:pPr>
                       <a:r>
-                        <a:rPr lang="en-US" sz="1000" dirty="0">
+                        <a:rPr lang="en-US" sz="1200" dirty="0">
                           <a:solidFill>
                             <a:srgbClr val="4A4A6A"/>
                           </a:solidFill>
                         </a:rPr>
                         <a:t>2.35s</a:t>
                       </a:r>
-                      <a:endParaRPr lang="en-US" sz="1000" dirty="0"/>
+                      <a:endParaRPr lang="en-US" sz="1200" dirty="0"/>
                     </a:p>
                   </a:txBody>
                   <a:tcPr marL="76200" marR="76200" marT="25400" marB="25400">
@@ -5627,14 +5627,14 @@
                         <a:buNone/>
                       </a:pPr>
                       <a:r>
-                        <a:rPr lang="en-US" sz="1000" dirty="0">
+                        <a:rPr lang="en-US" sz="1200" dirty="0">
                           <a:solidFill>
                             <a:srgbClr val="4A4A6A"/>
                           </a:solidFill>
                         </a:rPr>
                         <a:t>3.10s</a:t>
                       </a:r>
-                      <a:endParaRPr lang="en-US" sz="1000" dirty="0"/>
+                      <a:endParaRPr lang="en-US" sz="1200" dirty="0"/>
                     </a:p>
                   </a:txBody>
                   <a:tcPr marL="76200" marR="76200" marT="25400" marB="25400">
@@ -5688,14 +5688,14 @@
                         <a:buNone/>
                       </a:pPr>
                       <a:r>
-                        <a:rPr lang="en-US" sz="1000" dirty="0">
+                        <a:rPr lang="en-US" sz="1200" dirty="0">
                           <a:solidFill>
                             <a:srgbClr val="059669"/>
                           </a:solidFill>
                         </a:rPr>
                         <a:t>3.80s</a:t>
                       </a:r>
-                      <a:endParaRPr lang="en-US" sz="1000" dirty="0"/>
+                      <a:endParaRPr lang="en-US" sz="1200" dirty="0"/>
                     </a:p>
                   </a:txBody>
                   <a:tcPr marL="76200" marR="76200" marT="25400" marB="25400">
@@ -5741,7 +5741,7 @@
                   </a:tcPr>
                 </a:tc>
               </a:tr>
-              <a:tr h="329184">
+              <a:tr h="384048">
                 <a:tc>
                   <a:txBody>
                     <a:bodyPr/>
@@ -5751,14 +5751,14 @@
                         <a:buNone/>
                       </a:pPr>
                       <a:r>
-                        <a:rPr lang="en-US" sz="1000" dirty="0">
+                        <a:rPr lang="en-US" sz="1200" dirty="0">
                           <a:solidFill>
                             <a:srgbClr val="4A4A6A"/>
                           </a:solidFill>
                         </a:rPr>
                         <a:t>33 full_notify</a:t>
                       </a:r>
-                      <a:endParaRPr lang="en-US" sz="1000" dirty="0"/>
+                      <a:endParaRPr lang="en-US" sz="1200" dirty="0"/>
                     </a:p>
                   </a:txBody>
                   <a:tcPr marL="76200" marR="76200" marT="25400" marB="25400">
@@ -5812,14 +5812,14 @@
                         <a:buNone/>
                       </a:pPr>
                       <a:r>
-                        <a:rPr lang="en-US" sz="1000" dirty="0">
+                        <a:rPr lang="en-US" sz="1200" dirty="0">
                           <a:solidFill>
                             <a:srgbClr val="4A4A6A"/>
                           </a:solidFill>
                         </a:rPr>
                         <a:t>+ eventfd + consumer</a:t>
                       </a:r>
-                      <a:endParaRPr lang="en-US" sz="1000" dirty="0"/>
+                      <a:endParaRPr lang="en-US" sz="1200" dirty="0"/>
                     </a:p>
                   </a:txBody>
                   <a:tcPr marL="76200" marR="76200" marT="25400" marB="25400">
@@ -5873,14 +5873,14 @@
                         <a:buNone/>
                       </a:pPr>
                       <a:r>
-                        <a:rPr lang="en-US" sz="1000" dirty="0">
+                        <a:rPr lang="en-US" sz="1200" dirty="0">
                           <a:solidFill>
                             <a:srgbClr val="4A4A6A"/>
                           </a:solidFill>
                         </a:rPr>
                         <a:t>1.24s</a:t>
                       </a:r>
-                      <a:endParaRPr lang="en-US" sz="1000" dirty="0"/>
+                      <a:endParaRPr lang="en-US" sz="1200" dirty="0"/>
                     </a:p>
                   </a:txBody>
                   <a:tcPr marL="76200" marR="76200" marT="25400" marB="25400">
@@ -5934,14 +5934,14 @@
                         <a:buNone/>
                       </a:pPr>
                       <a:r>
-                        <a:rPr lang="en-US" sz="1000" dirty="0">
+                        <a:rPr lang="en-US" sz="1200" dirty="0">
                           <a:solidFill>
                             <a:srgbClr val="4A4A6A"/>
                           </a:solidFill>
                         </a:rPr>
                         <a:t>2.72s</a:t>
                       </a:r>
-                      <a:endParaRPr lang="en-US" sz="1000" dirty="0"/>
+                      <a:endParaRPr lang="en-US" sz="1200" dirty="0"/>
                     </a:p>
                   </a:txBody>
                   <a:tcPr marL="76200" marR="76200" marT="25400" marB="25400">
@@ -5995,14 +5995,14 @@
                         <a:buNone/>
                       </a:pPr>
                       <a:r>
-                        <a:rPr lang="en-US" sz="1000" dirty="0">
+                        <a:rPr lang="en-US" sz="1200" dirty="0">
                           <a:solidFill>
                             <a:srgbClr val="4A4A6A"/>
                           </a:solidFill>
                         </a:rPr>
                         <a:t>3.12s</a:t>
                       </a:r>
-                      <a:endParaRPr lang="en-US" sz="1000" dirty="0"/>
+                      <a:endParaRPr lang="en-US" sz="1200" dirty="0"/>
                     </a:p>
                   </a:txBody>
                   <a:tcPr marL="76200" marR="76200" marT="25400" marB="25400">
@@ -6056,14 +6056,14 @@
                         <a:buNone/>
                       </a:pPr>
                       <a:r>
-                        <a:rPr lang="en-US" sz="1000" dirty="0">
+                        <a:rPr lang="en-US" sz="1200" dirty="0">
                           <a:solidFill>
                             <a:srgbClr val="059669"/>
                           </a:solidFill>
                         </a:rPr>
                         <a:t>3.41s</a:t>
                       </a:r>
-                      <a:endParaRPr lang="en-US" sz="1000" dirty="0"/>
+                      <a:endParaRPr lang="en-US" sz="1200" dirty="0"/>
                     </a:p>
                   </a:txBody>
                   <a:tcPr marL="76200" marR="76200" marT="25400" marB="25400">
@@ -6274,7 +6274,7 @@
               <a:buNone/>
             </a:pPr>
             <a:r>
-              <a:rPr lang="en-US" sz="2400" b="1" dirty="0">
+              <a:rPr lang="en-US" sz="2800" b="1" dirty="0">
                 <a:solidFill>
                   <a:srgbClr val="2563EB"/>
                 </a:solidFill>
@@ -6284,7 +6284,7 @@
               </a:rPr>
               <a:t>03</a:t>
             </a:r>
-            <a:endParaRPr lang="en-US" sz="2400" dirty="0"/>
+            <a:endParaRPr lang="en-US" sz="2800" dirty="0"/>
           </a:p>
         </p:txBody>
       </p:sp>
@@ -6297,7 +6297,7 @@
         <p:spPr>
           <a:xfrm>
             <a:off x="1280160" y="137160"/>
-            <a:ext cx="9144000" cy="411480"/>
+            <a:ext cx="9144000" cy="502920"/>
           </a:xfrm>
           <a:prstGeom prst="rect">
             <a:avLst/>
@@ -6313,14 +6313,14 @@
               <a:buNone/>
             </a:pPr>
             <a:r>
-              <a:rPr lang="en-US" sz="2000" b="1" dirty="0">
+              <a:rPr lang="en-US" sz="2400" b="1" dirty="0">
                 <a:solidFill>
                   <a:srgbClr val="1A1A2E"/>
                 </a:solidFill>
               </a:rPr>
               <a:t>Producer 端三项优化</a:t>
             </a:r>
-            <a:endParaRPr lang="en-US" sz="2000" dirty="0"/>
+            <a:endParaRPr lang="en-US" sz="2400" dirty="0"/>
           </a:p>
         </p:txBody>
       </p:sp>
@@ -6332,8 +6332,8 @@
         </p:nvSpPr>
         <p:spPr>
           <a:xfrm>
-            <a:off x="1280160" y="530352"/>
-            <a:ext cx="9144000" cy="228600"/>
+            <a:off x="1280160" y="566928"/>
+            <a:ext cx="9144000" cy="274320"/>
           </a:xfrm>
           <a:prstGeom prst="rect">
             <a:avLst/>
@@ -6349,14 +6349,14 @@
               <a:buNone/>
             </a:pPr>
             <a:r>
-              <a:rPr lang="en-US" sz="1000" dirty="0">
+              <a:rPr lang="en-US" sz="1200" dirty="0">
                 <a:solidFill>
                   <a:srgbClr val="8888A8"/>
                 </a:solidFill>
               </a:rPr>
               <a:t>逐级降低 per-record 共享路径开销</a:t>
             </a:r>
-            <a:endParaRPr lang="en-US" sz="1000" dirty="0"/>
+            <a:endParaRPr lang="en-US" sz="1200" dirty="0"/>
           </a:p>
         </p:txBody>
       </p:sp>
@@ -6432,7 +6432,7 @@
               <a:buNone/>
             </a:pPr>
             <a:r>
-              <a:rPr lang="en-US" sz="2600" b="1" dirty="0">
+              <a:rPr lang="en-US" sz="3000" b="1" dirty="0">
                 <a:solidFill>
                   <a:srgbClr val="0891B2"/>
                 </a:solidFill>
@@ -6442,7 +6442,7 @@
               </a:rPr>
               <a:t>01</a:t>
             </a:r>
-            <a:endParaRPr lang="en-US" sz="2600" dirty="0"/>
+            <a:endParaRPr lang="en-US" sz="3000" dirty="0"/>
           </a:p>
         </p:txBody>
       </p:sp>
@@ -6455,7 +6455,7 @@
         <p:spPr>
           <a:xfrm>
             <a:off x="1371600" y="1325880"/>
-            <a:ext cx="5486400" cy="320040"/>
+            <a:ext cx="5486400" cy="365760"/>
           </a:xfrm>
           <a:prstGeom prst="rect">
             <a:avLst/>
@@ -6471,14 +6471,14 @@
               <a:buNone/>
             </a:pPr>
             <a:r>
-              <a:rPr lang="en-US" sz="1300" b="1" dirty="0">
+              <a:rPr lang="en-US" sz="1500" b="1" dirty="0">
                 <a:solidFill>
                   <a:srgbClr val="1A1A2E"/>
                 </a:solidFill>
               </a:rPr>
               <a:t>Notify Outside Writer Mutex</a:t>
             </a:r>
-            <a:endParaRPr lang="en-US" sz="1300" dirty="0"/>
+            <a:endParaRPr lang="en-US" sz="1500" dirty="0"/>
           </a:p>
         </p:txBody>
       </p:sp>
@@ -6639,7 +6639,7 @@
               <a:buNone/>
             </a:pPr>
             <a:r>
-              <a:rPr lang="en-US" sz="2600" b="1" dirty="0">
+              <a:rPr lang="en-US" sz="3000" b="1" dirty="0">
                 <a:solidFill>
                   <a:srgbClr val="2563EB"/>
                 </a:solidFill>
@@ -6649,7 +6649,7 @@
               </a:rPr>
               <a:t>02</a:t>
             </a:r>
-            <a:endParaRPr lang="en-US" sz="2600" dirty="0"/>
+            <a:endParaRPr lang="en-US" sz="3000" dirty="0"/>
           </a:p>
         </p:txBody>
       </p:sp>
@@ -6662,7 +6662,7 @@
         <p:spPr>
           <a:xfrm>
             <a:off x="1371600" y="3108960"/>
-            <a:ext cx="5486400" cy="320040"/>
+            <a:ext cx="5486400" cy="365760"/>
           </a:xfrm>
           <a:prstGeom prst="rect">
             <a:avLst/>
@@ -6678,14 +6678,14 @@
               <a:buNone/>
             </a:pPr>
             <a:r>
-              <a:rPr lang="en-US" sz="1300" b="1" dirty="0">
+              <a:rPr lang="en-US" sz="1500" b="1" dirty="0">
                 <a:solidFill>
                   <a:srgbClr val="1A1A2E"/>
                 </a:solidFill>
               </a:rPr>
               <a:t>Record Fill Outside Writer Mutex</a:t>
             </a:r>
-            <a:endParaRPr lang="en-US" sz="1300" dirty="0"/>
+            <a:endParaRPr lang="en-US" sz="1500" dirty="0"/>
           </a:p>
         </p:txBody>
       </p:sp>
@@ -6846,7 +6846,7 @@
               <a:buNone/>
             </a:pPr>
             <a:r>
-              <a:rPr lang="en-US" sz="2600" b="1" dirty="0">
+              <a:rPr lang="en-US" sz="3000" b="1" dirty="0">
                 <a:solidFill>
                   <a:srgbClr val="EA580C"/>
                 </a:solidFill>
@@ -6856,7 +6856,7 @@
               </a:rPr>
               <a:t>★</a:t>
             </a:r>
-            <a:endParaRPr lang="en-US" sz="2600" dirty="0"/>
+            <a:endParaRPr lang="en-US" sz="3000" dirty="0"/>
           </a:p>
         </p:txBody>
       </p:sp>
@@ -6869,7 +6869,7 @@
         <p:spPr>
           <a:xfrm>
             <a:off x="1371600" y="4892040"/>
-            <a:ext cx="5486400" cy="320040"/>
+            <a:ext cx="5486400" cy="365760"/>
           </a:xfrm>
           <a:prstGeom prst="rect">
             <a:avLst/>
@@ -6885,14 +6885,14 @@
               <a:buNone/>
             </a:pPr>
             <a:r>
-              <a:rPr lang="en-US" sz="1300" b="1" dirty="0">
+              <a:rPr lang="en-US" sz="1500" b="1" dirty="0">
                 <a:solidFill>
                   <a:srgbClr val="1A1A2E"/>
                 </a:solidFill>
               </a:rPr>
               <a:t>Stage 6  Batch  Publish</a:t>
             </a:r>
-            <a:endParaRPr lang="en-US" sz="1300" dirty="0"/>
+            <a:endParaRPr lang="en-US" sz="1500" dirty="0"/>
           </a:p>
         </p:txBody>
       </p:sp>
@@ -7078,7 +7078,7 @@
               <a:buNone/>
             </a:pPr>
             <a:r>
-              <a:rPr lang="en-US" sz="2400" b="1" dirty="0">
+              <a:rPr lang="en-US" sz="2800" b="1" dirty="0">
                 <a:solidFill>
                   <a:srgbClr val="2563EB"/>
                 </a:solidFill>
@@ -7088,7 +7088,7 @@
               </a:rPr>
               <a:t>04</a:t>
             </a:r>
-            <a:endParaRPr lang="en-US" sz="2400" dirty="0"/>
+            <a:endParaRPr lang="en-US" sz="2800" dirty="0"/>
           </a:p>
         </p:txBody>
       </p:sp>
@@ -7101,7 +7101,7 @@
         <p:spPr>
           <a:xfrm>
             <a:off x="1280160" y="137160"/>
-            <a:ext cx="9144000" cy="411480"/>
+            <a:ext cx="9144000" cy="502920"/>
           </a:xfrm>
           <a:prstGeom prst="rect">
             <a:avLst/>
@@ -7117,14 +7117,14 @@
               <a:buNone/>
             </a:pPr>
             <a:r>
-              <a:rPr lang="en-US" sz="2000" b="1" dirty="0">
+              <a:rPr lang="en-US" sz="2400" b="1" dirty="0">
                 <a:solidFill>
                   <a:srgbClr val="1A1A2E"/>
                 </a:solidFill>
               </a:rPr>
               <a:t>Batch Publish — Pink 验证数据</a:t>
             </a:r>
-            <a:endParaRPr lang="en-US" sz="2000" dirty="0"/>
+            <a:endParaRPr lang="en-US" sz="2400" dirty="0"/>
           </a:p>
         </p:txBody>
       </p:sp>
@@ -7136,8 +7136,8 @@
         </p:nvSpPr>
         <p:spPr>
           <a:xfrm>
-            <a:off x="1280160" y="530352"/>
-            <a:ext cx="9144000" cy="228600"/>
+            <a:off x="1280160" y="566928"/>
+            <a:ext cx="9144000" cy="274320"/>
           </a:xfrm>
           <a:prstGeom prst="rect">
             <a:avLst/>
@@ -7153,14 +7153,14 @@
               <a:buNone/>
             </a:pPr>
             <a:r>
-              <a:rPr lang="en-US" sz="1000" dirty="0">
+              <a:rPr lang="en-US" sz="1200" dirty="0">
                 <a:solidFill>
                   <a:srgbClr val="8888A8"/>
                 </a:solidFill>
               </a:rPr>
               <a:t>100万次固定负载  ·  Stage 6 full notify</a:t>
             </a:r>
-            <a:endParaRPr lang="en-US" sz="1000" dirty="0"/>
+            <a:endParaRPr lang="en-US" sz="1200" dirty="0"/>
           </a:p>
         </p:txBody>
       </p:sp>
@@ -7173,7 +7173,7 @@
         <p:spPr>
           <a:xfrm>
             <a:off x="274320" y="1234440"/>
-            <a:ext cx="2286000" cy="731520"/>
+            <a:ext cx="2286000" cy="822960"/>
           </a:xfrm>
           <a:prstGeom prst="rect">
             <a:avLst/>
@@ -7189,7 +7189,7 @@
               <a:buNone/>
             </a:pPr>
             <a:r>
-              <a:rPr lang="en-US" sz="4000" b="1" dirty="0">
+              <a:rPr lang="en-US" sz="4600" b="1" dirty="0">
                 <a:solidFill>
                   <a:srgbClr val="2563EB"/>
                 </a:solidFill>
@@ -7199,7 +7199,7 @@
               </a:rPr>
               <a:t>21.2%</a:t>
             </a:r>
-            <a:endParaRPr lang="en-US" sz="4000" dirty="0"/>
+            <a:endParaRPr lang="en-US" sz="4600" dirty="0"/>
           </a:p>
         </p:txBody>
       </p:sp>
@@ -7211,7 +7211,7 @@
         </p:nvSpPr>
         <p:spPr>
           <a:xfrm>
-            <a:off x="274320" y="1920240"/>
+            <a:off x="274320" y="2011680"/>
             <a:ext cx="2286000" cy="274320"/>
           </a:xfrm>
           <a:prstGeom prst="rect">
@@ -7228,14 +7228,14 @@
               <a:buNone/>
             </a:pPr>
             <a:r>
-              <a:rPr lang="en-US" sz="900" dirty="0">
+              <a:rPr lang="en-US" sz="1100" dirty="0">
                 <a:solidFill>
                   <a:srgbClr val="8888A8"/>
                 </a:solidFill>
               </a:rPr>
               <a:t>1 Thread</a:t>
             </a:r>
-            <a:endParaRPr lang="en-US" sz="900" dirty="0"/>
+            <a:endParaRPr lang="en-US" sz="1100" dirty="0"/>
           </a:p>
         </p:txBody>
       </p:sp>
@@ -7248,7 +7248,7 @@
         <p:spPr>
           <a:xfrm>
             <a:off x="3200400" y="1234440"/>
-            <a:ext cx="2286000" cy="731520"/>
+            <a:ext cx="2286000" cy="822960"/>
           </a:xfrm>
           <a:prstGeom prst="rect">
             <a:avLst/>
@@ -7264,7 +7264,7 @@
               <a:buNone/>
             </a:pPr>
             <a:r>
-              <a:rPr lang="en-US" sz="4000" b="1" dirty="0">
+              <a:rPr lang="en-US" sz="4600" b="1" dirty="0">
                 <a:solidFill>
                   <a:srgbClr val="2563EB"/>
                 </a:solidFill>
@@ -7274,7 +7274,7 @@
               </a:rPr>
               <a:t>68.4%</a:t>
             </a:r>
-            <a:endParaRPr lang="en-US" sz="4000" dirty="0"/>
+            <a:endParaRPr lang="en-US" sz="4600" dirty="0"/>
           </a:p>
         </p:txBody>
       </p:sp>
@@ -7286,7 +7286,7 @@
         </p:nvSpPr>
         <p:spPr>
           <a:xfrm>
-            <a:off x="3200400" y="1920240"/>
+            <a:off x="3200400" y="2011680"/>
             <a:ext cx="2286000" cy="274320"/>
           </a:xfrm>
           <a:prstGeom prst="rect">
@@ -7303,14 +7303,14 @@
               <a:buNone/>
             </a:pPr>
             <a:r>
-              <a:rPr lang="en-US" sz="900" dirty="0">
+              <a:rPr lang="en-US" sz="1100" dirty="0">
                 <a:solidFill>
                   <a:srgbClr val="8888A8"/>
                 </a:solidFill>
               </a:rPr>
               <a:t>4 Threads</a:t>
             </a:r>
-            <a:endParaRPr lang="en-US" sz="900" dirty="0"/>
+            <a:endParaRPr lang="en-US" sz="1100" dirty="0"/>
           </a:p>
         </p:txBody>
       </p:sp>
@@ -7323,7 +7323,7 @@
         <p:spPr>
           <a:xfrm>
             <a:off x="6126480" y="1234440"/>
-            <a:ext cx="2286000" cy="731520"/>
+            <a:ext cx="2286000" cy="822960"/>
           </a:xfrm>
           <a:prstGeom prst="rect">
             <a:avLst/>
@@ -7339,7 +7339,7 @@
               <a:buNone/>
             </a:pPr>
             <a:r>
-              <a:rPr lang="en-US" sz="4000" b="1" dirty="0">
+              <a:rPr lang="en-US" sz="4600" b="1" dirty="0">
                 <a:solidFill>
                   <a:srgbClr val="2563EB"/>
                 </a:solidFill>
@@ -7349,7 +7349,7 @@
               </a:rPr>
               <a:t>59.1%</a:t>
             </a:r>
-            <a:endParaRPr lang="en-US" sz="4000" dirty="0"/>
+            <a:endParaRPr lang="en-US" sz="4600" dirty="0"/>
           </a:p>
         </p:txBody>
       </p:sp>
@@ -7361,7 +7361,7 @@
         </p:nvSpPr>
         <p:spPr>
           <a:xfrm>
-            <a:off x="6126480" y="1920240"/>
+            <a:off x="6126480" y="2011680"/>
             <a:ext cx="2286000" cy="274320"/>
           </a:xfrm>
           <a:prstGeom prst="rect">
@@ -7378,14 +7378,14 @@
               <a:buNone/>
             </a:pPr>
             <a:r>
-              <a:rPr lang="en-US" sz="900" dirty="0">
+              <a:rPr lang="en-US" sz="1100" dirty="0">
                 <a:solidFill>
                   <a:srgbClr val="8888A8"/>
                 </a:solidFill>
               </a:rPr>
               <a:t>8 Threads</a:t>
             </a:r>
-            <a:endParaRPr lang="en-US" sz="900" dirty="0"/>
+            <a:endParaRPr lang="en-US" sz="1100" dirty="0"/>
           </a:p>
         </p:txBody>
       </p:sp>
@@ -7398,7 +7398,7 @@
         <p:spPr>
           <a:xfrm>
             <a:off x="9052560" y="1234440"/>
-            <a:ext cx="2286000" cy="731520"/>
+            <a:ext cx="2286000" cy="822960"/>
           </a:xfrm>
           <a:prstGeom prst="rect">
             <a:avLst/>
@@ -7414,7 +7414,7 @@
               <a:buNone/>
             </a:pPr>
             <a:r>
-              <a:rPr lang="en-US" sz="4000" b="1" dirty="0">
+              <a:rPr lang="en-US" sz="4600" b="1" dirty="0">
                 <a:solidFill>
                   <a:srgbClr val="2563EB"/>
                 </a:solidFill>
@@ -7424,7 +7424,7 @@
               </a:rPr>
               <a:t>60.7%</a:t>
             </a:r>
-            <a:endParaRPr lang="en-US" sz="4000" dirty="0"/>
+            <a:endParaRPr lang="en-US" sz="4600" dirty="0"/>
           </a:p>
         </p:txBody>
       </p:sp>
@@ -7436,7 +7436,7 @@
         </p:nvSpPr>
         <p:spPr>
           <a:xfrm>
-            <a:off x="9052560" y="1920240"/>
+            <a:off x="9052560" y="2011680"/>
             <a:ext cx="2286000" cy="274320"/>
           </a:xfrm>
           <a:prstGeom prst="rect">
@@ -7453,14 +7453,14 @@
               <a:buNone/>
             </a:pPr>
             <a:r>
-              <a:rPr lang="en-US" sz="900" dirty="0">
+              <a:rPr lang="en-US" sz="1100" dirty="0">
                 <a:solidFill>
                   <a:srgbClr val="8888A8"/>
                 </a:solidFill>
               </a:rPr>
               <a:t>16 Threads</a:t>
             </a:r>
-            <a:endParaRPr lang="en-US" sz="900" dirty="0"/>
+            <a:endParaRPr lang="en-US" sz="1100" dirty="0"/>
           </a:p>
         </p:txBody>
       </p:sp>
@@ -7492,7 +7492,7 @@
                 <a:gridCol w="2880360"/>
                 <a:gridCol w="2880360"/>
               </a:tblGrid>
-              <a:tr h="329184">
+              <a:tr h="384048">
                 <a:tc>
                   <a:txBody>
                     <a:bodyPr/>
@@ -7502,14 +7502,14 @@
                         <a:buNone/>
                       </a:pPr>
                       <a:r>
-                        <a:rPr lang="en-US" sz="1000" b="1" dirty="0">
+                        <a:rPr lang="en-US" sz="1200" b="1" dirty="0">
                           <a:solidFill>
                             <a:srgbClr val="2563EB"/>
                           </a:solidFill>
                         </a:rPr>
                         <a:t>Threads</a:t>
                       </a:r>
-                      <a:endParaRPr lang="en-US" sz="1000" dirty="0"/>
+                      <a:endParaRPr lang="en-US" sz="1200" dirty="0"/>
                     </a:p>
                   </a:txBody>
                   <a:tcPr marL="76200" marR="76200" marT="25400" marB="25400">
@@ -7563,14 +7563,14 @@
                         <a:buNone/>
                       </a:pPr>
                       <a:r>
-                        <a:rPr lang="en-US" sz="1000" b="1" dirty="0">
+                        <a:rPr lang="en-US" sz="1200" b="1" dirty="0">
                           <a:solidFill>
                             <a:srgbClr val="2563EB"/>
                           </a:solidFill>
                         </a:rPr>
                         <a:t>No Batch</a:t>
                       </a:r>
-                      <a:endParaRPr lang="en-US" sz="1000" dirty="0"/>
+                      <a:endParaRPr lang="en-US" sz="1200" dirty="0"/>
                     </a:p>
                   </a:txBody>
                   <a:tcPr marL="76200" marR="76200" marT="25400" marB="25400">
@@ -7624,14 +7624,14 @@
                         <a:buNone/>
                       </a:pPr>
                       <a:r>
-                        <a:rPr lang="en-US" sz="1000" b="1" dirty="0">
+                        <a:rPr lang="en-US" sz="1200" b="1" dirty="0">
                           <a:solidFill>
                             <a:srgbClr val="2563EB"/>
                           </a:solidFill>
                         </a:rPr>
                         <a:t>Batch = 64</a:t>
                       </a:r>
-                      <a:endParaRPr lang="en-US" sz="1000" dirty="0"/>
+                      <a:endParaRPr lang="en-US" sz="1200" dirty="0"/>
                     </a:p>
                   </a:txBody>
                   <a:tcPr marL="76200" marR="76200" marT="25400" marB="25400">
@@ -7685,14 +7685,14 @@
                         <a:buNone/>
                       </a:pPr>
                       <a:r>
-                        <a:rPr lang="en-US" sz="1000" b="1" dirty="0">
+                        <a:rPr lang="en-US" sz="1200" b="1" dirty="0">
                           <a:solidFill>
                             <a:srgbClr val="2563EB"/>
                           </a:solidFill>
                         </a:rPr>
                         <a:t>提升</a:t>
                       </a:r>
-                      <a:endParaRPr lang="en-US" sz="1000" dirty="0"/>
+                      <a:endParaRPr lang="en-US" sz="1200" dirty="0"/>
                     </a:p>
                   </a:txBody>
                   <a:tcPr marL="76200" marR="76200" marT="25400" marB="25400">
@@ -7738,7 +7738,7 @@
                   </a:tcPr>
                 </a:tc>
               </a:tr>
-              <a:tr h="329184">
+              <a:tr h="384048">
                 <a:tc>
                   <a:txBody>
                     <a:bodyPr/>
@@ -7748,14 +7748,14 @@
                         <a:buNone/>
                       </a:pPr>
                       <a:r>
-                        <a:rPr lang="en-US" sz="1000" dirty="0">
+                        <a:rPr lang="en-US" sz="1200" dirty="0">
                           <a:solidFill>
                             <a:srgbClr val="4A4A6A"/>
                           </a:solidFill>
                         </a:rPr>
                         <a:t>1</a:t>
                       </a:r>
-                      <a:endParaRPr lang="en-US" sz="1000" dirty="0"/>
+                      <a:endParaRPr lang="en-US" sz="1200" dirty="0"/>
                     </a:p>
                   </a:txBody>
                   <a:tcPr marL="76200" marR="76200" marT="25400" marB="25400">
@@ -7809,14 +7809,14 @@
                         <a:buNone/>
                       </a:pPr>
                       <a:r>
-                        <a:rPr lang="en-US" sz="1000" dirty="0">
+                        <a:rPr lang="en-US" sz="1200" dirty="0">
                           <a:solidFill>
                             <a:srgbClr val="4A4A6A"/>
                           </a:solidFill>
                         </a:rPr>
                         <a:t>1.545s</a:t>
                       </a:r>
-                      <a:endParaRPr lang="en-US" sz="1000" dirty="0"/>
+                      <a:endParaRPr lang="en-US" sz="1200" dirty="0"/>
                     </a:p>
                   </a:txBody>
                   <a:tcPr marL="76200" marR="76200" marT="25400" marB="25400">
@@ -7870,14 +7870,14 @@
                         <a:buNone/>
                       </a:pPr>
                       <a:r>
-                        <a:rPr lang="en-US" sz="1000" dirty="0">
+                        <a:rPr lang="en-US" sz="1200" dirty="0">
                           <a:solidFill>
                             <a:srgbClr val="4A4A6A"/>
                           </a:solidFill>
                         </a:rPr>
                         <a:t>1.217s</a:t>
                       </a:r>
-                      <a:endParaRPr lang="en-US" sz="1000" dirty="0"/>
+                      <a:endParaRPr lang="en-US" sz="1200" dirty="0"/>
                     </a:p>
                   </a:txBody>
                   <a:tcPr marL="76200" marR="76200" marT="25400" marB="25400">
@@ -7931,14 +7931,14 @@
                         <a:buNone/>
                       </a:pPr>
                       <a:r>
-                        <a:rPr lang="en-US" sz="1000" dirty="0">
+                        <a:rPr lang="en-US" sz="1200" dirty="0">
                           <a:solidFill>
                             <a:srgbClr val="059669"/>
                           </a:solidFill>
                         </a:rPr>
                         <a:t>↓ 21.2%</a:t>
                       </a:r>
-                      <a:endParaRPr lang="en-US" sz="1000" dirty="0"/>
+                      <a:endParaRPr lang="en-US" sz="1200" dirty="0"/>
                     </a:p>
                   </a:txBody>
                   <a:tcPr marL="76200" marR="76200" marT="25400" marB="25400">
@@ -7984,7 +7984,7 @@
                   </a:tcPr>
                 </a:tc>
               </a:tr>
-              <a:tr h="329184">
+              <a:tr h="384048">
                 <a:tc>
                   <a:txBody>
                     <a:bodyPr/>
@@ -7994,14 +7994,14 @@
                         <a:buNone/>
                       </a:pPr>
                       <a:r>
-                        <a:rPr lang="en-US" sz="1000" dirty="0">
+                        <a:rPr lang="en-US" sz="1200" dirty="0">
                           <a:solidFill>
                             <a:srgbClr val="4A4A6A"/>
                           </a:solidFill>
                         </a:rPr>
                         <a:t>4</a:t>
                       </a:r>
-                      <a:endParaRPr lang="en-US" sz="1000" dirty="0"/>
+                      <a:endParaRPr lang="en-US" sz="1200" dirty="0"/>
                     </a:p>
                   </a:txBody>
                   <a:tcPr marL="76200" marR="76200" marT="25400" marB="25400">
@@ -8055,14 +8055,14 @@
                         <a:buNone/>
                       </a:pPr>
                       <a:r>
-                        <a:rPr lang="en-US" sz="1000" dirty="0">
+                        <a:rPr lang="en-US" sz="1200" dirty="0">
                           <a:solidFill>
                             <a:srgbClr val="4A4A6A"/>
                           </a:solidFill>
                         </a:rPr>
                         <a:t>2.718s</a:t>
                       </a:r>
-                      <a:endParaRPr lang="en-US" sz="1000" dirty="0"/>
+                      <a:endParaRPr lang="en-US" sz="1200" dirty="0"/>
                     </a:p>
                   </a:txBody>
                   <a:tcPr marL="76200" marR="76200" marT="25400" marB="25400">
@@ -8116,14 +8116,14 @@
                         <a:buNone/>
                       </a:pPr>
                       <a:r>
-                        <a:rPr lang="en-US" sz="1000" dirty="0">
+                        <a:rPr lang="en-US" sz="1200" dirty="0">
                           <a:solidFill>
                             <a:srgbClr val="4A4A6A"/>
                           </a:solidFill>
                         </a:rPr>
                         <a:t>0.859s</a:t>
                       </a:r>
-                      <a:endParaRPr lang="en-US" sz="1000" dirty="0"/>
+                      <a:endParaRPr lang="en-US" sz="1200" dirty="0"/>
                     </a:p>
                   </a:txBody>
                   <a:tcPr marL="76200" marR="76200" marT="25400" marB="25400">
@@ -8177,14 +8177,14 @@
                         <a:buNone/>
                       </a:pPr>
                       <a:r>
-                        <a:rPr lang="en-US" sz="1000" dirty="0">
+                        <a:rPr lang="en-US" sz="1200" dirty="0">
                           <a:solidFill>
                             <a:srgbClr val="059669"/>
                           </a:solidFill>
                         </a:rPr>
                         <a:t>↓ 68.4%</a:t>
                       </a:r>
-                      <a:endParaRPr lang="en-US" sz="1000" dirty="0"/>
+                      <a:endParaRPr lang="en-US" sz="1200" dirty="0"/>
                     </a:p>
                   </a:txBody>
                   <a:tcPr marL="76200" marR="76200" marT="25400" marB="25400">
@@ -8230,7 +8230,7 @@
                   </a:tcPr>
                 </a:tc>
               </a:tr>
-              <a:tr h="329184">
+              <a:tr h="384048">
                 <a:tc>
                   <a:txBody>
                     <a:bodyPr/>
@@ -8240,14 +8240,14 @@
                         <a:buNone/>
                       </a:pPr>
                       <a:r>
-                        <a:rPr lang="en-US" sz="1000" dirty="0">
+                        <a:rPr lang="en-US" sz="1200" dirty="0">
                           <a:solidFill>
                             <a:srgbClr val="4A4A6A"/>
                           </a:solidFill>
                         </a:rPr>
                         <a:t>8</a:t>
                       </a:r>
-                      <a:endParaRPr lang="en-US" sz="1000" dirty="0"/>
+                      <a:endParaRPr lang="en-US" sz="1200" dirty="0"/>
                     </a:p>
                   </a:txBody>
                   <a:tcPr marL="76200" marR="76200" marT="25400" marB="25400">
@@ -8301,14 +8301,14 @@
                         <a:buNone/>
                       </a:pPr>
                       <a:r>
-                        <a:rPr lang="en-US" sz="1000" dirty="0">
+                        <a:rPr lang="en-US" sz="1200" dirty="0">
                           <a:solidFill>
                             <a:srgbClr val="4A4A6A"/>
                           </a:solidFill>
                         </a:rPr>
                         <a:t>3.121s</a:t>
                       </a:r>
-                      <a:endParaRPr lang="en-US" sz="1000" dirty="0"/>
+                      <a:endParaRPr lang="en-US" sz="1200" dirty="0"/>
                     </a:p>
                   </a:txBody>
                   <a:tcPr marL="76200" marR="76200" marT="25400" marB="25400">
@@ -8362,14 +8362,14 @@
                         <a:buNone/>
                       </a:pPr>
                       <a:r>
-                        <a:rPr lang="en-US" sz="1000" dirty="0">
+                        <a:rPr lang="en-US" sz="1200" dirty="0">
                           <a:solidFill>
                             <a:srgbClr val="4A4A6A"/>
                           </a:solidFill>
                         </a:rPr>
                         <a:t>1.278s</a:t>
                       </a:r>
-                      <a:endParaRPr lang="en-US" sz="1000" dirty="0"/>
+                      <a:endParaRPr lang="en-US" sz="1200" dirty="0"/>
                     </a:p>
                   </a:txBody>
                   <a:tcPr marL="76200" marR="76200" marT="25400" marB="25400">
@@ -8423,14 +8423,14 @@
                         <a:buNone/>
                       </a:pPr>
                       <a:r>
-                        <a:rPr lang="en-US" sz="1000" dirty="0">
+                        <a:rPr lang="en-US" sz="1200" dirty="0">
                           <a:solidFill>
                             <a:srgbClr val="059669"/>
                           </a:solidFill>
                         </a:rPr>
                         <a:t>↓ 59.1%</a:t>
                       </a:r>
-                      <a:endParaRPr lang="en-US" sz="1000" dirty="0"/>
+                      <a:endParaRPr lang="en-US" sz="1200" dirty="0"/>
                     </a:p>
                   </a:txBody>
                   <a:tcPr marL="76200" marR="76200" marT="25400" marB="25400">
@@ -8476,7 +8476,7 @@
                   </a:tcPr>
                 </a:tc>
               </a:tr>
-              <a:tr h="329184">
+              <a:tr h="384048">
                 <a:tc>
                   <a:txBody>
                     <a:bodyPr/>
@@ -8486,14 +8486,14 @@
                         <a:buNone/>
                       </a:pPr>
                       <a:r>
-                        <a:rPr lang="en-US" sz="1000" dirty="0">
+                        <a:rPr lang="en-US" sz="1200" dirty="0">
                           <a:solidFill>
                             <a:srgbClr val="4A4A6A"/>
                           </a:solidFill>
                         </a:rPr>
                         <a:t>16</a:t>
                       </a:r>
-                      <a:endParaRPr lang="en-US" sz="1000" dirty="0"/>
+                      <a:endParaRPr lang="en-US" sz="1200" dirty="0"/>
                     </a:p>
                   </a:txBody>
                   <a:tcPr marL="76200" marR="76200" marT="25400" marB="25400">
@@ -8547,14 +8547,14 @@
                         <a:buNone/>
                       </a:pPr>
                       <a:r>
-                        <a:rPr lang="en-US" sz="1000" dirty="0">
+                        <a:rPr lang="en-US" sz="1200" dirty="0">
                           <a:solidFill>
                             <a:srgbClr val="4A4A6A"/>
                           </a:solidFill>
                         </a:rPr>
                         <a:t>3.408s</a:t>
                       </a:r>
-                      <a:endParaRPr lang="en-US" sz="1000" dirty="0"/>
+                      <a:endParaRPr lang="en-US" sz="1200" dirty="0"/>
                     </a:p>
                   </a:txBody>
                   <a:tcPr marL="76200" marR="76200" marT="25400" marB="25400">
@@ -8608,14 +8608,14 @@
                         <a:buNone/>
                       </a:pPr>
                       <a:r>
-                        <a:rPr lang="en-US" sz="1000" dirty="0">
+                        <a:rPr lang="en-US" sz="1200" dirty="0">
                           <a:solidFill>
                             <a:srgbClr val="4A4A6A"/>
                           </a:solidFill>
                         </a:rPr>
                         <a:t>1.340s</a:t>
                       </a:r>
-                      <a:endParaRPr lang="en-US" sz="1000" dirty="0"/>
+                      <a:endParaRPr lang="en-US" sz="1200" dirty="0"/>
                     </a:p>
                   </a:txBody>
                   <a:tcPr marL="76200" marR="76200" marT="25400" marB="25400">
@@ -8669,14 +8669,14 @@
                         <a:buNone/>
                       </a:pPr>
                       <a:r>
-                        <a:rPr lang="en-US" sz="1000" dirty="0">
+                        <a:rPr lang="en-US" sz="1200" dirty="0">
                           <a:solidFill>
                             <a:srgbClr val="059669"/>
                           </a:solidFill>
                         </a:rPr>
                         <a:t>↓ 60.7%</a:t>
                       </a:r>
-                      <a:endParaRPr lang="en-US" sz="1000" dirty="0"/>
+                      <a:endParaRPr lang="en-US" sz="1200" dirty="0"/>
                     </a:p>
                   </a:txBody>
                   <a:tcPr marL="76200" marR="76200" marT="25400" marB="25400">
@@ -8887,7 +8887,7 @@
               <a:buNone/>
             </a:pPr>
             <a:r>
-              <a:rPr lang="en-US" sz="2400" b="1" dirty="0">
+              <a:rPr lang="en-US" sz="2800" b="1" dirty="0">
                 <a:solidFill>
                   <a:srgbClr val="2563EB"/>
                 </a:solidFill>
@@ -8897,7 +8897,7 @@
               </a:rPr>
               <a:t>05</a:t>
             </a:r>
-            <a:endParaRPr lang="en-US" sz="2400" dirty="0"/>
+            <a:endParaRPr lang="en-US" sz="2800" dirty="0"/>
           </a:p>
         </p:txBody>
       </p:sp>
@@ -8910,7 +8910,7 @@
         <p:spPr>
           <a:xfrm>
             <a:off x="1280160" y="137160"/>
-            <a:ext cx="9144000" cy="411480"/>
+            <a:ext cx="9144000" cy="502920"/>
           </a:xfrm>
           <a:prstGeom prst="rect">
             <a:avLst/>
@@ -8926,14 +8926,14 @@
               <a:buNone/>
             </a:pPr>
             <a:r>
-              <a:rPr lang="en-US" sz="2000" b="1" dirty="0">
+              <a:rPr lang="en-US" sz="2400" b="1" dirty="0">
                 <a:solidFill>
                   <a:srgbClr val="1A1A2E"/>
                 </a:solidFill>
               </a:rPr>
               <a:t>StackWriter 模块级瓶颈定位</a:t>
             </a:r>
-            <a:endParaRPr lang="en-US" sz="2000" dirty="0"/>
+            <a:endParaRPr lang="en-US" sz="2400" dirty="0"/>
           </a:p>
         </p:txBody>
       </p:sp>
@@ -8945,8 +8945,8 @@
         </p:nvSpPr>
         <p:spPr>
           <a:xfrm>
-            <a:off x="1280160" y="530352"/>
-            <a:ext cx="9144000" cy="228600"/>
+            <a:off x="1280160" y="566928"/>
+            <a:ext cx="9144000" cy="274320"/>
           </a:xfrm>
           <a:prstGeom prst="rect">
             <a:avLst/>
@@ -8962,14 +8962,14 @@
               <a:buNone/>
             </a:pPr>
             <a:r>
-              <a:rPr lang="en-US" sz="1000" dirty="0">
+              <a:rPr lang="en-US" sz="1200" dirty="0">
                 <a:solidFill>
                   <a:srgbClr val="8888A8"/>
                 </a:solidFill>
               </a:rPr>
               <a:t>sub-stage 34/35  ·  ring write 内锁 vs eventfd 开销分离</a:t>
             </a:r>
-            <a:endParaRPr lang="en-US" sz="1000" dirty="0"/>
+            <a:endParaRPr lang="en-US" sz="1200" dirty="0"/>
           </a:p>
         </p:txBody>
       </p:sp>
@@ -9003,7 +9003,7 @@
                 <a:gridCol w="1920240"/>
                 <a:gridCol w="1920240"/>
               </a:tblGrid>
-              <a:tr h="329184">
+              <a:tr h="384048">
                 <a:tc>
                   <a:txBody>
                     <a:bodyPr/>
@@ -9013,14 +9013,14 @@
                         <a:buNone/>
                       </a:pPr>
                       <a:r>
-                        <a:rPr lang="en-US" sz="1000" b="1" dirty="0">
+                        <a:rPr lang="en-US" sz="1200" b="1" dirty="0">
                           <a:solidFill>
                             <a:srgbClr val="2563EB"/>
                           </a:solidFill>
                         </a:rPr>
                         <a:t>Sub-stage</a:t>
                       </a:r>
-                      <a:endParaRPr lang="en-US" sz="1000" dirty="0"/>
+                      <a:endParaRPr lang="en-US" sz="1200" dirty="0"/>
                     </a:p>
                   </a:txBody>
                   <a:tcPr marL="76200" marR="76200" marT="25400" marB="25400">
@@ -9074,14 +9074,14 @@
                         <a:buNone/>
                       </a:pPr>
                       <a:r>
-                        <a:rPr lang="en-US" sz="1000" b="1" dirty="0">
+                        <a:rPr lang="en-US" sz="1200" b="1" dirty="0">
                           <a:solidFill>
                             <a:srgbClr val="2563EB"/>
                           </a:solidFill>
                         </a:rPr>
                         <a:t>测量内容</a:t>
                       </a:r>
-                      <a:endParaRPr lang="en-US" sz="1000" dirty="0"/>
+                      <a:endParaRPr lang="en-US" sz="1200" dirty="0"/>
                     </a:p>
                   </a:txBody>
                   <a:tcPr marL="76200" marR="76200" marT="25400" marB="25400">
@@ -9135,14 +9135,14 @@
                         <a:buNone/>
                       </a:pPr>
                       <a:r>
-                        <a:rPr lang="en-US" sz="1000" b="1" dirty="0">
+                        <a:rPr lang="en-US" sz="1200" b="1" dirty="0">
                           <a:solidFill>
                             <a:srgbClr val="2563EB"/>
                           </a:solidFill>
                         </a:rPr>
                         <a:t>1T</a:t>
                       </a:r>
-                      <a:endParaRPr lang="en-US" sz="1000" dirty="0"/>
+                      <a:endParaRPr lang="en-US" sz="1200" dirty="0"/>
                     </a:p>
                   </a:txBody>
                   <a:tcPr marL="76200" marR="76200" marT="25400" marB="25400">
@@ -9196,14 +9196,14 @@
                         <a:buNone/>
                       </a:pPr>
                       <a:r>
-                        <a:rPr lang="en-US" sz="1000" b="1" dirty="0">
+                        <a:rPr lang="en-US" sz="1200" b="1" dirty="0">
                           <a:solidFill>
                             <a:srgbClr val="2563EB"/>
                           </a:solidFill>
                         </a:rPr>
                         <a:t>4T</a:t>
                       </a:r>
-                      <a:endParaRPr lang="en-US" sz="1000" dirty="0"/>
+                      <a:endParaRPr lang="en-US" sz="1200" dirty="0"/>
                     </a:p>
                   </a:txBody>
                   <a:tcPr marL="76200" marR="76200" marT="25400" marB="25400">
@@ -9257,14 +9257,14 @@
                         <a:buNone/>
                       </a:pPr>
                       <a:r>
-                        <a:rPr lang="en-US" sz="1000" b="1" dirty="0">
+                        <a:rPr lang="en-US" sz="1200" b="1" dirty="0">
                           <a:solidFill>
                             <a:srgbClr val="2563EB"/>
                           </a:solidFill>
                         </a:rPr>
                         <a:t>8T</a:t>
                       </a:r>
-                      <a:endParaRPr lang="en-US" sz="1000" dirty="0"/>
+                      <a:endParaRPr lang="en-US" sz="1200" dirty="0"/>
                     </a:p>
                   </a:txBody>
                   <a:tcPr marL="76200" marR="76200" marT="25400" marB="25400">
@@ -9318,14 +9318,14 @@
                         <a:buNone/>
                       </a:pPr>
                       <a:r>
-                        <a:rPr lang="en-US" sz="1000" b="1" dirty="0">
+                        <a:rPr lang="en-US" sz="1200" b="1" dirty="0">
                           <a:solidFill>
                             <a:srgbClr val="2563EB"/>
                           </a:solidFill>
                         </a:rPr>
                         <a:t>16T</a:t>
                       </a:r>
-                      <a:endParaRPr lang="en-US" sz="1000" dirty="0"/>
+                      <a:endParaRPr lang="en-US" sz="1200" dirty="0"/>
                     </a:p>
                   </a:txBody>
                   <a:tcPr marL="76200" marR="76200" marT="25400" marB="25400">
@@ -9371,7 +9371,7 @@
                   </a:tcPr>
                 </a:tc>
               </a:tr>
-              <a:tr h="329184">
+              <a:tr h="384048">
                 <a:tc>
                   <a:txBody>
                     <a:bodyPr/>
@@ -9381,14 +9381,14 @@
                         <a:buNone/>
                       </a:pPr>
                       <a:r>
-                        <a:rPr lang="en-US" sz="1000" dirty="0">
+                        <a:rPr lang="en-US" sz="1200" dirty="0">
                           <a:solidFill>
                             <a:srgbClr val="4A4A6A"/>
                           </a:solidFill>
                         </a:rPr>
                         <a:t>34 write_only</a:t>
                       </a:r>
-                      <a:endParaRPr lang="en-US" sz="1000" dirty="0"/>
+                      <a:endParaRPr lang="en-US" sz="1200" dirty="0"/>
                     </a:p>
                   </a:txBody>
                   <a:tcPr marL="76200" marR="76200" marT="25400" marB="25400">
@@ -9442,14 +9442,14 @@
                         <a:buNone/>
                       </a:pPr>
                       <a:r>
-                        <a:rPr lang="en-US" sz="1000" dirty="0">
+                        <a:rPr lang="en-US" sz="1200" dirty="0">
                           <a:solidFill>
                             <a:srgbClr val="4A4A6A"/>
                           </a:solidFill>
                         </a:rPr>
                         <a:t>ring write + inner mutex</a:t>
                       </a:r>
-                      <a:endParaRPr lang="en-US" sz="1000" dirty="0"/>
+                      <a:endParaRPr lang="en-US" sz="1200" dirty="0"/>
                     </a:p>
                   </a:txBody>
                   <a:tcPr marL="76200" marR="76200" marT="25400" marB="25400">
@@ -9503,14 +9503,14 @@
                         <a:buNone/>
                       </a:pPr>
                       <a:r>
-                        <a:rPr lang="en-US" sz="1000" dirty="0">
+                        <a:rPr lang="en-US" sz="1200" dirty="0">
                           <a:solidFill>
                             <a:srgbClr val="4A4A6A"/>
                           </a:solidFill>
                         </a:rPr>
                         <a:t>8.60s</a:t>
                       </a:r>
-                      <a:endParaRPr lang="en-US" sz="1000" dirty="0"/>
+                      <a:endParaRPr lang="en-US" sz="1200" dirty="0"/>
                     </a:p>
                   </a:txBody>
                   <a:tcPr marL="76200" marR="76200" marT="25400" marB="25400">
@@ -9564,14 +9564,14 @@
                         <a:buNone/>
                       </a:pPr>
                       <a:r>
-                        <a:rPr lang="en-US" sz="1000" dirty="0">
+                        <a:rPr lang="en-US" sz="1200" dirty="0">
                           <a:solidFill>
                             <a:srgbClr val="4A4A6A"/>
                           </a:solidFill>
                         </a:rPr>
                         <a:t>20.94s</a:t>
                       </a:r>
-                      <a:endParaRPr lang="en-US" sz="1000" dirty="0"/>
+                      <a:endParaRPr lang="en-US" sz="1200" dirty="0"/>
                     </a:p>
                   </a:txBody>
                   <a:tcPr marL="76200" marR="76200" marT="25400" marB="25400">
@@ -9625,14 +9625,14 @@
                         <a:buNone/>
                       </a:pPr>
                       <a:r>
-                        <a:rPr lang="en-US" sz="1000" dirty="0">
+                        <a:rPr lang="en-US" sz="1200" dirty="0">
                           <a:solidFill>
                             <a:srgbClr val="4A4A6A"/>
                           </a:solidFill>
                         </a:rPr>
                         <a:t>27.40s</a:t>
                       </a:r>
-                      <a:endParaRPr lang="en-US" sz="1000" dirty="0"/>
+                      <a:endParaRPr lang="en-US" sz="1200" dirty="0"/>
                     </a:p>
                   </a:txBody>
                   <a:tcPr marL="76200" marR="76200" marT="25400" marB="25400">
@@ -9686,14 +9686,14 @@
                         <a:buNone/>
                       </a:pPr>
                       <a:r>
-                        <a:rPr lang="en-US" sz="1000" dirty="0">
+                        <a:rPr lang="en-US" sz="1200" dirty="0">
                           <a:solidFill>
                             <a:srgbClr val="059669"/>
                           </a:solidFill>
                         </a:rPr>
                         <a:t>32.25s</a:t>
                       </a:r>
-                      <a:endParaRPr lang="en-US" sz="1000" dirty="0"/>
+                      <a:endParaRPr lang="en-US" sz="1200" dirty="0"/>
                     </a:p>
                   </a:txBody>
                   <a:tcPr marL="76200" marR="76200" marT="25400" marB="25400">
@@ -9739,7 +9739,7 @@
                   </a:tcPr>
                 </a:tc>
               </a:tr>
-              <a:tr h="329184">
+              <a:tr h="384048">
                 <a:tc>
                   <a:txBody>
                     <a:bodyPr/>
@@ -9749,14 +9749,14 @@
                         <a:buNone/>
                       </a:pPr>
                       <a:r>
-                        <a:rPr lang="en-US" sz="1000" dirty="0">
+                        <a:rPr lang="en-US" sz="1200" dirty="0">
                           <a:solidFill>
                             <a:srgbClr val="4A4A6A"/>
                           </a:solidFill>
                         </a:rPr>
                         <a:t>35 flush_only</a:t>
                       </a:r>
-                      <a:endParaRPr lang="en-US" sz="1000" dirty="0"/>
+                      <a:endParaRPr lang="en-US" sz="1200" dirty="0"/>
                     </a:p>
                   </a:txBody>
                   <a:tcPr marL="76200" marR="76200" marT="25400" marB="25400">
@@ -9810,14 +9810,14 @@
                         <a:buNone/>
                       </a:pPr>
                       <a:r>
-                        <a:rPr lang="en-US" sz="1000" dirty="0">
+                        <a:rPr lang="en-US" sz="1200" dirty="0">
                           <a:solidFill>
                             <a:srgbClr val="4A4A6A"/>
                           </a:solidFill>
                         </a:rPr>
                         <a:t>write + eventfd 通知</a:t>
                       </a:r>
-                      <a:endParaRPr lang="en-US" sz="1000" dirty="0"/>
+                      <a:endParaRPr lang="en-US" sz="1200" dirty="0"/>
                     </a:p>
                   </a:txBody>
                   <a:tcPr marL="76200" marR="76200" marT="25400" marB="25400">
@@ -9871,14 +9871,14 @@
                         <a:buNone/>
                       </a:pPr>
                       <a:r>
-                        <a:rPr lang="en-US" sz="1000" dirty="0">
+                        <a:rPr lang="en-US" sz="1200" dirty="0">
                           <a:solidFill>
                             <a:srgbClr val="4A4A6A"/>
                           </a:solidFill>
                         </a:rPr>
                         <a:t>9.15s</a:t>
                       </a:r>
-                      <a:endParaRPr lang="en-US" sz="1000" dirty="0"/>
+                      <a:endParaRPr lang="en-US" sz="1200" dirty="0"/>
                     </a:p>
                   </a:txBody>
                   <a:tcPr marL="76200" marR="76200" marT="25400" marB="25400">
@@ -9932,14 +9932,14 @@
                         <a:buNone/>
                       </a:pPr>
                       <a:r>
-                        <a:rPr lang="en-US" sz="1000" dirty="0">
+                        <a:rPr lang="en-US" sz="1200" dirty="0">
                           <a:solidFill>
                             <a:srgbClr val="4A4A6A"/>
                           </a:solidFill>
                         </a:rPr>
                         <a:t>19.60s</a:t>
                       </a:r>
-                      <a:endParaRPr lang="en-US" sz="1000" dirty="0"/>
+                      <a:endParaRPr lang="en-US" sz="1200" dirty="0"/>
                     </a:p>
                   </a:txBody>
                   <a:tcPr marL="76200" marR="76200" marT="25400" marB="25400">
@@ -9993,14 +9993,14 @@
                         <a:buNone/>
                       </a:pPr>
                       <a:r>
-                        <a:rPr lang="en-US" sz="1000" dirty="0">
+                        <a:rPr lang="en-US" sz="1200" dirty="0">
                           <a:solidFill>
                             <a:srgbClr val="4A4A6A"/>
                           </a:solidFill>
                         </a:rPr>
                         <a:t>23.94s</a:t>
                       </a:r>
-                      <a:endParaRPr lang="en-US" sz="1000" dirty="0"/>
+                      <a:endParaRPr lang="en-US" sz="1200" dirty="0"/>
                     </a:p>
                   </a:txBody>
                   <a:tcPr marL="76200" marR="76200" marT="25400" marB="25400">
@@ -10054,14 +10054,14 @@
                         <a:buNone/>
                       </a:pPr>
                       <a:r>
-                        <a:rPr lang="en-US" sz="1000" dirty="0">
+                        <a:rPr lang="en-US" sz="1200" dirty="0">
                           <a:solidFill>
                             <a:srgbClr val="059669"/>
                           </a:solidFill>
                         </a:rPr>
                         <a:t>31.97s</a:t>
                       </a:r>
-                      <a:endParaRPr lang="en-US" sz="1000" dirty="0"/>
+                      <a:endParaRPr lang="en-US" sz="1200" dirty="0"/>
                     </a:p>
                   </a:txBody>
                   <a:tcPr marL="76200" marR="76200" marT="25400" marB="25400">
@@ -10107,7 +10107,7 @@
                   </a:tcPr>
                 </a:tc>
               </a:tr>
-              <a:tr h="329184">
+              <a:tr h="384048">
                 <a:tc>
                   <a:txBody>
                     <a:bodyPr/>
@@ -10117,14 +10117,14 @@
                         <a:buNone/>
                       </a:pPr>
                       <a:r>
-                        <a:rPr lang="en-US" sz="1000" dirty="0">
+                        <a:rPr lang="en-US" sz="1200" dirty="0">
                           <a:solidFill>
                             <a:srgbClr val="4A4A6A"/>
                           </a:solidFill>
                         </a:rPr>
                         <a:t>33 + batch64</a:t>
                       </a:r>
-                      <a:endParaRPr lang="en-US" sz="1000" dirty="0"/>
+                      <a:endParaRPr lang="en-US" sz="1200" dirty="0"/>
                     </a:p>
                   </a:txBody>
                   <a:tcPr marL="76200" marR="76200" marT="25400" marB="25400">
@@ -10178,14 +10178,14 @@
                         <a:buNone/>
                       </a:pPr>
                       <a:r>
-                        <a:rPr lang="en-US" sz="1000" dirty="0">
+                        <a:rPr lang="en-US" sz="1200" dirty="0">
                           <a:solidFill>
                             <a:srgbClr val="4A4A6A"/>
                           </a:solidFill>
                         </a:rPr>
                         <a:t>批处理后完整链路</a:t>
                       </a:r>
-                      <a:endParaRPr lang="en-US" sz="1000" dirty="0"/>
+                      <a:endParaRPr lang="en-US" sz="1200" dirty="0"/>
                     </a:p>
                   </a:txBody>
                   <a:tcPr marL="76200" marR="76200" marT="25400" marB="25400">
@@ -10239,14 +10239,14 @@
                         <a:buNone/>
                       </a:pPr>
                       <a:r>
-                        <a:rPr lang="en-US" sz="1000" dirty="0">
+                        <a:rPr lang="en-US" sz="1200" dirty="0">
                           <a:solidFill>
                             <a:srgbClr val="4A4A6A"/>
                           </a:solidFill>
                         </a:rPr>
                         <a:t>1.24s</a:t>
                       </a:r>
-                      <a:endParaRPr lang="en-US" sz="1000" dirty="0"/>
+                      <a:endParaRPr lang="en-US" sz="1200" dirty="0"/>
                     </a:p>
                   </a:txBody>
                   <a:tcPr marL="76200" marR="76200" marT="25400" marB="25400">
@@ -10300,14 +10300,14 @@
                         <a:buNone/>
                       </a:pPr>
                       <a:r>
-                        <a:rPr lang="en-US" sz="1000" dirty="0">
+                        <a:rPr lang="en-US" sz="1200" dirty="0">
                           <a:solidFill>
                             <a:srgbClr val="4A4A6A"/>
                           </a:solidFill>
                         </a:rPr>
                         <a:t>—</a:t>
                       </a:r>
-                      <a:endParaRPr lang="en-US" sz="1000" dirty="0"/>
+                      <a:endParaRPr lang="en-US" sz="1200" dirty="0"/>
                     </a:p>
                   </a:txBody>
                   <a:tcPr marL="76200" marR="76200" marT="25400" marB="25400">
@@ -10361,14 +10361,14 @@
                         <a:buNone/>
                       </a:pPr>
                       <a:r>
-                        <a:rPr lang="en-US" sz="1000" dirty="0">
+                        <a:rPr lang="en-US" sz="1200" dirty="0">
                           <a:solidFill>
                             <a:srgbClr val="4A4A6A"/>
                           </a:solidFill>
                         </a:rPr>
                         <a:t>1.26s</a:t>
                       </a:r>
-                      <a:endParaRPr lang="en-US" sz="1000" dirty="0"/>
+                      <a:endParaRPr lang="en-US" sz="1200" dirty="0"/>
                     </a:p>
                   </a:txBody>
                   <a:tcPr marL="76200" marR="76200" marT="25400" marB="25400">
@@ -10422,14 +10422,14 @@
                         <a:buNone/>
                       </a:pPr>
                       <a:r>
-                        <a:rPr lang="en-US" sz="1000" dirty="0">
+                        <a:rPr lang="en-US" sz="1200" dirty="0">
                           <a:solidFill>
                             <a:srgbClr val="059669"/>
                           </a:solidFill>
                         </a:rPr>
                         <a:t>1.37s</a:t>
                       </a:r>
-                      <a:endParaRPr lang="en-US" sz="1000" dirty="0"/>
+                      <a:endParaRPr lang="en-US" sz="1200" dirty="0"/>
                     </a:p>
                   </a:txBody>
                   <a:tcPr marL="76200" marR="76200" marT="25400" marB="25400">
@@ -10682,7 +10682,7 @@
               <a:buNone/>
             </a:pPr>
             <a:r>
-              <a:rPr lang="en-US" sz="2400" b="1" dirty="0">
+              <a:rPr lang="en-US" sz="2800" b="1" dirty="0">
                 <a:solidFill>
                   <a:srgbClr val="2563EB"/>
                 </a:solidFill>
@@ -10692,7 +10692,7 @@
               </a:rPr>
               <a:t>06</a:t>
             </a:r>
-            <a:endParaRPr lang="en-US" sz="2400" dirty="0"/>
+            <a:endParaRPr lang="en-US" sz="2800" dirty="0"/>
           </a:p>
         </p:txBody>
       </p:sp>
@@ -10705,7 +10705,7 @@
         <p:spPr>
           <a:xfrm>
             <a:off x="1280160" y="137160"/>
-            <a:ext cx="9144000" cy="411480"/>
+            <a:ext cx="9144000" cy="502920"/>
           </a:xfrm>
           <a:prstGeom prst="rect">
             <a:avLst/>
@@ -10721,14 +10721,14 @@
               <a:buNone/>
             </a:pPr>
             <a:r>
-              <a:rPr lang="en-US" sz="2000" b="1" dirty="0">
+              <a:rPr lang="en-US" sz="2400" b="1" dirty="0">
                 <a:solidFill>
                   <a:srgbClr val="1A1A2E"/>
                 </a:solidFill>
               </a:rPr>
               <a:t>Prototype  ↔  OpenHarmony  架构对齐</a:t>
             </a:r>
-            <a:endParaRPr lang="en-US" sz="2000" dirty="0"/>
+            <a:endParaRPr lang="en-US" sz="2400" dirty="0"/>
           </a:p>
         </p:txBody>
       </p:sp>
@@ -10740,8 +10740,8 @@
         </p:nvSpPr>
         <p:spPr>
           <a:xfrm>
-            <a:off x="1280160" y="530352"/>
-            <a:ext cx="9144000" cy="228600"/>
+            <a:off x="1280160" y="566928"/>
+            <a:ext cx="9144000" cy="274320"/>
           </a:xfrm>
           <a:prstGeom prst="rect">
             <a:avLst/>
@@ -10757,14 +10757,14 @@
               <a:buNone/>
             </a:pPr>
             <a:r>
-              <a:rPr lang="en-US" sz="1000" dirty="0">
+              <a:rPr lang="en-US" sz="1200" dirty="0">
                 <a:solidFill>
                   <a:srgbClr val="8888A8"/>
                 </a:solidFill>
               </a:rPr>
               <a:t>热路径模块映射</a:t>
             </a:r>
-            <a:endParaRPr lang="en-US" sz="1000" dirty="0"/>
+            <a:endParaRPr lang="en-US" sz="1200" dirty="0"/>
           </a:p>
         </p:txBody>
       </p:sp>
@@ -10795,7 +10795,7 @@
                 <a:gridCol w="3840480"/>
                 <a:gridCol w="3840480"/>
               </a:tblGrid>
-              <a:tr h="329184">
+              <a:tr h="384048">
                 <a:tc>
                   <a:txBody>
                     <a:bodyPr/>
@@ -10805,14 +10805,14 @@
                         <a:buNone/>
                       </a:pPr>
                       <a:r>
-                        <a:rPr lang="en-US" sz="1000" b="1" dirty="0">
+                        <a:rPr lang="en-US" sz="1200" b="1" dirty="0">
                           <a:solidFill>
                             <a:srgbClr val="2563EB"/>
                           </a:solidFill>
                         </a:rPr>
                         <a:t>热路径操作</a:t>
                       </a:r>
-                      <a:endParaRPr lang="en-US" sz="1000" dirty="0"/>
+                      <a:endParaRPr lang="en-US" sz="1200" dirty="0"/>
                     </a:p>
                   </a:txBody>
                   <a:tcPr marL="76200" marR="76200" marT="25400" marB="25400">
@@ -10866,14 +10866,14 @@
                         <a:buNone/>
                       </a:pPr>
                       <a:r>
-                        <a:rPr lang="en-US" sz="1000" b="1" dirty="0">
+                        <a:rPr lang="en-US" sz="1200" b="1" dirty="0">
                           <a:solidFill>
                             <a:srgbClr val="2563EB"/>
                           </a:solidFill>
                         </a:rPr>
                         <a:t>Prototype (Plan B)</a:t>
                       </a:r>
-                      <a:endParaRPr lang="en-US" sz="1000" dirty="0"/>
+                      <a:endParaRPr lang="en-US" sz="1200" dirty="0"/>
                     </a:p>
                   </a:txBody>
                   <a:tcPr marL="76200" marR="76200" marT="25400" marB="25400">
@@ -10927,14 +10927,14 @@
                         <a:buNone/>
                       </a:pPr>
                       <a:r>
-                        <a:rPr lang="en-US" sz="1000" b="1" dirty="0">
+                        <a:rPr lang="en-US" sz="1200" b="1" dirty="0">
                           <a:solidFill>
                             <a:srgbClr val="2563EB"/>
                           </a:solidFill>
                         </a:rPr>
                         <a:t>OpenHarmony (hook_client.cpp)</a:t>
                       </a:r>
-                      <a:endParaRPr lang="en-US" sz="1000" dirty="0"/>
+                      <a:endParaRPr lang="en-US" sz="1200" dirty="0"/>
                     </a:p>
                   </a:txBody>
                   <a:tcPr marL="76200" marR="76200" marT="25400" marB="25400">
@@ -10980,7 +10980,7 @@
                   </a:tcPr>
                 </a:tc>
               </a:tr>
-              <a:tr h="329184">
+              <a:tr h="384048">
                 <a:tc>
                   <a:txBody>
                     <a:bodyPr/>
@@ -10990,14 +10990,14 @@
                         <a:buNone/>
                       </a:pPr>
                       <a:r>
-                        <a:rPr lang="en-US" sz="1000" dirty="0">
+                        <a:rPr lang="en-US" sz="1200" dirty="0">
                           <a:solidFill>
                             <a:srgbClr val="4A4A6A"/>
                           </a:solidFill>
                         </a:rPr>
                         <a:t>malloc / filter / sample</a:t>
                       </a:r>
-                      <a:endParaRPr lang="en-US" sz="1000" dirty="0"/>
+                      <a:endParaRPr lang="en-US" sz="1200" dirty="0"/>
                     </a:p>
                   </a:txBody>
                   <a:tcPr marL="76200" marR="76200" marT="25400" marB="25400">
@@ -11051,14 +11051,14 @@
                         <a:buNone/>
                       </a:pPr>
                       <a:r>
-                        <a:rPr lang="en-US" sz="1000" dirty="0">
+                        <a:rPr lang="en-US" sz="1200" dirty="0">
                           <a:solidFill>
                             <a:srgbClr val="4A4A6A"/>
                           </a:solidFill>
                         </a:rPr>
                         <a:t>hook_writer</a:t>
                       </a:r>
-                      <a:endParaRPr lang="en-US" sz="1000" dirty="0"/>
+                      <a:endParaRPr lang="en-US" sz="1200" dirty="0"/>
                     </a:p>
                   </a:txBody>
                   <a:tcPr marL="76200" marR="76200" marT="25400" marB="25400">
@@ -11112,14 +11112,14 @@
                         <a:buNone/>
                       </a:pPr>
                       <a:r>
-                        <a:rPr lang="en-US" sz="1000" dirty="0">
+                        <a:rPr lang="en-US" sz="1200" dirty="0">
                           <a:solidFill>
                             <a:srgbClr val="059669"/>
                           </a:solidFill>
                         </a:rPr>
                         <a:t>hook_malloc</a:t>
                       </a:r>
-                      <a:endParaRPr lang="en-US" sz="1000" dirty="0"/>
+                      <a:endParaRPr lang="en-US" sz="1200" dirty="0"/>
                     </a:p>
                   </a:txBody>
                   <a:tcPr marL="76200" marR="76200" marT="25400" marB="25400">
@@ -11165,7 +11165,7 @@
                   </a:tcPr>
                 </a:tc>
               </a:tr>
-              <a:tr h="329184">
+              <a:tr h="384048">
                 <a:tc>
                   <a:txBody>
                     <a:bodyPr/>
@@ -11175,14 +11175,14 @@
                         <a:buNone/>
                       </a:pPr>
                       <a:r>
-                        <a:rPr lang="en-US" sz="1000" dirty="0">
+                        <a:rPr lang="en-US" sz="1200" dirty="0">
                           <a:solidFill>
                             <a:srgbClr val="4A4A6A"/>
                           </a:solidFill>
                         </a:rPr>
                         <a:t>re-entry guard</a:t>
                       </a:r>
-                      <a:endParaRPr lang="en-US" sz="1000" dirty="0"/>
+                      <a:endParaRPr lang="en-US" sz="1200" dirty="0"/>
                     </a:p>
                   </a:txBody>
                   <a:tcPr marL="76200" marR="76200" marT="25400" marB="25400">
@@ -11236,14 +11236,14 @@
                         <a:buNone/>
                       </a:pPr>
                       <a:r>
-                        <a:rPr lang="en-US" sz="1000" dirty="0">
+                        <a:rPr lang="en-US" sz="1200" dirty="0">
                           <a:solidFill>
                             <a:srgbClr val="4A4A6A"/>
                           </a:solidFill>
                         </a:rPr>
                         <a:t>HookReentryGuard</a:t>
                       </a:r>
-                      <a:endParaRPr lang="en-US" sz="1000" dirty="0"/>
+                      <a:endParaRPr lang="en-US" sz="1200" dirty="0"/>
                     </a:p>
                   </a:txBody>
                   <a:tcPr marL="76200" marR="76200" marT="25400" marB="25400">
@@ -11297,14 +11297,14 @@
                         <a:buNone/>
                       </a:pPr>
                       <a:r>
-                        <a:rPr lang="en-US" sz="1000" dirty="0">
+                        <a:rPr lang="en-US" sz="1200" dirty="0">
                           <a:solidFill>
                             <a:srgbClr val="059669"/>
                           </a:solidFill>
                         </a:rPr>
                         <a:t>__set_hook_flag</a:t>
                       </a:r>
-                      <a:endParaRPr lang="en-US" sz="1000" dirty="0"/>
+                      <a:endParaRPr lang="en-US" sz="1200" dirty="0"/>
                     </a:p>
                   </a:txBody>
                   <a:tcPr marL="76200" marR="76200" marT="25400" marB="25400">
@@ -11350,7 +11350,7 @@
                   </a:tcPr>
                 </a:tc>
               </a:tr>
-              <a:tr h="329184">
+              <a:tr h="384048">
                 <a:tc>
                   <a:txBody>
                     <a:bodyPr/>
@@ -11360,14 +11360,14 @@
                         <a:buNone/>
                       </a:pPr>
                       <a:r>
-                        <a:rPr lang="en-US" sz="1000" dirty="0">
+                        <a:rPr lang="en-US" sz="1200" dirty="0">
                           <a:solidFill>
                             <a:srgbClr val="4A4A6A"/>
                           </a:solidFill>
                         </a:rPr>
                         <a:t>StackRawData fill</a:t>
                       </a:r>
-                      <a:endParaRPr lang="en-US" sz="1000" dirty="0"/>
+                      <a:endParaRPr lang="en-US" sz="1200" dirty="0"/>
                     </a:p>
                   </a:txBody>
                   <a:tcPr marL="76200" marR="76200" marT="25400" marB="25400">
@@ -11421,14 +11421,14 @@
                         <a:buNone/>
                       </a:pPr>
                       <a:r>
-                        <a:rPr lang="en-US" sz="1000" dirty="0">
+                        <a:rPr lang="en-US" sz="1200" dirty="0">
                           <a:solidFill>
                             <a:srgbClr val="4A4A6A"/>
                           </a:solidFill>
                         </a:rPr>
                         <a:t>simplified</a:t>
                       </a:r>
-                      <a:endParaRPr lang="en-US" sz="1000" dirty="0"/>
+                      <a:endParaRPr lang="en-US" sz="1200" dirty="0"/>
                     </a:p>
                   </a:txBody>
                   <a:tcPr marL="76200" marR="76200" marT="25400" marB="25400">
@@ -11482,14 +11482,14 @@
                         <a:buNone/>
                       </a:pPr>
                       <a:r>
-                        <a:rPr lang="en-US" sz="1000" dirty="0">
+                        <a:rPr lang="en-US" sz="1200" dirty="0">
                           <a:solidFill>
                             <a:srgbClr val="059669"/>
                           </a:solidFill>
                         </a:rPr>
                         <a:t>rawdata.{pid, tid, size, addr, ts}</a:t>
                       </a:r>
-                      <a:endParaRPr lang="en-US" sz="1000" dirty="0"/>
+                      <a:endParaRPr lang="en-US" sz="1200" dirty="0"/>
                     </a:p>
                   </a:txBody>
                   <a:tcPr marL="76200" marR="76200" marT="25400" marB="25400">
@@ -11535,7 +11535,7 @@
                   </a:tcPr>
                 </a:tc>
               </a:tr>
-              <a:tr h="329184">
+              <a:tr h="384048">
                 <a:tc>
                   <a:txBody>
                     <a:bodyPr/>
@@ -11545,14 +11545,14 @@
                         <a:buNone/>
                       </a:pPr>
                       <a:r>
-                        <a:rPr lang="en-US" sz="1000" dirty="0">
+                        <a:rPr lang="en-US" sz="1200" dirty="0">
                           <a:solidFill>
                             <a:srgbClr val="4A4A6A"/>
                           </a:solidFill>
                         </a:rPr>
                         <a:t>AddressHandler</a:t>
                       </a:r>
-                      <a:endParaRPr lang="en-US" sz="1000" dirty="0"/>
+                      <a:endParaRPr lang="en-US" sz="1200" dirty="0"/>
                     </a:p>
                   </a:txBody>
                   <a:tcPr marL="76200" marR="76200" marT="25400" marB="25400">
@@ -11606,14 +11606,14 @@
                         <a:buNone/>
                       </a:pPr>
                       <a:r>
-                        <a:rPr lang="en-US" sz="1000" dirty="0">
+                        <a:rPr lang="en-US" sz="1200" dirty="0">
                           <a:solidFill>
                             <a:srgbClr val="4A4A6A"/>
                           </a:solidFill>
                         </a:rPr>
                         <a:t>address_handler.h  [NEW]</a:t>
                       </a:r>
-                      <a:endParaRPr lang="en-US" sz="1000" dirty="0"/>
+                      <a:endParaRPr lang="en-US" sz="1200" dirty="0"/>
                     </a:p>
                   </a:txBody>
                   <a:tcPr marL="76200" marR="76200" marT="25400" marB="25400">
@@ -11667,14 +11667,14 @@
                         <a:buNone/>
                       </a:pPr>
                       <a:r>
-                        <a:rPr lang="en-US" sz="1000" dirty="0">
+                        <a:rPr lang="en-US" sz="1200" dirty="0">
                           <a:solidFill>
                             <a:srgbClr val="059669"/>
                           </a:solidFill>
                         </a:rPr>
                         <a:t>AddAllocAddr()</a:t>
                       </a:r>
-                      <a:endParaRPr lang="en-US" sz="1000" dirty="0"/>
+                      <a:endParaRPr lang="en-US" sz="1200" dirty="0"/>
                     </a:p>
                   </a:txBody>
                   <a:tcPr marL="76200" marR="76200" marT="25400" marB="25400">
@@ -11720,7 +11720,7 @@
                   </a:tcPr>
                 </a:tc>
               </a:tr>
-              <a:tr h="329184">
+              <a:tr h="384048">
                 <a:tc>
                   <a:txBody>
                     <a:bodyPr/>
@@ -11730,14 +11730,14 @@
                         <a:buNone/>
                       </a:pPr>
                       <a:r>
-                        <a:rPr lang="en-US" sz="1000" dirty="0">
+                        <a:rPr lang="en-US" sz="1200" dirty="0">
                           <a:solidFill>
                             <a:srgbClr val="4A4A6A"/>
                           </a:solidFill>
                         </a:rPr>
                         <a:t>StackWriter write</a:t>
                       </a:r>
-                      <a:endParaRPr lang="en-US" sz="1000" dirty="0"/>
+                      <a:endParaRPr lang="en-US" sz="1200" dirty="0"/>
                     </a:p>
                   </a:txBody>
                   <a:tcPr marL="76200" marR="76200" marT="25400" marB="25400">
@@ -11791,14 +11791,14 @@
                         <a:buNone/>
                       </a:pPr>
                       <a:r>
-                        <a:rPr lang="en-US" sz="1000" dirty="0">
+                        <a:rPr lang="en-US" sz="1200" dirty="0">
                           <a:solidFill>
                             <a:srgbClr val="4A4A6A"/>
                           </a:solidFill>
                         </a:rPr>
                         <a:t>stack_writer.cpp  [NEW]</a:t>
                       </a:r>
-                      <a:endParaRPr lang="en-US" sz="1000" dirty="0"/>
+                      <a:endParaRPr lang="en-US" sz="1200" dirty="0"/>
                     </a:p>
                   </a:txBody>
                   <a:tcPr marL="76200" marR="76200" marT="25400" marB="25400">
@@ -11852,14 +11852,14 @@
                         <a:buNone/>
                       </a:pPr>
                       <a:r>
-                        <a:rPr lang="en-US" sz="1000" dirty="0">
+                        <a:rPr lang="en-US" sz="1200" dirty="0">
                           <a:solidFill>
                             <a:srgbClr val="059669"/>
                           </a:solidFill>
                         </a:rPr>
                         <a:t>WriteWithPayloadTimeout</a:t>
                       </a:r>
-                      <a:endParaRPr lang="en-US" sz="1000" dirty="0"/>
+                      <a:endParaRPr lang="en-US" sz="1200" dirty="0"/>
                     </a:p>
                   </a:txBody>
                   <a:tcPr marL="76200" marR="76200" marT="25400" marB="25400">
@@ -11905,7 +11905,7 @@
                   </a:tcPr>
                 </a:tc>
               </a:tr>
-              <a:tr h="329184">
+              <a:tr h="384048">
                 <a:tc>
                   <a:txBody>
                     <a:bodyPr/>
@@ -11915,14 +11915,14 @@
                         <a:buNone/>
                       </a:pPr>
                       <a:r>
-                        <a:rPr lang="en-US" sz="1000" dirty="0">
+                        <a:rPr lang="en-US" sz="1200" dirty="0">
                           <a:solidFill>
                             <a:srgbClr val="4A4A6A"/>
                           </a:solidFill>
                         </a:rPr>
                         <a:t>StackWriter flush</a:t>
                       </a:r>
-                      <a:endParaRPr lang="en-US" sz="1000" dirty="0"/>
+                      <a:endParaRPr lang="en-US" sz="1200" dirty="0"/>
                     </a:p>
                   </a:txBody>
                   <a:tcPr marL="76200" marR="76200" marT="25400" marB="25400">
@@ -11976,14 +11976,14 @@
                         <a:buNone/>
                       </a:pPr>
                       <a:r>
-                        <a:rPr lang="en-US" sz="1000" dirty="0">
+                        <a:rPr lang="en-US" sz="1200" dirty="0">
                           <a:solidFill>
                             <a:srgbClr val="4A4A6A"/>
                           </a:solidFill>
                         </a:rPr>
                         <a:t>Flush / FlushEventFd  [NEW]</a:t>
                       </a:r>
-                      <a:endParaRPr lang="en-US" sz="1000" dirty="0"/>
+                      <a:endParaRPr lang="en-US" sz="1200" dirty="0"/>
                     </a:p>
                   </a:txBody>
                   <a:tcPr marL="76200" marR="76200" marT="25400" marB="25400">
@@ -12037,14 +12037,14 @@
                         <a:buNone/>
                       </a:pPr>
                       <a:r>
-                        <a:rPr lang="en-US" sz="1000" dirty="0">
+                        <a:rPr lang="en-US" sz="1200" dirty="0">
                           <a:solidFill>
                             <a:srgbClr val="059669"/>
                           </a:solidFill>
                         </a:rPr>
                         <a:t>Flush → EventNotifier::Post</a:t>
                       </a:r>
-                      <a:endParaRPr lang="en-US" sz="1000" dirty="0"/>
+                      <a:endParaRPr lang="en-US" sz="1200" dirty="0"/>
                     </a:p>
                   </a:txBody>
                   <a:tcPr marL="76200" marR="76200" marT="25400" marB="25400">
@@ -12191,7 +12191,7 @@
               <a:buNone/>
             </a:pPr>
             <a:r>
-              <a:rPr lang="en-US" sz="2400" b="1" dirty="0">
+              <a:rPr lang="en-US" sz="2800" b="1" dirty="0">
                 <a:solidFill>
                   <a:srgbClr val="2563EB"/>
                 </a:solidFill>
@@ -12201,7 +12201,7 @@
               </a:rPr>
               <a:t>07</a:t>
             </a:r>
-            <a:endParaRPr lang="en-US" sz="2400" dirty="0"/>
+            <a:endParaRPr lang="en-US" sz="2800" dirty="0"/>
           </a:p>
         </p:txBody>
       </p:sp>
@@ -12214,7 +12214,7 @@
         <p:spPr>
           <a:xfrm>
             <a:off x="1280160" y="137160"/>
-            <a:ext cx="9144000" cy="411480"/>
+            <a:ext cx="9144000" cy="502920"/>
           </a:xfrm>
           <a:prstGeom prst="rect">
             <a:avLst/>
@@ -12230,14 +12230,14 @@
               <a:buNone/>
             </a:pPr>
             <a:r>
-              <a:rPr lang="en-US" sz="2000" b="1" dirty="0">
+              <a:rPr lang="en-US" sz="2400" b="1" dirty="0">
                 <a:solidFill>
                   <a:srgbClr val="1A1A2E"/>
                 </a:solidFill>
               </a:rPr>
               <a:t>OpenHarmony Fork — 优化移植状态</a:t>
             </a:r>
-            <a:endParaRPr lang="en-US" sz="2000" dirty="0"/>
+            <a:endParaRPr lang="en-US" sz="2400" dirty="0"/>
           </a:p>
         </p:txBody>
       </p:sp>
@@ -12249,8 +12249,8 @@
         </p:nvSpPr>
         <p:spPr>
           <a:xfrm>
-            <a:off x="1280160" y="530352"/>
-            <a:ext cx="9144000" cy="228600"/>
+            <a:off x="1280160" y="566928"/>
+            <a:ext cx="9144000" cy="274320"/>
           </a:xfrm>
           <a:prstGeom prst="rect">
             <a:avLst/>
@@ -12266,14 +12266,14 @@
               <a:buNone/>
             </a:pPr>
             <a:r>
-              <a:rPr lang="en-US" sz="1000" dirty="0">
+              <a:rPr lang="en-US" sz="1200" dirty="0">
                 <a:solidFill>
                   <a:srgbClr val="8888A8"/>
                 </a:solidFill>
               </a:rPr>
               <a:t>gitlab.youtune.tech/cychi/cyc_nativehook</a:t>
             </a:r>
-            <a:endParaRPr lang="en-US" sz="1000" dirty="0"/>
+            <a:endParaRPr lang="en-US" sz="1200" dirty="0"/>
           </a:p>
         </p:txBody>
       </p:sp>
@@ -12305,7 +12305,7 @@
                 <a:gridCol w="2880360"/>
                 <a:gridCol w="2880360"/>
               </a:tblGrid>
-              <a:tr h="329184">
+              <a:tr h="384048">
                 <a:tc>
                   <a:txBody>
                     <a:bodyPr/>
@@ -12315,14 +12315,14 @@
                         <a:buNone/>
                       </a:pPr>
                       <a:r>
-                        <a:rPr lang="en-US" sz="1000" b="1" dirty="0">
+                        <a:rPr lang="en-US" sz="1200" b="1" dirty="0">
                           <a:solidFill>
                             <a:srgbClr val="2563EB"/>
                           </a:solidFill>
                         </a:rPr>
                         <a:t>函数</a:t>
                       </a:r>
-                      <a:endParaRPr lang="en-US" sz="1000" dirty="0"/>
+                      <a:endParaRPr lang="en-US" sz="1200" dirty="0"/>
                     </a:p>
                   </a:txBody>
                   <a:tcPr marL="76200" marR="76200" marT="25400" marB="25400">
@@ -12376,14 +12376,14 @@
                         <a:buNone/>
                       </a:pPr>
                       <a:r>
-                        <a:rPr lang="en-US" sz="1000" b="1" dirty="0">
+                        <a:rPr lang="en-US" sz="1200" b="1" dirty="0">
                           <a:solidFill>
                             <a:srgbClr val="2563EB"/>
                           </a:solidFill>
                         </a:rPr>
                         <a:t>调用场景</a:t>
                       </a:r>
-                      <a:endParaRPr lang="en-US" sz="1000" dirty="0"/>
+                      <a:endParaRPr lang="en-US" sz="1200" dirty="0"/>
                     </a:p>
                   </a:txBody>
                   <a:tcPr marL="76200" marR="76200" marT="25400" marB="25400">
@@ -12437,14 +12437,14 @@
                         <a:buNone/>
                       </a:pPr>
                       <a:r>
-                        <a:rPr lang="en-US" sz="1000" b="1" dirty="0">
+                        <a:rPr lang="en-US" sz="1200" b="1" dirty="0">
                           <a:solidFill>
                             <a:srgbClr val="2563EB"/>
                           </a:solidFill>
                         </a:rPr>
                         <a:t>record-fill-before-lock</a:t>
                       </a:r>
-                      <a:endParaRPr lang="en-US" sz="1000" dirty="0"/>
+                      <a:endParaRPr lang="en-US" sz="1200" dirty="0"/>
                     </a:p>
                   </a:txBody>
                   <a:tcPr marL="76200" marR="76200" marT="25400" marB="25400">
@@ -12498,14 +12498,14 @@
                         <a:buNone/>
                       </a:pPr>
                       <a:r>
-                        <a:rPr lang="en-US" sz="1000" b="1" dirty="0">
+                        <a:rPr lang="en-US" sz="1200" b="1" dirty="0">
                           <a:solidFill>
                             <a:srgbClr val="2563EB"/>
                           </a:solidFill>
                         </a:rPr>
                         <a:t>batch publish</a:t>
                       </a:r>
-                      <a:endParaRPr lang="en-US" sz="1000" dirty="0"/>
+                      <a:endParaRPr lang="en-US" sz="1200" dirty="0"/>
                     </a:p>
                   </a:txBody>
                   <a:tcPr marL="76200" marR="76200" marT="25400" marB="25400">
@@ -12551,7 +12551,7 @@
                   </a:tcPr>
                 </a:tc>
               </a:tr>
-              <a:tr h="329184">
+              <a:tr h="384048">
                 <a:tc>
                   <a:txBody>
                     <a:bodyPr/>
@@ -12561,14 +12561,14 @@
                         <a:buNone/>
                       </a:pPr>
                       <a:r>
-                        <a:rPr lang="en-US" sz="1000" dirty="0">
+                        <a:rPr lang="en-US" sz="1200" dirty="0">
                           <a:solidFill>
                             <a:srgbClr val="4A4A6A"/>
                           </a:solidFill>
                         </a:rPr>
                         <a:t>hook_malloc</a:t>
                       </a:r>
-                      <a:endParaRPr lang="en-US" sz="1000" dirty="0"/>
+                      <a:endParaRPr lang="en-US" sz="1200" dirty="0"/>
                     </a:p>
                   </a:txBody>
                   <a:tcPr marL="76200" marR="76200" marT="25400" marB="25400">
@@ -12622,14 +12622,14 @@
                         <a:buNone/>
                       </a:pPr>
                       <a:r>
-                        <a:rPr lang="en-US" sz="1000" dirty="0">
+                        <a:rPr lang="en-US" sz="1200" dirty="0">
                           <a:solidFill>
                             <a:srgbClr val="4A4A6A"/>
                           </a:solidFill>
                         </a:rPr>
                         <a:t>主分配路径</a:t>
                       </a:r>
-                      <a:endParaRPr lang="en-US" sz="1000" dirty="0"/>
+                      <a:endParaRPr lang="en-US" sz="1200" dirty="0"/>
                     </a:p>
                   </a:txBody>
                   <a:tcPr marL="76200" marR="76200" marT="25400" marB="25400">
@@ -12683,14 +12683,14 @@
                         <a:buNone/>
                       </a:pPr>
                       <a:r>
-                        <a:rPr lang="en-US" sz="1000" dirty="0">
+                        <a:rPr lang="en-US" sz="1200" dirty="0">
                           <a:solidFill>
                             <a:srgbClr val="4A4A6A"/>
                           </a:solidFill>
                         </a:rPr>
                         <a:t>✓</a:t>
                       </a:r>
-                      <a:endParaRPr lang="en-US" sz="1000" dirty="0"/>
+                      <a:endParaRPr lang="en-US" sz="1200" dirty="0"/>
                     </a:p>
                   </a:txBody>
                   <a:tcPr marL="76200" marR="76200" marT="25400" marB="25400">
@@ -12744,14 +12744,14 @@
                         <a:buNone/>
                       </a:pPr>
                       <a:r>
-                        <a:rPr lang="en-US" sz="1000" dirty="0">
+                        <a:rPr lang="en-US" sz="1200" dirty="0">
                           <a:solidFill>
                             <a:srgbClr val="059669"/>
                           </a:solidFill>
                         </a:rPr>
                         <a:t>✓</a:t>
                       </a:r>
-                      <a:endParaRPr lang="en-US" sz="1000" dirty="0"/>
+                      <a:endParaRPr lang="en-US" sz="1200" dirty="0"/>
                     </a:p>
                   </a:txBody>
                   <a:tcPr marL="76200" marR="76200" marT="25400" marB="25400">
@@ -12797,7 +12797,7 @@
                   </a:tcPr>
                 </a:tc>
               </a:tr>
-              <a:tr h="329184">
+              <a:tr h="384048">
                 <a:tc>
                   <a:txBody>
                     <a:bodyPr/>
@@ -12807,14 +12807,14 @@
                         <a:buNone/>
                       </a:pPr>
                       <a:r>
-                        <a:rPr lang="en-US" sz="1000" dirty="0">
+                        <a:rPr lang="en-US" sz="1200" dirty="0">
                           <a:solidFill>
                             <a:srgbClr val="4A4A6A"/>
                           </a:solidFill>
                         </a:rPr>
                         <a:t>hook_calloc</a:t>
                       </a:r>
-                      <a:endParaRPr lang="en-US" sz="1000" dirty="0"/>
+                      <a:endParaRPr lang="en-US" sz="1200" dirty="0"/>
                     </a:p>
                   </a:txBody>
                   <a:tcPr marL="76200" marR="76200" marT="25400" marB="25400">
@@ -12868,14 +12868,14 @@
                         <a:buNone/>
                       </a:pPr>
                       <a:r>
-                        <a:rPr lang="en-US" sz="1000" dirty="0">
+                        <a:rPr lang="en-US" sz="1200" dirty="0">
                           <a:solidFill>
                             <a:srgbClr val="4A4A6A"/>
                           </a:solidFill>
                         </a:rPr>
                         <a:t>C++ new 底层调用</a:t>
                       </a:r>
-                      <a:endParaRPr lang="en-US" sz="1000" dirty="0"/>
+                      <a:endParaRPr lang="en-US" sz="1200" dirty="0"/>
                     </a:p>
                   </a:txBody>
                   <a:tcPr marL="76200" marR="76200" marT="25400" marB="25400">
@@ -12929,14 +12929,14 @@
                         <a:buNone/>
                       </a:pPr>
                       <a:r>
-                        <a:rPr lang="en-US" sz="1000" dirty="0">
+                        <a:rPr lang="en-US" sz="1200" dirty="0">
                           <a:solidFill>
                             <a:srgbClr val="4A4A6A"/>
                           </a:solidFill>
                         </a:rPr>
                         <a:t>✓</a:t>
                       </a:r>
-                      <a:endParaRPr lang="en-US" sz="1000" dirty="0"/>
+                      <a:endParaRPr lang="en-US" sz="1200" dirty="0"/>
                     </a:p>
                   </a:txBody>
                   <a:tcPr marL="76200" marR="76200" marT="25400" marB="25400">
@@ -12990,14 +12990,14 @@
                         <a:buNone/>
                       </a:pPr>
                       <a:r>
-                        <a:rPr lang="en-US" sz="1000" dirty="0">
+                        <a:rPr lang="en-US" sz="1200" dirty="0">
                           <a:solidFill>
                             <a:srgbClr val="059669"/>
                           </a:solidFill>
                         </a:rPr>
                         <a:t>✓</a:t>
                       </a:r>
-                      <a:endParaRPr lang="en-US" sz="1000" dirty="0"/>
+                      <a:endParaRPr lang="en-US" sz="1200" dirty="0"/>
                     </a:p>
                   </a:txBody>
                   <a:tcPr marL="76200" marR="76200" marT="25400" marB="25400">
@@ -13043,7 +13043,7 @@
                   </a:tcPr>
                 </a:tc>
               </a:tr>
-              <a:tr h="329184">
+              <a:tr h="384048">
                 <a:tc>
                   <a:txBody>
                     <a:bodyPr/>
@@ -13053,14 +13053,14 @@
                         <a:buNone/>
                       </a:pPr>
                       <a:r>
-                        <a:rPr lang="en-US" sz="1000" dirty="0">
+                        <a:rPr lang="en-US" sz="1200" dirty="0">
                           <a:solidFill>
                             <a:srgbClr val="4A4A6A"/>
                           </a:solidFill>
                         </a:rPr>
                         <a:t>hook_realloc</a:t>
                       </a:r>
-                      <a:endParaRPr lang="en-US" sz="1000" dirty="0"/>
+                      <a:endParaRPr lang="en-US" sz="1200" dirty="0"/>
                     </a:p>
                   </a:txBody>
                   <a:tcPr marL="76200" marR="76200" marT="25400" marB="25400">
@@ -13114,14 +13114,14 @@
                         <a:buNone/>
                       </a:pPr>
                       <a:r>
-                        <a:rPr lang="en-US" sz="1000" dirty="0">
+                        <a:rPr lang="en-US" sz="1200" dirty="0">
                           <a:solidFill>
                             <a:srgbClr val="4A4A6A"/>
                           </a:solidFill>
                         </a:rPr>
                         <a:t>vector 扩容（free+alloc）</a:t>
                       </a:r>
-                      <a:endParaRPr lang="en-US" sz="1000" dirty="0"/>
+                      <a:endParaRPr lang="en-US" sz="1200" dirty="0"/>
                     </a:p>
                   </a:txBody>
                   <a:tcPr marL="76200" marR="76200" marT="25400" marB="25400">
@@ -13175,14 +13175,14 @@
                         <a:buNone/>
                       </a:pPr>
                       <a:r>
-                        <a:rPr lang="en-US" sz="1000" dirty="0">
+                        <a:rPr lang="en-US" sz="1200" dirty="0">
                           <a:solidFill>
                             <a:srgbClr val="4A4A6A"/>
                           </a:solidFill>
                         </a:rPr>
                         <a:t>✓</a:t>
                       </a:r>
-                      <a:endParaRPr lang="en-US" sz="1000" dirty="0"/>
+                      <a:endParaRPr lang="en-US" sz="1200" dirty="0"/>
                     </a:p>
                   </a:txBody>
                   <a:tcPr marL="76200" marR="76200" marT="25400" marB="25400">
@@ -13236,14 +13236,14 @@
                         <a:buNone/>
                       </a:pPr>
                       <a:r>
-                        <a:rPr lang="en-US" sz="1000" dirty="0">
+                        <a:rPr lang="en-US" sz="1200" dirty="0">
                           <a:solidFill>
                             <a:srgbClr val="059669"/>
                           </a:solidFill>
                         </a:rPr>
                         <a:t>✓</a:t>
                       </a:r>
-                      <a:endParaRPr lang="en-US" sz="1000" dirty="0"/>
+                      <a:endParaRPr lang="en-US" sz="1200" dirty="0"/>
                     </a:p>
                   </a:txBody>
                   <a:tcPr marL="76200" marR="76200" marT="25400" marB="25400">
@@ -13289,7 +13289,7 @@
                   </a:tcPr>
                 </a:tc>
               </a:tr>
-              <a:tr h="329184">
+              <a:tr h="384048">
                 <a:tc>
                   <a:txBody>
                     <a:bodyPr/>
@@ -13299,14 +13299,14 @@
                         <a:buNone/>
                       </a:pPr>
                       <a:r>
-                        <a:rPr lang="en-US" sz="1000" dirty="0">
+                        <a:rPr lang="en-US" sz="1200" dirty="0">
                           <a:solidFill>
                             <a:srgbClr val="4A4A6A"/>
                           </a:solidFill>
                         </a:rPr>
                         <a:t>hook_aligned_alloc</a:t>
                       </a:r>
-                      <a:endParaRPr lang="en-US" sz="1000" dirty="0"/>
+                      <a:endParaRPr lang="en-US" sz="1200" dirty="0"/>
                     </a:p>
                   </a:txBody>
                   <a:tcPr marL="76200" marR="76200" marT="25400" marB="25400">
@@ -13360,14 +13360,14 @@
                         <a:buNone/>
                       </a:pPr>
                       <a:r>
-                        <a:rPr lang="en-US" sz="1000" dirty="0">
+                        <a:rPr lang="en-US" sz="1200" dirty="0">
                           <a:solidFill>
                             <a:srgbClr val="4A4A6A"/>
                           </a:solidFill>
                         </a:rPr>
                         <a:t>对齐分配</a:t>
                       </a:r>
-                      <a:endParaRPr lang="en-US" sz="1000" dirty="0"/>
+                      <a:endParaRPr lang="en-US" sz="1200" dirty="0"/>
                     </a:p>
                   </a:txBody>
                   <a:tcPr marL="76200" marR="76200" marT="25400" marB="25400">
@@ -13421,14 +13421,14 @@
                         <a:buNone/>
                       </a:pPr>
                       <a:r>
-                        <a:rPr lang="en-US" sz="1000" dirty="0">
+                        <a:rPr lang="en-US" sz="1200" dirty="0">
                           <a:solidFill>
                             <a:srgbClr val="4A4A6A"/>
                           </a:solidFill>
                         </a:rPr>
                         <a:t>✓</a:t>
                       </a:r>
-                      <a:endParaRPr lang="en-US" sz="1000" dirty="0"/>
+                      <a:endParaRPr lang="en-US" sz="1200" dirty="0"/>
                     </a:p>
                   </a:txBody>
                   <a:tcPr marL="76200" marR="76200" marT="25400" marB="25400">
@@ -13482,14 +13482,14 @@
                         <a:buNone/>
                       </a:pPr>
                       <a:r>
-                        <a:rPr lang="en-US" sz="1000" dirty="0">
+                        <a:rPr lang="en-US" sz="1200" dirty="0">
                           <a:solidFill>
                             <a:srgbClr val="059669"/>
                           </a:solidFill>
                         </a:rPr>
                         <a:t>—</a:t>
                       </a:r>
-                      <a:endParaRPr lang="en-US" sz="1000" dirty="0"/>
+                      <a:endParaRPr lang="en-US" sz="1200" dirty="0"/>
                     </a:p>
                   </a:txBody>
                   <a:tcPr marL="76200" marR="76200" marT="25400" marB="25400">
@@ -13535,7 +13535,7 @@
                   </a:tcPr>
                 </a:tc>
               </a:tr>
-              <a:tr h="329184">
+              <a:tr h="384048">
                 <a:tc>
                   <a:txBody>
                     <a:bodyPr/>
@@ -13545,14 +13545,14 @@
                         <a:buNone/>
                       </a:pPr>
                       <a:r>
-                        <a:rPr lang="en-US" sz="1000" dirty="0">
+                        <a:rPr lang="en-US" sz="1200" dirty="0">
                           <a:solidFill>
                             <a:srgbClr val="4A4A6A"/>
                           </a:solidFill>
                         </a:rPr>
                         <a:t>hook_free</a:t>
                       </a:r>
-                      <a:endParaRPr lang="en-US" sz="1000" dirty="0"/>
+                      <a:endParaRPr lang="en-US" sz="1200" dirty="0"/>
                     </a:p>
                   </a:txBody>
                   <a:tcPr marL="76200" marR="76200" marT="25400" marB="25400">
@@ -13606,14 +13606,14 @@
                         <a:buNone/>
                       </a:pPr>
                       <a:r>
-                        <a:rPr lang="en-US" sz="1000" dirty="0">
+                        <a:rPr lang="en-US" sz="1200" dirty="0">
                           <a:solidFill>
                             <a:srgbClr val="4A4A6A"/>
                           </a:solidFill>
                         </a:rPr>
                         <a:t>释放路径</a:t>
                       </a:r>
-                      <a:endParaRPr lang="en-US" sz="1000" dirty="0"/>
+                      <a:endParaRPr lang="en-US" sz="1200" dirty="0"/>
                     </a:p>
                   </a:txBody>
                   <a:tcPr marL="76200" marR="76200" marT="25400" marB="25400">
@@ -13667,14 +13667,14 @@
                         <a:buNone/>
                       </a:pPr>
                       <a:r>
-                        <a:rPr lang="en-US" sz="1000" dirty="0">
+                        <a:rPr lang="en-US" sz="1200" dirty="0">
                           <a:solidFill>
                             <a:srgbClr val="4A4A6A"/>
                           </a:solidFill>
                         </a:rPr>
                         <a:t>✓</a:t>
                       </a:r>
-                      <a:endParaRPr lang="en-US" sz="1000" dirty="0"/>
+                      <a:endParaRPr lang="en-US" sz="1200" dirty="0"/>
                     </a:p>
                   </a:txBody>
                   <a:tcPr marL="76200" marR="76200" marT="25400" marB="25400">
@@ -13728,14 +13728,14 @@
                         <a:buNone/>
                       </a:pPr>
                       <a:r>
-                        <a:rPr lang="en-US" sz="1000" dirty="0">
+                        <a:rPr lang="en-US" sz="1200" dirty="0">
                           <a:solidFill>
                             <a:srgbClr val="059669"/>
                           </a:solidFill>
                         </a:rPr>
                         <a:t>✓</a:t>
                       </a:r>
-                      <a:endParaRPr lang="en-US" sz="1000" dirty="0"/>
+                      <a:endParaRPr lang="en-US" sz="1200" dirty="0"/>
                     </a:p>
                   </a:txBody>
                   <a:tcPr marL="76200" marR="76200" marT="25400" marB="25400">
@@ -13946,7 +13946,7 @@
               <a:buNone/>
             </a:pPr>
             <a:r>
-              <a:rPr lang="en-US" sz="2400" b="1" dirty="0">
+              <a:rPr lang="en-US" sz="2800" b="1" dirty="0">
                 <a:solidFill>
                   <a:srgbClr val="2563EB"/>
                 </a:solidFill>
@@ -13956,7 +13956,7 @@
               </a:rPr>
               <a:t>08</a:t>
             </a:r>
-            <a:endParaRPr lang="en-US" sz="2400" dirty="0"/>
+            <a:endParaRPr lang="en-US" sz="2800" dirty="0"/>
           </a:p>
         </p:txBody>
       </p:sp>
@@ -13969,7 +13969,7 @@
         <p:spPr>
           <a:xfrm>
             <a:off x="1280160" y="137160"/>
-            <a:ext cx="9144000" cy="411480"/>
+            <a:ext cx="9144000" cy="502920"/>
           </a:xfrm>
           <a:prstGeom prst="rect">
             <a:avLst/>
@@ -13985,14 +13985,14 @@
               <a:buNone/>
             </a:pPr>
             <a:r>
-              <a:rPr lang="en-US" sz="2000" b="1" dirty="0">
+              <a:rPr lang="en-US" sz="2400" b="1" dirty="0">
                 <a:solidFill>
                   <a:srgbClr val="1A1A2E"/>
                 </a:solidFill>
               </a:rPr>
               <a:t>经验教训 &amp; 三步预检方法</a:t>
             </a:r>
-            <a:endParaRPr lang="en-US" sz="2000" dirty="0"/>
+            <a:endParaRPr lang="en-US" sz="2400" dirty="0"/>
           </a:p>
         </p:txBody>
       </p:sp>
@@ -14004,8 +14004,8 @@
         </p:nvSpPr>
         <p:spPr>
           <a:xfrm>
-            <a:off x="1280160" y="530352"/>
-            <a:ext cx="9144000" cy="228600"/>
+            <a:off x="1280160" y="566928"/>
+            <a:ext cx="9144000" cy="274320"/>
           </a:xfrm>
           <a:prstGeom prst="rect">
             <a:avLst/>
@@ -14021,14 +14021,14 @@
               <a:buNone/>
             </a:pPr>
             <a:r>
-              <a:rPr lang="en-US" sz="1000" dirty="0">
+              <a:rPr lang="en-US" sz="1200" dirty="0">
                 <a:solidFill>
                   <a:srgbClr val="8888A8"/>
                 </a:solidFill>
               </a:rPr>
               <a:t>两个无效优化如何发生，以及后续怎么避免</a:t>
             </a:r>
-            <a:endParaRPr lang="en-US" sz="1000" dirty="0"/>
+            <a:endParaRPr lang="en-US" sz="1200" dirty="0"/>
           </a:p>
         </p:txBody>
       </p:sp>
@@ -14068,7 +14068,7 @@
         <p:spPr>
           <a:xfrm>
             <a:off x="502920" y="1371600"/>
-            <a:ext cx="3657600" cy="274320"/>
+            <a:ext cx="3657600" cy="320040"/>
           </a:xfrm>
           <a:prstGeom prst="rect">
             <a:avLst/>
@@ -14084,14 +14084,14 @@
               <a:buNone/>
             </a:pPr>
             <a:r>
-              <a:rPr lang="en-US" sz="1300" b="1" dirty="0">
+              <a:rPr lang="en-US" sz="1600" b="1" dirty="0">
                 <a:solidFill>
                   <a:srgbClr val="DB2777"/>
                 </a:solidFill>
               </a:rPr>
               <a:t>失败的优化</a:t>
             </a:r>
-            <a:endParaRPr lang="en-US" sz="1300" dirty="0"/>
+            <a:endParaRPr lang="en-US" sz="1600" dirty="0"/>
           </a:p>
         </p:txBody>
       </p:sp>
@@ -14313,7 +14313,7 @@
         <p:spPr>
           <a:xfrm>
             <a:off x="6126480" y="1371600"/>
-            <a:ext cx="4572000" cy="274320"/>
+            <a:ext cx="4572000" cy="320040"/>
           </a:xfrm>
           <a:prstGeom prst="rect">
             <a:avLst/>
@@ -14329,14 +14329,14 @@
               <a:buNone/>
             </a:pPr>
             <a:r>
-              <a:rPr lang="en-US" sz="1300" b="1" dirty="0">
+              <a:rPr lang="en-US" sz="1600" b="1" dirty="0">
                 <a:solidFill>
                   <a:srgbClr val="059669"/>
                 </a:solidFill>
               </a:rPr>
               <a:t>三步预检法  [AGENTS.md]</a:t>
             </a:r>
-            <a:endParaRPr lang="en-US" sz="1300" dirty="0"/>
+            <a:endParaRPr lang="en-US" sz="1600" dirty="0"/>
           </a:p>
         </p:txBody>
       </p:sp>

</xml_diff>

<commit_message>
Update slide 3 script: explain ablation methodology
</commit_message>
<xml_diff>
--- a/presentation/native_hook_progress_2026-06-05.pptx
+++ b/presentation/native_hook_progress_2026-06-05.pptx
@@ -4,6 +4,9 @@
   <p:sldMasterIdLst>
     <p:sldMasterId id="2147483648" r:id="rId1"/>
   </p:sldMasterIdLst>
+  <p:notesMasterIdLst>
+    <p:notesMasterId r:id="rId12"/>
+  </p:notesMasterIdLst>
   <p:sldIdLst>
     <p:sldId id="256" r:id="rId2"/>
     <p:sldId id="257" r:id="rId3"/>
@@ -16,9 +19,6 @@
     <p:sldId id="264" r:id="rId10"/>
     <p:sldId id="265" r:id="rId11"/>
   </p:sldIdLst>
-  <p:notesMasterIdLst>
-    <p:notesMasterId r:id="rId12"/>
-  </p:notesMasterIdLst>
   <p:sldSz cx="12192000" cy="6858000"/>
   <p:notesSz cx="6858000" cy="12192000"/>
   <p:defaultTextStyle>
@@ -113,6 +113,11 @@
       </a:defRPr>
     </a:lvl9pPr>
   </p:defaultTextStyle>
+  <p:extLst>
+    <p:ext uri="{EFAFB233-063F-42B5-8137-9DF3F51BA10A}">
+      <p15:sldGuideLst xmlns:p15="http://schemas.microsoft.com/office/powerpoint/2012/main"/>
+    </p:ext>
+  </p:extLst>
 </p:presentation>
 </file>
 
@@ -138,234 +143,10 @@
           <a:chExt cx="0" cy="0"/>
         </a:xfrm>
       </p:grpSpPr>
-      <p:sp>
-        <p:nvSpPr>
-          <p:cNvPr id="2" name="Header Placeholder 1"/>
-          <p:cNvSpPr>
-            <a:spLocks noGrp="1"/>
-          </p:cNvSpPr>
-          <p:nvPr>
-            <p:ph type="hdr" sz="quarter"/>
-          </p:nvPr>
-        </p:nvSpPr>
-        <p:spPr>
-          <a:xfrm>
-            <a:off x="0" y="0"/>
-            <a:ext cx="2971800" cy="458788"/>
-          </a:xfrm>
-          <a:prstGeom prst="rect">
-            <a:avLst/>
-          </a:prstGeom>
-        </p:spPr>
-        <p:txBody>
-          <a:bodyPr vert="horz" lIns="91440" tIns="45720" rIns="91440" bIns="45720" rtlCol="0"/>
-          <a:lstStyle>
-            <a:lvl1pPr algn="l">
-              <a:defRPr sz="1200"/>
-            </a:lvl1pPr>
-          </a:lstStyle>
-          <a:p>
-            <a:endParaRPr lang="en-US"/>
-          </a:p>
-        </p:txBody>
-      </p:sp>
-      <p:sp>
-        <p:nvSpPr>
-          <p:cNvPr id="3" name="Date Placeholder 2"/>
-          <p:cNvSpPr>
-            <a:spLocks noGrp="1"/>
-          </p:cNvSpPr>
-          <p:nvPr>
-            <p:ph type="dt" idx="1"/>
-          </p:nvPr>
-        </p:nvSpPr>
-        <p:spPr>
-          <a:xfrm>
-            <a:off x="3884613" y="0"/>
-            <a:ext cx="2971800" cy="458788"/>
-          </a:xfrm>
-          <a:prstGeom prst="rect">
-            <a:avLst/>
-          </a:prstGeom>
-        </p:spPr>
-        <p:txBody>
-          <a:bodyPr vert="horz" lIns="91440" tIns="45720" rIns="91440" bIns="45720" rtlCol="0"/>
-          <a:lstStyle>
-            <a:lvl1pPr algn="r">
-              <a:defRPr sz="1200"/>
-            </a:lvl1pPr>
-          </a:lstStyle>
-          <a:p>
-            <a:fld id="{5282F153-3F37-0F45-9E97-73ACFA13230C}" type="datetimeFigureOut">
-              <a:rPr lang="en-US"/>
-              <a:t>7/23/19</a:t>
-            </a:fld>
-            <a:endParaRPr lang="en-US"/>
-          </a:p>
-        </p:txBody>
-      </p:sp>
-      <p:sp>
-        <p:nvSpPr>
-          <p:cNvPr id="4" name="Slide Image Placeholder 3"/>
-          <p:cNvSpPr>
-            <a:spLocks noGrp="1" noRot="1" noChangeAspect="1"/>
-          </p:cNvSpPr>
-          <p:nvPr>
-            <p:ph type="sldImg" idx="2"/>
-          </p:nvPr>
-        </p:nvSpPr>
-        <p:spPr>
-          <a:xfrm>
-            <a:off x="685800" y="1143000"/>
-            <a:ext cx="5486400" cy="3086100"/>
-          </a:xfrm>
-          <a:prstGeom prst="rect">
-            <a:avLst/>
-          </a:prstGeom>
-          <a:noFill/>
-          <a:ln w="12700">
-            <a:solidFill>
-              <a:prstClr val="black"/>
-            </a:solidFill>
-          </a:ln>
-        </p:spPr>
-        <p:txBody>
-          <a:bodyPr vert="horz" lIns="91440" tIns="45720" rIns="91440" bIns="45720" rtlCol="0" anchor="ctr"/>
-          <a:lstStyle/>
-          <a:p>
-            <a:endParaRPr lang="en-US"/>
-          </a:p>
-        </p:txBody>
-      </p:sp>
-      <p:sp>
-        <p:nvSpPr>
-          <p:cNvPr id="5" name="Notes Placeholder 4"/>
-          <p:cNvSpPr>
-            <a:spLocks noGrp="1"/>
-          </p:cNvSpPr>
-          <p:nvPr>
-            <p:ph type="body" sz="quarter" idx="3"/>
-          </p:nvPr>
-        </p:nvSpPr>
-        <p:spPr>
-          <a:xfrm>
-            <a:off x="685800" y="4400550"/>
-            <a:ext cx="5486400" cy="3600450"/>
-          </a:xfrm>
-          <a:prstGeom prst="rect">
-            <a:avLst/>
-          </a:prstGeom>
-        </p:spPr>
-        <p:txBody>
-          <a:bodyPr vert="horz" lIns="91440" tIns="45720" rIns="91440" bIns="45720" rtlCol="0"/>
-          <a:lstStyle/>
-          <a:p>
-            <a:pPr lvl="0"/>
-            <a:r>
-              <a:rPr lang="en-US"/>
-              <a:t>Click to edit Master text styles</a:t>
-            </a:r>
-          </a:p>
-          <a:p>
-            <a:pPr lvl="1"/>
-            <a:r>
-              <a:rPr lang="en-US"/>
-              <a:t>Second level</a:t>
-            </a:r>
-          </a:p>
-          <a:p>
-            <a:pPr lvl="2"/>
-            <a:r>
-              <a:rPr lang="en-US"/>
-              <a:t>Third level</a:t>
-            </a:r>
-          </a:p>
-          <a:p>
-            <a:pPr lvl="3"/>
-            <a:r>
-              <a:rPr lang="en-US"/>
-              <a:t>Fourth level</a:t>
-            </a:r>
-          </a:p>
-          <a:p>
-            <a:pPr lvl="4"/>
-            <a:r>
-              <a:rPr lang="en-US"/>
-              <a:t>Fifth level</a:t>
-            </a:r>
-          </a:p>
-        </p:txBody>
-      </p:sp>
-      <p:sp>
-        <p:nvSpPr>
-          <p:cNvPr id="6" name="Footer Placeholder 5"/>
-          <p:cNvSpPr>
-            <a:spLocks noGrp="1"/>
-          </p:cNvSpPr>
-          <p:nvPr>
-            <p:ph type="ftr" sz="quarter" idx="4"/>
-          </p:nvPr>
-        </p:nvSpPr>
-        <p:spPr>
-          <a:xfrm>
-            <a:off x="0" y="8685213"/>
-            <a:ext cx="2971800" cy="458787"/>
-          </a:xfrm>
-          <a:prstGeom prst="rect">
-            <a:avLst/>
-          </a:prstGeom>
-        </p:spPr>
-        <p:txBody>
-          <a:bodyPr vert="horz" lIns="91440" tIns="45720" rIns="91440" bIns="45720" rtlCol="0" anchor="b"/>
-          <a:lstStyle>
-            <a:lvl1pPr algn="l">
-              <a:defRPr sz="1200"/>
-            </a:lvl1pPr>
-          </a:lstStyle>
-          <a:p>
-            <a:endParaRPr lang="en-US"/>
-          </a:p>
-        </p:txBody>
-      </p:sp>
-      <p:sp>
-        <p:nvSpPr>
-          <p:cNvPr id="7" name="Slide Number Placeholder 6"/>
-          <p:cNvSpPr>
-            <a:spLocks noGrp="1"/>
-          </p:cNvSpPr>
-          <p:nvPr>
-            <p:ph type="sldNum" sz="quarter" idx="5"/>
-          </p:nvPr>
-        </p:nvSpPr>
-        <p:spPr>
-          <a:xfrm>
-            <a:off x="3884613" y="8685213"/>
-            <a:ext cx="2971800" cy="458787"/>
-          </a:xfrm>
-          <a:prstGeom prst="rect">
-            <a:avLst/>
-          </a:prstGeom>
-        </p:spPr>
-        <p:txBody>
-          <a:bodyPr vert="horz" lIns="91440" tIns="45720" rIns="91440" bIns="45720" rtlCol="0" anchor="b"/>
-          <a:lstStyle>
-            <a:lvl1pPr algn="r">
-              <a:defRPr sz="1200"/>
-            </a:lvl1pPr>
-          </a:lstStyle>
-          <a:p>
-            <a:fld id="{CE5E9CC1-C706-0F49-92D6-E571CC5EEA8F}" type="slidenum">
-              <a:rPr lang="en-US"/>
-              <a:t>‹#›</a:t>
-            </a:fld>
-            <a:endParaRPr lang="en-US"/>
-          </a:p>
-        </p:txBody>
-      </p:sp>
     </p:spTree>
     <p:extLst>
       <p:ext uri="{BB962C8B-B14F-4D97-AF65-F5344CB8AC3E}">
-        <p14:creationId xmlns:p14="http://schemas.microsoft.com/office/powerpoint/2010/main" val="1024086991"/>
+        <p14:creationId xmlns:p14="http://schemas.microsoft.com/office/powerpoint/2010/main" val="2670897419"/>
       </p:ext>
     </p:extLst>
   </p:cSld>
@@ -509,10 +290,6 @@
           <a:bodyPr/>
           <a:lstStyle/>
           <a:p>
-            <a:r>
-              <a:rPr lang="en-US" dirty="0"/>
-              <a:t/>
-            </a:r>
             <a:endParaRPr lang="en-US" dirty="0"/>
           </a:p>
         </p:txBody>
@@ -597,10 +374,6 @@
           <a:bodyPr/>
           <a:lstStyle/>
           <a:p>
-            <a:r>
-              <a:rPr lang="en-US" dirty="0"/>
-              <a:t/>
-            </a:r>
             <a:endParaRPr lang="en-US" dirty="0"/>
           </a:p>
         </p:txBody>
@@ -685,10 +458,6 @@
           <a:bodyPr/>
           <a:lstStyle/>
           <a:p>
-            <a:r>
-              <a:rPr lang="en-US" dirty="0"/>
-              <a:t/>
-            </a:r>
             <a:endParaRPr lang="en-US" dirty="0"/>
           </a:p>
         </p:txBody>
@@ -773,10 +542,6 @@
           <a:bodyPr/>
           <a:lstStyle/>
           <a:p>
-            <a:r>
-              <a:rPr lang="en-US" dirty="0"/>
-              <a:t/>
-            </a:r>
             <a:endParaRPr lang="en-US" dirty="0"/>
           </a:p>
         </p:txBody>
@@ -861,10 +626,6 @@
           <a:bodyPr/>
           <a:lstStyle/>
           <a:p>
-            <a:r>
-              <a:rPr lang="en-US" dirty="0"/>
-              <a:t/>
-            </a:r>
             <a:endParaRPr lang="en-US" dirty="0"/>
           </a:p>
         </p:txBody>
@@ -949,10 +710,6 @@
           <a:bodyPr/>
           <a:lstStyle/>
           <a:p>
-            <a:r>
-              <a:rPr lang="en-US" dirty="0"/>
-              <a:t/>
-            </a:r>
             <a:endParaRPr lang="en-US" dirty="0"/>
           </a:p>
         </p:txBody>
@@ -1037,10 +794,6 @@
           <a:bodyPr/>
           <a:lstStyle/>
           <a:p>
-            <a:r>
-              <a:rPr lang="en-US" dirty="0"/>
-              <a:t/>
-            </a:r>
             <a:endParaRPr lang="en-US" dirty="0"/>
           </a:p>
         </p:txBody>
@@ -1125,10 +878,6 @@
           <a:bodyPr/>
           <a:lstStyle/>
           <a:p>
-            <a:r>
-              <a:rPr lang="en-US" dirty="0"/>
-              <a:t/>
-            </a:r>
             <a:endParaRPr lang="en-US" dirty="0"/>
           </a:p>
         </p:txBody>
@@ -1213,10 +962,6 @@
           <a:bodyPr/>
           <a:lstStyle/>
           <a:p>
-            <a:r>
-              <a:rPr lang="en-US" dirty="0"/>
-              <a:t/>
-            </a:r>
             <a:endParaRPr lang="en-US" dirty="0"/>
           </a:p>
         </p:txBody>
@@ -1301,10 +1046,6 @@
           <a:bodyPr/>
           <a:lstStyle/>
           <a:p>
-            <a:r>
-              <a:rPr lang="en-US" dirty="0"/>
-              <a:t/>
-            </a:r>
             <a:endParaRPr lang="en-US" dirty="0"/>
           </a:p>
         </p:txBody>
@@ -1378,6 +1119,11 @@
 <file path=ppt/slideMasters/slideMaster1.xml><?xml version="1.0" encoding="utf-8"?>
 <p:sldMaster xmlns:a="http://schemas.openxmlformats.org/drawingml/2006/main" xmlns:r="http://schemas.openxmlformats.org/officeDocument/2006/relationships" xmlns:p="http://schemas.openxmlformats.org/presentationml/2006/main">
   <p:cSld>
+    <p:bg>
+      <p:bgRef idx="1001">
+        <a:schemeClr val="bg1"/>
+      </p:bgRef>
+    </p:bg>
     <p:spTree>
       <p:nvGrpSpPr>
         <p:cNvPr id="1" name=""/>
@@ -1660,6 +1406,7 @@
         <a:solidFill>
           <a:srgbClr val="F4F6FB"/>
         </a:solidFill>
+        <a:effectLst/>
       </p:bgPr>
     </p:bg>
     <p:spTree>
@@ -1697,7 +1444,7 @@
           <a:bodyPr wrap="square" rtlCol="0" anchor="ctr"/>
           <a:lstStyle/>
           <a:p>
-            <a:pPr algn="ctr" indent="0" marL="0">
+            <a:pPr marL="0" indent="0" algn="ctr">
               <a:buNone/>
             </a:pPr>
             <a:r>
@@ -1733,7 +1480,7 @@
           <a:bodyPr wrap="square" rtlCol="0" anchor="ctr"/>
           <a:lstStyle/>
           <a:p>
-            <a:pPr algn="ctr" indent="0" marL="0">
+            <a:pPr marL="0" indent="0" algn="ctr">
               <a:buNone/>
             </a:pPr>
             <a:r>
@@ -1789,7 +1536,7 @@
           <a:bodyPr wrap="square" rtlCol="0" anchor="ctr"/>
           <a:lstStyle/>
           <a:p>
-            <a:pPr algn="ctr" indent="0" marL="0">
+            <a:pPr marL="0" indent="0" algn="ctr">
               <a:buNone/>
             </a:pPr>
             <a:r>
@@ -1820,6 +1567,7 @@
         <a:solidFill>
           <a:srgbClr val="F4F6FB"/>
         </a:solidFill>
+        <a:effectLst/>
       </p:bgPr>
     </p:bg>
     <p:spTree>
@@ -1897,7 +1645,7 @@
           <a:bodyPr wrap="square" rtlCol="0" anchor="ctr"/>
           <a:lstStyle/>
           <a:p>
-            <a:pPr algn="r" indent="0" marL="0">
+            <a:pPr marL="0" indent="0" algn="r">
               <a:buNone/>
             </a:pPr>
             <a:r>
@@ -1936,7 +1684,7 @@
           <a:bodyPr wrap="square" rtlCol="0" anchor="ctr"/>
           <a:lstStyle/>
           <a:p>
-            <a:pPr indent="0" marL="0">
+            <a:pPr marL="0" indent="0">
               <a:buNone/>
             </a:pPr>
             <a:r>
@@ -2019,7 +1767,7 @@
           <a:bodyPr wrap="square" rtlCol="0" anchor="ctr"/>
           <a:lstStyle/>
           <a:p>
-            <a:pPr indent="0" marL="0">
+            <a:pPr marL="0" indent="0">
               <a:buNone/>
             </a:pPr>
             <a:r>
@@ -2058,7 +1806,7 @@
           <a:bodyPr wrap="square" rtlCol="0" anchor="ctr"/>
           <a:lstStyle/>
           <a:p>
-            <a:pPr indent="0" marL="0">
+            <a:pPr marL="0" indent="0">
               <a:buNone/>
             </a:pPr>
             <a:r>
@@ -2094,7 +1842,7 @@
           <a:bodyPr wrap="square" rtlCol="0" anchor="ctr"/>
           <a:lstStyle/>
           <a:p>
-            <a:pPr indent="0" marL="0">
+            <a:pPr marL="0" indent="0">
               <a:buNone/>
             </a:pPr>
             <a:r>
@@ -2177,7 +1925,7 @@
           <a:bodyPr wrap="square" rtlCol="0" anchor="ctr"/>
           <a:lstStyle/>
           <a:p>
-            <a:pPr indent="0" marL="0">
+            <a:pPr marL="0" indent="0">
               <a:buNone/>
             </a:pPr>
             <a:r>
@@ -2216,7 +1964,7 @@
           <a:bodyPr wrap="square" rtlCol="0" anchor="ctr"/>
           <a:lstStyle/>
           <a:p>
-            <a:pPr indent="0" marL="0">
+            <a:pPr marL="0" indent="0">
               <a:buNone/>
             </a:pPr>
             <a:r>
@@ -2252,7 +2000,7 @@
           <a:bodyPr wrap="square" rtlCol="0" anchor="ctr"/>
           <a:lstStyle/>
           <a:p>
-            <a:pPr indent="0" marL="0">
+            <a:pPr marL="0" indent="0">
               <a:buNone/>
             </a:pPr>
             <a:r>
@@ -2335,7 +2083,7 @@
           <a:bodyPr wrap="square" rtlCol="0" anchor="ctr"/>
           <a:lstStyle/>
           <a:p>
-            <a:pPr indent="0" marL="0">
+            <a:pPr marL="0" indent="0">
               <a:buNone/>
             </a:pPr>
             <a:r>
@@ -2374,7 +2122,7 @@
           <a:bodyPr wrap="square" rtlCol="0" anchor="ctr"/>
           <a:lstStyle/>
           <a:p>
-            <a:pPr indent="0" marL="0">
+            <a:pPr marL="0" indent="0">
               <a:buNone/>
             </a:pPr>
             <a:r>
@@ -2410,7 +2158,7 @@
           <a:bodyPr wrap="square" rtlCol="0" anchor="ctr"/>
           <a:lstStyle/>
           <a:p>
-            <a:pPr indent="0" marL="0">
+            <a:pPr marL="0" indent="0">
               <a:buNone/>
             </a:pPr>
             <a:r>
@@ -2441,6 +2189,7 @@
         <a:solidFill>
           <a:srgbClr val="F4F6FB"/>
         </a:solidFill>
+        <a:effectLst/>
       </p:bgPr>
     </p:bg>
     <p:spTree>
@@ -2518,7 +2267,7 @@
           <a:bodyPr wrap="square" rtlCol="0" anchor="ctr"/>
           <a:lstStyle/>
           <a:p>
-            <a:pPr algn="r" indent="0" marL="0">
+            <a:pPr marL="0" indent="0" algn="r">
               <a:buNone/>
             </a:pPr>
             <a:r>
@@ -2557,7 +2306,7 @@
           <a:bodyPr wrap="square" rtlCol="0" anchor="ctr"/>
           <a:lstStyle/>
           <a:p>
-            <a:pPr indent="0" marL="0">
+            <a:pPr marL="0" indent="0">
               <a:buNone/>
             </a:pPr>
             <a:r>
@@ -2593,7 +2342,7 @@
           <a:bodyPr wrap="square" rtlCol="0" anchor="ctr"/>
           <a:lstStyle/>
           <a:p>
-            <a:pPr indent="0" marL="0">
+            <a:pPr marL="0" indent="0">
               <a:buNone/>
             </a:pPr>
             <a:r>
@@ -2676,7 +2425,7 @@
           <a:bodyPr wrap="square" rtlCol="0" anchor="ctr"/>
           <a:lstStyle/>
           <a:p>
-            <a:pPr indent="0" marL="0">
+            <a:pPr marL="0" indent="0">
               <a:buNone/>
             </a:pPr>
             <a:r>
@@ -2715,7 +2464,7 @@
           <a:bodyPr wrap="square" rtlCol="0" anchor="ctr"/>
           <a:lstStyle/>
           <a:p>
-            <a:pPr indent="0" marL="0">
+            <a:pPr marL="0" indent="0">
               <a:buNone/>
             </a:pPr>
             <a:r>
@@ -2751,7 +2500,7 @@
           <a:bodyPr wrap="square" rtlCol="0" anchor="ctr"/>
           <a:lstStyle/>
           <a:p>
-            <a:pPr indent="0" marL="0">
+            <a:pPr marL="0" indent="0">
               <a:lnSpc>
                 <a:spcPts val="2000"/>
               </a:lnSpc>
@@ -2768,7 +2517,7 @@
             <a:endParaRPr lang="en-US" sz="1200" dirty="0"/>
           </a:p>
           <a:p>
-            <a:pPr indent="0" marL="0">
+            <a:pPr marL="0" indent="0">
               <a:lnSpc>
                 <a:spcPts val="2000"/>
               </a:lnSpc>
@@ -2854,7 +2603,7 @@
           <a:bodyPr wrap="square" rtlCol="0" anchor="ctr"/>
           <a:lstStyle/>
           <a:p>
-            <a:pPr indent="0" marL="0">
+            <a:pPr marL="0" indent="0">
               <a:buNone/>
             </a:pPr>
             <a:r>
@@ -2893,7 +2642,7 @@
           <a:bodyPr wrap="square" rtlCol="0" anchor="ctr"/>
           <a:lstStyle/>
           <a:p>
-            <a:pPr indent="0" marL="0">
+            <a:pPr marL="0" indent="0">
               <a:buNone/>
             </a:pPr>
             <a:r>
@@ -2929,7 +2678,7 @@
           <a:bodyPr wrap="square" rtlCol="0" anchor="ctr"/>
           <a:lstStyle/>
           <a:p>
-            <a:pPr indent="0" marL="0">
+            <a:pPr marL="0" indent="0">
               <a:lnSpc>
                 <a:spcPts val="2000"/>
               </a:lnSpc>
@@ -2946,7 +2695,7 @@
             <a:endParaRPr lang="en-US" sz="1200" dirty="0"/>
           </a:p>
           <a:p>
-            <a:pPr indent="0" marL="0">
+            <a:pPr marL="0" indent="0">
               <a:lnSpc>
                 <a:spcPts val="2000"/>
               </a:lnSpc>
@@ -3032,7 +2781,7 @@
           <a:bodyPr wrap="square" rtlCol="0" anchor="ctr"/>
           <a:lstStyle/>
           <a:p>
-            <a:pPr indent="0" marL="0">
+            <a:pPr marL="0" indent="0">
               <a:buNone/>
             </a:pPr>
             <a:r>
@@ -3071,7 +2820,7 @@
           <a:bodyPr wrap="square" rtlCol="0" anchor="ctr"/>
           <a:lstStyle/>
           <a:p>
-            <a:pPr indent="0" marL="0">
+            <a:pPr marL="0" indent="0">
               <a:buNone/>
             </a:pPr>
             <a:r>
@@ -3107,7 +2856,7 @@
           <a:bodyPr wrap="square" rtlCol="0" anchor="ctr"/>
           <a:lstStyle/>
           <a:p>
-            <a:pPr indent="0" marL="0">
+            <a:pPr marL="0" indent="0">
               <a:lnSpc>
                 <a:spcPts val="2000"/>
               </a:lnSpc>
@@ -3124,7 +2873,7 @@
             <a:endParaRPr lang="en-US" sz="1200" dirty="0"/>
           </a:p>
           <a:p>
-            <a:pPr indent="0" marL="0">
+            <a:pPr marL="0" indent="0">
               <a:lnSpc>
                 <a:spcPts val="2000"/>
               </a:lnSpc>
@@ -3210,7 +2959,7 @@
           <a:bodyPr wrap="square" rtlCol="0" anchor="ctr"/>
           <a:lstStyle/>
           <a:p>
-            <a:pPr indent="0" marL="0">
+            <a:pPr marL="0" indent="0">
               <a:buNone/>
             </a:pPr>
             <a:r>
@@ -3249,7 +2998,7 @@
           <a:bodyPr wrap="square" rtlCol="0" anchor="ctr"/>
           <a:lstStyle/>
           <a:p>
-            <a:pPr indent="0" marL="0">
+            <a:pPr marL="0" indent="0">
               <a:buNone/>
             </a:pPr>
             <a:r>
@@ -3285,7 +3034,7 @@
           <a:bodyPr wrap="square" rtlCol="0" anchor="ctr"/>
           <a:lstStyle/>
           <a:p>
-            <a:pPr indent="0" marL="0">
+            <a:pPr marL="0" indent="0">
               <a:lnSpc>
                 <a:spcPts val="2000"/>
               </a:lnSpc>
@@ -3302,7 +3051,7 @@
             <a:endParaRPr lang="en-US" sz="1200" dirty="0"/>
           </a:p>
           <a:p>
-            <a:pPr indent="0" marL="0">
+            <a:pPr marL="0" indent="0">
               <a:lnSpc>
                 <a:spcPts val="2000"/>
               </a:lnSpc>
@@ -3336,6 +3085,7 @@
         <a:solidFill>
           <a:srgbClr val="F4F6FB"/>
         </a:solidFill>
+        <a:effectLst/>
       </p:bgPr>
     </p:bg>
     <p:spTree>
@@ -3413,7 +3163,7 @@
           <a:bodyPr wrap="square" rtlCol="0" anchor="ctr"/>
           <a:lstStyle/>
           <a:p>
-            <a:pPr algn="r" indent="0" marL="0">
+            <a:pPr marL="0" indent="0" algn="r">
               <a:buNone/>
             </a:pPr>
             <a:r>
@@ -3452,7 +3202,7 @@
           <a:bodyPr wrap="square" rtlCol="0" anchor="ctr"/>
           <a:lstStyle/>
           <a:p>
-            <a:pPr indent="0" marL="0">
+            <a:pPr marL="0" indent="0">
               <a:buNone/>
             </a:pPr>
             <a:r>
@@ -3488,7 +3238,7 @@
           <a:bodyPr wrap="square" rtlCol="0" anchor="ctr"/>
           <a:lstStyle/>
           <a:p>
-            <a:pPr indent="0" marL="0">
+            <a:pPr marL="0" indent="0">
               <a:buNone/>
             </a:pPr>
             <a:r>
@@ -3505,7 +3255,7 @@
       </p:sp>
       <p:graphicFrame>
         <p:nvGraphicFramePr>
-          <p:cNvPr id="4" name="Table 0"/>
+          <p:cNvPr id="7" name="Table 0"/>
           <p:cNvGraphicFramePr>
             <a:graphicFrameLocks noGrp="1"/>
           </p:cNvGraphicFramePr>
@@ -3526,12 +3276,48 @@
             <a:tbl>
               <a:tblPr/>
               <a:tblGrid>
-                <a:gridCol w="1920240"/>
-                <a:gridCol w="1920240"/>
-                <a:gridCol w="1920240"/>
-                <a:gridCol w="1920240"/>
-                <a:gridCol w="1920240"/>
-                <a:gridCol w="1920240"/>
+                <a:gridCol w="1920240">
+                  <a:extLst>
+                    <a:ext uri="{9D8B030D-6E8A-4147-A177-3AD203B41FA5}">
+                      <a16:colId xmlns:a16="http://schemas.microsoft.com/office/drawing/2014/main" val="20000"/>
+                    </a:ext>
+                  </a:extLst>
+                </a:gridCol>
+                <a:gridCol w="1920240">
+                  <a:extLst>
+                    <a:ext uri="{9D8B030D-6E8A-4147-A177-3AD203B41FA5}">
+                      <a16:colId xmlns:a16="http://schemas.microsoft.com/office/drawing/2014/main" val="20001"/>
+                    </a:ext>
+                  </a:extLst>
+                </a:gridCol>
+                <a:gridCol w="1920240">
+                  <a:extLst>
+                    <a:ext uri="{9D8B030D-6E8A-4147-A177-3AD203B41FA5}">
+                      <a16:colId xmlns:a16="http://schemas.microsoft.com/office/drawing/2014/main" val="20002"/>
+                    </a:ext>
+                  </a:extLst>
+                </a:gridCol>
+                <a:gridCol w="1920240">
+                  <a:extLst>
+                    <a:ext uri="{9D8B030D-6E8A-4147-A177-3AD203B41FA5}">
+                      <a16:colId xmlns:a16="http://schemas.microsoft.com/office/drawing/2014/main" val="20003"/>
+                    </a:ext>
+                  </a:extLst>
+                </a:gridCol>
+                <a:gridCol w="1920240">
+                  <a:extLst>
+                    <a:ext uri="{9D8B030D-6E8A-4147-A177-3AD203B41FA5}">
+                      <a16:colId xmlns:a16="http://schemas.microsoft.com/office/drawing/2014/main" val="20004"/>
+                    </a:ext>
+                  </a:extLst>
+                </a:gridCol>
+                <a:gridCol w="1920240">
+                  <a:extLst>
+                    <a:ext uri="{9D8B030D-6E8A-4147-A177-3AD203B41FA5}">
+                      <a16:colId xmlns:a16="http://schemas.microsoft.com/office/drawing/2014/main" val="20005"/>
+                    </a:ext>
+                  </a:extLst>
+                </a:gridCol>
               </a:tblGrid>
               <a:tr h="384048">
                 <a:tc>
@@ -3539,7 +3325,7 @@
                     <a:bodyPr/>
                     <a:lstStyle/>
                     <a:p>
-                      <a:pPr algn="l" indent="0" marL="0">
+                      <a:pPr marL="0" indent="0" algn="l">
                         <a:buNone/>
                       </a:pPr>
                       <a:r>
@@ -3600,7 +3386,7 @@
                     <a:bodyPr/>
                     <a:lstStyle/>
                     <a:p>
-                      <a:pPr algn="ctr" indent="0" marL="0">
+                      <a:pPr marL="0" indent="0" algn="ctr">
                         <a:buNone/>
                       </a:pPr>
                       <a:r>
@@ -3661,7 +3447,7 @@
                     <a:bodyPr/>
                     <a:lstStyle/>
                     <a:p>
-                      <a:pPr algn="ctr" indent="0" marL="0">
+                      <a:pPr marL="0" indent="0" algn="ctr">
                         <a:buNone/>
                       </a:pPr>
                       <a:r>
@@ -3722,7 +3508,7 @@
                     <a:bodyPr/>
                     <a:lstStyle/>
                     <a:p>
-                      <a:pPr algn="ctr" indent="0" marL="0">
+                      <a:pPr marL="0" indent="0" algn="ctr">
                         <a:buNone/>
                       </a:pPr>
                       <a:r>
@@ -3783,7 +3569,7 @@
                     <a:bodyPr/>
                     <a:lstStyle/>
                     <a:p>
-                      <a:pPr algn="ctr" indent="0" marL="0">
+                      <a:pPr marL="0" indent="0" algn="ctr">
                         <a:buNone/>
                       </a:pPr>
                       <a:r>
@@ -3844,7 +3630,7 @@
                     <a:bodyPr/>
                     <a:lstStyle/>
                     <a:p>
-                      <a:pPr algn="ctr" indent="0" marL="0">
+                      <a:pPr marL="0" indent="0" algn="ctr">
                         <a:buNone/>
                       </a:pPr>
                       <a:r>
@@ -3900,6 +3686,11 @@
                     </a:solidFill>
                   </a:tcPr>
                 </a:tc>
+                <a:extLst>
+                  <a:ext uri="{0D108BD9-81ED-4DB2-BD59-A6C34878D82A}">
+                    <a16:rowId xmlns:a16="http://schemas.microsoft.com/office/drawing/2014/main" val="10000"/>
+                  </a:ext>
+                </a:extLst>
               </a:tr>
               <a:tr h="384048">
                 <a:tc>
@@ -3907,7 +3698,7 @@
                     <a:bodyPr/>
                     <a:lstStyle/>
                     <a:p>
-                      <a:pPr algn="l" indent="0" marL="0">
+                      <a:pPr marL="0" indent="0" algn="l">
                         <a:buNone/>
                       </a:pPr>
                       <a:r>
@@ -3968,7 +3759,7 @@
                     <a:bodyPr/>
                     <a:lstStyle/>
                     <a:p>
-                      <a:pPr algn="ctr" indent="0" marL="0">
+                      <a:pPr marL="0" indent="0" algn="ctr">
                         <a:buNone/>
                       </a:pPr>
                       <a:r>
@@ -4029,7 +3820,7 @@
                     <a:bodyPr/>
                     <a:lstStyle/>
                     <a:p>
-                      <a:pPr algn="ctr" indent="0" marL="0">
+                      <a:pPr marL="0" indent="0" algn="ctr">
                         <a:buNone/>
                       </a:pPr>
                       <a:r>
@@ -4090,7 +3881,7 @@
                     <a:bodyPr/>
                     <a:lstStyle/>
                     <a:p>
-                      <a:pPr algn="ctr" indent="0" marL="0">
+                      <a:pPr marL="0" indent="0" algn="ctr">
                         <a:buNone/>
                       </a:pPr>
                       <a:r>
@@ -4151,7 +3942,7 @@
                     <a:bodyPr/>
                     <a:lstStyle/>
                     <a:p>
-                      <a:pPr algn="ctr" indent="0" marL="0">
+                      <a:pPr marL="0" indent="0" algn="ctr">
                         <a:buNone/>
                       </a:pPr>
                       <a:r>
@@ -4212,7 +4003,7 @@
                     <a:bodyPr/>
                     <a:lstStyle/>
                     <a:p>
-                      <a:pPr algn="ctr" indent="0" marL="0">
+                      <a:pPr marL="0" indent="0" algn="ctr">
                         <a:buNone/>
                       </a:pPr>
                       <a:r>
@@ -4268,6 +4059,11 @@
                     </a:solidFill>
                   </a:tcPr>
                 </a:tc>
+                <a:extLst>
+                  <a:ext uri="{0D108BD9-81ED-4DB2-BD59-A6C34878D82A}">
+                    <a16:rowId xmlns:a16="http://schemas.microsoft.com/office/drawing/2014/main" val="10001"/>
+                  </a:ext>
+                </a:extLst>
               </a:tr>
               <a:tr h="384048">
                 <a:tc>
@@ -4275,7 +4071,7 @@
                     <a:bodyPr/>
                     <a:lstStyle/>
                     <a:p>
-                      <a:pPr algn="l" indent="0" marL="0">
+                      <a:pPr marL="0" indent="0" algn="l">
                         <a:buNone/>
                       </a:pPr>
                       <a:r>
@@ -4336,7 +4132,7 @@
                     <a:bodyPr/>
                     <a:lstStyle/>
                     <a:p>
-                      <a:pPr algn="ctr" indent="0" marL="0">
+                      <a:pPr marL="0" indent="0" algn="ctr">
                         <a:buNone/>
                       </a:pPr>
                       <a:r>
@@ -4397,7 +4193,7 @@
                     <a:bodyPr/>
                     <a:lstStyle/>
                     <a:p>
-                      <a:pPr algn="ctr" indent="0" marL="0">
+                      <a:pPr marL="0" indent="0" algn="ctr">
                         <a:buNone/>
                       </a:pPr>
                       <a:r>
@@ -4458,7 +4254,7 @@
                     <a:bodyPr/>
                     <a:lstStyle/>
                     <a:p>
-                      <a:pPr algn="ctr" indent="0" marL="0">
+                      <a:pPr marL="0" indent="0" algn="ctr">
                         <a:buNone/>
                       </a:pPr>
                       <a:r>
@@ -4519,7 +4315,7 @@
                     <a:bodyPr/>
                     <a:lstStyle/>
                     <a:p>
-                      <a:pPr algn="ctr" indent="0" marL="0">
+                      <a:pPr marL="0" indent="0" algn="ctr">
                         <a:buNone/>
                       </a:pPr>
                       <a:r>
@@ -4580,7 +4376,7 @@
                     <a:bodyPr/>
                     <a:lstStyle/>
                     <a:p>
-                      <a:pPr algn="ctr" indent="0" marL="0">
+                      <a:pPr marL="0" indent="0" algn="ctr">
                         <a:buNone/>
                       </a:pPr>
                       <a:r>
@@ -4636,6 +4432,11 @@
                     </a:solidFill>
                   </a:tcPr>
                 </a:tc>
+                <a:extLst>
+                  <a:ext uri="{0D108BD9-81ED-4DB2-BD59-A6C34878D82A}">
+                    <a16:rowId xmlns:a16="http://schemas.microsoft.com/office/drawing/2014/main" val="10002"/>
+                  </a:ext>
+                </a:extLst>
               </a:tr>
               <a:tr h="384048">
                 <a:tc>
@@ -4643,7 +4444,7 @@
                     <a:bodyPr/>
                     <a:lstStyle/>
                     <a:p>
-                      <a:pPr algn="l" indent="0" marL="0">
+                      <a:pPr marL="0" indent="0" algn="l">
                         <a:buNone/>
                       </a:pPr>
                       <a:r>
@@ -4704,7 +4505,7 @@
                     <a:bodyPr/>
                     <a:lstStyle/>
                     <a:p>
-                      <a:pPr algn="ctr" indent="0" marL="0">
+                      <a:pPr marL="0" indent="0" algn="ctr">
                         <a:buNone/>
                       </a:pPr>
                       <a:r>
@@ -4765,7 +4566,7 @@
                     <a:bodyPr/>
                     <a:lstStyle/>
                     <a:p>
-                      <a:pPr algn="ctr" indent="0" marL="0">
+                      <a:pPr marL="0" indent="0" algn="ctr">
                         <a:buNone/>
                       </a:pPr>
                       <a:r>
@@ -4826,7 +4627,7 @@
                     <a:bodyPr/>
                     <a:lstStyle/>
                     <a:p>
-                      <a:pPr algn="ctr" indent="0" marL="0">
+                      <a:pPr marL="0" indent="0" algn="ctr">
                         <a:buNone/>
                       </a:pPr>
                       <a:r>
@@ -4887,7 +4688,7 @@
                     <a:bodyPr/>
                     <a:lstStyle/>
                     <a:p>
-                      <a:pPr algn="ctr" indent="0" marL="0">
+                      <a:pPr marL="0" indent="0" algn="ctr">
                         <a:buNone/>
                       </a:pPr>
                       <a:r>
@@ -4948,7 +4749,7 @@
                     <a:bodyPr/>
                     <a:lstStyle/>
                     <a:p>
-                      <a:pPr algn="ctr" indent="0" marL="0">
+                      <a:pPr marL="0" indent="0" algn="ctr">
                         <a:buNone/>
                       </a:pPr>
                       <a:r>
@@ -5004,6 +4805,11 @@
                     </a:solidFill>
                   </a:tcPr>
                 </a:tc>
+                <a:extLst>
+                  <a:ext uri="{0D108BD9-81ED-4DB2-BD59-A6C34878D82A}">
+                    <a16:rowId xmlns:a16="http://schemas.microsoft.com/office/drawing/2014/main" val="10003"/>
+                  </a:ext>
+                </a:extLst>
               </a:tr>
               <a:tr h="384048">
                 <a:tc>
@@ -5011,7 +4817,7 @@
                     <a:bodyPr/>
                     <a:lstStyle/>
                     <a:p>
-                      <a:pPr algn="l" indent="0" marL="0">
+                      <a:pPr marL="0" indent="0" algn="l">
                         <a:buNone/>
                       </a:pPr>
                       <a:r>
@@ -5072,7 +4878,7 @@
                     <a:bodyPr/>
                     <a:lstStyle/>
                     <a:p>
-                      <a:pPr algn="ctr" indent="0" marL="0">
+                      <a:pPr marL="0" indent="0" algn="ctr">
                         <a:buNone/>
                       </a:pPr>
                       <a:r>
@@ -5133,7 +4939,7 @@
                     <a:bodyPr/>
                     <a:lstStyle/>
                     <a:p>
-                      <a:pPr algn="ctr" indent="0" marL="0">
+                      <a:pPr marL="0" indent="0" algn="ctr">
                         <a:buNone/>
                       </a:pPr>
                       <a:r>
@@ -5194,7 +5000,7 @@
                     <a:bodyPr/>
                     <a:lstStyle/>
                     <a:p>
-                      <a:pPr algn="ctr" indent="0" marL="0">
+                      <a:pPr marL="0" indent="0" algn="ctr">
                         <a:buNone/>
                       </a:pPr>
                       <a:r>
@@ -5255,7 +5061,7 @@
                     <a:bodyPr/>
                     <a:lstStyle/>
                     <a:p>
-                      <a:pPr algn="ctr" indent="0" marL="0">
+                      <a:pPr marL="0" indent="0" algn="ctr">
                         <a:buNone/>
                       </a:pPr>
                       <a:r>
@@ -5316,7 +5122,7 @@
                     <a:bodyPr/>
                     <a:lstStyle/>
                     <a:p>
-                      <a:pPr algn="ctr" indent="0" marL="0">
+                      <a:pPr marL="0" indent="0" algn="ctr">
                         <a:buNone/>
                       </a:pPr>
                       <a:r>
@@ -5372,6 +5178,11 @@
                     </a:solidFill>
                   </a:tcPr>
                 </a:tc>
+                <a:extLst>
+                  <a:ext uri="{0D108BD9-81ED-4DB2-BD59-A6C34878D82A}">
+                    <a16:rowId xmlns:a16="http://schemas.microsoft.com/office/drawing/2014/main" val="10004"/>
+                  </a:ext>
+                </a:extLst>
               </a:tr>
               <a:tr h="384048">
                 <a:tc>
@@ -5379,7 +5190,7 @@
                     <a:bodyPr/>
                     <a:lstStyle/>
                     <a:p>
-                      <a:pPr algn="l" indent="0" marL="0">
+                      <a:pPr marL="0" indent="0" algn="l">
                         <a:buNone/>
                       </a:pPr>
                       <a:r>
@@ -5440,7 +5251,7 @@
                     <a:bodyPr/>
                     <a:lstStyle/>
                     <a:p>
-                      <a:pPr algn="ctr" indent="0" marL="0">
+                      <a:pPr marL="0" indent="0" algn="ctr">
                         <a:buNone/>
                       </a:pPr>
                       <a:r>
@@ -5501,7 +5312,7 @@
                     <a:bodyPr/>
                     <a:lstStyle/>
                     <a:p>
-                      <a:pPr algn="ctr" indent="0" marL="0">
+                      <a:pPr marL="0" indent="0" algn="ctr">
                         <a:buNone/>
                       </a:pPr>
                       <a:r>
@@ -5562,7 +5373,7 @@
                     <a:bodyPr/>
                     <a:lstStyle/>
                     <a:p>
-                      <a:pPr algn="ctr" indent="0" marL="0">
+                      <a:pPr marL="0" indent="0" algn="ctr">
                         <a:buNone/>
                       </a:pPr>
                       <a:r>
@@ -5623,7 +5434,7 @@
                     <a:bodyPr/>
                     <a:lstStyle/>
                     <a:p>
-                      <a:pPr algn="ctr" indent="0" marL="0">
+                      <a:pPr marL="0" indent="0" algn="ctr">
                         <a:buNone/>
                       </a:pPr>
                       <a:r>
@@ -5684,7 +5495,7 @@
                     <a:bodyPr/>
                     <a:lstStyle/>
                     <a:p>
-                      <a:pPr algn="ctr" indent="0" marL="0">
+                      <a:pPr marL="0" indent="0" algn="ctr">
                         <a:buNone/>
                       </a:pPr>
                       <a:r>
@@ -5740,6 +5551,11 @@
                     </a:solidFill>
                   </a:tcPr>
                 </a:tc>
+                <a:extLst>
+                  <a:ext uri="{0D108BD9-81ED-4DB2-BD59-A6C34878D82A}">
+                    <a16:rowId xmlns:a16="http://schemas.microsoft.com/office/drawing/2014/main" val="10005"/>
+                  </a:ext>
+                </a:extLst>
               </a:tr>
               <a:tr h="384048">
                 <a:tc>
@@ -5747,7 +5563,7 @@
                     <a:bodyPr/>
                     <a:lstStyle/>
                     <a:p>
-                      <a:pPr algn="l" indent="0" marL="0">
+                      <a:pPr marL="0" indent="0" algn="l">
                         <a:buNone/>
                       </a:pPr>
                       <a:r>
@@ -5808,7 +5624,7 @@
                     <a:bodyPr/>
                     <a:lstStyle/>
                     <a:p>
-                      <a:pPr algn="ctr" indent="0" marL="0">
+                      <a:pPr marL="0" indent="0" algn="ctr">
                         <a:buNone/>
                       </a:pPr>
                       <a:r>
@@ -5869,7 +5685,7 @@
                     <a:bodyPr/>
                     <a:lstStyle/>
                     <a:p>
-                      <a:pPr algn="ctr" indent="0" marL="0">
+                      <a:pPr marL="0" indent="0" algn="ctr">
                         <a:buNone/>
                       </a:pPr>
                       <a:r>
@@ -5930,7 +5746,7 @@
                     <a:bodyPr/>
                     <a:lstStyle/>
                     <a:p>
-                      <a:pPr algn="ctr" indent="0" marL="0">
+                      <a:pPr marL="0" indent="0" algn="ctr">
                         <a:buNone/>
                       </a:pPr>
                       <a:r>
@@ -5991,7 +5807,7 @@
                     <a:bodyPr/>
                     <a:lstStyle/>
                     <a:p>
-                      <a:pPr algn="ctr" indent="0" marL="0">
+                      <a:pPr marL="0" indent="0" algn="ctr">
                         <a:buNone/>
                       </a:pPr>
                       <a:r>
@@ -6052,7 +5868,7 @@
                     <a:bodyPr/>
                     <a:lstStyle/>
                     <a:p>
-                      <a:pPr algn="ctr" indent="0" marL="0">
+                      <a:pPr marL="0" indent="0" algn="ctr">
                         <a:buNone/>
                       </a:pPr>
                       <a:r>
@@ -6108,6 +5924,11 @@
                     </a:solidFill>
                   </a:tcPr>
                 </a:tc>
+                <a:extLst>
+                  <a:ext uri="{0D108BD9-81ED-4DB2-BD59-A6C34878D82A}">
+                    <a16:rowId xmlns:a16="http://schemas.microsoft.com/office/drawing/2014/main" val="10006"/>
+                  </a:ext>
+                </a:extLst>
               </a:tr>
             </a:tbl>
           </a:graphicData>
@@ -6193,6 +6014,7 @@
         <a:solidFill>
           <a:srgbClr val="F4F6FB"/>
         </a:solidFill>
+        <a:effectLst/>
       </p:bgPr>
     </p:bg>
     <p:spTree>
@@ -6270,7 +6092,7 @@
           <a:bodyPr wrap="square" rtlCol="0" anchor="ctr"/>
           <a:lstStyle/>
           <a:p>
-            <a:pPr algn="r" indent="0" marL="0">
+            <a:pPr marL="0" indent="0" algn="r">
               <a:buNone/>
             </a:pPr>
             <a:r>
@@ -6309,7 +6131,7 @@
           <a:bodyPr wrap="square" rtlCol="0" anchor="ctr"/>
           <a:lstStyle/>
           <a:p>
-            <a:pPr indent="0" marL="0">
+            <a:pPr marL="0" indent="0">
               <a:buNone/>
             </a:pPr>
             <a:r>
@@ -6345,7 +6167,7 @@
           <a:bodyPr wrap="square" rtlCol="0" anchor="ctr"/>
           <a:lstStyle/>
           <a:p>
-            <a:pPr indent="0" marL="0">
+            <a:pPr marL="0" indent="0">
               <a:buNone/>
             </a:pPr>
             <a:r>
@@ -6428,7 +6250,7 @@
           <a:bodyPr wrap="square" rtlCol="0" anchor="ctr"/>
           <a:lstStyle/>
           <a:p>
-            <a:pPr indent="0" marL="0">
+            <a:pPr marL="0" indent="0">
               <a:buNone/>
             </a:pPr>
             <a:r>
@@ -6467,7 +6289,7 @@
           <a:bodyPr wrap="square" rtlCol="0" anchor="ctr"/>
           <a:lstStyle/>
           <a:p>
-            <a:pPr indent="0" marL="0">
+            <a:pPr marL="0" indent="0">
               <a:buNone/>
             </a:pPr>
             <a:r>
@@ -6635,7 +6457,7 @@
           <a:bodyPr wrap="square" rtlCol="0" anchor="ctr"/>
           <a:lstStyle/>
           <a:p>
-            <a:pPr indent="0" marL="0">
+            <a:pPr marL="0" indent="0">
               <a:buNone/>
             </a:pPr>
             <a:r>
@@ -6674,7 +6496,7 @@
           <a:bodyPr wrap="square" rtlCol="0" anchor="ctr"/>
           <a:lstStyle/>
           <a:p>
-            <a:pPr indent="0" marL="0">
+            <a:pPr marL="0" indent="0">
               <a:buNone/>
             </a:pPr>
             <a:r>
@@ -6842,7 +6664,7 @@
           <a:bodyPr wrap="square" rtlCol="0" anchor="ctr"/>
           <a:lstStyle/>
           <a:p>
-            <a:pPr indent="0" marL="0">
+            <a:pPr marL="0" indent="0">
               <a:buNone/>
             </a:pPr>
             <a:r>
@@ -6881,7 +6703,7 @@
           <a:bodyPr wrap="square" rtlCol="0" anchor="ctr"/>
           <a:lstStyle/>
           <a:p>
-            <a:pPr indent="0" marL="0">
+            <a:pPr marL="0" indent="0">
               <a:buNone/>
             </a:pPr>
             <a:r>
@@ -6997,6 +6819,7 @@
         <a:solidFill>
           <a:srgbClr val="F4F6FB"/>
         </a:solidFill>
+        <a:effectLst/>
       </p:bgPr>
     </p:bg>
     <p:spTree>
@@ -7074,7 +6897,7 @@
           <a:bodyPr wrap="square" rtlCol="0" anchor="ctr"/>
           <a:lstStyle/>
           <a:p>
-            <a:pPr algn="r" indent="0" marL="0">
+            <a:pPr marL="0" indent="0" algn="r">
               <a:buNone/>
             </a:pPr>
             <a:r>
@@ -7113,7 +6936,7 @@
           <a:bodyPr wrap="square" rtlCol="0" anchor="ctr"/>
           <a:lstStyle/>
           <a:p>
-            <a:pPr indent="0" marL="0">
+            <a:pPr marL="0" indent="0">
               <a:buNone/>
             </a:pPr>
             <a:r>
@@ -7149,7 +6972,7 @@
           <a:bodyPr wrap="square" rtlCol="0" anchor="ctr"/>
           <a:lstStyle/>
           <a:p>
-            <a:pPr indent="0" marL="0">
+            <a:pPr marL="0" indent="0">
               <a:buNone/>
             </a:pPr>
             <a:r>
@@ -7185,7 +7008,7 @@
           <a:bodyPr wrap="square" rtlCol="0" anchor="ctr"/>
           <a:lstStyle/>
           <a:p>
-            <a:pPr algn="ctr" indent="0" marL="0">
+            <a:pPr marL="0" indent="0" algn="ctr">
               <a:buNone/>
             </a:pPr>
             <a:r>
@@ -7224,7 +7047,7 @@
           <a:bodyPr wrap="square" rtlCol="0" anchor="ctr"/>
           <a:lstStyle/>
           <a:p>
-            <a:pPr algn="ctr" indent="0" marL="0">
+            <a:pPr marL="0" indent="0" algn="ctr">
               <a:buNone/>
             </a:pPr>
             <a:r>
@@ -7260,7 +7083,7 @@
           <a:bodyPr wrap="square" rtlCol="0" anchor="ctr"/>
           <a:lstStyle/>
           <a:p>
-            <a:pPr algn="ctr" indent="0" marL="0">
+            <a:pPr marL="0" indent="0" algn="ctr">
               <a:buNone/>
             </a:pPr>
             <a:r>
@@ -7299,7 +7122,7 @@
           <a:bodyPr wrap="square" rtlCol="0" anchor="ctr"/>
           <a:lstStyle/>
           <a:p>
-            <a:pPr algn="ctr" indent="0" marL="0">
+            <a:pPr marL="0" indent="0" algn="ctr">
               <a:buNone/>
             </a:pPr>
             <a:r>
@@ -7335,7 +7158,7 @@
           <a:bodyPr wrap="square" rtlCol="0" anchor="ctr"/>
           <a:lstStyle/>
           <a:p>
-            <a:pPr algn="ctr" indent="0" marL="0">
+            <a:pPr marL="0" indent="0" algn="ctr">
               <a:buNone/>
             </a:pPr>
             <a:r>
@@ -7374,7 +7197,7 @@
           <a:bodyPr wrap="square" rtlCol="0" anchor="ctr"/>
           <a:lstStyle/>
           <a:p>
-            <a:pPr algn="ctr" indent="0" marL="0">
+            <a:pPr marL="0" indent="0" algn="ctr">
               <a:buNone/>
             </a:pPr>
             <a:r>
@@ -7410,7 +7233,7 @@
           <a:bodyPr wrap="square" rtlCol="0" anchor="ctr"/>
           <a:lstStyle/>
           <a:p>
-            <a:pPr algn="ctr" indent="0" marL="0">
+            <a:pPr marL="0" indent="0" algn="ctr">
               <a:buNone/>
             </a:pPr>
             <a:r>
@@ -7449,7 +7272,7 @@
           <a:bodyPr wrap="square" rtlCol="0" anchor="ctr"/>
           <a:lstStyle/>
           <a:p>
-            <a:pPr algn="ctr" indent="0" marL="0">
+            <a:pPr marL="0" indent="0" algn="ctr">
               <a:buNone/>
             </a:pPr>
             <a:r>
@@ -7466,7 +7289,7 @@
       </p:sp>
       <p:graphicFrame>
         <p:nvGraphicFramePr>
-          <p:cNvPr id="6" name="Table 0"/>
+          <p:cNvPr id="15" name="Table 0"/>
           <p:cNvGraphicFramePr>
             <a:graphicFrameLocks noGrp="1"/>
           </p:cNvGraphicFramePr>
@@ -7487,10 +7310,34 @@
             <a:tbl>
               <a:tblPr/>
               <a:tblGrid>
-                <a:gridCol w="2880360"/>
-                <a:gridCol w="2880360"/>
-                <a:gridCol w="2880360"/>
-                <a:gridCol w="2880360"/>
+                <a:gridCol w="2880360">
+                  <a:extLst>
+                    <a:ext uri="{9D8B030D-6E8A-4147-A177-3AD203B41FA5}">
+                      <a16:colId xmlns:a16="http://schemas.microsoft.com/office/drawing/2014/main" val="20000"/>
+                    </a:ext>
+                  </a:extLst>
+                </a:gridCol>
+                <a:gridCol w="2880360">
+                  <a:extLst>
+                    <a:ext uri="{9D8B030D-6E8A-4147-A177-3AD203B41FA5}">
+                      <a16:colId xmlns:a16="http://schemas.microsoft.com/office/drawing/2014/main" val="20001"/>
+                    </a:ext>
+                  </a:extLst>
+                </a:gridCol>
+                <a:gridCol w="2880360">
+                  <a:extLst>
+                    <a:ext uri="{9D8B030D-6E8A-4147-A177-3AD203B41FA5}">
+                      <a16:colId xmlns:a16="http://schemas.microsoft.com/office/drawing/2014/main" val="20002"/>
+                    </a:ext>
+                  </a:extLst>
+                </a:gridCol>
+                <a:gridCol w="2880360">
+                  <a:extLst>
+                    <a:ext uri="{9D8B030D-6E8A-4147-A177-3AD203B41FA5}">
+                      <a16:colId xmlns:a16="http://schemas.microsoft.com/office/drawing/2014/main" val="20003"/>
+                    </a:ext>
+                  </a:extLst>
+                </a:gridCol>
               </a:tblGrid>
               <a:tr h="384048">
                 <a:tc>
@@ -7498,7 +7345,7 @@
                     <a:bodyPr/>
                     <a:lstStyle/>
                     <a:p>
-                      <a:pPr algn="l" indent="0" marL="0">
+                      <a:pPr marL="0" indent="0" algn="l">
                         <a:buNone/>
                       </a:pPr>
                       <a:r>
@@ -7559,7 +7406,7 @@
                     <a:bodyPr/>
                     <a:lstStyle/>
                     <a:p>
-                      <a:pPr algn="ctr" indent="0" marL="0">
+                      <a:pPr marL="0" indent="0" algn="ctr">
                         <a:buNone/>
                       </a:pPr>
                       <a:r>
@@ -7620,7 +7467,7 @@
                     <a:bodyPr/>
                     <a:lstStyle/>
                     <a:p>
-                      <a:pPr algn="ctr" indent="0" marL="0">
+                      <a:pPr marL="0" indent="0" algn="ctr">
                         <a:buNone/>
                       </a:pPr>
                       <a:r>
@@ -7681,7 +7528,7 @@
                     <a:bodyPr/>
                     <a:lstStyle/>
                     <a:p>
-                      <a:pPr algn="ctr" indent="0" marL="0">
+                      <a:pPr marL="0" indent="0" algn="ctr">
                         <a:buNone/>
                       </a:pPr>
                       <a:r>
@@ -7737,6 +7584,11 @@
                     </a:solidFill>
                   </a:tcPr>
                 </a:tc>
+                <a:extLst>
+                  <a:ext uri="{0D108BD9-81ED-4DB2-BD59-A6C34878D82A}">
+                    <a16:rowId xmlns:a16="http://schemas.microsoft.com/office/drawing/2014/main" val="10000"/>
+                  </a:ext>
+                </a:extLst>
               </a:tr>
               <a:tr h="384048">
                 <a:tc>
@@ -7744,7 +7596,7 @@
                     <a:bodyPr/>
                     <a:lstStyle/>
                     <a:p>
-                      <a:pPr algn="l" indent="0" marL="0">
+                      <a:pPr marL="0" indent="0" algn="l">
                         <a:buNone/>
                       </a:pPr>
                       <a:r>
@@ -7805,7 +7657,7 @@
                     <a:bodyPr/>
                     <a:lstStyle/>
                     <a:p>
-                      <a:pPr algn="ctr" indent="0" marL="0">
+                      <a:pPr marL="0" indent="0" algn="ctr">
                         <a:buNone/>
                       </a:pPr>
                       <a:r>
@@ -7866,7 +7718,7 @@
                     <a:bodyPr/>
                     <a:lstStyle/>
                     <a:p>
-                      <a:pPr algn="ctr" indent="0" marL="0">
+                      <a:pPr marL="0" indent="0" algn="ctr">
                         <a:buNone/>
                       </a:pPr>
                       <a:r>
@@ -7927,7 +7779,7 @@
                     <a:bodyPr/>
                     <a:lstStyle/>
                     <a:p>
-                      <a:pPr algn="ctr" indent="0" marL="0">
+                      <a:pPr marL="0" indent="0" algn="ctr">
                         <a:buNone/>
                       </a:pPr>
                       <a:r>
@@ -7983,6 +7835,11 @@
                     </a:solidFill>
                   </a:tcPr>
                 </a:tc>
+                <a:extLst>
+                  <a:ext uri="{0D108BD9-81ED-4DB2-BD59-A6C34878D82A}">
+                    <a16:rowId xmlns:a16="http://schemas.microsoft.com/office/drawing/2014/main" val="10001"/>
+                  </a:ext>
+                </a:extLst>
               </a:tr>
               <a:tr h="384048">
                 <a:tc>
@@ -7990,7 +7847,7 @@
                     <a:bodyPr/>
                     <a:lstStyle/>
                     <a:p>
-                      <a:pPr algn="l" indent="0" marL="0">
+                      <a:pPr marL="0" indent="0" algn="l">
                         <a:buNone/>
                       </a:pPr>
                       <a:r>
@@ -8051,7 +7908,7 @@
                     <a:bodyPr/>
                     <a:lstStyle/>
                     <a:p>
-                      <a:pPr algn="ctr" indent="0" marL="0">
+                      <a:pPr marL="0" indent="0" algn="ctr">
                         <a:buNone/>
                       </a:pPr>
                       <a:r>
@@ -8112,7 +7969,7 @@
                     <a:bodyPr/>
                     <a:lstStyle/>
                     <a:p>
-                      <a:pPr algn="ctr" indent="0" marL="0">
+                      <a:pPr marL="0" indent="0" algn="ctr">
                         <a:buNone/>
                       </a:pPr>
                       <a:r>
@@ -8173,7 +8030,7 @@
                     <a:bodyPr/>
                     <a:lstStyle/>
                     <a:p>
-                      <a:pPr algn="ctr" indent="0" marL="0">
+                      <a:pPr marL="0" indent="0" algn="ctr">
                         <a:buNone/>
                       </a:pPr>
                       <a:r>
@@ -8229,6 +8086,11 @@
                     </a:solidFill>
                   </a:tcPr>
                 </a:tc>
+                <a:extLst>
+                  <a:ext uri="{0D108BD9-81ED-4DB2-BD59-A6C34878D82A}">
+                    <a16:rowId xmlns:a16="http://schemas.microsoft.com/office/drawing/2014/main" val="10002"/>
+                  </a:ext>
+                </a:extLst>
               </a:tr>
               <a:tr h="384048">
                 <a:tc>
@@ -8236,7 +8098,7 @@
                     <a:bodyPr/>
                     <a:lstStyle/>
                     <a:p>
-                      <a:pPr algn="l" indent="0" marL="0">
+                      <a:pPr marL="0" indent="0" algn="l">
                         <a:buNone/>
                       </a:pPr>
                       <a:r>
@@ -8297,7 +8159,7 @@
                     <a:bodyPr/>
                     <a:lstStyle/>
                     <a:p>
-                      <a:pPr algn="ctr" indent="0" marL="0">
+                      <a:pPr marL="0" indent="0" algn="ctr">
                         <a:buNone/>
                       </a:pPr>
                       <a:r>
@@ -8358,7 +8220,7 @@
                     <a:bodyPr/>
                     <a:lstStyle/>
                     <a:p>
-                      <a:pPr algn="ctr" indent="0" marL="0">
+                      <a:pPr marL="0" indent="0" algn="ctr">
                         <a:buNone/>
                       </a:pPr>
                       <a:r>
@@ -8419,7 +8281,7 @@
                     <a:bodyPr/>
                     <a:lstStyle/>
                     <a:p>
-                      <a:pPr algn="ctr" indent="0" marL="0">
+                      <a:pPr marL="0" indent="0" algn="ctr">
                         <a:buNone/>
                       </a:pPr>
                       <a:r>
@@ -8475,6 +8337,11 @@
                     </a:solidFill>
                   </a:tcPr>
                 </a:tc>
+                <a:extLst>
+                  <a:ext uri="{0D108BD9-81ED-4DB2-BD59-A6C34878D82A}">
+                    <a16:rowId xmlns:a16="http://schemas.microsoft.com/office/drawing/2014/main" val="10003"/>
+                  </a:ext>
+                </a:extLst>
               </a:tr>
               <a:tr h="384048">
                 <a:tc>
@@ -8482,7 +8349,7 @@
                     <a:bodyPr/>
                     <a:lstStyle/>
                     <a:p>
-                      <a:pPr algn="l" indent="0" marL="0">
+                      <a:pPr marL="0" indent="0" algn="l">
                         <a:buNone/>
                       </a:pPr>
                       <a:r>
@@ -8543,7 +8410,7 @@
                     <a:bodyPr/>
                     <a:lstStyle/>
                     <a:p>
-                      <a:pPr algn="ctr" indent="0" marL="0">
+                      <a:pPr marL="0" indent="0" algn="ctr">
                         <a:buNone/>
                       </a:pPr>
                       <a:r>
@@ -8604,7 +8471,7 @@
                     <a:bodyPr/>
                     <a:lstStyle/>
                     <a:p>
-                      <a:pPr algn="ctr" indent="0" marL="0">
+                      <a:pPr marL="0" indent="0" algn="ctr">
                         <a:buNone/>
                       </a:pPr>
                       <a:r>
@@ -8665,7 +8532,7 @@
                     <a:bodyPr/>
                     <a:lstStyle/>
                     <a:p>
-                      <a:pPr algn="ctr" indent="0" marL="0">
+                      <a:pPr marL="0" indent="0" algn="ctr">
                         <a:buNone/>
                       </a:pPr>
                       <a:r>
@@ -8721,6 +8588,11 @@
                     </a:solidFill>
                   </a:tcPr>
                 </a:tc>
+                <a:extLst>
+                  <a:ext uri="{0D108BD9-81ED-4DB2-BD59-A6C34878D82A}">
+                    <a16:rowId xmlns:a16="http://schemas.microsoft.com/office/drawing/2014/main" val="10004"/>
+                  </a:ext>
+                </a:extLst>
               </a:tr>
             </a:tbl>
           </a:graphicData>
@@ -8806,6 +8678,7 @@
         <a:solidFill>
           <a:srgbClr val="F4F6FB"/>
         </a:solidFill>
+        <a:effectLst/>
       </p:bgPr>
     </p:bg>
     <p:spTree>
@@ -8883,7 +8756,7 @@
           <a:bodyPr wrap="square" rtlCol="0" anchor="ctr"/>
           <a:lstStyle/>
           <a:p>
-            <a:pPr algn="r" indent="0" marL="0">
+            <a:pPr marL="0" indent="0" algn="r">
               <a:buNone/>
             </a:pPr>
             <a:r>
@@ -8922,7 +8795,7 @@
           <a:bodyPr wrap="square" rtlCol="0" anchor="ctr"/>
           <a:lstStyle/>
           <a:p>
-            <a:pPr indent="0" marL="0">
+            <a:pPr marL="0" indent="0">
               <a:buNone/>
             </a:pPr>
             <a:r>
@@ -8958,7 +8831,7 @@
           <a:bodyPr wrap="square" rtlCol="0" anchor="ctr"/>
           <a:lstStyle/>
           <a:p>
-            <a:pPr indent="0" marL="0">
+            <a:pPr marL="0" indent="0">
               <a:buNone/>
             </a:pPr>
             <a:r>
@@ -8996,12 +8869,48 @@
             <a:tbl>
               <a:tblPr/>
               <a:tblGrid>
-                <a:gridCol w="1920240"/>
-                <a:gridCol w="1920240"/>
-                <a:gridCol w="1920240"/>
-                <a:gridCol w="1920240"/>
-                <a:gridCol w="1920240"/>
-                <a:gridCol w="1920240"/>
+                <a:gridCol w="1920240">
+                  <a:extLst>
+                    <a:ext uri="{9D8B030D-6E8A-4147-A177-3AD203B41FA5}">
+                      <a16:colId xmlns:a16="http://schemas.microsoft.com/office/drawing/2014/main" val="20000"/>
+                    </a:ext>
+                  </a:extLst>
+                </a:gridCol>
+                <a:gridCol w="1920240">
+                  <a:extLst>
+                    <a:ext uri="{9D8B030D-6E8A-4147-A177-3AD203B41FA5}">
+                      <a16:colId xmlns:a16="http://schemas.microsoft.com/office/drawing/2014/main" val="20001"/>
+                    </a:ext>
+                  </a:extLst>
+                </a:gridCol>
+                <a:gridCol w="1920240">
+                  <a:extLst>
+                    <a:ext uri="{9D8B030D-6E8A-4147-A177-3AD203B41FA5}">
+                      <a16:colId xmlns:a16="http://schemas.microsoft.com/office/drawing/2014/main" val="20002"/>
+                    </a:ext>
+                  </a:extLst>
+                </a:gridCol>
+                <a:gridCol w="1920240">
+                  <a:extLst>
+                    <a:ext uri="{9D8B030D-6E8A-4147-A177-3AD203B41FA5}">
+                      <a16:colId xmlns:a16="http://schemas.microsoft.com/office/drawing/2014/main" val="20003"/>
+                    </a:ext>
+                  </a:extLst>
+                </a:gridCol>
+                <a:gridCol w="1920240">
+                  <a:extLst>
+                    <a:ext uri="{9D8B030D-6E8A-4147-A177-3AD203B41FA5}">
+                      <a16:colId xmlns:a16="http://schemas.microsoft.com/office/drawing/2014/main" val="20004"/>
+                    </a:ext>
+                  </a:extLst>
+                </a:gridCol>
+                <a:gridCol w="1920240">
+                  <a:extLst>
+                    <a:ext uri="{9D8B030D-6E8A-4147-A177-3AD203B41FA5}">
+                      <a16:colId xmlns:a16="http://schemas.microsoft.com/office/drawing/2014/main" val="20005"/>
+                    </a:ext>
+                  </a:extLst>
+                </a:gridCol>
               </a:tblGrid>
               <a:tr h="384048">
                 <a:tc>
@@ -9009,7 +8918,7 @@
                     <a:bodyPr/>
                     <a:lstStyle/>
                     <a:p>
-                      <a:pPr algn="l" indent="0" marL="0">
+                      <a:pPr marL="0" indent="0" algn="l">
                         <a:buNone/>
                       </a:pPr>
                       <a:r>
@@ -9070,7 +8979,7 @@
                     <a:bodyPr/>
                     <a:lstStyle/>
                     <a:p>
-                      <a:pPr algn="ctr" indent="0" marL="0">
+                      <a:pPr marL="0" indent="0" algn="ctr">
                         <a:buNone/>
                       </a:pPr>
                       <a:r>
@@ -9131,7 +9040,7 @@
                     <a:bodyPr/>
                     <a:lstStyle/>
                     <a:p>
-                      <a:pPr algn="ctr" indent="0" marL="0">
+                      <a:pPr marL="0" indent="0" algn="ctr">
                         <a:buNone/>
                       </a:pPr>
                       <a:r>
@@ -9192,7 +9101,7 @@
                     <a:bodyPr/>
                     <a:lstStyle/>
                     <a:p>
-                      <a:pPr algn="ctr" indent="0" marL="0">
+                      <a:pPr marL="0" indent="0" algn="ctr">
                         <a:buNone/>
                       </a:pPr>
                       <a:r>
@@ -9253,7 +9162,7 @@
                     <a:bodyPr/>
                     <a:lstStyle/>
                     <a:p>
-                      <a:pPr algn="ctr" indent="0" marL="0">
+                      <a:pPr marL="0" indent="0" algn="ctr">
                         <a:buNone/>
                       </a:pPr>
                       <a:r>
@@ -9314,7 +9223,7 @@
                     <a:bodyPr/>
                     <a:lstStyle/>
                     <a:p>
-                      <a:pPr algn="ctr" indent="0" marL="0">
+                      <a:pPr marL="0" indent="0" algn="ctr">
                         <a:buNone/>
                       </a:pPr>
                       <a:r>
@@ -9370,6 +9279,11 @@
                     </a:solidFill>
                   </a:tcPr>
                 </a:tc>
+                <a:extLst>
+                  <a:ext uri="{0D108BD9-81ED-4DB2-BD59-A6C34878D82A}">
+                    <a16:rowId xmlns:a16="http://schemas.microsoft.com/office/drawing/2014/main" val="10000"/>
+                  </a:ext>
+                </a:extLst>
               </a:tr>
               <a:tr h="384048">
                 <a:tc>
@@ -9377,7 +9291,7 @@
                     <a:bodyPr/>
                     <a:lstStyle/>
                     <a:p>
-                      <a:pPr algn="l" indent="0" marL="0">
+                      <a:pPr marL="0" indent="0" algn="l">
                         <a:buNone/>
                       </a:pPr>
                       <a:r>
@@ -9438,7 +9352,7 @@
                     <a:bodyPr/>
                     <a:lstStyle/>
                     <a:p>
-                      <a:pPr algn="ctr" indent="0" marL="0">
+                      <a:pPr marL="0" indent="0" algn="ctr">
                         <a:buNone/>
                       </a:pPr>
                       <a:r>
@@ -9499,7 +9413,7 @@
                     <a:bodyPr/>
                     <a:lstStyle/>
                     <a:p>
-                      <a:pPr algn="ctr" indent="0" marL="0">
+                      <a:pPr marL="0" indent="0" algn="ctr">
                         <a:buNone/>
                       </a:pPr>
                       <a:r>
@@ -9560,7 +9474,7 @@
                     <a:bodyPr/>
                     <a:lstStyle/>
                     <a:p>
-                      <a:pPr algn="ctr" indent="0" marL="0">
+                      <a:pPr marL="0" indent="0" algn="ctr">
                         <a:buNone/>
                       </a:pPr>
                       <a:r>
@@ -9621,7 +9535,7 @@
                     <a:bodyPr/>
                     <a:lstStyle/>
                     <a:p>
-                      <a:pPr algn="ctr" indent="0" marL="0">
+                      <a:pPr marL="0" indent="0" algn="ctr">
                         <a:buNone/>
                       </a:pPr>
                       <a:r>
@@ -9682,7 +9596,7 @@
                     <a:bodyPr/>
                     <a:lstStyle/>
                     <a:p>
-                      <a:pPr algn="ctr" indent="0" marL="0">
+                      <a:pPr marL="0" indent="0" algn="ctr">
                         <a:buNone/>
                       </a:pPr>
                       <a:r>
@@ -9738,6 +9652,11 @@
                     </a:solidFill>
                   </a:tcPr>
                 </a:tc>
+                <a:extLst>
+                  <a:ext uri="{0D108BD9-81ED-4DB2-BD59-A6C34878D82A}">
+                    <a16:rowId xmlns:a16="http://schemas.microsoft.com/office/drawing/2014/main" val="10001"/>
+                  </a:ext>
+                </a:extLst>
               </a:tr>
               <a:tr h="384048">
                 <a:tc>
@@ -9745,7 +9664,7 @@
                     <a:bodyPr/>
                     <a:lstStyle/>
                     <a:p>
-                      <a:pPr algn="l" indent="0" marL="0">
+                      <a:pPr marL="0" indent="0" algn="l">
                         <a:buNone/>
                       </a:pPr>
                       <a:r>
@@ -9806,7 +9725,7 @@
                     <a:bodyPr/>
                     <a:lstStyle/>
                     <a:p>
-                      <a:pPr algn="ctr" indent="0" marL="0">
+                      <a:pPr marL="0" indent="0" algn="ctr">
                         <a:buNone/>
                       </a:pPr>
                       <a:r>
@@ -9867,7 +9786,7 @@
                     <a:bodyPr/>
                     <a:lstStyle/>
                     <a:p>
-                      <a:pPr algn="ctr" indent="0" marL="0">
+                      <a:pPr marL="0" indent="0" algn="ctr">
                         <a:buNone/>
                       </a:pPr>
                       <a:r>
@@ -9928,7 +9847,7 @@
                     <a:bodyPr/>
                     <a:lstStyle/>
                     <a:p>
-                      <a:pPr algn="ctr" indent="0" marL="0">
+                      <a:pPr marL="0" indent="0" algn="ctr">
                         <a:buNone/>
                       </a:pPr>
                       <a:r>
@@ -9989,7 +9908,7 @@
                     <a:bodyPr/>
                     <a:lstStyle/>
                     <a:p>
-                      <a:pPr algn="ctr" indent="0" marL="0">
+                      <a:pPr marL="0" indent="0" algn="ctr">
                         <a:buNone/>
                       </a:pPr>
                       <a:r>
@@ -10050,7 +9969,7 @@
                     <a:bodyPr/>
                     <a:lstStyle/>
                     <a:p>
-                      <a:pPr algn="ctr" indent="0" marL="0">
+                      <a:pPr marL="0" indent="0" algn="ctr">
                         <a:buNone/>
                       </a:pPr>
                       <a:r>
@@ -10106,6 +10025,11 @@
                     </a:solidFill>
                   </a:tcPr>
                 </a:tc>
+                <a:extLst>
+                  <a:ext uri="{0D108BD9-81ED-4DB2-BD59-A6C34878D82A}">
+                    <a16:rowId xmlns:a16="http://schemas.microsoft.com/office/drawing/2014/main" val="10002"/>
+                  </a:ext>
+                </a:extLst>
               </a:tr>
               <a:tr h="384048">
                 <a:tc>
@@ -10113,7 +10037,7 @@
                     <a:bodyPr/>
                     <a:lstStyle/>
                     <a:p>
-                      <a:pPr algn="l" indent="0" marL="0">
+                      <a:pPr marL="0" indent="0" algn="l">
                         <a:buNone/>
                       </a:pPr>
                       <a:r>
@@ -10174,7 +10098,7 @@
                     <a:bodyPr/>
                     <a:lstStyle/>
                     <a:p>
-                      <a:pPr algn="ctr" indent="0" marL="0">
+                      <a:pPr marL="0" indent="0" algn="ctr">
                         <a:buNone/>
                       </a:pPr>
                       <a:r>
@@ -10235,7 +10159,7 @@
                     <a:bodyPr/>
                     <a:lstStyle/>
                     <a:p>
-                      <a:pPr algn="ctr" indent="0" marL="0">
+                      <a:pPr marL="0" indent="0" algn="ctr">
                         <a:buNone/>
                       </a:pPr>
                       <a:r>
@@ -10296,7 +10220,7 @@
                     <a:bodyPr/>
                     <a:lstStyle/>
                     <a:p>
-                      <a:pPr algn="ctr" indent="0" marL="0">
+                      <a:pPr marL="0" indent="0" algn="ctr">
                         <a:buNone/>
                       </a:pPr>
                       <a:r>
@@ -10357,7 +10281,7 @@
                     <a:bodyPr/>
                     <a:lstStyle/>
                     <a:p>
-                      <a:pPr algn="ctr" indent="0" marL="0">
+                      <a:pPr marL="0" indent="0" algn="ctr">
                         <a:buNone/>
                       </a:pPr>
                       <a:r>
@@ -10418,7 +10342,7 @@
                     <a:bodyPr/>
                     <a:lstStyle/>
                     <a:p>
-                      <a:pPr algn="ctr" indent="0" marL="0">
+                      <a:pPr marL="0" indent="0" algn="ctr">
                         <a:buNone/>
                       </a:pPr>
                       <a:r>
@@ -10474,6 +10398,11 @@
                     </a:solidFill>
                   </a:tcPr>
                 </a:tc>
+                <a:extLst>
+                  <a:ext uri="{0D108BD9-81ED-4DB2-BD59-A6C34878D82A}">
+                    <a16:rowId xmlns:a16="http://schemas.microsoft.com/office/drawing/2014/main" val="10003"/>
+                  </a:ext>
+                </a:extLst>
               </a:tr>
             </a:tbl>
           </a:graphicData>
@@ -10601,6 +10530,7 @@
         <a:solidFill>
           <a:srgbClr val="F4F6FB"/>
         </a:solidFill>
+        <a:effectLst/>
       </p:bgPr>
     </p:bg>
     <p:spTree>
@@ -10678,7 +10608,7 @@
           <a:bodyPr wrap="square" rtlCol="0" anchor="ctr"/>
           <a:lstStyle/>
           <a:p>
-            <a:pPr algn="r" indent="0" marL="0">
+            <a:pPr marL="0" indent="0" algn="r">
               <a:buNone/>
             </a:pPr>
             <a:r>
@@ -10717,7 +10647,7 @@
           <a:bodyPr wrap="square" rtlCol="0" anchor="ctr"/>
           <a:lstStyle/>
           <a:p>
-            <a:pPr indent="0" marL="0">
+            <a:pPr marL="0" indent="0">
               <a:buNone/>
             </a:pPr>
             <a:r>
@@ -10753,7 +10683,7 @@
           <a:bodyPr wrap="square" rtlCol="0" anchor="ctr"/>
           <a:lstStyle/>
           <a:p>
-            <a:pPr indent="0" marL="0">
+            <a:pPr marL="0" indent="0">
               <a:buNone/>
             </a:pPr>
             <a:r>
@@ -10791,9 +10721,27 @@
             <a:tbl>
               <a:tblPr/>
               <a:tblGrid>
-                <a:gridCol w="3840480"/>
-                <a:gridCol w="3840480"/>
-                <a:gridCol w="3840480"/>
+                <a:gridCol w="3840480">
+                  <a:extLst>
+                    <a:ext uri="{9D8B030D-6E8A-4147-A177-3AD203B41FA5}">
+                      <a16:colId xmlns:a16="http://schemas.microsoft.com/office/drawing/2014/main" val="20000"/>
+                    </a:ext>
+                  </a:extLst>
+                </a:gridCol>
+                <a:gridCol w="3840480">
+                  <a:extLst>
+                    <a:ext uri="{9D8B030D-6E8A-4147-A177-3AD203B41FA5}">
+                      <a16:colId xmlns:a16="http://schemas.microsoft.com/office/drawing/2014/main" val="20001"/>
+                    </a:ext>
+                  </a:extLst>
+                </a:gridCol>
+                <a:gridCol w="3840480">
+                  <a:extLst>
+                    <a:ext uri="{9D8B030D-6E8A-4147-A177-3AD203B41FA5}">
+                      <a16:colId xmlns:a16="http://schemas.microsoft.com/office/drawing/2014/main" val="20002"/>
+                    </a:ext>
+                  </a:extLst>
+                </a:gridCol>
               </a:tblGrid>
               <a:tr h="384048">
                 <a:tc>
@@ -10801,7 +10749,7 @@
                     <a:bodyPr/>
                     <a:lstStyle/>
                     <a:p>
-                      <a:pPr algn="l" indent="0" marL="0">
+                      <a:pPr marL="0" indent="0" algn="l">
                         <a:buNone/>
                       </a:pPr>
                       <a:r>
@@ -10862,7 +10810,7 @@
                     <a:bodyPr/>
                     <a:lstStyle/>
                     <a:p>
-                      <a:pPr algn="ctr" indent="0" marL="0">
+                      <a:pPr marL="0" indent="0" algn="ctr">
                         <a:buNone/>
                       </a:pPr>
                       <a:r>
@@ -10923,7 +10871,7 @@
                     <a:bodyPr/>
                     <a:lstStyle/>
                     <a:p>
-                      <a:pPr algn="ctr" indent="0" marL="0">
+                      <a:pPr marL="0" indent="0" algn="ctr">
                         <a:buNone/>
                       </a:pPr>
                       <a:r>
@@ -10979,6 +10927,11 @@
                     </a:solidFill>
                   </a:tcPr>
                 </a:tc>
+                <a:extLst>
+                  <a:ext uri="{0D108BD9-81ED-4DB2-BD59-A6C34878D82A}">
+                    <a16:rowId xmlns:a16="http://schemas.microsoft.com/office/drawing/2014/main" val="10000"/>
+                  </a:ext>
+                </a:extLst>
               </a:tr>
               <a:tr h="384048">
                 <a:tc>
@@ -10986,7 +10939,7 @@
                     <a:bodyPr/>
                     <a:lstStyle/>
                     <a:p>
-                      <a:pPr algn="l" indent="0" marL="0">
+                      <a:pPr marL="0" indent="0" algn="l">
                         <a:buNone/>
                       </a:pPr>
                       <a:r>
@@ -11047,7 +11000,7 @@
                     <a:bodyPr/>
                     <a:lstStyle/>
                     <a:p>
-                      <a:pPr algn="ctr" indent="0" marL="0">
+                      <a:pPr marL="0" indent="0" algn="ctr">
                         <a:buNone/>
                       </a:pPr>
                       <a:r>
@@ -11108,7 +11061,7 @@
                     <a:bodyPr/>
                     <a:lstStyle/>
                     <a:p>
-                      <a:pPr algn="ctr" indent="0" marL="0">
+                      <a:pPr marL="0" indent="0" algn="ctr">
                         <a:buNone/>
                       </a:pPr>
                       <a:r>
@@ -11164,6 +11117,11 @@
                     </a:solidFill>
                   </a:tcPr>
                 </a:tc>
+                <a:extLst>
+                  <a:ext uri="{0D108BD9-81ED-4DB2-BD59-A6C34878D82A}">
+                    <a16:rowId xmlns:a16="http://schemas.microsoft.com/office/drawing/2014/main" val="10001"/>
+                  </a:ext>
+                </a:extLst>
               </a:tr>
               <a:tr h="384048">
                 <a:tc>
@@ -11171,7 +11129,7 @@
                     <a:bodyPr/>
                     <a:lstStyle/>
                     <a:p>
-                      <a:pPr algn="l" indent="0" marL="0">
+                      <a:pPr marL="0" indent="0" algn="l">
                         <a:buNone/>
                       </a:pPr>
                       <a:r>
@@ -11232,7 +11190,7 @@
                     <a:bodyPr/>
                     <a:lstStyle/>
                     <a:p>
-                      <a:pPr algn="ctr" indent="0" marL="0">
+                      <a:pPr marL="0" indent="0" algn="ctr">
                         <a:buNone/>
                       </a:pPr>
                       <a:r>
@@ -11293,7 +11251,7 @@
                     <a:bodyPr/>
                     <a:lstStyle/>
                     <a:p>
-                      <a:pPr algn="ctr" indent="0" marL="0">
+                      <a:pPr marL="0" indent="0" algn="ctr">
                         <a:buNone/>
                       </a:pPr>
                       <a:r>
@@ -11349,6 +11307,11 @@
                     </a:solidFill>
                   </a:tcPr>
                 </a:tc>
+                <a:extLst>
+                  <a:ext uri="{0D108BD9-81ED-4DB2-BD59-A6C34878D82A}">
+                    <a16:rowId xmlns:a16="http://schemas.microsoft.com/office/drawing/2014/main" val="10002"/>
+                  </a:ext>
+                </a:extLst>
               </a:tr>
               <a:tr h="384048">
                 <a:tc>
@@ -11356,7 +11319,7 @@
                     <a:bodyPr/>
                     <a:lstStyle/>
                     <a:p>
-                      <a:pPr algn="l" indent="0" marL="0">
+                      <a:pPr marL="0" indent="0" algn="l">
                         <a:buNone/>
                       </a:pPr>
                       <a:r>
@@ -11417,7 +11380,7 @@
                     <a:bodyPr/>
                     <a:lstStyle/>
                     <a:p>
-                      <a:pPr algn="ctr" indent="0" marL="0">
+                      <a:pPr marL="0" indent="0" algn="ctr">
                         <a:buNone/>
                       </a:pPr>
                       <a:r>
@@ -11478,7 +11441,7 @@
                     <a:bodyPr/>
                     <a:lstStyle/>
                     <a:p>
-                      <a:pPr algn="ctr" indent="0" marL="0">
+                      <a:pPr marL="0" indent="0" algn="ctr">
                         <a:buNone/>
                       </a:pPr>
                       <a:r>
@@ -11534,6 +11497,11 @@
                     </a:solidFill>
                   </a:tcPr>
                 </a:tc>
+                <a:extLst>
+                  <a:ext uri="{0D108BD9-81ED-4DB2-BD59-A6C34878D82A}">
+                    <a16:rowId xmlns:a16="http://schemas.microsoft.com/office/drawing/2014/main" val="10003"/>
+                  </a:ext>
+                </a:extLst>
               </a:tr>
               <a:tr h="384048">
                 <a:tc>
@@ -11541,7 +11509,7 @@
                     <a:bodyPr/>
                     <a:lstStyle/>
                     <a:p>
-                      <a:pPr algn="l" indent="0" marL="0">
+                      <a:pPr marL="0" indent="0" algn="l">
                         <a:buNone/>
                       </a:pPr>
                       <a:r>
@@ -11602,7 +11570,7 @@
                     <a:bodyPr/>
                     <a:lstStyle/>
                     <a:p>
-                      <a:pPr algn="ctr" indent="0" marL="0">
+                      <a:pPr marL="0" indent="0" algn="ctr">
                         <a:buNone/>
                       </a:pPr>
                       <a:r>
@@ -11663,7 +11631,7 @@
                     <a:bodyPr/>
                     <a:lstStyle/>
                     <a:p>
-                      <a:pPr algn="ctr" indent="0" marL="0">
+                      <a:pPr marL="0" indent="0" algn="ctr">
                         <a:buNone/>
                       </a:pPr>
                       <a:r>
@@ -11719,6 +11687,11 @@
                     </a:solidFill>
                   </a:tcPr>
                 </a:tc>
+                <a:extLst>
+                  <a:ext uri="{0D108BD9-81ED-4DB2-BD59-A6C34878D82A}">
+                    <a16:rowId xmlns:a16="http://schemas.microsoft.com/office/drawing/2014/main" val="10004"/>
+                  </a:ext>
+                </a:extLst>
               </a:tr>
               <a:tr h="384048">
                 <a:tc>
@@ -11726,7 +11699,7 @@
                     <a:bodyPr/>
                     <a:lstStyle/>
                     <a:p>
-                      <a:pPr algn="l" indent="0" marL="0">
+                      <a:pPr marL="0" indent="0" algn="l">
                         <a:buNone/>
                       </a:pPr>
                       <a:r>
@@ -11787,7 +11760,7 @@
                     <a:bodyPr/>
                     <a:lstStyle/>
                     <a:p>
-                      <a:pPr algn="ctr" indent="0" marL="0">
+                      <a:pPr marL="0" indent="0" algn="ctr">
                         <a:buNone/>
                       </a:pPr>
                       <a:r>
@@ -11848,7 +11821,7 @@
                     <a:bodyPr/>
                     <a:lstStyle/>
                     <a:p>
-                      <a:pPr algn="ctr" indent="0" marL="0">
+                      <a:pPr marL="0" indent="0" algn="ctr">
                         <a:buNone/>
                       </a:pPr>
                       <a:r>
@@ -11904,6 +11877,11 @@
                     </a:solidFill>
                   </a:tcPr>
                 </a:tc>
+                <a:extLst>
+                  <a:ext uri="{0D108BD9-81ED-4DB2-BD59-A6C34878D82A}">
+                    <a16:rowId xmlns:a16="http://schemas.microsoft.com/office/drawing/2014/main" val="10005"/>
+                  </a:ext>
+                </a:extLst>
               </a:tr>
               <a:tr h="384048">
                 <a:tc>
@@ -11911,7 +11889,7 @@
                     <a:bodyPr/>
                     <a:lstStyle/>
                     <a:p>
-                      <a:pPr algn="l" indent="0" marL="0">
+                      <a:pPr marL="0" indent="0" algn="l">
                         <a:buNone/>
                       </a:pPr>
                       <a:r>
@@ -11972,7 +11950,7 @@
                     <a:bodyPr/>
                     <a:lstStyle/>
                     <a:p>
-                      <a:pPr algn="ctr" indent="0" marL="0">
+                      <a:pPr marL="0" indent="0" algn="ctr">
                         <a:buNone/>
                       </a:pPr>
                       <a:r>
@@ -12033,7 +12011,7 @@
                     <a:bodyPr/>
                     <a:lstStyle/>
                     <a:p>
-                      <a:pPr algn="ctr" indent="0" marL="0">
+                      <a:pPr marL="0" indent="0" algn="ctr">
                         <a:buNone/>
                       </a:pPr>
                       <a:r>
@@ -12089,6 +12067,11 @@
                     </a:solidFill>
                   </a:tcPr>
                 </a:tc>
+                <a:extLst>
+                  <a:ext uri="{0D108BD9-81ED-4DB2-BD59-A6C34878D82A}">
+                    <a16:rowId xmlns:a16="http://schemas.microsoft.com/office/drawing/2014/main" val="10006"/>
+                  </a:ext>
+                </a:extLst>
               </a:tr>
             </a:tbl>
           </a:graphicData>
@@ -12110,6 +12093,7 @@
         <a:solidFill>
           <a:srgbClr val="F4F6FB"/>
         </a:solidFill>
+        <a:effectLst/>
       </p:bgPr>
     </p:bg>
     <p:spTree>
@@ -12187,7 +12171,7 @@
           <a:bodyPr wrap="square" rtlCol="0" anchor="ctr"/>
           <a:lstStyle/>
           <a:p>
-            <a:pPr algn="r" indent="0" marL="0">
+            <a:pPr marL="0" indent="0" algn="r">
               <a:buNone/>
             </a:pPr>
             <a:r>
@@ -12226,7 +12210,7 @@
           <a:bodyPr wrap="square" rtlCol="0" anchor="ctr"/>
           <a:lstStyle/>
           <a:p>
-            <a:pPr indent="0" marL="0">
+            <a:pPr marL="0" indent="0">
               <a:buNone/>
             </a:pPr>
             <a:r>
@@ -12262,7 +12246,7 @@
           <a:bodyPr wrap="square" rtlCol="0" anchor="ctr"/>
           <a:lstStyle/>
           <a:p>
-            <a:pPr indent="0" marL="0">
+            <a:pPr marL="0" indent="0">
               <a:buNone/>
             </a:pPr>
             <a:r>
@@ -12293,17 +12277,41 @@
         </p:nvGraphicFramePr>
         <p:xfrm>
           <a:off x="274320" y="1188720"/>
-          <a:ext cx="11521440" cy="914400"/>
+          <a:ext cx="11521440" cy="2304288"/>
         </p:xfrm>
         <a:graphic>
           <a:graphicData uri="http://schemas.openxmlformats.org/drawingml/2006/table">
             <a:tbl>
               <a:tblPr/>
               <a:tblGrid>
-                <a:gridCol w="2880360"/>
-                <a:gridCol w="2880360"/>
-                <a:gridCol w="2880360"/>
-                <a:gridCol w="2880360"/>
+                <a:gridCol w="2880360">
+                  <a:extLst>
+                    <a:ext uri="{9D8B030D-6E8A-4147-A177-3AD203B41FA5}">
+                      <a16:colId xmlns:a16="http://schemas.microsoft.com/office/drawing/2014/main" val="20000"/>
+                    </a:ext>
+                  </a:extLst>
+                </a:gridCol>
+                <a:gridCol w="2880360">
+                  <a:extLst>
+                    <a:ext uri="{9D8B030D-6E8A-4147-A177-3AD203B41FA5}">
+                      <a16:colId xmlns:a16="http://schemas.microsoft.com/office/drawing/2014/main" val="20001"/>
+                    </a:ext>
+                  </a:extLst>
+                </a:gridCol>
+                <a:gridCol w="2880360">
+                  <a:extLst>
+                    <a:ext uri="{9D8B030D-6E8A-4147-A177-3AD203B41FA5}">
+                      <a16:colId xmlns:a16="http://schemas.microsoft.com/office/drawing/2014/main" val="20002"/>
+                    </a:ext>
+                  </a:extLst>
+                </a:gridCol>
+                <a:gridCol w="2880360">
+                  <a:extLst>
+                    <a:ext uri="{9D8B030D-6E8A-4147-A177-3AD203B41FA5}">
+                      <a16:colId xmlns:a16="http://schemas.microsoft.com/office/drawing/2014/main" val="20003"/>
+                    </a:ext>
+                  </a:extLst>
+                </a:gridCol>
               </a:tblGrid>
               <a:tr h="384048">
                 <a:tc>
@@ -12311,7 +12319,7 @@
                     <a:bodyPr/>
                     <a:lstStyle/>
                     <a:p>
-                      <a:pPr algn="l" indent="0" marL="0">
+                      <a:pPr marL="0" indent="0" algn="l">
                         <a:buNone/>
                       </a:pPr>
                       <a:r>
@@ -12372,7 +12380,7 @@
                     <a:bodyPr/>
                     <a:lstStyle/>
                     <a:p>
-                      <a:pPr algn="ctr" indent="0" marL="0">
+                      <a:pPr marL="0" indent="0" algn="ctr">
                         <a:buNone/>
                       </a:pPr>
                       <a:r>
@@ -12433,7 +12441,7 @@
                     <a:bodyPr/>
                     <a:lstStyle/>
                     <a:p>
-                      <a:pPr algn="ctr" indent="0" marL="0">
+                      <a:pPr marL="0" indent="0" algn="ctr">
                         <a:buNone/>
                       </a:pPr>
                       <a:r>
@@ -12494,7 +12502,7 @@
                     <a:bodyPr/>
                     <a:lstStyle/>
                     <a:p>
-                      <a:pPr algn="ctr" indent="0" marL="0">
+                      <a:pPr marL="0" indent="0" algn="ctr">
                         <a:buNone/>
                       </a:pPr>
                       <a:r>
@@ -12550,6 +12558,11 @@
                     </a:solidFill>
                   </a:tcPr>
                 </a:tc>
+                <a:extLst>
+                  <a:ext uri="{0D108BD9-81ED-4DB2-BD59-A6C34878D82A}">
+                    <a16:rowId xmlns:a16="http://schemas.microsoft.com/office/drawing/2014/main" val="10000"/>
+                  </a:ext>
+                </a:extLst>
               </a:tr>
               <a:tr h="384048">
                 <a:tc>
@@ -12557,7 +12570,7 @@
                     <a:bodyPr/>
                     <a:lstStyle/>
                     <a:p>
-                      <a:pPr algn="l" indent="0" marL="0">
+                      <a:pPr marL="0" indent="0" algn="l">
                         <a:buNone/>
                       </a:pPr>
                       <a:r>
@@ -12618,7 +12631,7 @@
                     <a:bodyPr/>
                     <a:lstStyle/>
                     <a:p>
-                      <a:pPr algn="ctr" indent="0" marL="0">
+                      <a:pPr marL="0" indent="0" algn="ctr">
                         <a:buNone/>
                       </a:pPr>
                       <a:r>
@@ -12679,7 +12692,7 @@
                     <a:bodyPr/>
                     <a:lstStyle/>
                     <a:p>
-                      <a:pPr algn="ctr" indent="0" marL="0">
+                      <a:pPr marL="0" indent="0" algn="ctr">
                         <a:buNone/>
                       </a:pPr>
                       <a:r>
@@ -12740,7 +12753,7 @@
                     <a:bodyPr/>
                     <a:lstStyle/>
                     <a:p>
-                      <a:pPr algn="ctr" indent="0" marL="0">
+                      <a:pPr marL="0" indent="0" algn="ctr">
                         <a:buNone/>
                       </a:pPr>
                       <a:r>
@@ -12796,6 +12809,11 @@
                     </a:solidFill>
                   </a:tcPr>
                 </a:tc>
+                <a:extLst>
+                  <a:ext uri="{0D108BD9-81ED-4DB2-BD59-A6C34878D82A}">
+                    <a16:rowId xmlns:a16="http://schemas.microsoft.com/office/drawing/2014/main" val="10001"/>
+                  </a:ext>
+                </a:extLst>
               </a:tr>
               <a:tr h="384048">
                 <a:tc>
@@ -12803,7 +12821,7 @@
                     <a:bodyPr/>
                     <a:lstStyle/>
                     <a:p>
-                      <a:pPr algn="l" indent="0" marL="0">
+                      <a:pPr marL="0" indent="0" algn="l">
                         <a:buNone/>
                       </a:pPr>
                       <a:r>
@@ -12864,7 +12882,7 @@
                     <a:bodyPr/>
                     <a:lstStyle/>
                     <a:p>
-                      <a:pPr algn="ctr" indent="0" marL="0">
+                      <a:pPr marL="0" indent="0" algn="ctr">
                         <a:buNone/>
                       </a:pPr>
                       <a:r>
@@ -12925,7 +12943,7 @@
                     <a:bodyPr/>
                     <a:lstStyle/>
                     <a:p>
-                      <a:pPr algn="ctr" indent="0" marL="0">
+                      <a:pPr marL="0" indent="0" algn="ctr">
                         <a:buNone/>
                       </a:pPr>
                       <a:r>
@@ -12986,7 +13004,7 @@
                     <a:bodyPr/>
                     <a:lstStyle/>
                     <a:p>
-                      <a:pPr algn="ctr" indent="0" marL="0">
+                      <a:pPr marL="0" indent="0" algn="ctr">
                         <a:buNone/>
                       </a:pPr>
                       <a:r>
@@ -13042,6 +13060,11 @@
                     </a:solidFill>
                   </a:tcPr>
                 </a:tc>
+                <a:extLst>
+                  <a:ext uri="{0D108BD9-81ED-4DB2-BD59-A6C34878D82A}">
+                    <a16:rowId xmlns:a16="http://schemas.microsoft.com/office/drawing/2014/main" val="10002"/>
+                  </a:ext>
+                </a:extLst>
               </a:tr>
               <a:tr h="384048">
                 <a:tc>
@@ -13049,7 +13072,7 @@
                     <a:bodyPr/>
                     <a:lstStyle/>
                     <a:p>
-                      <a:pPr algn="l" indent="0" marL="0">
+                      <a:pPr marL="0" indent="0" algn="l">
                         <a:buNone/>
                       </a:pPr>
                       <a:r>
@@ -13110,7 +13133,7 @@
                     <a:bodyPr/>
                     <a:lstStyle/>
                     <a:p>
-                      <a:pPr algn="ctr" indent="0" marL="0">
+                      <a:pPr marL="0" indent="0" algn="ctr">
                         <a:buNone/>
                       </a:pPr>
                       <a:r>
@@ -13171,7 +13194,7 @@
                     <a:bodyPr/>
                     <a:lstStyle/>
                     <a:p>
-                      <a:pPr algn="ctr" indent="0" marL="0">
+                      <a:pPr marL="0" indent="0" algn="ctr">
                         <a:buNone/>
                       </a:pPr>
                       <a:r>
@@ -13232,7 +13255,7 @@
                     <a:bodyPr/>
                     <a:lstStyle/>
                     <a:p>
-                      <a:pPr algn="ctr" indent="0" marL="0">
+                      <a:pPr marL="0" indent="0" algn="ctr">
                         <a:buNone/>
                       </a:pPr>
                       <a:r>
@@ -13288,6 +13311,11 @@
                     </a:solidFill>
                   </a:tcPr>
                 </a:tc>
+                <a:extLst>
+                  <a:ext uri="{0D108BD9-81ED-4DB2-BD59-A6C34878D82A}">
+                    <a16:rowId xmlns:a16="http://schemas.microsoft.com/office/drawing/2014/main" val="10003"/>
+                  </a:ext>
+                </a:extLst>
               </a:tr>
               <a:tr h="384048">
                 <a:tc>
@@ -13295,7 +13323,7 @@
                     <a:bodyPr/>
                     <a:lstStyle/>
                     <a:p>
-                      <a:pPr algn="l" indent="0" marL="0">
+                      <a:pPr marL="0" indent="0" algn="l">
                         <a:buNone/>
                       </a:pPr>
                       <a:r>
@@ -13356,7 +13384,7 @@
                     <a:bodyPr/>
                     <a:lstStyle/>
                     <a:p>
-                      <a:pPr algn="ctr" indent="0" marL="0">
+                      <a:pPr marL="0" indent="0" algn="ctr">
                         <a:buNone/>
                       </a:pPr>
                       <a:r>
@@ -13417,7 +13445,7 @@
                     <a:bodyPr/>
                     <a:lstStyle/>
                     <a:p>
-                      <a:pPr algn="ctr" indent="0" marL="0">
+                      <a:pPr marL="0" indent="0" algn="ctr">
                         <a:buNone/>
                       </a:pPr>
                       <a:r>
@@ -13478,7 +13506,7 @@
                     <a:bodyPr/>
                     <a:lstStyle/>
                     <a:p>
-                      <a:pPr algn="ctr" indent="0" marL="0">
+                      <a:pPr marL="0" indent="0" algn="ctr">
                         <a:buNone/>
                       </a:pPr>
                       <a:r>
@@ -13534,6 +13562,11 @@
                     </a:solidFill>
                   </a:tcPr>
                 </a:tc>
+                <a:extLst>
+                  <a:ext uri="{0D108BD9-81ED-4DB2-BD59-A6C34878D82A}">
+                    <a16:rowId xmlns:a16="http://schemas.microsoft.com/office/drawing/2014/main" val="10004"/>
+                  </a:ext>
+                </a:extLst>
               </a:tr>
               <a:tr h="384048">
                 <a:tc>
@@ -13541,7 +13574,7 @@
                     <a:bodyPr/>
                     <a:lstStyle/>
                     <a:p>
-                      <a:pPr algn="l" indent="0" marL="0">
+                      <a:pPr marL="0" indent="0" algn="l">
                         <a:buNone/>
                       </a:pPr>
                       <a:r>
@@ -13602,7 +13635,7 @@
                     <a:bodyPr/>
                     <a:lstStyle/>
                     <a:p>
-                      <a:pPr algn="ctr" indent="0" marL="0">
+                      <a:pPr marL="0" indent="0" algn="ctr">
                         <a:buNone/>
                       </a:pPr>
                       <a:r>
@@ -13663,7 +13696,7 @@
                     <a:bodyPr/>
                     <a:lstStyle/>
                     <a:p>
-                      <a:pPr algn="ctr" indent="0" marL="0">
+                      <a:pPr marL="0" indent="0" algn="ctr">
                         <a:buNone/>
                       </a:pPr>
                       <a:r>
@@ -13724,7 +13757,7 @@
                     <a:bodyPr/>
                     <a:lstStyle/>
                     <a:p>
-                      <a:pPr algn="ctr" indent="0" marL="0">
+                      <a:pPr marL="0" indent="0" algn="ctr">
                         <a:buNone/>
                       </a:pPr>
                       <a:r>
@@ -13780,6 +13813,11 @@
                     </a:solidFill>
                   </a:tcPr>
                 </a:tc>
+                <a:extLst>
+                  <a:ext uri="{0D108BD9-81ED-4DB2-BD59-A6C34878D82A}">
+                    <a16:rowId xmlns:a16="http://schemas.microsoft.com/office/drawing/2014/main" val="10005"/>
+                  </a:ext>
+                </a:extLst>
               </a:tr>
             </a:tbl>
           </a:graphicData>
@@ -13865,6 +13903,7 @@
         <a:solidFill>
           <a:srgbClr val="F4F6FB"/>
         </a:solidFill>
+        <a:effectLst/>
       </p:bgPr>
     </p:bg>
     <p:spTree>
@@ -13942,7 +13981,7 @@
           <a:bodyPr wrap="square" rtlCol="0" anchor="ctr"/>
           <a:lstStyle/>
           <a:p>
-            <a:pPr algn="r" indent="0" marL="0">
+            <a:pPr marL="0" indent="0" algn="r">
               <a:buNone/>
             </a:pPr>
             <a:r>
@@ -13981,7 +14020,7 @@
           <a:bodyPr wrap="square" rtlCol="0" anchor="ctr"/>
           <a:lstStyle/>
           <a:p>
-            <a:pPr indent="0" marL="0">
+            <a:pPr marL="0" indent="0">
               <a:buNone/>
             </a:pPr>
             <a:r>
@@ -14017,7 +14056,7 @@
           <a:bodyPr wrap="square" rtlCol="0" anchor="ctr"/>
           <a:lstStyle/>
           <a:p>
-            <a:pPr indent="0" marL="0">
+            <a:pPr marL="0" indent="0">
               <a:buNone/>
             </a:pPr>
             <a:r>
@@ -14080,7 +14119,7 @@
           <a:bodyPr wrap="square" rtlCol="0" anchor="ctr"/>
           <a:lstStyle/>
           <a:p>
-            <a:pPr indent="0" marL="0">
+            <a:pPr marL="0" indent="0">
               <a:buNone/>
             </a:pPr>
             <a:r>
@@ -14325,7 +14364,7 @@
           <a:bodyPr wrap="square" rtlCol="0" anchor="ctr"/>
           <a:lstStyle/>
           <a:p>
-            <a:pPr indent="0" marL="0">
+            <a:pPr marL="0" indent="0">
               <a:buNone/>
             </a:pPr>
             <a:r>
@@ -14398,21 +14437,16 @@
                   <a:srgbClr val="4A4A6A"/>
                 </a:solidFill>
               </a:rPr>
-              <a:t>    原型每个模块 ↔ 真实代码 函数+行号</a:t>
+              <a:t>    原型每个模块 ↔ 真实代码 </a:t>
             </a:r>
-            <a:endParaRPr lang="en-US" sz="1100" dirty="0"/>
-          </a:p>
-          <a:p>
-            <a:pPr marL="342900" indent="-342900">
-              <a:lnSpc>
-                <a:spcPts val="2400"/>
-              </a:lnSpc>
-              <a:spcAft>
-                <a:spcPts val="400"/>
-              </a:spcAft>
-              <a:buSzPct val="100000"/>
-              <a:buChar char="•"/>
-            </a:pPr>
+            <a:r>
+              <a:rPr lang="en-US" sz="1100" dirty="0" err="1">
+                <a:solidFill>
+                  <a:srgbClr val="4A4A6A"/>
+                </a:solidFill>
+              </a:rPr>
+              <a:t>函数+行号</a:t>
+            </a:r>
             <a:endParaRPr lang="en-US" sz="1100" dirty="0"/>
           </a:p>
           <a:p>
@@ -14453,21 +14487,16 @@
                   <a:srgbClr val="4A4A6A"/>
                 </a:solidFill>
               </a:rPr>
-              <a:t>    原型补缺失模块，数据精确对标</a:t>
+              <a:t>    </a:t>
             </a:r>
-            <a:endParaRPr lang="en-US" sz="1100" dirty="0"/>
-          </a:p>
-          <a:p>
-            <a:pPr marL="342900" indent="-342900">
-              <a:lnSpc>
-                <a:spcPts val="2400"/>
-              </a:lnSpc>
-              <a:spcAft>
-                <a:spcPts val="400"/>
-              </a:spcAft>
-              <a:buSzPct val="100000"/>
-              <a:buChar char="•"/>
-            </a:pPr>
+            <a:r>
+              <a:rPr lang="en-US" sz="1100" dirty="0" err="1">
+                <a:solidFill>
+                  <a:srgbClr val="4A4A6A"/>
+                </a:solidFill>
+              </a:rPr>
+              <a:t>原型补缺失模块，数据精确对标</a:t>
+            </a:r>
             <a:endParaRPr lang="en-US" sz="1100" dirty="0"/>
           </a:p>
           <a:p>
@@ -14878,4 +14907,299 @@
     </a:ext>
   </a:extLst>
 </a:theme>
+</file>
+
+<file path=ppt/theme/theme2.xml><?xml version="1.0" encoding="utf-8"?>
+<a:theme xmlns:a="http://schemas.openxmlformats.org/drawingml/2006/main" name="Office 主题​​">
+  <a:themeElements>
+    <a:clrScheme name="Office">
+      <a:dk1>
+        <a:sysClr val="windowText" lastClr="000000"/>
+      </a:dk1>
+      <a:lt1>
+        <a:sysClr val="window" lastClr="FFFFFF"/>
+      </a:lt1>
+      <a:dk2>
+        <a:srgbClr val="44546A"/>
+      </a:dk2>
+      <a:lt2>
+        <a:srgbClr val="E7E6E6"/>
+      </a:lt2>
+      <a:accent1>
+        <a:srgbClr val="4472C4"/>
+      </a:accent1>
+      <a:accent2>
+        <a:srgbClr val="ED7D31"/>
+      </a:accent2>
+      <a:accent3>
+        <a:srgbClr val="A5A5A5"/>
+      </a:accent3>
+      <a:accent4>
+        <a:srgbClr val="FFC000"/>
+      </a:accent4>
+      <a:accent5>
+        <a:srgbClr val="5B9BD5"/>
+      </a:accent5>
+      <a:accent6>
+        <a:srgbClr val="70AD47"/>
+      </a:accent6>
+      <a:hlink>
+        <a:srgbClr val="0563C1"/>
+      </a:hlink>
+      <a:folHlink>
+        <a:srgbClr val="954F72"/>
+      </a:folHlink>
+    </a:clrScheme>
+    <a:fontScheme name="Office">
+      <a:majorFont>
+        <a:latin typeface="等线 Light" panose="020F0302020204030204"/>
+        <a:ea typeface=""/>
+        <a:cs typeface=""/>
+        <a:font script="Jpan" typeface="游ゴシック Light"/>
+        <a:font script="Hang" typeface="맑은 고딕"/>
+        <a:font script="Hans" typeface="等线 Light"/>
+        <a:font script="Hant" typeface="新細明體"/>
+        <a:font script="Arab" typeface="Times New Roman"/>
+        <a:font script="Hebr" typeface="Times New Roman"/>
+        <a:font script="Thai" typeface="Angsana New"/>
+        <a:font script="Ethi" typeface="Nyala"/>
+        <a:font script="Beng" typeface="Vrinda"/>
+        <a:font script="Gujr" typeface="Shruti"/>
+        <a:font script="Khmr" typeface="MoolBoran"/>
+        <a:font script="Knda" typeface="Tunga"/>
+        <a:font script="Guru" typeface="Raavi"/>
+        <a:font script="Cans" typeface="Euphemia"/>
+        <a:font script="Cher" typeface="Plantagenet Cherokee"/>
+        <a:font script="Yiii" typeface="Microsoft Yi Baiti"/>
+        <a:font script="Tibt" typeface="Microsoft Himalaya"/>
+        <a:font script="Thaa" typeface="MV Boli"/>
+        <a:font script="Deva" typeface="Mangal"/>
+        <a:font script="Telu" typeface="Gautami"/>
+        <a:font script="Taml" typeface="Latha"/>
+        <a:font script="Syrc" typeface="Estrangelo Edessa"/>
+        <a:font script="Orya" typeface="Kalinga"/>
+        <a:font script="Mlym" typeface="Kartika"/>
+        <a:font script="Laoo" typeface="DokChampa"/>
+        <a:font script="Sinh" typeface="Iskoola Pota"/>
+        <a:font script="Mong" typeface="Mongolian Baiti"/>
+        <a:font script="Viet" typeface="Times New Roman"/>
+        <a:font script="Uigh" typeface="Microsoft Uighur"/>
+        <a:font script="Geor" typeface="Sylfaen"/>
+        <a:font script="Armn" typeface="Arial"/>
+        <a:font script="Bugi" typeface="Leelawadee UI"/>
+        <a:font script="Bopo" typeface="Microsoft JhengHei"/>
+        <a:font script="Java" typeface="Javanese Text"/>
+        <a:font script="Lisu" typeface="Segoe UI"/>
+        <a:font script="Mymr" typeface="Myanmar Text"/>
+        <a:font script="Nkoo" typeface="Ebrima"/>
+        <a:font script="Olck" typeface="Nirmala UI"/>
+        <a:font script="Osma" typeface="Ebrima"/>
+        <a:font script="Phag" typeface="Phagspa"/>
+        <a:font script="Syrn" typeface="Estrangelo Edessa"/>
+        <a:font script="Syrj" typeface="Estrangelo Edessa"/>
+        <a:font script="Syre" typeface="Estrangelo Edessa"/>
+        <a:font script="Sora" typeface="Nirmala UI"/>
+        <a:font script="Tale" typeface="Microsoft Tai Le"/>
+        <a:font script="Talu" typeface="Microsoft New Tai Lue"/>
+        <a:font script="Tfng" typeface="Ebrima"/>
+      </a:majorFont>
+      <a:minorFont>
+        <a:latin typeface="等线" panose="020F0502020204030204"/>
+        <a:ea typeface=""/>
+        <a:cs typeface=""/>
+        <a:font script="Jpan" typeface="游ゴシック"/>
+        <a:font script="Hang" typeface="맑은 고딕"/>
+        <a:font script="Hans" typeface="等线"/>
+        <a:font script="Hant" typeface="新細明體"/>
+        <a:font script="Arab" typeface="Arial"/>
+        <a:font script="Hebr" typeface="Arial"/>
+        <a:font script="Thai" typeface="Cordia New"/>
+        <a:font script="Ethi" typeface="Nyala"/>
+        <a:font script="Beng" typeface="Vrinda"/>
+        <a:font script="Gujr" typeface="Shruti"/>
+        <a:font script="Khmr" typeface="DaunPenh"/>
+        <a:font script="Knda" typeface="Tunga"/>
+        <a:font script="Guru" typeface="Raavi"/>
+        <a:font script="Cans" typeface="Euphemia"/>
+        <a:font script="Cher" typeface="Plantagenet Cherokee"/>
+        <a:font script="Yiii" typeface="Microsoft Yi Baiti"/>
+        <a:font script="Tibt" typeface="Microsoft Himalaya"/>
+        <a:font script="Thaa" typeface="MV Boli"/>
+        <a:font script="Deva" typeface="Mangal"/>
+        <a:font script="Telu" typeface="Gautami"/>
+        <a:font script="Taml" typeface="Latha"/>
+        <a:font script="Syrc" typeface="Estrangelo Edessa"/>
+        <a:font script="Orya" typeface="Kalinga"/>
+        <a:font script="Mlym" typeface="Kartika"/>
+        <a:font script="Laoo" typeface="DokChampa"/>
+        <a:font script="Sinh" typeface="Iskoola Pota"/>
+        <a:font script="Mong" typeface="Mongolian Baiti"/>
+        <a:font script="Viet" typeface="Arial"/>
+        <a:font script="Uigh" typeface="Microsoft Uighur"/>
+        <a:font script="Geor" typeface="Sylfaen"/>
+        <a:font script="Armn" typeface="Arial"/>
+        <a:font script="Bugi" typeface="Leelawadee UI"/>
+        <a:font script="Bopo" typeface="Microsoft JhengHei"/>
+        <a:font script="Java" typeface="Javanese Text"/>
+        <a:font script="Lisu" typeface="Segoe UI"/>
+        <a:font script="Mymr" typeface="Myanmar Text"/>
+        <a:font script="Nkoo" typeface="Ebrima"/>
+        <a:font script="Olck" typeface="Nirmala UI"/>
+        <a:font script="Osma" typeface="Ebrima"/>
+        <a:font script="Phag" typeface="Phagspa"/>
+        <a:font script="Syrn" typeface="Estrangelo Edessa"/>
+        <a:font script="Syrj" typeface="Estrangelo Edessa"/>
+        <a:font script="Syre" typeface="Estrangelo Edessa"/>
+        <a:font script="Sora" typeface="Nirmala UI"/>
+        <a:font script="Tale" typeface="Microsoft Tai Le"/>
+        <a:font script="Talu" typeface="Microsoft New Tai Lue"/>
+        <a:font script="Tfng" typeface="Ebrima"/>
+      </a:minorFont>
+    </a:fontScheme>
+    <a:fmtScheme name="Office">
+      <a:fillStyleLst>
+        <a:solidFill>
+          <a:schemeClr val="phClr"/>
+        </a:solidFill>
+        <a:gradFill rotWithShape="1">
+          <a:gsLst>
+            <a:gs pos="0">
+              <a:schemeClr val="phClr">
+                <a:lumMod val="110000"/>
+                <a:satMod val="105000"/>
+                <a:tint val="67000"/>
+              </a:schemeClr>
+            </a:gs>
+            <a:gs pos="50000">
+              <a:schemeClr val="phClr">
+                <a:lumMod val="105000"/>
+                <a:satMod val="103000"/>
+                <a:tint val="73000"/>
+              </a:schemeClr>
+            </a:gs>
+            <a:gs pos="100000">
+              <a:schemeClr val="phClr">
+                <a:lumMod val="105000"/>
+                <a:satMod val="109000"/>
+                <a:tint val="81000"/>
+              </a:schemeClr>
+            </a:gs>
+          </a:gsLst>
+          <a:lin ang="5400000" scaled="0"/>
+        </a:gradFill>
+        <a:gradFill rotWithShape="1">
+          <a:gsLst>
+            <a:gs pos="0">
+              <a:schemeClr val="phClr">
+                <a:satMod val="103000"/>
+                <a:lumMod val="102000"/>
+                <a:tint val="94000"/>
+              </a:schemeClr>
+            </a:gs>
+            <a:gs pos="50000">
+              <a:schemeClr val="phClr">
+                <a:satMod val="110000"/>
+                <a:lumMod val="100000"/>
+                <a:shade val="100000"/>
+              </a:schemeClr>
+            </a:gs>
+            <a:gs pos="100000">
+              <a:schemeClr val="phClr">
+                <a:lumMod val="99000"/>
+                <a:satMod val="120000"/>
+                <a:shade val="78000"/>
+              </a:schemeClr>
+            </a:gs>
+          </a:gsLst>
+          <a:lin ang="5400000" scaled="0"/>
+        </a:gradFill>
+      </a:fillStyleLst>
+      <a:lnStyleLst>
+        <a:ln w="6350" cap="flat" cmpd="sng" algn="ctr">
+          <a:solidFill>
+            <a:schemeClr val="phClr"/>
+          </a:solidFill>
+          <a:prstDash val="solid"/>
+          <a:miter lim="800000"/>
+        </a:ln>
+        <a:ln w="12700" cap="flat" cmpd="sng" algn="ctr">
+          <a:solidFill>
+            <a:schemeClr val="phClr"/>
+          </a:solidFill>
+          <a:prstDash val="solid"/>
+          <a:miter lim="800000"/>
+        </a:ln>
+        <a:ln w="19050" cap="flat" cmpd="sng" algn="ctr">
+          <a:solidFill>
+            <a:schemeClr val="phClr"/>
+          </a:solidFill>
+          <a:prstDash val="solid"/>
+          <a:miter lim="800000"/>
+        </a:ln>
+      </a:lnStyleLst>
+      <a:effectStyleLst>
+        <a:effectStyle>
+          <a:effectLst/>
+        </a:effectStyle>
+        <a:effectStyle>
+          <a:effectLst/>
+        </a:effectStyle>
+        <a:effectStyle>
+          <a:effectLst>
+            <a:outerShdw blurRad="57150" dist="19050" dir="5400000" algn="ctr" rotWithShape="0">
+              <a:srgbClr val="000000">
+                <a:alpha val="63000"/>
+              </a:srgbClr>
+            </a:outerShdw>
+          </a:effectLst>
+        </a:effectStyle>
+      </a:effectStyleLst>
+      <a:bgFillStyleLst>
+        <a:solidFill>
+          <a:schemeClr val="phClr"/>
+        </a:solidFill>
+        <a:solidFill>
+          <a:schemeClr val="phClr">
+            <a:tint val="95000"/>
+            <a:satMod val="170000"/>
+          </a:schemeClr>
+        </a:solidFill>
+        <a:gradFill rotWithShape="1">
+          <a:gsLst>
+            <a:gs pos="0">
+              <a:schemeClr val="phClr">
+                <a:tint val="93000"/>
+                <a:satMod val="150000"/>
+                <a:shade val="98000"/>
+                <a:lumMod val="102000"/>
+              </a:schemeClr>
+            </a:gs>
+            <a:gs pos="50000">
+              <a:schemeClr val="phClr">
+                <a:tint val="98000"/>
+                <a:satMod val="130000"/>
+                <a:shade val="90000"/>
+                <a:lumMod val="103000"/>
+              </a:schemeClr>
+            </a:gs>
+            <a:gs pos="100000">
+              <a:schemeClr val="phClr">
+                <a:shade val="63000"/>
+                <a:satMod val="120000"/>
+              </a:schemeClr>
+            </a:gs>
+          </a:gsLst>
+          <a:lin ang="5400000" scaled="0"/>
+        </a:gradFill>
+      </a:bgFillStyleLst>
+    </a:fmtScheme>
+  </a:themeElements>
+  <a:objectDefaults/>
+  <a:extraClrSchemeLst/>
+  <a:extLst>
+    <a:ext uri="{05A4C25C-085E-4340-85A3-A5531E510DB2}">
+      <thm15:themeFamily xmlns:thm15="http://schemas.microsoft.com/office/thememl/2012/main" name="Office Theme" id="{62F939B6-93AF-4DB8-9C6B-D6C7DFDC589F}" vid="{4A3C46E8-61CC-4603-A589-7422A47A8E4A}"/>
+    </a:ext>
+  </a:extLst>
+</a:theme>
 </file>
</xml_diff>

<commit_message>
Update eBPF card in slide 2 to match script
</commit_message>
<xml_diff>
--- a/presentation/native_hook_progress_2026-06-05.pptx
+++ b/presentation/native_hook_progress_2026-06-05.pptx
@@ -4,9 +4,6 @@
   <p:sldMasterIdLst>
     <p:sldMasterId id="2147483648" r:id="rId1"/>
   </p:sldMasterIdLst>
-  <p:notesMasterIdLst>
-    <p:notesMasterId r:id="rId12"/>
-  </p:notesMasterIdLst>
   <p:sldIdLst>
     <p:sldId id="256" r:id="rId2"/>
     <p:sldId id="257" r:id="rId3"/>
@@ -19,6 +16,9 @@
     <p:sldId id="264" r:id="rId10"/>
     <p:sldId id="265" r:id="rId11"/>
   </p:sldIdLst>
+  <p:notesMasterIdLst>
+    <p:notesMasterId r:id="rId12"/>
+  </p:notesMasterIdLst>
   <p:sldSz cx="12192000" cy="6858000"/>
   <p:notesSz cx="6858000" cy="12192000"/>
   <p:defaultTextStyle>
@@ -113,11 +113,6 @@
       </a:defRPr>
     </a:lvl9pPr>
   </p:defaultTextStyle>
-  <p:extLst>
-    <p:ext uri="{EFAFB233-063F-42B5-8137-9DF3F51BA10A}">
-      <p15:sldGuideLst xmlns:p15="http://schemas.microsoft.com/office/powerpoint/2012/main"/>
-    </p:ext>
-  </p:extLst>
 </p:presentation>
 </file>
 
@@ -143,10 +138,234 @@
           <a:chExt cx="0" cy="0"/>
         </a:xfrm>
       </p:grpSpPr>
+      <p:sp>
+        <p:nvSpPr>
+          <p:cNvPr id="2" name="Header Placeholder 1"/>
+          <p:cNvSpPr>
+            <a:spLocks noGrp="1"/>
+          </p:cNvSpPr>
+          <p:nvPr>
+            <p:ph type="hdr" sz="quarter"/>
+          </p:nvPr>
+        </p:nvSpPr>
+        <p:spPr>
+          <a:xfrm>
+            <a:off x="0" y="0"/>
+            <a:ext cx="2971800" cy="458788"/>
+          </a:xfrm>
+          <a:prstGeom prst="rect">
+            <a:avLst/>
+          </a:prstGeom>
+        </p:spPr>
+        <p:txBody>
+          <a:bodyPr vert="horz" lIns="91440" tIns="45720" rIns="91440" bIns="45720" rtlCol="0"/>
+          <a:lstStyle>
+            <a:lvl1pPr algn="l">
+              <a:defRPr sz="1200"/>
+            </a:lvl1pPr>
+          </a:lstStyle>
+          <a:p>
+            <a:endParaRPr lang="en-US"/>
+          </a:p>
+        </p:txBody>
+      </p:sp>
+      <p:sp>
+        <p:nvSpPr>
+          <p:cNvPr id="3" name="Date Placeholder 2"/>
+          <p:cNvSpPr>
+            <a:spLocks noGrp="1"/>
+          </p:cNvSpPr>
+          <p:nvPr>
+            <p:ph type="dt" idx="1"/>
+          </p:nvPr>
+        </p:nvSpPr>
+        <p:spPr>
+          <a:xfrm>
+            <a:off x="3884613" y="0"/>
+            <a:ext cx="2971800" cy="458788"/>
+          </a:xfrm>
+          <a:prstGeom prst="rect">
+            <a:avLst/>
+          </a:prstGeom>
+        </p:spPr>
+        <p:txBody>
+          <a:bodyPr vert="horz" lIns="91440" tIns="45720" rIns="91440" bIns="45720" rtlCol="0"/>
+          <a:lstStyle>
+            <a:lvl1pPr algn="r">
+              <a:defRPr sz="1200"/>
+            </a:lvl1pPr>
+          </a:lstStyle>
+          <a:p>
+            <a:fld id="{5282F153-3F37-0F45-9E97-73ACFA13230C}" type="datetimeFigureOut">
+              <a:rPr lang="en-US"/>
+              <a:t>7/23/19</a:t>
+            </a:fld>
+            <a:endParaRPr lang="en-US"/>
+          </a:p>
+        </p:txBody>
+      </p:sp>
+      <p:sp>
+        <p:nvSpPr>
+          <p:cNvPr id="4" name="Slide Image Placeholder 3"/>
+          <p:cNvSpPr>
+            <a:spLocks noGrp="1" noRot="1" noChangeAspect="1"/>
+          </p:cNvSpPr>
+          <p:nvPr>
+            <p:ph type="sldImg" idx="2"/>
+          </p:nvPr>
+        </p:nvSpPr>
+        <p:spPr>
+          <a:xfrm>
+            <a:off x="685800" y="1143000"/>
+            <a:ext cx="5486400" cy="3086100"/>
+          </a:xfrm>
+          <a:prstGeom prst="rect">
+            <a:avLst/>
+          </a:prstGeom>
+          <a:noFill/>
+          <a:ln w="12700">
+            <a:solidFill>
+              <a:prstClr val="black"/>
+            </a:solidFill>
+          </a:ln>
+        </p:spPr>
+        <p:txBody>
+          <a:bodyPr vert="horz" lIns="91440" tIns="45720" rIns="91440" bIns="45720" rtlCol="0" anchor="ctr"/>
+          <a:lstStyle/>
+          <a:p>
+            <a:endParaRPr lang="en-US"/>
+          </a:p>
+        </p:txBody>
+      </p:sp>
+      <p:sp>
+        <p:nvSpPr>
+          <p:cNvPr id="5" name="Notes Placeholder 4"/>
+          <p:cNvSpPr>
+            <a:spLocks noGrp="1"/>
+          </p:cNvSpPr>
+          <p:nvPr>
+            <p:ph type="body" sz="quarter" idx="3"/>
+          </p:nvPr>
+        </p:nvSpPr>
+        <p:spPr>
+          <a:xfrm>
+            <a:off x="685800" y="4400550"/>
+            <a:ext cx="5486400" cy="3600450"/>
+          </a:xfrm>
+          <a:prstGeom prst="rect">
+            <a:avLst/>
+          </a:prstGeom>
+        </p:spPr>
+        <p:txBody>
+          <a:bodyPr vert="horz" lIns="91440" tIns="45720" rIns="91440" bIns="45720" rtlCol="0"/>
+          <a:lstStyle/>
+          <a:p>
+            <a:pPr lvl="0"/>
+            <a:r>
+              <a:rPr lang="en-US"/>
+              <a:t>Click to edit Master text styles</a:t>
+            </a:r>
+          </a:p>
+          <a:p>
+            <a:pPr lvl="1"/>
+            <a:r>
+              <a:rPr lang="en-US"/>
+              <a:t>Second level</a:t>
+            </a:r>
+          </a:p>
+          <a:p>
+            <a:pPr lvl="2"/>
+            <a:r>
+              <a:rPr lang="en-US"/>
+              <a:t>Third level</a:t>
+            </a:r>
+          </a:p>
+          <a:p>
+            <a:pPr lvl="3"/>
+            <a:r>
+              <a:rPr lang="en-US"/>
+              <a:t>Fourth level</a:t>
+            </a:r>
+          </a:p>
+          <a:p>
+            <a:pPr lvl="4"/>
+            <a:r>
+              <a:rPr lang="en-US"/>
+              <a:t>Fifth level</a:t>
+            </a:r>
+          </a:p>
+        </p:txBody>
+      </p:sp>
+      <p:sp>
+        <p:nvSpPr>
+          <p:cNvPr id="6" name="Footer Placeholder 5"/>
+          <p:cNvSpPr>
+            <a:spLocks noGrp="1"/>
+          </p:cNvSpPr>
+          <p:nvPr>
+            <p:ph type="ftr" sz="quarter" idx="4"/>
+          </p:nvPr>
+        </p:nvSpPr>
+        <p:spPr>
+          <a:xfrm>
+            <a:off x="0" y="8685213"/>
+            <a:ext cx="2971800" cy="458787"/>
+          </a:xfrm>
+          <a:prstGeom prst="rect">
+            <a:avLst/>
+          </a:prstGeom>
+        </p:spPr>
+        <p:txBody>
+          <a:bodyPr vert="horz" lIns="91440" tIns="45720" rIns="91440" bIns="45720" rtlCol="0" anchor="b"/>
+          <a:lstStyle>
+            <a:lvl1pPr algn="l">
+              <a:defRPr sz="1200"/>
+            </a:lvl1pPr>
+          </a:lstStyle>
+          <a:p>
+            <a:endParaRPr lang="en-US"/>
+          </a:p>
+        </p:txBody>
+      </p:sp>
+      <p:sp>
+        <p:nvSpPr>
+          <p:cNvPr id="7" name="Slide Number Placeholder 6"/>
+          <p:cNvSpPr>
+            <a:spLocks noGrp="1"/>
+          </p:cNvSpPr>
+          <p:nvPr>
+            <p:ph type="sldNum" sz="quarter" idx="5"/>
+          </p:nvPr>
+        </p:nvSpPr>
+        <p:spPr>
+          <a:xfrm>
+            <a:off x="3884613" y="8685213"/>
+            <a:ext cx="2971800" cy="458787"/>
+          </a:xfrm>
+          <a:prstGeom prst="rect">
+            <a:avLst/>
+          </a:prstGeom>
+        </p:spPr>
+        <p:txBody>
+          <a:bodyPr vert="horz" lIns="91440" tIns="45720" rIns="91440" bIns="45720" rtlCol="0" anchor="b"/>
+          <a:lstStyle>
+            <a:lvl1pPr algn="r">
+              <a:defRPr sz="1200"/>
+            </a:lvl1pPr>
+          </a:lstStyle>
+          <a:p>
+            <a:fld id="{CE5E9CC1-C706-0F49-92D6-E571CC5EEA8F}" type="slidenum">
+              <a:rPr lang="en-US"/>
+              <a:t>‹#›</a:t>
+            </a:fld>
+            <a:endParaRPr lang="en-US"/>
+          </a:p>
+        </p:txBody>
+      </p:sp>
     </p:spTree>
     <p:extLst>
       <p:ext uri="{BB962C8B-B14F-4D97-AF65-F5344CB8AC3E}">
-        <p14:creationId xmlns:p14="http://schemas.microsoft.com/office/powerpoint/2010/main" val="2670897419"/>
+        <p14:creationId xmlns:p14="http://schemas.microsoft.com/office/powerpoint/2010/main" val="1024086991"/>
       </p:ext>
     </p:extLst>
   </p:cSld>
@@ -290,6 +509,10 @@
           <a:bodyPr/>
           <a:lstStyle/>
           <a:p>
+            <a:r>
+              <a:rPr lang="en-US" dirty="0"/>
+              <a:t/>
+            </a:r>
             <a:endParaRPr lang="en-US" dirty="0"/>
           </a:p>
         </p:txBody>
@@ -374,6 +597,10 @@
           <a:bodyPr/>
           <a:lstStyle/>
           <a:p>
+            <a:r>
+              <a:rPr lang="en-US" dirty="0"/>
+              <a:t/>
+            </a:r>
             <a:endParaRPr lang="en-US" dirty="0"/>
           </a:p>
         </p:txBody>
@@ -458,6 +685,10 @@
           <a:bodyPr/>
           <a:lstStyle/>
           <a:p>
+            <a:r>
+              <a:rPr lang="en-US" dirty="0"/>
+              <a:t/>
+            </a:r>
             <a:endParaRPr lang="en-US" dirty="0"/>
           </a:p>
         </p:txBody>
@@ -542,6 +773,10 @@
           <a:bodyPr/>
           <a:lstStyle/>
           <a:p>
+            <a:r>
+              <a:rPr lang="en-US" dirty="0"/>
+              <a:t/>
+            </a:r>
             <a:endParaRPr lang="en-US" dirty="0"/>
           </a:p>
         </p:txBody>
@@ -626,6 +861,10 @@
           <a:bodyPr/>
           <a:lstStyle/>
           <a:p>
+            <a:r>
+              <a:rPr lang="en-US" dirty="0"/>
+              <a:t/>
+            </a:r>
             <a:endParaRPr lang="en-US" dirty="0"/>
           </a:p>
         </p:txBody>
@@ -710,6 +949,10 @@
           <a:bodyPr/>
           <a:lstStyle/>
           <a:p>
+            <a:r>
+              <a:rPr lang="en-US" dirty="0"/>
+              <a:t/>
+            </a:r>
             <a:endParaRPr lang="en-US" dirty="0"/>
           </a:p>
         </p:txBody>
@@ -794,6 +1037,10 @@
           <a:bodyPr/>
           <a:lstStyle/>
           <a:p>
+            <a:r>
+              <a:rPr lang="en-US" dirty="0"/>
+              <a:t/>
+            </a:r>
             <a:endParaRPr lang="en-US" dirty="0"/>
           </a:p>
         </p:txBody>
@@ -878,6 +1125,10 @@
           <a:bodyPr/>
           <a:lstStyle/>
           <a:p>
+            <a:r>
+              <a:rPr lang="en-US" dirty="0"/>
+              <a:t/>
+            </a:r>
             <a:endParaRPr lang="en-US" dirty="0"/>
           </a:p>
         </p:txBody>
@@ -962,6 +1213,10 @@
           <a:bodyPr/>
           <a:lstStyle/>
           <a:p>
+            <a:r>
+              <a:rPr lang="en-US" dirty="0"/>
+              <a:t/>
+            </a:r>
             <a:endParaRPr lang="en-US" dirty="0"/>
           </a:p>
         </p:txBody>
@@ -1046,6 +1301,10 @@
           <a:bodyPr/>
           <a:lstStyle/>
           <a:p>
+            <a:r>
+              <a:rPr lang="en-US" dirty="0"/>
+              <a:t/>
+            </a:r>
             <a:endParaRPr lang="en-US" dirty="0"/>
           </a:p>
         </p:txBody>
@@ -1119,11 +1378,6 @@
 <file path=ppt/slideMasters/slideMaster1.xml><?xml version="1.0" encoding="utf-8"?>
 <p:sldMaster xmlns:a="http://schemas.openxmlformats.org/drawingml/2006/main" xmlns:r="http://schemas.openxmlformats.org/officeDocument/2006/relationships" xmlns:p="http://schemas.openxmlformats.org/presentationml/2006/main">
   <p:cSld>
-    <p:bg>
-      <p:bgRef idx="1001">
-        <a:schemeClr val="bg1"/>
-      </p:bgRef>
-    </p:bg>
     <p:spTree>
       <p:nvGrpSpPr>
         <p:cNvPr id="1" name=""/>
@@ -1406,7 +1660,6 @@
         <a:solidFill>
           <a:srgbClr val="F4F6FB"/>
         </a:solidFill>
-        <a:effectLst/>
       </p:bgPr>
     </p:bg>
     <p:spTree>
@@ -1444,7 +1697,7 @@
           <a:bodyPr wrap="square" rtlCol="0" anchor="ctr"/>
           <a:lstStyle/>
           <a:p>
-            <a:pPr marL="0" indent="0" algn="ctr">
+            <a:pPr algn="ctr" indent="0" marL="0">
               <a:buNone/>
             </a:pPr>
             <a:r>
@@ -1480,7 +1733,7 @@
           <a:bodyPr wrap="square" rtlCol="0" anchor="ctr"/>
           <a:lstStyle/>
           <a:p>
-            <a:pPr marL="0" indent="0" algn="ctr">
+            <a:pPr algn="ctr" indent="0" marL="0">
               <a:buNone/>
             </a:pPr>
             <a:r>
@@ -1536,7 +1789,7 @@
           <a:bodyPr wrap="square" rtlCol="0" anchor="ctr"/>
           <a:lstStyle/>
           <a:p>
-            <a:pPr marL="0" indent="0" algn="ctr">
+            <a:pPr algn="ctr" indent="0" marL="0">
               <a:buNone/>
             </a:pPr>
             <a:r>
@@ -1567,7 +1820,6 @@
         <a:solidFill>
           <a:srgbClr val="F4F6FB"/>
         </a:solidFill>
-        <a:effectLst/>
       </p:bgPr>
     </p:bg>
     <p:spTree>
@@ -1645,7 +1897,7 @@
           <a:bodyPr wrap="square" rtlCol="0" anchor="ctr"/>
           <a:lstStyle/>
           <a:p>
-            <a:pPr marL="0" indent="0" algn="r">
+            <a:pPr algn="r" indent="0" marL="0">
               <a:buNone/>
             </a:pPr>
             <a:r>
@@ -1684,7 +1936,7 @@
           <a:bodyPr wrap="square" rtlCol="0" anchor="ctr"/>
           <a:lstStyle/>
           <a:p>
-            <a:pPr marL="0" indent="0">
+            <a:pPr indent="0" marL="0">
               <a:buNone/>
             </a:pPr>
             <a:r>
@@ -1767,7 +2019,7 @@
           <a:bodyPr wrap="square" rtlCol="0" anchor="ctr"/>
           <a:lstStyle/>
           <a:p>
-            <a:pPr marL="0" indent="0">
+            <a:pPr indent="0" marL="0">
               <a:buNone/>
             </a:pPr>
             <a:r>
@@ -1806,7 +2058,7 @@
           <a:bodyPr wrap="square" rtlCol="0" anchor="ctr"/>
           <a:lstStyle/>
           <a:p>
-            <a:pPr marL="0" indent="0">
+            <a:pPr indent="0" marL="0">
               <a:buNone/>
             </a:pPr>
             <a:r>
@@ -1842,7 +2094,7 @@
           <a:bodyPr wrap="square" rtlCol="0" anchor="ctr"/>
           <a:lstStyle/>
           <a:p>
-            <a:pPr marL="0" indent="0">
+            <a:pPr indent="0" marL="0">
               <a:buNone/>
             </a:pPr>
             <a:r>
@@ -1925,7 +2177,7 @@
           <a:bodyPr wrap="square" rtlCol="0" anchor="ctr"/>
           <a:lstStyle/>
           <a:p>
-            <a:pPr marL="0" indent="0">
+            <a:pPr indent="0" marL="0">
               <a:buNone/>
             </a:pPr>
             <a:r>
@@ -1964,7 +2216,7 @@
           <a:bodyPr wrap="square" rtlCol="0" anchor="ctr"/>
           <a:lstStyle/>
           <a:p>
-            <a:pPr marL="0" indent="0">
+            <a:pPr indent="0" marL="0">
               <a:buNone/>
             </a:pPr>
             <a:r>
@@ -2000,7 +2252,7 @@
           <a:bodyPr wrap="square" rtlCol="0" anchor="ctr"/>
           <a:lstStyle/>
           <a:p>
-            <a:pPr marL="0" indent="0">
+            <a:pPr indent="0" marL="0">
               <a:buNone/>
             </a:pPr>
             <a:r>
@@ -2083,7 +2335,7 @@
           <a:bodyPr wrap="square" rtlCol="0" anchor="ctr"/>
           <a:lstStyle/>
           <a:p>
-            <a:pPr marL="0" indent="0">
+            <a:pPr indent="0" marL="0">
               <a:buNone/>
             </a:pPr>
             <a:r>
@@ -2122,7 +2374,7 @@
           <a:bodyPr wrap="square" rtlCol="0" anchor="ctr"/>
           <a:lstStyle/>
           <a:p>
-            <a:pPr marL="0" indent="0">
+            <a:pPr indent="0" marL="0">
               <a:buNone/>
             </a:pPr>
             <a:r>
@@ -2158,7 +2410,7 @@
           <a:bodyPr wrap="square" rtlCol="0" anchor="ctr"/>
           <a:lstStyle/>
           <a:p>
-            <a:pPr marL="0" indent="0">
+            <a:pPr indent="0" marL="0">
               <a:buNone/>
             </a:pPr>
             <a:r>
@@ -2189,7 +2441,6 @@
         <a:solidFill>
           <a:srgbClr val="F4F6FB"/>
         </a:solidFill>
-        <a:effectLst/>
       </p:bgPr>
     </p:bg>
     <p:spTree>
@@ -2267,7 +2518,7 @@
           <a:bodyPr wrap="square" rtlCol="0" anchor="ctr"/>
           <a:lstStyle/>
           <a:p>
-            <a:pPr marL="0" indent="0" algn="r">
+            <a:pPr algn="r" indent="0" marL="0">
               <a:buNone/>
             </a:pPr>
             <a:r>
@@ -2306,7 +2557,7 @@
           <a:bodyPr wrap="square" rtlCol="0" anchor="ctr"/>
           <a:lstStyle/>
           <a:p>
-            <a:pPr marL="0" indent="0">
+            <a:pPr indent="0" marL="0">
               <a:buNone/>
             </a:pPr>
             <a:r>
@@ -2342,7 +2593,7 @@
           <a:bodyPr wrap="square" rtlCol="0" anchor="ctr"/>
           <a:lstStyle/>
           <a:p>
-            <a:pPr marL="0" indent="0">
+            <a:pPr indent="0" marL="0">
               <a:buNone/>
             </a:pPr>
             <a:r>
@@ -2425,7 +2676,7 @@
           <a:bodyPr wrap="square" rtlCol="0" anchor="ctr"/>
           <a:lstStyle/>
           <a:p>
-            <a:pPr marL="0" indent="0">
+            <a:pPr indent="0" marL="0">
               <a:buNone/>
             </a:pPr>
             <a:r>
@@ -2464,7 +2715,7 @@
           <a:bodyPr wrap="square" rtlCol="0" anchor="ctr"/>
           <a:lstStyle/>
           <a:p>
-            <a:pPr marL="0" indent="0">
+            <a:pPr indent="0" marL="0">
               <a:buNone/>
             </a:pPr>
             <a:r>
@@ -2500,7 +2751,7 @@
           <a:bodyPr wrap="square" rtlCol="0" anchor="ctr"/>
           <a:lstStyle/>
           <a:p>
-            <a:pPr marL="0" indent="0">
+            <a:pPr indent="0" marL="0">
               <a:lnSpc>
                 <a:spcPts val="2000"/>
               </a:lnSpc>
@@ -2517,7 +2768,7 @@
             <a:endParaRPr lang="en-US" sz="1200" dirty="0"/>
           </a:p>
           <a:p>
-            <a:pPr marL="0" indent="0">
+            <a:pPr indent="0" marL="0">
               <a:lnSpc>
                 <a:spcPts val="2000"/>
               </a:lnSpc>
@@ -2603,7 +2854,7 @@
           <a:bodyPr wrap="square" rtlCol="0" anchor="ctr"/>
           <a:lstStyle/>
           <a:p>
-            <a:pPr marL="0" indent="0">
+            <a:pPr indent="0" marL="0">
               <a:buNone/>
             </a:pPr>
             <a:r>
@@ -2642,7 +2893,7 @@
           <a:bodyPr wrap="square" rtlCol="0" anchor="ctr"/>
           <a:lstStyle/>
           <a:p>
-            <a:pPr marL="0" indent="0">
+            <a:pPr indent="0" marL="0">
               <a:buNone/>
             </a:pPr>
             <a:r>
@@ -2678,7 +2929,7 @@
           <a:bodyPr wrap="square" rtlCol="0" anchor="ctr"/>
           <a:lstStyle/>
           <a:p>
-            <a:pPr marL="0" indent="0">
+            <a:pPr indent="0" marL="0">
               <a:lnSpc>
                 <a:spcPts val="2000"/>
               </a:lnSpc>
@@ -2695,7 +2946,7 @@
             <a:endParaRPr lang="en-US" sz="1200" dirty="0"/>
           </a:p>
           <a:p>
-            <a:pPr marL="0" indent="0">
+            <a:pPr indent="0" marL="0">
               <a:lnSpc>
                 <a:spcPts val="2000"/>
               </a:lnSpc>
@@ -2781,7 +3032,7 @@
           <a:bodyPr wrap="square" rtlCol="0" anchor="ctr"/>
           <a:lstStyle/>
           <a:p>
-            <a:pPr marL="0" indent="0">
+            <a:pPr indent="0" marL="0">
               <a:buNone/>
             </a:pPr>
             <a:r>
@@ -2820,7 +3071,7 @@
           <a:bodyPr wrap="square" rtlCol="0" anchor="ctr"/>
           <a:lstStyle/>
           <a:p>
-            <a:pPr marL="0" indent="0">
+            <a:pPr indent="0" marL="0">
               <a:buNone/>
             </a:pPr>
             <a:r>
@@ -2856,7 +3107,7 @@
           <a:bodyPr wrap="square" rtlCol="0" anchor="ctr"/>
           <a:lstStyle/>
           <a:p>
-            <a:pPr marL="0" indent="0">
+            <a:pPr indent="0" marL="0">
               <a:lnSpc>
                 <a:spcPts val="2000"/>
               </a:lnSpc>
@@ -2873,7 +3124,7 @@
             <a:endParaRPr lang="en-US" sz="1200" dirty="0"/>
           </a:p>
           <a:p>
-            <a:pPr marL="0" indent="0">
+            <a:pPr indent="0" marL="0">
               <a:lnSpc>
                 <a:spcPts val="2000"/>
               </a:lnSpc>
@@ -2959,7 +3210,7 @@
           <a:bodyPr wrap="square" rtlCol="0" anchor="ctr"/>
           <a:lstStyle/>
           <a:p>
-            <a:pPr marL="0" indent="0">
+            <a:pPr indent="0" marL="0">
               <a:buNone/>
             </a:pPr>
             <a:r>
@@ -2971,7 +3222,7 @@
                 <a:ea typeface="Consolas" pitchFamily="34" charset="-122"/>
                 <a:cs typeface="Consolas" pitchFamily="34" charset="-120"/>
               </a:rPr>
-              <a:t>PAUSED</a:t>
+              <a:t>EXPLAINED</a:t>
             </a:r>
             <a:endParaRPr lang="en-US" sz="1000" dirty="0"/>
           </a:p>
@@ -2998,7 +3249,7 @@
           <a:bodyPr wrap="square" rtlCol="0" anchor="ctr"/>
           <a:lstStyle/>
           <a:p>
-            <a:pPr marL="0" indent="0">
+            <a:pPr indent="0" marL="0">
               <a:buNone/>
             </a:pPr>
             <a:r>
@@ -3034,7 +3285,7 @@
           <a:bodyPr wrap="square" rtlCol="0" anchor="ctr"/>
           <a:lstStyle/>
           <a:p>
-            <a:pPr marL="0" indent="0">
+            <a:pPr indent="0" marL="0">
               <a:lnSpc>
                 <a:spcPts val="2000"/>
               </a:lnSpc>
@@ -3046,12 +3297,12 @@
                   <a:srgbClr val="4A4A6A"/>
                 </a:solidFill>
               </a:rPr>
-              <a:t>本轮聚焦producer端</a:t>
+              <a:t>固定总负载指标，多线程并行就该比单线程快</a:t>
             </a:r>
             <a:endParaRPr lang="en-US" sz="1200" dirty="0"/>
           </a:p>
           <a:p>
-            <a:pPr marL="0" indent="0">
+            <a:pPr indent="0" marL="0">
               <a:lnSpc>
                 <a:spcPts val="2000"/>
               </a:lnSpc>
@@ -3063,7 +3314,24 @@
                   <a:srgbClr val="4A4A6A"/>
                 </a:solidFill>
               </a:rPr>
-              <a:t>eBPF线暂停，待后续</a:t>
+              <a:t>eBPF单线程开销重，4T并行优势体现</a:t>
+            </a:r>
+            <a:endParaRPr lang="en-US" sz="1200" dirty="0"/>
+          </a:p>
+          <a:p>
+            <a:pPr indent="0" marL="0">
+              <a:lnSpc>
+                <a:spcPts val="2000"/>
+              </a:lnSpc>
+              <a:buNone/>
+            </a:pPr>
+            <a:r>
+              <a:rPr lang="en-US" sz="1200" dirty="0">
+                <a:solidFill>
+                  <a:srgbClr val="4A4A6A"/>
+                </a:solidFill>
+              </a:rPr>
+              <a:t>本轮聚焦producer端，eBPF暂停</a:t>
             </a:r>
             <a:endParaRPr lang="en-US" sz="1200" dirty="0"/>
           </a:p>
@@ -3085,7 +3353,6 @@
         <a:solidFill>
           <a:srgbClr val="F4F6FB"/>
         </a:solidFill>
-        <a:effectLst/>
       </p:bgPr>
     </p:bg>
     <p:spTree>
@@ -3163,7 +3430,7 @@
           <a:bodyPr wrap="square" rtlCol="0" anchor="ctr"/>
           <a:lstStyle/>
           <a:p>
-            <a:pPr marL="0" indent="0" algn="r">
+            <a:pPr algn="r" indent="0" marL="0">
               <a:buNone/>
             </a:pPr>
             <a:r>
@@ -3202,7 +3469,7 @@
           <a:bodyPr wrap="square" rtlCol="0" anchor="ctr"/>
           <a:lstStyle/>
           <a:p>
-            <a:pPr marL="0" indent="0">
+            <a:pPr indent="0" marL="0">
               <a:buNone/>
             </a:pPr>
             <a:r>
@@ -3238,7 +3505,7 @@
           <a:bodyPr wrap="square" rtlCol="0" anchor="ctr"/>
           <a:lstStyle/>
           <a:p>
-            <a:pPr marL="0" indent="0">
+            <a:pPr indent="0" marL="0">
               <a:buNone/>
             </a:pPr>
             <a:r>
@@ -3255,7 +3522,7 @@
       </p:sp>
       <p:graphicFrame>
         <p:nvGraphicFramePr>
-          <p:cNvPr id="7" name="Table 0"/>
+          <p:cNvPr id="4" name="Table 0"/>
           <p:cNvGraphicFramePr>
             <a:graphicFrameLocks noGrp="1"/>
           </p:cNvGraphicFramePr>
@@ -3276,48 +3543,12 @@
             <a:tbl>
               <a:tblPr/>
               <a:tblGrid>
-                <a:gridCol w="1920240">
-                  <a:extLst>
-                    <a:ext uri="{9D8B030D-6E8A-4147-A177-3AD203B41FA5}">
-                      <a16:colId xmlns:a16="http://schemas.microsoft.com/office/drawing/2014/main" val="20000"/>
-                    </a:ext>
-                  </a:extLst>
-                </a:gridCol>
-                <a:gridCol w="1920240">
-                  <a:extLst>
-                    <a:ext uri="{9D8B030D-6E8A-4147-A177-3AD203B41FA5}">
-                      <a16:colId xmlns:a16="http://schemas.microsoft.com/office/drawing/2014/main" val="20001"/>
-                    </a:ext>
-                  </a:extLst>
-                </a:gridCol>
-                <a:gridCol w="1920240">
-                  <a:extLst>
-                    <a:ext uri="{9D8B030D-6E8A-4147-A177-3AD203B41FA5}">
-                      <a16:colId xmlns:a16="http://schemas.microsoft.com/office/drawing/2014/main" val="20002"/>
-                    </a:ext>
-                  </a:extLst>
-                </a:gridCol>
-                <a:gridCol w="1920240">
-                  <a:extLst>
-                    <a:ext uri="{9D8B030D-6E8A-4147-A177-3AD203B41FA5}">
-                      <a16:colId xmlns:a16="http://schemas.microsoft.com/office/drawing/2014/main" val="20003"/>
-                    </a:ext>
-                  </a:extLst>
-                </a:gridCol>
-                <a:gridCol w="1920240">
-                  <a:extLst>
-                    <a:ext uri="{9D8B030D-6E8A-4147-A177-3AD203B41FA5}">
-                      <a16:colId xmlns:a16="http://schemas.microsoft.com/office/drawing/2014/main" val="20004"/>
-                    </a:ext>
-                  </a:extLst>
-                </a:gridCol>
-                <a:gridCol w="1920240">
-                  <a:extLst>
-                    <a:ext uri="{9D8B030D-6E8A-4147-A177-3AD203B41FA5}">
-                      <a16:colId xmlns:a16="http://schemas.microsoft.com/office/drawing/2014/main" val="20005"/>
-                    </a:ext>
-                  </a:extLst>
-                </a:gridCol>
+                <a:gridCol w="1920240"/>
+                <a:gridCol w="1920240"/>
+                <a:gridCol w="1920240"/>
+                <a:gridCol w="1920240"/>
+                <a:gridCol w="1920240"/>
+                <a:gridCol w="1920240"/>
               </a:tblGrid>
               <a:tr h="384048">
                 <a:tc>
@@ -3325,7 +3556,7 @@
                     <a:bodyPr/>
                     <a:lstStyle/>
                     <a:p>
-                      <a:pPr marL="0" indent="0" algn="l">
+                      <a:pPr algn="l" indent="0" marL="0">
                         <a:buNone/>
                       </a:pPr>
                       <a:r>
@@ -3386,7 +3617,7 @@
                     <a:bodyPr/>
                     <a:lstStyle/>
                     <a:p>
-                      <a:pPr marL="0" indent="0" algn="ctr">
+                      <a:pPr algn="ctr" indent="0" marL="0">
                         <a:buNone/>
                       </a:pPr>
                       <a:r>
@@ -3447,7 +3678,7 @@
                     <a:bodyPr/>
                     <a:lstStyle/>
                     <a:p>
-                      <a:pPr marL="0" indent="0" algn="ctr">
+                      <a:pPr algn="ctr" indent="0" marL="0">
                         <a:buNone/>
                       </a:pPr>
                       <a:r>
@@ -3508,7 +3739,7 @@
                     <a:bodyPr/>
                     <a:lstStyle/>
                     <a:p>
-                      <a:pPr marL="0" indent="0" algn="ctr">
+                      <a:pPr algn="ctr" indent="0" marL="0">
                         <a:buNone/>
                       </a:pPr>
                       <a:r>
@@ -3569,7 +3800,7 @@
                     <a:bodyPr/>
                     <a:lstStyle/>
                     <a:p>
-                      <a:pPr marL="0" indent="0" algn="ctr">
+                      <a:pPr algn="ctr" indent="0" marL="0">
                         <a:buNone/>
                       </a:pPr>
                       <a:r>
@@ -3630,7 +3861,7 @@
                     <a:bodyPr/>
                     <a:lstStyle/>
                     <a:p>
-                      <a:pPr marL="0" indent="0" algn="ctr">
+                      <a:pPr algn="ctr" indent="0" marL="0">
                         <a:buNone/>
                       </a:pPr>
                       <a:r>
@@ -3686,11 +3917,6 @@
                     </a:solidFill>
                   </a:tcPr>
                 </a:tc>
-                <a:extLst>
-                  <a:ext uri="{0D108BD9-81ED-4DB2-BD59-A6C34878D82A}">
-                    <a16:rowId xmlns:a16="http://schemas.microsoft.com/office/drawing/2014/main" val="10000"/>
-                  </a:ext>
-                </a:extLst>
               </a:tr>
               <a:tr h="384048">
                 <a:tc>
@@ -3698,7 +3924,7 @@
                     <a:bodyPr/>
                     <a:lstStyle/>
                     <a:p>
-                      <a:pPr marL="0" indent="0" algn="l">
+                      <a:pPr algn="l" indent="0" marL="0">
                         <a:buNone/>
                       </a:pPr>
                       <a:r>
@@ -3759,7 +3985,7 @@
                     <a:bodyPr/>
                     <a:lstStyle/>
                     <a:p>
-                      <a:pPr marL="0" indent="0" algn="ctr">
+                      <a:pPr algn="ctr" indent="0" marL="0">
                         <a:buNone/>
                       </a:pPr>
                       <a:r>
@@ -3820,7 +4046,7 @@
                     <a:bodyPr/>
                     <a:lstStyle/>
                     <a:p>
-                      <a:pPr marL="0" indent="0" algn="ctr">
+                      <a:pPr algn="ctr" indent="0" marL="0">
                         <a:buNone/>
                       </a:pPr>
                       <a:r>
@@ -3881,7 +4107,7 @@
                     <a:bodyPr/>
                     <a:lstStyle/>
                     <a:p>
-                      <a:pPr marL="0" indent="0" algn="ctr">
+                      <a:pPr algn="ctr" indent="0" marL="0">
                         <a:buNone/>
                       </a:pPr>
                       <a:r>
@@ -3942,7 +4168,7 @@
                     <a:bodyPr/>
                     <a:lstStyle/>
                     <a:p>
-                      <a:pPr marL="0" indent="0" algn="ctr">
+                      <a:pPr algn="ctr" indent="0" marL="0">
                         <a:buNone/>
                       </a:pPr>
                       <a:r>
@@ -4003,7 +4229,7 @@
                     <a:bodyPr/>
                     <a:lstStyle/>
                     <a:p>
-                      <a:pPr marL="0" indent="0" algn="ctr">
+                      <a:pPr algn="ctr" indent="0" marL="0">
                         <a:buNone/>
                       </a:pPr>
                       <a:r>
@@ -4059,11 +4285,6 @@
                     </a:solidFill>
                   </a:tcPr>
                 </a:tc>
-                <a:extLst>
-                  <a:ext uri="{0D108BD9-81ED-4DB2-BD59-A6C34878D82A}">
-                    <a16:rowId xmlns:a16="http://schemas.microsoft.com/office/drawing/2014/main" val="10001"/>
-                  </a:ext>
-                </a:extLst>
               </a:tr>
               <a:tr h="384048">
                 <a:tc>
@@ -4071,7 +4292,7 @@
                     <a:bodyPr/>
                     <a:lstStyle/>
                     <a:p>
-                      <a:pPr marL="0" indent="0" algn="l">
+                      <a:pPr algn="l" indent="0" marL="0">
                         <a:buNone/>
                       </a:pPr>
                       <a:r>
@@ -4132,7 +4353,7 @@
                     <a:bodyPr/>
                     <a:lstStyle/>
                     <a:p>
-                      <a:pPr marL="0" indent="0" algn="ctr">
+                      <a:pPr algn="ctr" indent="0" marL="0">
                         <a:buNone/>
                       </a:pPr>
                       <a:r>
@@ -4193,7 +4414,7 @@
                     <a:bodyPr/>
                     <a:lstStyle/>
                     <a:p>
-                      <a:pPr marL="0" indent="0" algn="ctr">
+                      <a:pPr algn="ctr" indent="0" marL="0">
                         <a:buNone/>
                       </a:pPr>
                       <a:r>
@@ -4254,7 +4475,7 @@
                     <a:bodyPr/>
                     <a:lstStyle/>
                     <a:p>
-                      <a:pPr marL="0" indent="0" algn="ctr">
+                      <a:pPr algn="ctr" indent="0" marL="0">
                         <a:buNone/>
                       </a:pPr>
                       <a:r>
@@ -4315,7 +4536,7 @@
                     <a:bodyPr/>
                     <a:lstStyle/>
                     <a:p>
-                      <a:pPr marL="0" indent="0" algn="ctr">
+                      <a:pPr algn="ctr" indent="0" marL="0">
                         <a:buNone/>
                       </a:pPr>
                       <a:r>
@@ -4376,7 +4597,7 @@
                     <a:bodyPr/>
                     <a:lstStyle/>
                     <a:p>
-                      <a:pPr marL="0" indent="0" algn="ctr">
+                      <a:pPr algn="ctr" indent="0" marL="0">
                         <a:buNone/>
                       </a:pPr>
                       <a:r>
@@ -4432,11 +4653,6 @@
                     </a:solidFill>
                   </a:tcPr>
                 </a:tc>
-                <a:extLst>
-                  <a:ext uri="{0D108BD9-81ED-4DB2-BD59-A6C34878D82A}">
-                    <a16:rowId xmlns:a16="http://schemas.microsoft.com/office/drawing/2014/main" val="10002"/>
-                  </a:ext>
-                </a:extLst>
               </a:tr>
               <a:tr h="384048">
                 <a:tc>
@@ -4444,7 +4660,7 @@
                     <a:bodyPr/>
                     <a:lstStyle/>
                     <a:p>
-                      <a:pPr marL="0" indent="0" algn="l">
+                      <a:pPr algn="l" indent="0" marL="0">
                         <a:buNone/>
                       </a:pPr>
                       <a:r>
@@ -4505,7 +4721,7 @@
                     <a:bodyPr/>
                     <a:lstStyle/>
                     <a:p>
-                      <a:pPr marL="0" indent="0" algn="ctr">
+                      <a:pPr algn="ctr" indent="0" marL="0">
                         <a:buNone/>
                       </a:pPr>
                       <a:r>
@@ -4566,7 +4782,7 @@
                     <a:bodyPr/>
                     <a:lstStyle/>
                     <a:p>
-                      <a:pPr marL="0" indent="0" algn="ctr">
+                      <a:pPr algn="ctr" indent="0" marL="0">
                         <a:buNone/>
                       </a:pPr>
                       <a:r>
@@ -4627,7 +4843,7 @@
                     <a:bodyPr/>
                     <a:lstStyle/>
                     <a:p>
-                      <a:pPr marL="0" indent="0" algn="ctr">
+                      <a:pPr algn="ctr" indent="0" marL="0">
                         <a:buNone/>
                       </a:pPr>
                       <a:r>
@@ -4688,7 +4904,7 @@
                     <a:bodyPr/>
                     <a:lstStyle/>
                     <a:p>
-                      <a:pPr marL="0" indent="0" algn="ctr">
+                      <a:pPr algn="ctr" indent="0" marL="0">
                         <a:buNone/>
                       </a:pPr>
                       <a:r>
@@ -4749,7 +4965,7 @@
                     <a:bodyPr/>
                     <a:lstStyle/>
                     <a:p>
-                      <a:pPr marL="0" indent="0" algn="ctr">
+                      <a:pPr algn="ctr" indent="0" marL="0">
                         <a:buNone/>
                       </a:pPr>
                       <a:r>
@@ -4805,11 +5021,6 @@
                     </a:solidFill>
                   </a:tcPr>
                 </a:tc>
-                <a:extLst>
-                  <a:ext uri="{0D108BD9-81ED-4DB2-BD59-A6C34878D82A}">
-                    <a16:rowId xmlns:a16="http://schemas.microsoft.com/office/drawing/2014/main" val="10003"/>
-                  </a:ext>
-                </a:extLst>
               </a:tr>
               <a:tr h="384048">
                 <a:tc>
@@ -4817,7 +5028,7 @@
                     <a:bodyPr/>
                     <a:lstStyle/>
                     <a:p>
-                      <a:pPr marL="0" indent="0" algn="l">
+                      <a:pPr algn="l" indent="0" marL="0">
                         <a:buNone/>
                       </a:pPr>
                       <a:r>
@@ -4878,7 +5089,7 @@
                     <a:bodyPr/>
                     <a:lstStyle/>
                     <a:p>
-                      <a:pPr marL="0" indent="0" algn="ctr">
+                      <a:pPr algn="ctr" indent="0" marL="0">
                         <a:buNone/>
                       </a:pPr>
                       <a:r>
@@ -4939,7 +5150,7 @@
                     <a:bodyPr/>
                     <a:lstStyle/>
                     <a:p>
-                      <a:pPr marL="0" indent="0" algn="ctr">
+                      <a:pPr algn="ctr" indent="0" marL="0">
                         <a:buNone/>
                       </a:pPr>
                       <a:r>
@@ -5000,7 +5211,7 @@
                     <a:bodyPr/>
                     <a:lstStyle/>
                     <a:p>
-                      <a:pPr marL="0" indent="0" algn="ctr">
+                      <a:pPr algn="ctr" indent="0" marL="0">
                         <a:buNone/>
                       </a:pPr>
                       <a:r>
@@ -5061,7 +5272,7 @@
                     <a:bodyPr/>
                     <a:lstStyle/>
                     <a:p>
-                      <a:pPr marL="0" indent="0" algn="ctr">
+                      <a:pPr algn="ctr" indent="0" marL="0">
                         <a:buNone/>
                       </a:pPr>
                       <a:r>
@@ -5122,7 +5333,7 @@
                     <a:bodyPr/>
                     <a:lstStyle/>
                     <a:p>
-                      <a:pPr marL="0" indent="0" algn="ctr">
+                      <a:pPr algn="ctr" indent="0" marL="0">
                         <a:buNone/>
                       </a:pPr>
                       <a:r>
@@ -5178,11 +5389,6 @@
                     </a:solidFill>
                   </a:tcPr>
                 </a:tc>
-                <a:extLst>
-                  <a:ext uri="{0D108BD9-81ED-4DB2-BD59-A6C34878D82A}">
-                    <a16:rowId xmlns:a16="http://schemas.microsoft.com/office/drawing/2014/main" val="10004"/>
-                  </a:ext>
-                </a:extLst>
               </a:tr>
               <a:tr h="384048">
                 <a:tc>
@@ -5190,7 +5396,7 @@
                     <a:bodyPr/>
                     <a:lstStyle/>
                     <a:p>
-                      <a:pPr marL="0" indent="0" algn="l">
+                      <a:pPr algn="l" indent="0" marL="0">
                         <a:buNone/>
                       </a:pPr>
                       <a:r>
@@ -5251,7 +5457,7 @@
                     <a:bodyPr/>
                     <a:lstStyle/>
                     <a:p>
-                      <a:pPr marL="0" indent="0" algn="ctr">
+                      <a:pPr algn="ctr" indent="0" marL="0">
                         <a:buNone/>
                       </a:pPr>
                       <a:r>
@@ -5312,7 +5518,7 @@
                     <a:bodyPr/>
                     <a:lstStyle/>
                     <a:p>
-                      <a:pPr marL="0" indent="0" algn="ctr">
+                      <a:pPr algn="ctr" indent="0" marL="0">
                         <a:buNone/>
                       </a:pPr>
                       <a:r>
@@ -5373,7 +5579,7 @@
                     <a:bodyPr/>
                     <a:lstStyle/>
                     <a:p>
-                      <a:pPr marL="0" indent="0" algn="ctr">
+                      <a:pPr algn="ctr" indent="0" marL="0">
                         <a:buNone/>
                       </a:pPr>
                       <a:r>
@@ -5434,7 +5640,7 @@
                     <a:bodyPr/>
                     <a:lstStyle/>
                     <a:p>
-                      <a:pPr marL="0" indent="0" algn="ctr">
+                      <a:pPr algn="ctr" indent="0" marL="0">
                         <a:buNone/>
                       </a:pPr>
                       <a:r>
@@ -5495,7 +5701,7 @@
                     <a:bodyPr/>
                     <a:lstStyle/>
                     <a:p>
-                      <a:pPr marL="0" indent="0" algn="ctr">
+                      <a:pPr algn="ctr" indent="0" marL="0">
                         <a:buNone/>
                       </a:pPr>
                       <a:r>
@@ -5551,11 +5757,6 @@
                     </a:solidFill>
                   </a:tcPr>
                 </a:tc>
-                <a:extLst>
-                  <a:ext uri="{0D108BD9-81ED-4DB2-BD59-A6C34878D82A}">
-                    <a16:rowId xmlns:a16="http://schemas.microsoft.com/office/drawing/2014/main" val="10005"/>
-                  </a:ext>
-                </a:extLst>
               </a:tr>
               <a:tr h="384048">
                 <a:tc>
@@ -5563,7 +5764,7 @@
                     <a:bodyPr/>
                     <a:lstStyle/>
                     <a:p>
-                      <a:pPr marL="0" indent="0" algn="l">
+                      <a:pPr algn="l" indent="0" marL="0">
                         <a:buNone/>
                       </a:pPr>
                       <a:r>
@@ -5624,7 +5825,7 @@
                     <a:bodyPr/>
                     <a:lstStyle/>
                     <a:p>
-                      <a:pPr marL="0" indent="0" algn="ctr">
+                      <a:pPr algn="ctr" indent="0" marL="0">
                         <a:buNone/>
                       </a:pPr>
                       <a:r>
@@ -5685,7 +5886,7 @@
                     <a:bodyPr/>
                     <a:lstStyle/>
                     <a:p>
-                      <a:pPr marL="0" indent="0" algn="ctr">
+                      <a:pPr algn="ctr" indent="0" marL="0">
                         <a:buNone/>
                       </a:pPr>
                       <a:r>
@@ -5746,7 +5947,7 @@
                     <a:bodyPr/>
                     <a:lstStyle/>
                     <a:p>
-                      <a:pPr marL="0" indent="0" algn="ctr">
+                      <a:pPr algn="ctr" indent="0" marL="0">
                         <a:buNone/>
                       </a:pPr>
                       <a:r>
@@ -5807,7 +6008,7 @@
                     <a:bodyPr/>
                     <a:lstStyle/>
                     <a:p>
-                      <a:pPr marL="0" indent="0" algn="ctr">
+                      <a:pPr algn="ctr" indent="0" marL="0">
                         <a:buNone/>
                       </a:pPr>
                       <a:r>
@@ -5868,7 +6069,7 @@
                     <a:bodyPr/>
                     <a:lstStyle/>
                     <a:p>
-                      <a:pPr marL="0" indent="0" algn="ctr">
+                      <a:pPr algn="ctr" indent="0" marL="0">
                         <a:buNone/>
                       </a:pPr>
                       <a:r>
@@ -5924,11 +6125,6 @@
                     </a:solidFill>
                   </a:tcPr>
                 </a:tc>
-                <a:extLst>
-                  <a:ext uri="{0D108BD9-81ED-4DB2-BD59-A6C34878D82A}">
-                    <a16:rowId xmlns:a16="http://schemas.microsoft.com/office/drawing/2014/main" val="10006"/>
-                  </a:ext>
-                </a:extLst>
               </a:tr>
             </a:tbl>
           </a:graphicData>
@@ -6014,7 +6210,6 @@
         <a:solidFill>
           <a:srgbClr val="F4F6FB"/>
         </a:solidFill>
-        <a:effectLst/>
       </p:bgPr>
     </p:bg>
     <p:spTree>
@@ -6092,7 +6287,7 @@
           <a:bodyPr wrap="square" rtlCol="0" anchor="ctr"/>
           <a:lstStyle/>
           <a:p>
-            <a:pPr marL="0" indent="0" algn="r">
+            <a:pPr algn="r" indent="0" marL="0">
               <a:buNone/>
             </a:pPr>
             <a:r>
@@ -6131,7 +6326,7 @@
           <a:bodyPr wrap="square" rtlCol="0" anchor="ctr"/>
           <a:lstStyle/>
           <a:p>
-            <a:pPr marL="0" indent="0">
+            <a:pPr indent="0" marL="0">
               <a:buNone/>
             </a:pPr>
             <a:r>
@@ -6167,7 +6362,7 @@
           <a:bodyPr wrap="square" rtlCol="0" anchor="ctr"/>
           <a:lstStyle/>
           <a:p>
-            <a:pPr marL="0" indent="0">
+            <a:pPr indent="0" marL="0">
               <a:buNone/>
             </a:pPr>
             <a:r>
@@ -6250,7 +6445,7 @@
           <a:bodyPr wrap="square" rtlCol="0" anchor="ctr"/>
           <a:lstStyle/>
           <a:p>
-            <a:pPr marL="0" indent="0">
+            <a:pPr indent="0" marL="0">
               <a:buNone/>
             </a:pPr>
             <a:r>
@@ -6289,7 +6484,7 @@
           <a:bodyPr wrap="square" rtlCol="0" anchor="ctr"/>
           <a:lstStyle/>
           <a:p>
-            <a:pPr marL="0" indent="0">
+            <a:pPr indent="0" marL="0">
               <a:buNone/>
             </a:pPr>
             <a:r>
@@ -6457,7 +6652,7 @@
           <a:bodyPr wrap="square" rtlCol="0" anchor="ctr"/>
           <a:lstStyle/>
           <a:p>
-            <a:pPr marL="0" indent="0">
+            <a:pPr indent="0" marL="0">
               <a:buNone/>
             </a:pPr>
             <a:r>
@@ -6496,7 +6691,7 @@
           <a:bodyPr wrap="square" rtlCol="0" anchor="ctr"/>
           <a:lstStyle/>
           <a:p>
-            <a:pPr marL="0" indent="0">
+            <a:pPr indent="0" marL="0">
               <a:buNone/>
             </a:pPr>
             <a:r>
@@ -6664,7 +6859,7 @@
           <a:bodyPr wrap="square" rtlCol="0" anchor="ctr"/>
           <a:lstStyle/>
           <a:p>
-            <a:pPr marL="0" indent="0">
+            <a:pPr indent="0" marL="0">
               <a:buNone/>
             </a:pPr>
             <a:r>
@@ -6703,7 +6898,7 @@
           <a:bodyPr wrap="square" rtlCol="0" anchor="ctr"/>
           <a:lstStyle/>
           <a:p>
-            <a:pPr marL="0" indent="0">
+            <a:pPr indent="0" marL="0">
               <a:buNone/>
             </a:pPr>
             <a:r>
@@ -6819,7 +7014,6 @@
         <a:solidFill>
           <a:srgbClr val="F4F6FB"/>
         </a:solidFill>
-        <a:effectLst/>
       </p:bgPr>
     </p:bg>
     <p:spTree>
@@ -6897,7 +7091,7 @@
           <a:bodyPr wrap="square" rtlCol="0" anchor="ctr"/>
           <a:lstStyle/>
           <a:p>
-            <a:pPr marL="0" indent="0" algn="r">
+            <a:pPr algn="r" indent="0" marL="0">
               <a:buNone/>
             </a:pPr>
             <a:r>
@@ -6936,7 +7130,7 @@
           <a:bodyPr wrap="square" rtlCol="0" anchor="ctr"/>
           <a:lstStyle/>
           <a:p>
-            <a:pPr marL="0" indent="0">
+            <a:pPr indent="0" marL="0">
               <a:buNone/>
             </a:pPr>
             <a:r>
@@ -6972,7 +7166,7 @@
           <a:bodyPr wrap="square" rtlCol="0" anchor="ctr"/>
           <a:lstStyle/>
           <a:p>
-            <a:pPr marL="0" indent="0">
+            <a:pPr indent="0" marL="0">
               <a:buNone/>
             </a:pPr>
             <a:r>
@@ -7008,7 +7202,7 @@
           <a:bodyPr wrap="square" rtlCol="0" anchor="ctr"/>
           <a:lstStyle/>
           <a:p>
-            <a:pPr marL="0" indent="0" algn="ctr">
+            <a:pPr algn="ctr" indent="0" marL="0">
               <a:buNone/>
             </a:pPr>
             <a:r>
@@ -7047,7 +7241,7 @@
           <a:bodyPr wrap="square" rtlCol="0" anchor="ctr"/>
           <a:lstStyle/>
           <a:p>
-            <a:pPr marL="0" indent="0" algn="ctr">
+            <a:pPr algn="ctr" indent="0" marL="0">
               <a:buNone/>
             </a:pPr>
             <a:r>
@@ -7083,7 +7277,7 @@
           <a:bodyPr wrap="square" rtlCol="0" anchor="ctr"/>
           <a:lstStyle/>
           <a:p>
-            <a:pPr marL="0" indent="0" algn="ctr">
+            <a:pPr algn="ctr" indent="0" marL="0">
               <a:buNone/>
             </a:pPr>
             <a:r>
@@ -7122,7 +7316,7 @@
           <a:bodyPr wrap="square" rtlCol="0" anchor="ctr"/>
           <a:lstStyle/>
           <a:p>
-            <a:pPr marL="0" indent="0" algn="ctr">
+            <a:pPr algn="ctr" indent="0" marL="0">
               <a:buNone/>
             </a:pPr>
             <a:r>
@@ -7158,7 +7352,7 @@
           <a:bodyPr wrap="square" rtlCol="0" anchor="ctr"/>
           <a:lstStyle/>
           <a:p>
-            <a:pPr marL="0" indent="0" algn="ctr">
+            <a:pPr algn="ctr" indent="0" marL="0">
               <a:buNone/>
             </a:pPr>
             <a:r>
@@ -7197,7 +7391,7 @@
           <a:bodyPr wrap="square" rtlCol="0" anchor="ctr"/>
           <a:lstStyle/>
           <a:p>
-            <a:pPr marL="0" indent="0" algn="ctr">
+            <a:pPr algn="ctr" indent="0" marL="0">
               <a:buNone/>
             </a:pPr>
             <a:r>
@@ -7233,7 +7427,7 @@
           <a:bodyPr wrap="square" rtlCol="0" anchor="ctr"/>
           <a:lstStyle/>
           <a:p>
-            <a:pPr marL="0" indent="0" algn="ctr">
+            <a:pPr algn="ctr" indent="0" marL="0">
               <a:buNone/>
             </a:pPr>
             <a:r>
@@ -7272,7 +7466,7 @@
           <a:bodyPr wrap="square" rtlCol="0" anchor="ctr"/>
           <a:lstStyle/>
           <a:p>
-            <a:pPr marL="0" indent="0" algn="ctr">
+            <a:pPr algn="ctr" indent="0" marL="0">
               <a:buNone/>
             </a:pPr>
             <a:r>
@@ -7289,7 +7483,7 @@
       </p:sp>
       <p:graphicFrame>
         <p:nvGraphicFramePr>
-          <p:cNvPr id="15" name="Table 0"/>
+          <p:cNvPr id="6" name="Table 0"/>
           <p:cNvGraphicFramePr>
             <a:graphicFrameLocks noGrp="1"/>
           </p:cNvGraphicFramePr>
@@ -7310,34 +7504,10 @@
             <a:tbl>
               <a:tblPr/>
               <a:tblGrid>
-                <a:gridCol w="2880360">
-                  <a:extLst>
-                    <a:ext uri="{9D8B030D-6E8A-4147-A177-3AD203B41FA5}">
-                      <a16:colId xmlns:a16="http://schemas.microsoft.com/office/drawing/2014/main" val="20000"/>
-                    </a:ext>
-                  </a:extLst>
-                </a:gridCol>
-                <a:gridCol w="2880360">
-                  <a:extLst>
-                    <a:ext uri="{9D8B030D-6E8A-4147-A177-3AD203B41FA5}">
-                      <a16:colId xmlns:a16="http://schemas.microsoft.com/office/drawing/2014/main" val="20001"/>
-                    </a:ext>
-                  </a:extLst>
-                </a:gridCol>
-                <a:gridCol w="2880360">
-                  <a:extLst>
-                    <a:ext uri="{9D8B030D-6E8A-4147-A177-3AD203B41FA5}">
-                      <a16:colId xmlns:a16="http://schemas.microsoft.com/office/drawing/2014/main" val="20002"/>
-                    </a:ext>
-                  </a:extLst>
-                </a:gridCol>
-                <a:gridCol w="2880360">
-                  <a:extLst>
-                    <a:ext uri="{9D8B030D-6E8A-4147-A177-3AD203B41FA5}">
-                      <a16:colId xmlns:a16="http://schemas.microsoft.com/office/drawing/2014/main" val="20003"/>
-                    </a:ext>
-                  </a:extLst>
-                </a:gridCol>
+                <a:gridCol w="2880360"/>
+                <a:gridCol w="2880360"/>
+                <a:gridCol w="2880360"/>
+                <a:gridCol w="2880360"/>
               </a:tblGrid>
               <a:tr h="384048">
                 <a:tc>
@@ -7345,7 +7515,7 @@
                     <a:bodyPr/>
                     <a:lstStyle/>
                     <a:p>
-                      <a:pPr marL="0" indent="0" algn="l">
+                      <a:pPr algn="l" indent="0" marL="0">
                         <a:buNone/>
                       </a:pPr>
                       <a:r>
@@ -7406,7 +7576,7 @@
                     <a:bodyPr/>
                     <a:lstStyle/>
                     <a:p>
-                      <a:pPr marL="0" indent="0" algn="ctr">
+                      <a:pPr algn="ctr" indent="0" marL="0">
                         <a:buNone/>
                       </a:pPr>
                       <a:r>
@@ -7467,7 +7637,7 @@
                     <a:bodyPr/>
                     <a:lstStyle/>
                     <a:p>
-                      <a:pPr marL="0" indent="0" algn="ctr">
+                      <a:pPr algn="ctr" indent="0" marL="0">
                         <a:buNone/>
                       </a:pPr>
                       <a:r>
@@ -7528,7 +7698,7 @@
                     <a:bodyPr/>
                     <a:lstStyle/>
                     <a:p>
-                      <a:pPr marL="0" indent="0" algn="ctr">
+                      <a:pPr algn="ctr" indent="0" marL="0">
                         <a:buNone/>
                       </a:pPr>
                       <a:r>
@@ -7584,11 +7754,6 @@
                     </a:solidFill>
                   </a:tcPr>
                 </a:tc>
-                <a:extLst>
-                  <a:ext uri="{0D108BD9-81ED-4DB2-BD59-A6C34878D82A}">
-                    <a16:rowId xmlns:a16="http://schemas.microsoft.com/office/drawing/2014/main" val="10000"/>
-                  </a:ext>
-                </a:extLst>
               </a:tr>
               <a:tr h="384048">
                 <a:tc>
@@ -7596,7 +7761,7 @@
                     <a:bodyPr/>
                     <a:lstStyle/>
                     <a:p>
-                      <a:pPr marL="0" indent="0" algn="l">
+                      <a:pPr algn="l" indent="0" marL="0">
                         <a:buNone/>
                       </a:pPr>
                       <a:r>
@@ -7657,7 +7822,7 @@
                     <a:bodyPr/>
                     <a:lstStyle/>
                     <a:p>
-                      <a:pPr marL="0" indent="0" algn="ctr">
+                      <a:pPr algn="ctr" indent="0" marL="0">
                         <a:buNone/>
                       </a:pPr>
                       <a:r>
@@ -7718,7 +7883,7 @@
                     <a:bodyPr/>
                     <a:lstStyle/>
                     <a:p>
-                      <a:pPr marL="0" indent="0" algn="ctr">
+                      <a:pPr algn="ctr" indent="0" marL="0">
                         <a:buNone/>
                       </a:pPr>
                       <a:r>
@@ -7779,7 +7944,7 @@
                     <a:bodyPr/>
                     <a:lstStyle/>
                     <a:p>
-                      <a:pPr marL="0" indent="0" algn="ctr">
+                      <a:pPr algn="ctr" indent="0" marL="0">
                         <a:buNone/>
                       </a:pPr>
                       <a:r>
@@ -7835,11 +8000,6 @@
                     </a:solidFill>
                   </a:tcPr>
                 </a:tc>
-                <a:extLst>
-                  <a:ext uri="{0D108BD9-81ED-4DB2-BD59-A6C34878D82A}">
-                    <a16:rowId xmlns:a16="http://schemas.microsoft.com/office/drawing/2014/main" val="10001"/>
-                  </a:ext>
-                </a:extLst>
               </a:tr>
               <a:tr h="384048">
                 <a:tc>
@@ -7847,7 +8007,7 @@
                     <a:bodyPr/>
                     <a:lstStyle/>
                     <a:p>
-                      <a:pPr marL="0" indent="0" algn="l">
+                      <a:pPr algn="l" indent="0" marL="0">
                         <a:buNone/>
                       </a:pPr>
                       <a:r>
@@ -7908,7 +8068,7 @@
                     <a:bodyPr/>
                     <a:lstStyle/>
                     <a:p>
-                      <a:pPr marL="0" indent="0" algn="ctr">
+                      <a:pPr algn="ctr" indent="0" marL="0">
                         <a:buNone/>
                       </a:pPr>
                       <a:r>
@@ -7969,7 +8129,7 @@
                     <a:bodyPr/>
                     <a:lstStyle/>
                     <a:p>
-                      <a:pPr marL="0" indent="0" algn="ctr">
+                      <a:pPr algn="ctr" indent="0" marL="0">
                         <a:buNone/>
                       </a:pPr>
                       <a:r>
@@ -8030,7 +8190,7 @@
                     <a:bodyPr/>
                     <a:lstStyle/>
                     <a:p>
-                      <a:pPr marL="0" indent="0" algn="ctr">
+                      <a:pPr algn="ctr" indent="0" marL="0">
                         <a:buNone/>
                       </a:pPr>
                       <a:r>
@@ -8086,11 +8246,6 @@
                     </a:solidFill>
                   </a:tcPr>
                 </a:tc>
-                <a:extLst>
-                  <a:ext uri="{0D108BD9-81ED-4DB2-BD59-A6C34878D82A}">
-                    <a16:rowId xmlns:a16="http://schemas.microsoft.com/office/drawing/2014/main" val="10002"/>
-                  </a:ext>
-                </a:extLst>
               </a:tr>
               <a:tr h="384048">
                 <a:tc>
@@ -8098,7 +8253,7 @@
                     <a:bodyPr/>
                     <a:lstStyle/>
                     <a:p>
-                      <a:pPr marL="0" indent="0" algn="l">
+                      <a:pPr algn="l" indent="0" marL="0">
                         <a:buNone/>
                       </a:pPr>
                       <a:r>
@@ -8159,7 +8314,7 @@
                     <a:bodyPr/>
                     <a:lstStyle/>
                     <a:p>
-                      <a:pPr marL="0" indent="0" algn="ctr">
+                      <a:pPr algn="ctr" indent="0" marL="0">
                         <a:buNone/>
                       </a:pPr>
                       <a:r>
@@ -8220,7 +8375,7 @@
                     <a:bodyPr/>
                     <a:lstStyle/>
                     <a:p>
-                      <a:pPr marL="0" indent="0" algn="ctr">
+                      <a:pPr algn="ctr" indent="0" marL="0">
                         <a:buNone/>
                       </a:pPr>
                       <a:r>
@@ -8281,7 +8436,7 @@
                     <a:bodyPr/>
                     <a:lstStyle/>
                     <a:p>
-                      <a:pPr marL="0" indent="0" algn="ctr">
+                      <a:pPr algn="ctr" indent="0" marL="0">
                         <a:buNone/>
                       </a:pPr>
                       <a:r>
@@ -8337,11 +8492,6 @@
                     </a:solidFill>
                   </a:tcPr>
                 </a:tc>
-                <a:extLst>
-                  <a:ext uri="{0D108BD9-81ED-4DB2-BD59-A6C34878D82A}">
-                    <a16:rowId xmlns:a16="http://schemas.microsoft.com/office/drawing/2014/main" val="10003"/>
-                  </a:ext>
-                </a:extLst>
               </a:tr>
               <a:tr h="384048">
                 <a:tc>
@@ -8349,7 +8499,7 @@
                     <a:bodyPr/>
                     <a:lstStyle/>
                     <a:p>
-                      <a:pPr marL="0" indent="0" algn="l">
+                      <a:pPr algn="l" indent="0" marL="0">
                         <a:buNone/>
                       </a:pPr>
                       <a:r>
@@ -8410,7 +8560,7 @@
                     <a:bodyPr/>
                     <a:lstStyle/>
                     <a:p>
-                      <a:pPr marL="0" indent="0" algn="ctr">
+                      <a:pPr algn="ctr" indent="0" marL="0">
                         <a:buNone/>
                       </a:pPr>
                       <a:r>
@@ -8471,7 +8621,7 @@
                     <a:bodyPr/>
                     <a:lstStyle/>
                     <a:p>
-                      <a:pPr marL="0" indent="0" algn="ctr">
+                      <a:pPr algn="ctr" indent="0" marL="0">
                         <a:buNone/>
                       </a:pPr>
                       <a:r>
@@ -8532,7 +8682,7 @@
                     <a:bodyPr/>
                     <a:lstStyle/>
                     <a:p>
-                      <a:pPr marL="0" indent="0" algn="ctr">
+                      <a:pPr algn="ctr" indent="0" marL="0">
                         <a:buNone/>
                       </a:pPr>
                       <a:r>
@@ -8588,11 +8738,6 @@
                     </a:solidFill>
                   </a:tcPr>
                 </a:tc>
-                <a:extLst>
-                  <a:ext uri="{0D108BD9-81ED-4DB2-BD59-A6C34878D82A}">
-                    <a16:rowId xmlns:a16="http://schemas.microsoft.com/office/drawing/2014/main" val="10004"/>
-                  </a:ext>
-                </a:extLst>
               </a:tr>
             </a:tbl>
           </a:graphicData>
@@ -8678,7 +8823,6 @@
         <a:solidFill>
           <a:srgbClr val="F4F6FB"/>
         </a:solidFill>
-        <a:effectLst/>
       </p:bgPr>
     </p:bg>
     <p:spTree>
@@ -8756,7 +8900,7 @@
           <a:bodyPr wrap="square" rtlCol="0" anchor="ctr"/>
           <a:lstStyle/>
           <a:p>
-            <a:pPr marL="0" indent="0" algn="r">
+            <a:pPr algn="r" indent="0" marL="0">
               <a:buNone/>
             </a:pPr>
             <a:r>
@@ -8795,7 +8939,7 @@
           <a:bodyPr wrap="square" rtlCol="0" anchor="ctr"/>
           <a:lstStyle/>
           <a:p>
-            <a:pPr marL="0" indent="0">
+            <a:pPr indent="0" marL="0">
               <a:buNone/>
             </a:pPr>
             <a:r>
@@ -8831,7 +8975,7 @@
           <a:bodyPr wrap="square" rtlCol="0" anchor="ctr"/>
           <a:lstStyle/>
           <a:p>
-            <a:pPr marL="0" indent="0">
+            <a:pPr indent="0" marL="0">
               <a:buNone/>
             </a:pPr>
             <a:r>
@@ -8869,48 +9013,12 @@
             <a:tbl>
               <a:tblPr/>
               <a:tblGrid>
-                <a:gridCol w="1920240">
-                  <a:extLst>
-                    <a:ext uri="{9D8B030D-6E8A-4147-A177-3AD203B41FA5}">
-                      <a16:colId xmlns:a16="http://schemas.microsoft.com/office/drawing/2014/main" val="20000"/>
-                    </a:ext>
-                  </a:extLst>
-                </a:gridCol>
-                <a:gridCol w="1920240">
-                  <a:extLst>
-                    <a:ext uri="{9D8B030D-6E8A-4147-A177-3AD203B41FA5}">
-                      <a16:colId xmlns:a16="http://schemas.microsoft.com/office/drawing/2014/main" val="20001"/>
-                    </a:ext>
-                  </a:extLst>
-                </a:gridCol>
-                <a:gridCol w="1920240">
-                  <a:extLst>
-                    <a:ext uri="{9D8B030D-6E8A-4147-A177-3AD203B41FA5}">
-                      <a16:colId xmlns:a16="http://schemas.microsoft.com/office/drawing/2014/main" val="20002"/>
-                    </a:ext>
-                  </a:extLst>
-                </a:gridCol>
-                <a:gridCol w="1920240">
-                  <a:extLst>
-                    <a:ext uri="{9D8B030D-6E8A-4147-A177-3AD203B41FA5}">
-                      <a16:colId xmlns:a16="http://schemas.microsoft.com/office/drawing/2014/main" val="20003"/>
-                    </a:ext>
-                  </a:extLst>
-                </a:gridCol>
-                <a:gridCol w="1920240">
-                  <a:extLst>
-                    <a:ext uri="{9D8B030D-6E8A-4147-A177-3AD203B41FA5}">
-                      <a16:colId xmlns:a16="http://schemas.microsoft.com/office/drawing/2014/main" val="20004"/>
-                    </a:ext>
-                  </a:extLst>
-                </a:gridCol>
-                <a:gridCol w="1920240">
-                  <a:extLst>
-                    <a:ext uri="{9D8B030D-6E8A-4147-A177-3AD203B41FA5}">
-                      <a16:colId xmlns:a16="http://schemas.microsoft.com/office/drawing/2014/main" val="20005"/>
-                    </a:ext>
-                  </a:extLst>
-                </a:gridCol>
+                <a:gridCol w="1920240"/>
+                <a:gridCol w="1920240"/>
+                <a:gridCol w="1920240"/>
+                <a:gridCol w="1920240"/>
+                <a:gridCol w="1920240"/>
+                <a:gridCol w="1920240"/>
               </a:tblGrid>
               <a:tr h="384048">
                 <a:tc>
@@ -8918,7 +9026,7 @@
                     <a:bodyPr/>
                     <a:lstStyle/>
                     <a:p>
-                      <a:pPr marL="0" indent="0" algn="l">
+                      <a:pPr algn="l" indent="0" marL="0">
                         <a:buNone/>
                       </a:pPr>
                       <a:r>
@@ -8979,7 +9087,7 @@
                     <a:bodyPr/>
                     <a:lstStyle/>
                     <a:p>
-                      <a:pPr marL="0" indent="0" algn="ctr">
+                      <a:pPr algn="ctr" indent="0" marL="0">
                         <a:buNone/>
                       </a:pPr>
                       <a:r>
@@ -9040,7 +9148,7 @@
                     <a:bodyPr/>
                     <a:lstStyle/>
                     <a:p>
-                      <a:pPr marL="0" indent="0" algn="ctr">
+                      <a:pPr algn="ctr" indent="0" marL="0">
                         <a:buNone/>
                       </a:pPr>
                       <a:r>
@@ -9101,7 +9209,7 @@
                     <a:bodyPr/>
                     <a:lstStyle/>
                     <a:p>
-                      <a:pPr marL="0" indent="0" algn="ctr">
+                      <a:pPr algn="ctr" indent="0" marL="0">
                         <a:buNone/>
                       </a:pPr>
                       <a:r>
@@ -9162,7 +9270,7 @@
                     <a:bodyPr/>
                     <a:lstStyle/>
                     <a:p>
-                      <a:pPr marL="0" indent="0" algn="ctr">
+                      <a:pPr algn="ctr" indent="0" marL="0">
                         <a:buNone/>
                       </a:pPr>
                       <a:r>
@@ -9223,7 +9331,7 @@
                     <a:bodyPr/>
                     <a:lstStyle/>
                     <a:p>
-                      <a:pPr marL="0" indent="0" algn="ctr">
+                      <a:pPr algn="ctr" indent="0" marL="0">
                         <a:buNone/>
                       </a:pPr>
                       <a:r>
@@ -9279,11 +9387,6 @@
                     </a:solidFill>
                   </a:tcPr>
                 </a:tc>
-                <a:extLst>
-                  <a:ext uri="{0D108BD9-81ED-4DB2-BD59-A6C34878D82A}">
-                    <a16:rowId xmlns:a16="http://schemas.microsoft.com/office/drawing/2014/main" val="10000"/>
-                  </a:ext>
-                </a:extLst>
               </a:tr>
               <a:tr h="384048">
                 <a:tc>
@@ -9291,7 +9394,7 @@
                     <a:bodyPr/>
                     <a:lstStyle/>
                     <a:p>
-                      <a:pPr marL="0" indent="0" algn="l">
+                      <a:pPr algn="l" indent="0" marL="0">
                         <a:buNone/>
                       </a:pPr>
                       <a:r>
@@ -9352,7 +9455,7 @@
                     <a:bodyPr/>
                     <a:lstStyle/>
                     <a:p>
-                      <a:pPr marL="0" indent="0" algn="ctr">
+                      <a:pPr algn="ctr" indent="0" marL="0">
                         <a:buNone/>
                       </a:pPr>
                       <a:r>
@@ -9413,7 +9516,7 @@
                     <a:bodyPr/>
                     <a:lstStyle/>
                     <a:p>
-                      <a:pPr marL="0" indent="0" algn="ctr">
+                      <a:pPr algn="ctr" indent="0" marL="0">
                         <a:buNone/>
                       </a:pPr>
                       <a:r>
@@ -9474,7 +9577,7 @@
                     <a:bodyPr/>
                     <a:lstStyle/>
                     <a:p>
-                      <a:pPr marL="0" indent="0" algn="ctr">
+                      <a:pPr algn="ctr" indent="0" marL="0">
                         <a:buNone/>
                       </a:pPr>
                       <a:r>
@@ -9535,7 +9638,7 @@
                     <a:bodyPr/>
                     <a:lstStyle/>
                     <a:p>
-                      <a:pPr marL="0" indent="0" algn="ctr">
+                      <a:pPr algn="ctr" indent="0" marL="0">
                         <a:buNone/>
                       </a:pPr>
                       <a:r>
@@ -9596,7 +9699,7 @@
                     <a:bodyPr/>
                     <a:lstStyle/>
                     <a:p>
-                      <a:pPr marL="0" indent="0" algn="ctr">
+                      <a:pPr algn="ctr" indent="0" marL="0">
                         <a:buNone/>
                       </a:pPr>
                       <a:r>
@@ -9652,11 +9755,6 @@
                     </a:solidFill>
                   </a:tcPr>
                 </a:tc>
-                <a:extLst>
-                  <a:ext uri="{0D108BD9-81ED-4DB2-BD59-A6C34878D82A}">
-                    <a16:rowId xmlns:a16="http://schemas.microsoft.com/office/drawing/2014/main" val="10001"/>
-                  </a:ext>
-                </a:extLst>
               </a:tr>
               <a:tr h="384048">
                 <a:tc>
@@ -9664,7 +9762,7 @@
                     <a:bodyPr/>
                     <a:lstStyle/>
                     <a:p>
-                      <a:pPr marL="0" indent="0" algn="l">
+                      <a:pPr algn="l" indent="0" marL="0">
                         <a:buNone/>
                       </a:pPr>
                       <a:r>
@@ -9725,7 +9823,7 @@
                     <a:bodyPr/>
                     <a:lstStyle/>
                     <a:p>
-                      <a:pPr marL="0" indent="0" algn="ctr">
+                      <a:pPr algn="ctr" indent="0" marL="0">
                         <a:buNone/>
                       </a:pPr>
                       <a:r>
@@ -9786,7 +9884,7 @@
                     <a:bodyPr/>
                     <a:lstStyle/>
                     <a:p>
-                      <a:pPr marL="0" indent="0" algn="ctr">
+                      <a:pPr algn="ctr" indent="0" marL="0">
                         <a:buNone/>
                       </a:pPr>
                       <a:r>
@@ -9847,7 +9945,7 @@
                     <a:bodyPr/>
                     <a:lstStyle/>
                     <a:p>
-                      <a:pPr marL="0" indent="0" algn="ctr">
+                      <a:pPr algn="ctr" indent="0" marL="0">
                         <a:buNone/>
                       </a:pPr>
                       <a:r>
@@ -9908,7 +10006,7 @@
                     <a:bodyPr/>
                     <a:lstStyle/>
                     <a:p>
-                      <a:pPr marL="0" indent="0" algn="ctr">
+                      <a:pPr algn="ctr" indent="0" marL="0">
                         <a:buNone/>
                       </a:pPr>
                       <a:r>
@@ -9969,7 +10067,7 @@
                     <a:bodyPr/>
                     <a:lstStyle/>
                     <a:p>
-                      <a:pPr marL="0" indent="0" algn="ctr">
+                      <a:pPr algn="ctr" indent="0" marL="0">
                         <a:buNone/>
                       </a:pPr>
                       <a:r>
@@ -10025,11 +10123,6 @@
                     </a:solidFill>
                   </a:tcPr>
                 </a:tc>
-                <a:extLst>
-                  <a:ext uri="{0D108BD9-81ED-4DB2-BD59-A6C34878D82A}">
-                    <a16:rowId xmlns:a16="http://schemas.microsoft.com/office/drawing/2014/main" val="10002"/>
-                  </a:ext>
-                </a:extLst>
               </a:tr>
               <a:tr h="384048">
                 <a:tc>
@@ -10037,7 +10130,7 @@
                     <a:bodyPr/>
                     <a:lstStyle/>
                     <a:p>
-                      <a:pPr marL="0" indent="0" algn="l">
+                      <a:pPr algn="l" indent="0" marL="0">
                         <a:buNone/>
                       </a:pPr>
                       <a:r>
@@ -10098,7 +10191,7 @@
                     <a:bodyPr/>
                     <a:lstStyle/>
                     <a:p>
-                      <a:pPr marL="0" indent="0" algn="ctr">
+                      <a:pPr algn="ctr" indent="0" marL="0">
                         <a:buNone/>
                       </a:pPr>
                       <a:r>
@@ -10159,7 +10252,7 @@
                     <a:bodyPr/>
                     <a:lstStyle/>
                     <a:p>
-                      <a:pPr marL="0" indent="0" algn="ctr">
+                      <a:pPr algn="ctr" indent="0" marL="0">
                         <a:buNone/>
                       </a:pPr>
                       <a:r>
@@ -10220,7 +10313,7 @@
                     <a:bodyPr/>
                     <a:lstStyle/>
                     <a:p>
-                      <a:pPr marL="0" indent="0" algn="ctr">
+                      <a:pPr algn="ctr" indent="0" marL="0">
                         <a:buNone/>
                       </a:pPr>
                       <a:r>
@@ -10281,7 +10374,7 @@
                     <a:bodyPr/>
                     <a:lstStyle/>
                     <a:p>
-                      <a:pPr marL="0" indent="0" algn="ctr">
+                      <a:pPr algn="ctr" indent="0" marL="0">
                         <a:buNone/>
                       </a:pPr>
                       <a:r>
@@ -10342,7 +10435,7 @@
                     <a:bodyPr/>
                     <a:lstStyle/>
                     <a:p>
-                      <a:pPr marL="0" indent="0" algn="ctr">
+                      <a:pPr algn="ctr" indent="0" marL="0">
                         <a:buNone/>
                       </a:pPr>
                       <a:r>
@@ -10398,11 +10491,6 @@
                     </a:solidFill>
                   </a:tcPr>
                 </a:tc>
-                <a:extLst>
-                  <a:ext uri="{0D108BD9-81ED-4DB2-BD59-A6C34878D82A}">
-                    <a16:rowId xmlns:a16="http://schemas.microsoft.com/office/drawing/2014/main" val="10003"/>
-                  </a:ext>
-                </a:extLst>
               </a:tr>
             </a:tbl>
           </a:graphicData>
@@ -10530,7 +10618,6 @@
         <a:solidFill>
           <a:srgbClr val="F4F6FB"/>
         </a:solidFill>
-        <a:effectLst/>
       </p:bgPr>
     </p:bg>
     <p:spTree>
@@ -10608,7 +10695,7 @@
           <a:bodyPr wrap="square" rtlCol="0" anchor="ctr"/>
           <a:lstStyle/>
           <a:p>
-            <a:pPr marL="0" indent="0" algn="r">
+            <a:pPr algn="r" indent="0" marL="0">
               <a:buNone/>
             </a:pPr>
             <a:r>
@@ -10647,7 +10734,7 @@
           <a:bodyPr wrap="square" rtlCol="0" anchor="ctr"/>
           <a:lstStyle/>
           <a:p>
-            <a:pPr marL="0" indent="0">
+            <a:pPr indent="0" marL="0">
               <a:buNone/>
             </a:pPr>
             <a:r>
@@ -10683,7 +10770,7 @@
           <a:bodyPr wrap="square" rtlCol="0" anchor="ctr"/>
           <a:lstStyle/>
           <a:p>
-            <a:pPr marL="0" indent="0">
+            <a:pPr indent="0" marL="0">
               <a:buNone/>
             </a:pPr>
             <a:r>
@@ -10721,27 +10808,9 @@
             <a:tbl>
               <a:tblPr/>
               <a:tblGrid>
-                <a:gridCol w="3840480">
-                  <a:extLst>
-                    <a:ext uri="{9D8B030D-6E8A-4147-A177-3AD203B41FA5}">
-                      <a16:colId xmlns:a16="http://schemas.microsoft.com/office/drawing/2014/main" val="20000"/>
-                    </a:ext>
-                  </a:extLst>
-                </a:gridCol>
-                <a:gridCol w="3840480">
-                  <a:extLst>
-                    <a:ext uri="{9D8B030D-6E8A-4147-A177-3AD203B41FA5}">
-                      <a16:colId xmlns:a16="http://schemas.microsoft.com/office/drawing/2014/main" val="20001"/>
-                    </a:ext>
-                  </a:extLst>
-                </a:gridCol>
-                <a:gridCol w="3840480">
-                  <a:extLst>
-                    <a:ext uri="{9D8B030D-6E8A-4147-A177-3AD203B41FA5}">
-                      <a16:colId xmlns:a16="http://schemas.microsoft.com/office/drawing/2014/main" val="20002"/>
-                    </a:ext>
-                  </a:extLst>
-                </a:gridCol>
+                <a:gridCol w="3840480"/>
+                <a:gridCol w="3840480"/>
+                <a:gridCol w="3840480"/>
               </a:tblGrid>
               <a:tr h="384048">
                 <a:tc>
@@ -10749,7 +10818,7 @@
                     <a:bodyPr/>
                     <a:lstStyle/>
                     <a:p>
-                      <a:pPr marL="0" indent="0" algn="l">
+                      <a:pPr algn="l" indent="0" marL="0">
                         <a:buNone/>
                       </a:pPr>
                       <a:r>
@@ -10810,7 +10879,7 @@
                     <a:bodyPr/>
                     <a:lstStyle/>
                     <a:p>
-                      <a:pPr marL="0" indent="0" algn="ctr">
+                      <a:pPr algn="ctr" indent="0" marL="0">
                         <a:buNone/>
                       </a:pPr>
                       <a:r>
@@ -10871,7 +10940,7 @@
                     <a:bodyPr/>
                     <a:lstStyle/>
                     <a:p>
-                      <a:pPr marL="0" indent="0" algn="ctr">
+                      <a:pPr algn="ctr" indent="0" marL="0">
                         <a:buNone/>
                       </a:pPr>
                       <a:r>
@@ -10927,11 +10996,6 @@
                     </a:solidFill>
                   </a:tcPr>
                 </a:tc>
-                <a:extLst>
-                  <a:ext uri="{0D108BD9-81ED-4DB2-BD59-A6C34878D82A}">
-                    <a16:rowId xmlns:a16="http://schemas.microsoft.com/office/drawing/2014/main" val="10000"/>
-                  </a:ext>
-                </a:extLst>
               </a:tr>
               <a:tr h="384048">
                 <a:tc>
@@ -10939,7 +11003,7 @@
                     <a:bodyPr/>
                     <a:lstStyle/>
                     <a:p>
-                      <a:pPr marL="0" indent="0" algn="l">
+                      <a:pPr algn="l" indent="0" marL="0">
                         <a:buNone/>
                       </a:pPr>
                       <a:r>
@@ -11000,7 +11064,7 @@
                     <a:bodyPr/>
                     <a:lstStyle/>
                     <a:p>
-                      <a:pPr marL="0" indent="0" algn="ctr">
+                      <a:pPr algn="ctr" indent="0" marL="0">
                         <a:buNone/>
                       </a:pPr>
                       <a:r>
@@ -11061,7 +11125,7 @@
                     <a:bodyPr/>
                     <a:lstStyle/>
                     <a:p>
-                      <a:pPr marL="0" indent="0" algn="ctr">
+                      <a:pPr algn="ctr" indent="0" marL="0">
                         <a:buNone/>
                       </a:pPr>
                       <a:r>
@@ -11117,11 +11181,6 @@
                     </a:solidFill>
                   </a:tcPr>
                 </a:tc>
-                <a:extLst>
-                  <a:ext uri="{0D108BD9-81ED-4DB2-BD59-A6C34878D82A}">
-                    <a16:rowId xmlns:a16="http://schemas.microsoft.com/office/drawing/2014/main" val="10001"/>
-                  </a:ext>
-                </a:extLst>
               </a:tr>
               <a:tr h="384048">
                 <a:tc>
@@ -11129,7 +11188,7 @@
                     <a:bodyPr/>
                     <a:lstStyle/>
                     <a:p>
-                      <a:pPr marL="0" indent="0" algn="l">
+                      <a:pPr algn="l" indent="0" marL="0">
                         <a:buNone/>
                       </a:pPr>
                       <a:r>
@@ -11190,7 +11249,7 @@
                     <a:bodyPr/>
                     <a:lstStyle/>
                     <a:p>
-                      <a:pPr marL="0" indent="0" algn="ctr">
+                      <a:pPr algn="ctr" indent="0" marL="0">
                         <a:buNone/>
                       </a:pPr>
                       <a:r>
@@ -11251,7 +11310,7 @@
                     <a:bodyPr/>
                     <a:lstStyle/>
                     <a:p>
-                      <a:pPr marL="0" indent="0" algn="ctr">
+                      <a:pPr algn="ctr" indent="0" marL="0">
                         <a:buNone/>
                       </a:pPr>
                       <a:r>
@@ -11307,11 +11366,6 @@
                     </a:solidFill>
                   </a:tcPr>
                 </a:tc>
-                <a:extLst>
-                  <a:ext uri="{0D108BD9-81ED-4DB2-BD59-A6C34878D82A}">
-                    <a16:rowId xmlns:a16="http://schemas.microsoft.com/office/drawing/2014/main" val="10002"/>
-                  </a:ext>
-                </a:extLst>
               </a:tr>
               <a:tr h="384048">
                 <a:tc>
@@ -11319,7 +11373,7 @@
                     <a:bodyPr/>
                     <a:lstStyle/>
                     <a:p>
-                      <a:pPr marL="0" indent="0" algn="l">
+                      <a:pPr algn="l" indent="0" marL="0">
                         <a:buNone/>
                       </a:pPr>
                       <a:r>
@@ -11380,7 +11434,7 @@
                     <a:bodyPr/>
                     <a:lstStyle/>
                     <a:p>
-                      <a:pPr marL="0" indent="0" algn="ctr">
+                      <a:pPr algn="ctr" indent="0" marL="0">
                         <a:buNone/>
                       </a:pPr>
                       <a:r>
@@ -11441,7 +11495,7 @@
                     <a:bodyPr/>
                     <a:lstStyle/>
                     <a:p>
-                      <a:pPr marL="0" indent="0" algn="ctr">
+                      <a:pPr algn="ctr" indent="0" marL="0">
                         <a:buNone/>
                       </a:pPr>
                       <a:r>
@@ -11497,11 +11551,6 @@
                     </a:solidFill>
                   </a:tcPr>
                 </a:tc>
-                <a:extLst>
-                  <a:ext uri="{0D108BD9-81ED-4DB2-BD59-A6C34878D82A}">
-                    <a16:rowId xmlns:a16="http://schemas.microsoft.com/office/drawing/2014/main" val="10003"/>
-                  </a:ext>
-                </a:extLst>
               </a:tr>
               <a:tr h="384048">
                 <a:tc>
@@ -11509,7 +11558,7 @@
                     <a:bodyPr/>
                     <a:lstStyle/>
                     <a:p>
-                      <a:pPr marL="0" indent="0" algn="l">
+                      <a:pPr algn="l" indent="0" marL="0">
                         <a:buNone/>
                       </a:pPr>
                       <a:r>
@@ -11570,7 +11619,7 @@
                     <a:bodyPr/>
                     <a:lstStyle/>
                     <a:p>
-                      <a:pPr marL="0" indent="0" algn="ctr">
+                      <a:pPr algn="ctr" indent="0" marL="0">
                         <a:buNone/>
                       </a:pPr>
                       <a:r>
@@ -11631,7 +11680,7 @@
                     <a:bodyPr/>
                     <a:lstStyle/>
                     <a:p>
-                      <a:pPr marL="0" indent="0" algn="ctr">
+                      <a:pPr algn="ctr" indent="0" marL="0">
                         <a:buNone/>
                       </a:pPr>
                       <a:r>
@@ -11687,11 +11736,6 @@
                     </a:solidFill>
                   </a:tcPr>
                 </a:tc>
-                <a:extLst>
-                  <a:ext uri="{0D108BD9-81ED-4DB2-BD59-A6C34878D82A}">
-                    <a16:rowId xmlns:a16="http://schemas.microsoft.com/office/drawing/2014/main" val="10004"/>
-                  </a:ext>
-                </a:extLst>
               </a:tr>
               <a:tr h="384048">
                 <a:tc>
@@ -11699,7 +11743,7 @@
                     <a:bodyPr/>
                     <a:lstStyle/>
                     <a:p>
-                      <a:pPr marL="0" indent="0" algn="l">
+                      <a:pPr algn="l" indent="0" marL="0">
                         <a:buNone/>
                       </a:pPr>
                       <a:r>
@@ -11760,7 +11804,7 @@
                     <a:bodyPr/>
                     <a:lstStyle/>
                     <a:p>
-                      <a:pPr marL="0" indent="0" algn="ctr">
+                      <a:pPr algn="ctr" indent="0" marL="0">
                         <a:buNone/>
                       </a:pPr>
                       <a:r>
@@ -11821,7 +11865,7 @@
                     <a:bodyPr/>
                     <a:lstStyle/>
                     <a:p>
-                      <a:pPr marL="0" indent="0" algn="ctr">
+                      <a:pPr algn="ctr" indent="0" marL="0">
                         <a:buNone/>
                       </a:pPr>
                       <a:r>
@@ -11877,11 +11921,6 @@
                     </a:solidFill>
                   </a:tcPr>
                 </a:tc>
-                <a:extLst>
-                  <a:ext uri="{0D108BD9-81ED-4DB2-BD59-A6C34878D82A}">
-                    <a16:rowId xmlns:a16="http://schemas.microsoft.com/office/drawing/2014/main" val="10005"/>
-                  </a:ext>
-                </a:extLst>
               </a:tr>
               <a:tr h="384048">
                 <a:tc>
@@ -11889,7 +11928,7 @@
                     <a:bodyPr/>
                     <a:lstStyle/>
                     <a:p>
-                      <a:pPr marL="0" indent="0" algn="l">
+                      <a:pPr algn="l" indent="0" marL="0">
                         <a:buNone/>
                       </a:pPr>
                       <a:r>
@@ -11950,7 +11989,7 @@
                     <a:bodyPr/>
                     <a:lstStyle/>
                     <a:p>
-                      <a:pPr marL="0" indent="0" algn="ctr">
+                      <a:pPr algn="ctr" indent="0" marL="0">
                         <a:buNone/>
                       </a:pPr>
                       <a:r>
@@ -12011,7 +12050,7 @@
                     <a:bodyPr/>
                     <a:lstStyle/>
                     <a:p>
-                      <a:pPr marL="0" indent="0" algn="ctr">
+                      <a:pPr algn="ctr" indent="0" marL="0">
                         <a:buNone/>
                       </a:pPr>
                       <a:r>
@@ -12067,11 +12106,6 @@
                     </a:solidFill>
                   </a:tcPr>
                 </a:tc>
-                <a:extLst>
-                  <a:ext uri="{0D108BD9-81ED-4DB2-BD59-A6C34878D82A}">
-                    <a16:rowId xmlns:a16="http://schemas.microsoft.com/office/drawing/2014/main" val="10006"/>
-                  </a:ext>
-                </a:extLst>
               </a:tr>
             </a:tbl>
           </a:graphicData>
@@ -12093,7 +12127,6 @@
         <a:solidFill>
           <a:srgbClr val="F4F6FB"/>
         </a:solidFill>
-        <a:effectLst/>
       </p:bgPr>
     </p:bg>
     <p:spTree>
@@ -12171,7 +12204,7 @@
           <a:bodyPr wrap="square" rtlCol="0" anchor="ctr"/>
           <a:lstStyle/>
           <a:p>
-            <a:pPr marL="0" indent="0" algn="r">
+            <a:pPr algn="r" indent="0" marL="0">
               <a:buNone/>
             </a:pPr>
             <a:r>
@@ -12210,7 +12243,7 @@
           <a:bodyPr wrap="square" rtlCol="0" anchor="ctr"/>
           <a:lstStyle/>
           <a:p>
-            <a:pPr marL="0" indent="0">
+            <a:pPr indent="0" marL="0">
               <a:buNone/>
             </a:pPr>
             <a:r>
@@ -12246,7 +12279,7 @@
           <a:bodyPr wrap="square" rtlCol="0" anchor="ctr"/>
           <a:lstStyle/>
           <a:p>
-            <a:pPr marL="0" indent="0">
+            <a:pPr indent="0" marL="0">
               <a:buNone/>
             </a:pPr>
             <a:r>
@@ -12277,41 +12310,17 @@
         </p:nvGraphicFramePr>
         <p:xfrm>
           <a:off x="274320" y="1188720"/>
-          <a:ext cx="11521440" cy="2304288"/>
+          <a:ext cx="11521440" cy="914400"/>
         </p:xfrm>
         <a:graphic>
           <a:graphicData uri="http://schemas.openxmlformats.org/drawingml/2006/table">
             <a:tbl>
               <a:tblPr/>
               <a:tblGrid>
-                <a:gridCol w="2880360">
-                  <a:extLst>
-                    <a:ext uri="{9D8B030D-6E8A-4147-A177-3AD203B41FA5}">
-                      <a16:colId xmlns:a16="http://schemas.microsoft.com/office/drawing/2014/main" val="20000"/>
-                    </a:ext>
-                  </a:extLst>
-                </a:gridCol>
-                <a:gridCol w="2880360">
-                  <a:extLst>
-                    <a:ext uri="{9D8B030D-6E8A-4147-A177-3AD203B41FA5}">
-                      <a16:colId xmlns:a16="http://schemas.microsoft.com/office/drawing/2014/main" val="20001"/>
-                    </a:ext>
-                  </a:extLst>
-                </a:gridCol>
-                <a:gridCol w="2880360">
-                  <a:extLst>
-                    <a:ext uri="{9D8B030D-6E8A-4147-A177-3AD203B41FA5}">
-                      <a16:colId xmlns:a16="http://schemas.microsoft.com/office/drawing/2014/main" val="20002"/>
-                    </a:ext>
-                  </a:extLst>
-                </a:gridCol>
-                <a:gridCol w="2880360">
-                  <a:extLst>
-                    <a:ext uri="{9D8B030D-6E8A-4147-A177-3AD203B41FA5}">
-                      <a16:colId xmlns:a16="http://schemas.microsoft.com/office/drawing/2014/main" val="20003"/>
-                    </a:ext>
-                  </a:extLst>
-                </a:gridCol>
+                <a:gridCol w="2880360"/>
+                <a:gridCol w="2880360"/>
+                <a:gridCol w="2880360"/>
+                <a:gridCol w="2880360"/>
               </a:tblGrid>
               <a:tr h="384048">
                 <a:tc>
@@ -12319,7 +12328,7 @@
                     <a:bodyPr/>
                     <a:lstStyle/>
                     <a:p>
-                      <a:pPr marL="0" indent="0" algn="l">
+                      <a:pPr algn="l" indent="0" marL="0">
                         <a:buNone/>
                       </a:pPr>
                       <a:r>
@@ -12380,7 +12389,7 @@
                     <a:bodyPr/>
                     <a:lstStyle/>
                     <a:p>
-                      <a:pPr marL="0" indent="0" algn="ctr">
+                      <a:pPr algn="ctr" indent="0" marL="0">
                         <a:buNone/>
                       </a:pPr>
                       <a:r>
@@ -12441,7 +12450,7 @@
                     <a:bodyPr/>
                     <a:lstStyle/>
                     <a:p>
-                      <a:pPr marL="0" indent="0" algn="ctr">
+                      <a:pPr algn="ctr" indent="0" marL="0">
                         <a:buNone/>
                       </a:pPr>
                       <a:r>
@@ -12502,7 +12511,7 @@
                     <a:bodyPr/>
                     <a:lstStyle/>
                     <a:p>
-                      <a:pPr marL="0" indent="0" algn="ctr">
+                      <a:pPr algn="ctr" indent="0" marL="0">
                         <a:buNone/>
                       </a:pPr>
                       <a:r>
@@ -12558,11 +12567,6 @@
                     </a:solidFill>
                   </a:tcPr>
                 </a:tc>
-                <a:extLst>
-                  <a:ext uri="{0D108BD9-81ED-4DB2-BD59-A6C34878D82A}">
-                    <a16:rowId xmlns:a16="http://schemas.microsoft.com/office/drawing/2014/main" val="10000"/>
-                  </a:ext>
-                </a:extLst>
               </a:tr>
               <a:tr h="384048">
                 <a:tc>
@@ -12570,7 +12574,7 @@
                     <a:bodyPr/>
                     <a:lstStyle/>
                     <a:p>
-                      <a:pPr marL="0" indent="0" algn="l">
+                      <a:pPr algn="l" indent="0" marL="0">
                         <a:buNone/>
                       </a:pPr>
                       <a:r>
@@ -12631,7 +12635,7 @@
                     <a:bodyPr/>
                     <a:lstStyle/>
                     <a:p>
-                      <a:pPr marL="0" indent="0" algn="ctr">
+                      <a:pPr algn="ctr" indent="0" marL="0">
                         <a:buNone/>
                       </a:pPr>
                       <a:r>
@@ -12692,7 +12696,7 @@
                     <a:bodyPr/>
                     <a:lstStyle/>
                     <a:p>
-                      <a:pPr marL="0" indent="0" algn="ctr">
+                      <a:pPr algn="ctr" indent="0" marL="0">
                         <a:buNone/>
                       </a:pPr>
                       <a:r>
@@ -12753,7 +12757,7 @@
                     <a:bodyPr/>
                     <a:lstStyle/>
                     <a:p>
-                      <a:pPr marL="0" indent="0" algn="ctr">
+                      <a:pPr algn="ctr" indent="0" marL="0">
                         <a:buNone/>
                       </a:pPr>
                       <a:r>
@@ -12809,11 +12813,6 @@
                     </a:solidFill>
                   </a:tcPr>
                 </a:tc>
-                <a:extLst>
-                  <a:ext uri="{0D108BD9-81ED-4DB2-BD59-A6C34878D82A}">
-                    <a16:rowId xmlns:a16="http://schemas.microsoft.com/office/drawing/2014/main" val="10001"/>
-                  </a:ext>
-                </a:extLst>
               </a:tr>
               <a:tr h="384048">
                 <a:tc>
@@ -12821,7 +12820,7 @@
                     <a:bodyPr/>
                     <a:lstStyle/>
                     <a:p>
-                      <a:pPr marL="0" indent="0" algn="l">
+                      <a:pPr algn="l" indent="0" marL="0">
                         <a:buNone/>
                       </a:pPr>
                       <a:r>
@@ -12882,7 +12881,7 @@
                     <a:bodyPr/>
                     <a:lstStyle/>
                     <a:p>
-                      <a:pPr marL="0" indent="0" algn="ctr">
+                      <a:pPr algn="ctr" indent="0" marL="0">
                         <a:buNone/>
                       </a:pPr>
                       <a:r>
@@ -12943,7 +12942,7 @@
                     <a:bodyPr/>
                     <a:lstStyle/>
                     <a:p>
-                      <a:pPr marL="0" indent="0" algn="ctr">
+                      <a:pPr algn="ctr" indent="0" marL="0">
                         <a:buNone/>
                       </a:pPr>
                       <a:r>
@@ -13004,7 +13003,7 @@
                     <a:bodyPr/>
                     <a:lstStyle/>
                     <a:p>
-                      <a:pPr marL="0" indent="0" algn="ctr">
+                      <a:pPr algn="ctr" indent="0" marL="0">
                         <a:buNone/>
                       </a:pPr>
                       <a:r>
@@ -13060,11 +13059,6 @@
                     </a:solidFill>
                   </a:tcPr>
                 </a:tc>
-                <a:extLst>
-                  <a:ext uri="{0D108BD9-81ED-4DB2-BD59-A6C34878D82A}">
-                    <a16:rowId xmlns:a16="http://schemas.microsoft.com/office/drawing/2014/main" val="10002"/>
-                  </a:ext>
-                </a:extLst>
               </a:tr>
               <a:tr h="384048">
                 <a:tc>
@@ -13072,7 +13066,7 @@
                     <a:bodyPr/>
                     <a:lstStyle/>
                     <a:p>
-                      <a:pPr marL="0" indent="0" algn="l">
+                      <a:pPr algn="l" indent="0" marL="0">
                         <a:buNone/>
                       </a:pPr>
                       <a:r>
@@ -13133,7 +13127,7 @@
                     <a:bodyPr/>
                     <a:lstStyle/>
                     <a:p>
-                      <a:pPr marL="0" indent="0" algn="ctr">
+                      <a:pPr algn="ctr" indent="0" marL="0">
                         <a:buNone/>
                       </a:pPr>
                       <a:r>
@@ -13194,7 +13188,7 @@
                     <a:bodyPr/>
                     <a:lstStyle/>
                     <a:p>
-                      <a:pPr marL="0" indent="0" algn="ctr">
+                      <a:pPr algn="ctr" indent="0" marL="0">
                         <a:buNone/>
                       </a:pPr>
                       <a:r>
@@ -13255,7 +13249,7 @@
                     <a:bodyPr/>
                     <a:lstStyle/>
                     <a:p>
-                      <a:pPr marL="0" indent="0" algn="ctr">
+                      <a:pPr algn="ctr" indent="0" marL="0">
                         <a:buNone/>
                       </a:pPr>
                       <a:r>
@@ -13311,11 +13305,6 @@
                     </a:solidFill>
                   </a:tcPr>
                 </a:tc>
-                <a:extLst>
-                  <a:ext uri="{0D108BD9-81ED-4DB2-BD59-A6C34878D82A}">
-                    <a16:rowId xmlns:a16="http://schemas.microsoft.com/office/drawing/2014/main" val="10003"/>
-                  </a:ext>
-                </a:extLst>
               </a:tr>
               <a:tr h="384048">
                 <a:tc>
@@ -13323,7 +13312,7 @@
                     <a:bodyPr/>
                     <a:lstStyle/>
                     <a:p>
-                      <a:pPr marL="0" indent="0" algn="l">
+                      <a:pPr algn="l" indent="0" marL="0">
                         <a:buNone/>
                       </a:pPr>
                       <a:r>
@@ -13384,7 +13373,7 @@
                     <a:bodyPr/>
                     <a:lstStyle/>
                     <a:p>
-                      <a:pPr marL="0" indent="0" algn="ctr">
+                      <a:pPr algn="ctr" indent="0" marL="0">
                         <a:buNone/>
                       </a:pPr>
                       <a:r>
@@ -13445,7 +13434,7 @@
                     <a:bodyPr/>
                     <a:lstStyle/>
                     <a:p>
-                      <a:pPr marL="0" indent="0" algn="ctr">
+                      <a:pPr algn="ctr" indent="0" marL="0">
                         <a:buNone/>
                       </a:pPr>
                       <a:r>
@@ -13506,7 +13495,7 @@
                     <a:bodyPr/>
                     <a:lstStyle/>
                     <a:p>
-                      <a:pPr marL="0" indent="0" algn="ctr">
+                      <a:pPr algn="ctr" indent="0" marL="0">
                         <a:buNone/>
                       </a:pPr>
                       <a:r>
@@ -13562,11 +13551,6 @@
                     </a:solidFill>
                   </a:tcPr>
                 </a:tc>
-                <a:extLst>
-                  <a:ext uri="{0D108BD9-81ED-4DB2-BD59-A6C34878D82A}">
-                    <a16:rowId xmlns:a16="http://schemas.microsoft.com/office/drawing/2014/main" val="10004"/>
-                  </a:ext>
-                </a:extLst>
               </a:tr>
               <a:tr h="384048">
                 <a:tc>
@@ -13574,7 +13558,7 @@
                     <a:bodyPr/>
                     <a:lstStyle/>
                     <a:p>
-                      <a:pPr marL="0" indent="0" algn="l">
+                      <a:pPr algn="l" indent="0" marL="0">
                         <a:buNone/>
                       </a:pPr>
                       <a:r>
@@ -13635,7 +13619,7 @@
                     <a:bodyPr/>
                     <a:lstStyle/>
                     <a:p>
-                      <a:pPr marL="0" indent="0" algn="ctr">
+                      <a:pPr algn="ctr" indent="0" marL="0">
                         <a:buNone/>
                       </a:pPr>
                       <a:r>
@@ -13696,7 +13680,7 @@
                     <a:bodyPr/>
                     <a:lstStyle/>
                     <a:p>
-                      <a:pPr marL="0" indent="0" algn="ctr">
+                      <a:pPr algn="ctr" indent="0" marL="0">
                         <a:buNone/>
                       </a:pPr>
                       <a:r>
@@ -13757,7 +13741,7 @@
                     <a:bodyPr/>
                     <a:lstStyle/>
                     <a:p>
-                      <a:pPr marL="0" indent="0" algn="ctr">
+                      <a:pPr algn="ctr" indent="0" marL="0">
                         <a:buNone/>
                       </a:pPr>
                       <a:r>
@@ -13813,11 +13797,6 @@
                     </a:solidFill>
                   </a:tcPr>
                 </a:tc>
-                <a:extLst>
-                  <a:ext uri="{0D108BD9-81ED-4DB2-BD59-A6C34878D82A}">
-                    <a16:rowId xmlns:a16="http://schemas.microsoft.com/office/drawing/2014/main" val="10005"/>
-                  </a:ext>
-                </a:extLst>
               </a:tr>
             </a:tbl>
           </a:graphicData>
@@ -13903,7 +13882,6 @@
         <a:solidFill>
           <a:srgbClr val="F4F6FB"/>
         </a:solidFill>
-        <a:effectLst/>
       </p:bgPr>
     </p:bg>
     <p:spTree>
@@ -13981,7 +13959,7 @@
           <a:bodyPr wrap="square" rtlCol="0" anchor="ctr"/>
           <a:lstStyle/>
           <a:p>
-            <a:pPr marL="0" indent="0" algn="r">
+            <a:pPr algn="r" indent="0" marL="0">
               <a:buNone/>
             </a:pPr>
             <a:r>
@@ -14020,7 +13998,7 @@
           <a:bodyPr wrap="square" rtlCol="0" anchor="ctr"/>
           <a:lstStyle/>
           <a:p>
-            <a:pPr marL="0" indent="0">
+            <a:pPr indent="0" marL="0">
               <a:buNone/>
             </a:pPr>
             <a:r>
@@ -14056,7 +14034,7 @@
           <a:bodyPr wrap="square" rtlCol="0" anchor="ctr"/>
           <a:lstStyle/>
           <a:p>
-            <a:pPr marL="0" indent="0">
+            <a:pPr indent="0" marL="0">
               <a:buNone/>
             </a:pPr>
             <a:r>
@@ -14119,7 +14097,7 @@
           <a:bodyPr wrap="square" rtlCol="0" anchor="ctr"/>
           <a:lstStyle/>
           <a:p>
-            <a:pPr marL="0" indent="0">
+            <a:pPr indent="0" marL="0">
               <a:buNone/>
             </a:pPr>
             <a:r>
@@ -14364,7 +14342,7 @@
           <a:bodyPr wrap="square" rtlCol="0" anchor="ctr"/>
           <a:lstStyle/>
           <a:p>
-            <a:pPr marL="0" indent="0">
+            <a:pPr indent="0" marL="0">
               <a:buNone/>
             </a:pPr>
             <a:r>
@@ -14437,16 +14415,21 @@
                   <a:srgbClr val="4A4A6A"/>
                 </a:solidFill>
               </a:rPr>
-              <a:t>    原型每个模块 ↔ 真实代码 </a:t>
+              <a:t>    原型每个模块 ↔ 真实代码 函数+行号</a:t>
             </a:r>
-            <a:r>
-              <a:rPr lang="en-US" sz="1100" dirty="0" err="1">
-                <a:solidFill>
-                  <a:srgbClr val="4A4A6A"/>
-                </a:solidFill>
-              </a:rPr>
-              <a:t>函数+行号</a:t>
-            </a:r>
+            <a:endParaRPr lang="en-US" sz="1100" dirty="0"/>
+          </a:p>
+          <a:p>
+            <a:pPr marL="342900" indent="-342900">
+              <a:lnSpc>
+                <a:spcPts val="2400"/>
+              </a:lnSpc>
+              <a:spcAft>
+                <a:spcPts val="400"/>
+              </a:spcAft>
+              <a:buSzPct val="100000"/>
+              <a:buChar char="•"/>
+            </a:pPr>
             <a:endParaRPr lang="en-US" sz="1100" dirty="0"/>
           </a:p>
           <a:p>
@@ -14487,16 +14470,21 @@
                   <a:srgbClr val="4A4A6A"/>
                 </a:solidFill>
               </a:rPr>
-              <a:t>    </a:t>
+              <a:t>    原型补缺失模块，数据精确对标</a:t>
             </a:r>
-            <a:r>
-              <a:rPr lang="en-US" sz="1100" dirty="0" err="1">
-                <a:solidFill>
-                  <a:srgbClr val="4A4A6A"/>
-                </a:solidFill>
-              </a:rPr>
-              <a:t>原型补缺失模块，数据精确对标</a:t>
-            </a:r>
+            <a:endParaRPr lang="en-US" sz="1100" dirty="0"/>
+          </a:p>
+          <a:p>
+            <a:pPr marL="342900" indent="-342900">
+              <a:lnSpc>
+                <a:spcPts val="2400"/>
+              </a:lnSpc>
+              <a:spcAft>
+                <a:spcPts val="400"/>
+              </a:spcAft>
+              <a:buSzPct val="100000"/>
+              <a:buChar char="•"/>
+            </a:pPr>
             <a:endParaRPr lang="en-US" sz="1100" dirty="0"/>
           </a:p>
           <a:p>
@@ -14907,299 +14895,4 @@
     </a:ext>
   </a:extLst>
 </a:theme>
-</file>
-
-<file path=ppt/theme/theme2.xml><?xml version="1.0" encoding="utf-8"?>
-<a:theme xmlns:a="http://schemas.openxmlformats.org/drawingml/2006/main" name="Office 主题​​">
-  <a:themeElements>
-    <a:clrScheme name="Office">
-      <a:dk1>
-        <a:sysClr val="windowText" lastClr="000000"/>
-      </a:dk1>
-      <a:lt1>
-        <a:sysClr val="window" lastClr="FFFFFF"/>
-      </a:lt1>
-      <a:dk2>
-        <a:srgbClr val="44546A"/>
-      </a:dk2>
-      <a:lt2>
-        <a:srgbClr val="E7E6E6"/>
-      </a:lt2>
-      <a:accent1>
-        <a:srgbClr val="4472C4"/>
-      </a:accent1>
-      <a:accent2>
-        <a:srgbClr val="ED7D31"/>
-      </a:accent2>
-      <a:accent3>
-        <a:srgbClr val="A5A5A5"/>
-      </a:accent3>
-      <a:accent4>
-        <a:srgbClr val="FFC000"/>
-      </a:accent4>
-      <a:accent5>
-        <a:srgbClr val="5B9BD5"/>
-      </a:accent5>
-      <a:accent6>
-        <a:srgbClr val="70AD47"/>
-      </a:accent6>
-      <a:hlink>
-        <a:srgbClr val="0563C1"/>
-      </a:hlink>
-      <a:folHlink>
-        <a:srgbClr val="954F72"/>
-      </a:folHlink>
-    </a:clrScheme>
-    <a:fontScheme name="Office">
-      <a:majorFont>
-        <a:latin typeface="等线 Light" panose="020F0302020204030204"/>
-        <a:ea typeface=""/>
-        <a:cs typeface=""/>
-        <a:font script="Jpan" typeface="游ゴシック Light"/>
-        <a:font script="Hang" typeface="맑은 고딕"/>
-        <a:font script="Hans" typeface="等线 Light"/>
-        <a:font script="Hant" typeface="新細明體"/>
-        <a:font script="Arab" typeface="Times New Roman"/>
-        <a:font script="Hebr" typeface="Times New Roman"/>
-        <a:font script="Thai" typeface="Angsana New"/>
-        <a:font script="Ethi" typeface="Nyala"/>
-        <a:font script="Beng" typeface="Vrinda"/>
-        <a:font script="Gujr" typeface="Shruti"/>
-        <a:font script="Khmr" typeface="MoolBoran"/>
-        <a:font script="Knda" typeface="Tunga"/>
-        <a:font script="Guru" typeface="Raavi"/>
-        <a:font script="Cans" typeface="Euphemia"/>
-        <a:font script="Cher" typeface="Plantagenet Cherokee"/>
-        <a:font script="Yiii" typeface="Microsoft Yi Baiti"/>
-        <a:font script="Tibt" typeface="Microsoft Himalaya"/>
-        <a:font script="Thaa" typeface="MV Boli"/>
-        <a:font script="Deva" typeface="Mangal"/>
-        <a:font script="Telu" typeface="Gautami"/>
-        <a:font script="Taml" typeface="Latha"/>
-        <a:font script="Syrc" typeface="Estrangelo Edessa"/>
-        <a:font script="Orya" typeface="Kalinga"/>
-        <a:font script="Mlym" typeface="Kartika"/>
-        <a:font script="Laoo" typeface="DokChampa"/>
-        <a:font script="Sinh" typeface="Iskoola Pota"/>
-        <a:font script="Mong" typeface="Mongolian Baiti"/>
-        <a:font script="Viet" typeface="Times New Roman"/>
-        <a:font script="Uigh" typeface="Microsoft Uighur"/>
-        <a:font script="Geor" typeface="Sylfaen"/>
-        <a:font script="Armn" typeface="Arial"/>
-        <a:font script="Bugi" typeface="Leelawadee UI"/>
-        <a:font script="Bopo" typeface="Microsoft JhengHei"/>
-        <a:font script="Java" typeface="Javanese Text"/>
-        <a:font script="Lisu" typeface="Segoe UI"/>
-        <a:font script="Mymr" typeface="Myanmar Text"/>
-        <a:font script="Nkoo" typeface="Ebrima"/>
-        <a:font script="Olck" typeface="Nirmala UI"/>
-        <a:font script="Osma" typeface="Ebrima"/>
-        <a:font script="Phag" typeface="Phagspa"/>
-        <a:font script="Syrn" typeface="Estrangelo Edessa"/>
-        <a:font script="Syrj" typeface="Estrangelo Edessa"/>
-        <a:font script="Syre" typeface="Estrangelo Edessa"/>
-        <a:font script="Sora" typeface="Nirmala UI"/>
-        <a:font script="Tale" typeface="Microsoft Tai Le"/>
-        <a:font script="Talu" typeface="Microsoft New Tai Lue"/>
-        <a:font script="Tfng" typeface="Ebrima"/>
-      </a:majorFont>
-      <a:minorFont>
-        <a:latin typeface="等线" panose="020F0502020204030204"/>
-        <a:ea typeface=""/>
-        <a:cs typeface=""/>
-        <a:font script="Jpan" typeface="游ゴシック"/>
-        <a:font script="Hang" typeface="맑은 고딕"/>
-        <a:font script="Hans" typeface="等线"/>
-        <a:font script="Hant" typeface="新細明體"/>
-        <a:font script="Arab" typeface="Arial"/>
-        <a:font script="Hebr" typeface="Arial"/>
-        <a:font script="Thai" typeface="Cordia New"/>
-        <a:font script="Ethi" typeface="Nyala"/>
-        <a:font script="Beng" typeface="Vrinda"/>
-        <a:font script="Gujr" typeface="Shruti"/>
-        <a:font script="Khmr" typeface="DaunPenh"/>
-        <a:font script="Knda" typeface="Tunga"/>
-        <a:font script="Guru" typeface="Raavi"/>
-        <a:font script="Cans" typeface="Euphemia"/>
-        <a:font script="Cher" typeface="Plantagenet Cherokee"/>
-        <a:font script="Yiii" typeface="Microsoft Yi Baiti"/>
-        <a:font script="Tibt" typeface="Microsoft Himalaya"/>
-        <a:font script="Thaa" typeface="MV Boli"/>
-        <a:font script="Deva" typeface="Mangal"/>
-        <a:font script="Telu" typeface="Gautami"/>
-        <a:font script="Taml" typeface="Latha"/>
-        <a:font script="Syrc" typeface="Estrangelo Edessa"/>
-        <a:font script="Orya" typeface="Kalinga"/>
-        <a:font script="Mlym" typeface="Kartika"/>
-        <a:font script="Laoo" typeface="DokChampa"/>
-        <a:font script="Sinh" typeface="Iskoola Pota"/>
-        <a:font script="Mong" typeface="Mongolian Baiti"/>
-        <a:font script="Viet" typeface="Arial"/>
-        <a:font script="Uigh" typeface="Microsoft Uighur"/>
-        <a:font script="Geor" typeface="Sylfaen"/>
-        <a:font script="Armn" typeface="Arial"/>
-        <a:font script="Bugi" typeface="Leelawadee UI"/>
-        <a:font script="Bopo" typeface="Microsoft JhengHei"/>
-        <a:font script="Java" typeface="Javanese Text"/>
-        <a:font script="Lisu" typeface="Segoe UI"/>
-        <a:font script="Mymr" typeface="Myanmar Text"/>
-        <a:font script="Nkoo" typeface="Ebrima"/>
-        <a:font script="Olck" typeface="Nirmala UI"/>
-        <a:font script="Osma" typeface="Ebrima"/>
-        <a:font script="Phag" typeface="Phagspa"/>
-        <a:font script="Syrn" typeface="Estrangelo Edessa"/>
-        <a:font script="Syrj" typeface="Estrangelo Edessa"/>
-        <a:font script="Syre" typeface="Estrangelo Edessa"/>
-        <a:font script="Sora" typeface="Nirmala UI"/>
-        <a:font script="Tale" typeface="Microsoft Tai Le"/>
-        <a:font script="Talu" typeface="Microsoft New Tai Lue"/>
-        <a:font script="Tfng" typeface="Ebrima"/>
-      </a:minorFont>
-    </a:fontScheme>
-    <a:fmtScheme name="Office">
-      <a:fillStyleLst>
-        <a:solidFill>
-          <a:schemeClr val="phClr"/>
-        </a:solidFill>
-        <a:gradFill rotWithShape="1">
-          <a:gsLst>
-            <a:gs pos="0">
-              <a:schemeClr val="phClr">
-                <a:lumMod val="110000"/>
-                <a:satMod val="105000"/>
-                <a:tint val="67000"/>
-              </a:schemeClr>
-            </a:gs>
-            <a:gs pos="50000">
-              <a:schemeClr val="phClr">
-                <a:lumMod val="105000"/>
-                <a:satMod val="103000"/>
-                <a:tint val="73000"/>
-              </a:schemeClr>
-            </a:gs>
-            <a:gs pos="100000">
-              <a:schemeClr val="phClr">
-                <a:lumMod val="105000"/>
-                <a:satMod val="109000"/>
-                <a:tint val="81000"/>
-              </a:schemeClr>
-            </a:gs>
-          </a:gsLst>
-          <a:lin ang="5400000" scaled="0"/>
-        </a:gradFill>
-        <a:gradFill rotWithShape="1">
-          <a:gsLst>
-            <a:gs pos="0">
-              <a:schemeClr val="phClr">
-                <a:satMod val="103000"/>
-                <a:lumMod val="102000"/>
-                <a:tint val="94000"/>
-              </a:schemeClr>
-            </a:gs>
-            <a:gs pos="50000">
-              <a:schemeClr val="phClr">
-                <a:satMod val="110000"/>
-                <a:lumMod val="100000"/>
-                <a:shade val="100000"/>
-              </a:schemeClr>
-            </a:gs>
-            <a:gs pos="100000">
-              <a:schemeClr val="phClr">
-                <a:lumMod val="99000"/>
-                <a:satMod val="120000"/>
-                <a:shade val="78000"/>
-              </a:schemeClr>
-            </a:gs>
-          </a:gsLst>
-          <a:lin ang="5400000" scaled="0"/>
-        </a:gradFill>
-      </a:fillStyleLst>
-      <a:lnStyleLst>
-        <a:ln w="6350" cap="flat" cmpd="sng" algn="ctr">
-          <a:solidFill>
-            <a:schemeClr val="phClr"/>
-          </a:solidFill>
-          <a:prstDash val="solid"/>
-          <a:miter lim="800000"/>
-        </a:ln>
-        <a:ln w="12700" cap="flat" cmpd="sng" algn="ctr">
-          <a:solidFill>
-            <a:schemeClr val="phClr"/>
-          </a:solidFill>
-          <a:prstDash val="solid"/>
-          <a:miter lim="800000"/>
-        </a:ln>
-        <a:ln w="19050" cap="flat" cmpd="sng" algn="ctr">
-          <a:solidFill>
-            <a:schemeClr val="phClr"/>
-          </a:solidFill>
-          <a:prstDash val="solid"/>
-          <a:miter lim="800000"/>
-        </a:ln>
-      </a:lnStyleLst>
-      <a:effectStyleLst>
-        <a:effectStyle>
-          <a:effectLst/>
-        </a:effectStyle>
-        <a:effectStyle>
-          <a:effectLst/>
-        </a:effectStyle>
-        <a:effectStyle>
-          <a:effectLst>
-            <a:outerShdw blurRad="57150" dist="19050" dir="5400000" algn="ctr" rotWithShape="0">
-              <a:srgbClr val="000000">
-                <a:alpha val="63000"/>
-              </a:srgbClr>
-            </a:outerShdw>
-          </a:effectLst>
-        </a:effectStyle>
-      </a:effectStyleLst>
-      <a:bgFillStyleLst>
-        <a:solidFill>
-          <a:schemeClr val="phClr"/>
-        </a:solidFill>
-        <a:solidFill>
-          <a:schemeClr val="phClr">
-            <a:tint val="95000"/>
-            <a:satMod val="170000"/>
-          </a:schemeClr>
-        </a:solidFill>
-        <a:gradFill rotWithShape="1">
-          <a:gsLst>
-            <a:gs pos="0">
-              <a:schemeClr val="phClr">
-                <a:tint val="93000"/>
-                <a:satMod val="150000"/>
-                <a:shade val="98000"/>
-                <a:lumMod val="102000"/>
-              </a:schemeClr>
-            </a:gs>
-            <a:gs pos="50000">
-              <a:schemeClr val="phClr">
-                <a:tint val="98000"/>
-                <a:satMod val="130000"/>
-                <a:shade val="90000"/>
-                <a:lumMod val="103000"/>
-              </a:schemeClr>
-            </a:gs>
-            <a:gs pos="100000">
-              <a:schemeClr val="phClr">
-                <a:shade val="63000"/>
-                <a:satMod val="120000"/>
-              </a:schemeClr>
-            </a:gs>
-          </a:gsLst>
-          <a:lin ang="5400000" scaled="0"/>
-        </a:gradFill>
-      </a:bgFillStyleLst>
-    </a:fmtScheme>
-  </a:themeElements>
-  <a:objectDefaults/>
-  <a:extraClrSchemeLst/>
-  <a:extLst>
-    <a:ext uri="{05A4C25C-085E-4340-85A3-A5531E510DB2}">
-      <thm15:themeFamily xmlns:thm15="http://schemas.microsoft.com/office/thememl/2012/main" name="Office Theme" id="{62F939B6-93AF-4DB8-9C6B-D6C7DFDC589F}" vid="{4A3C46E8-61CC-4603-A589-7422A47A8E4A}"/>
-    </a:ext>
-  </a:extLst>
-</a:theme>
 </file>
</xml_diff>

<commit_message>
Remove Notify Outside Mutex from slide 4 (already in real code)
</commit_message>
<xml_diff>
--- a/presentation/native_hook_progress_2026-06-05.pptx
+++ b/presentation/native_hook_progress_2026-06-05.pptx
@@ -6335,7 +6335,7 @@
                   <a:srgbClr val="1A1A2E"/>
                 </a:solidFill>
               </a:rPr>
-              <a:t>Producer 端三项优化</a:t>
+              <a:t>Producer 端两项优化</a:t>
             </a:r>
             <a:endParaRPr lang="en-US" sz="2400" dirty="0"/>
           </a:p>
@@ -6371,7 +6371,7 @@
                   <a:srgbClr val="8888A8"/>
                 </a:solidFill>
               </a:rPr>
-              <a:t>逐级降低 per-record 共享路径开销</a:t>
+              <a:t>缩短 per-record 共享路径开销</a:t>
             </a:r>
             <a:endParaRPr lang="en-US" sz="1200" dirty="0"/>
           </a:p>
@@ -6398,7 +6398,7 @@
           </a:solidFill>
           <a:ln w="15240">
             <a:solidFill>
-              <a:srgbClr val="0891B2"/>
+              <a:srgbClr val="2563EB"/>
             </a:solidFill>
             <a:prstDash val="solid"/>
           </a:ln>
@@ -6419,7 +6419,7 @@
             <a:avLst/>
           </a:prstGeom>
           <a:solidFill>
-            <a:srgbClr val="0891B2"/>
+            <a:srgbClr val="2563EB"/>
           </a:solidFill>
           <a:ln/>
         </p:spPr>
@@ -6451,7 +6451,7 @@
             <a:r>
               <a:rPr lang="en-US" sz="3000" b="1" dirty="0">
                 <a:solidFill>
-                  <a:srgbClr val="0891B2"/>
+                  <a:srgbClr val="2563EB"/>
                 </a:solidFill>
                 <a:latin typeface="Consolas" pitchFamily="34" charset="0"/>
                 <a:ea typeface="Consolas" pitchFamily="34" charset="-122"/>
@@ -6493,7 +6493,7 @@
                   <a:srgbClr val="1A1A2E"/>
                 </a:solidFill>
               </a:rPr>
-              <a:t>Notify Outside Writer Mutex</a:t>
+              <a:t>Record Fill Outside Writer Mutex</a:t>
             </a:r>
             <a:endParaRPr lang="en-US" sz="1500" dirty="0"/>
           </a:p>
@@ -6508,213 +6508,6 @@
         <p:spPr>
           <a:xfrm>
             <a:off x="1554480" y="1691640"/>
-            <a:ext cx="9875520" cy="914400"/>
-          </a:xfrm>
-          <a:prstGeom prst="rect">
-            <a:avLst/>
-          </a:prstGeom>
-          <a:noFill/>
-          <a:ln/>
-        </p:spPr>
-        <p:txBody>
-          <a:bodyPr wrap="square" rtlCol="0" anchor="t"/>
-          <a:lstStyle/>
-          <a:p>
-            <a:pPr marL="342900" indent="-342900">
-              <a:lnSpc>
-                <a:spcPts val="2400"/>
-              </a:lnSpc>
-              <a:spcAft>
-                <a:spcPts val="400"/>
-              </a:spcAft>
-              <a:buSzPct val="100000"/>
-              <a:buChar char="•"/>
-            </a:pPr>
-            <a:r>
-              <a:rPr lang="en-US" sz="1100" dirty="0">
-                <a:solidFill>
-                  <a:srgbClr val="4A4A6A"/>
-                </a:solidFill>
-              </a:rPr>
-              <a:t>eventfd 写入移出 writer 锁临界区</a:t>
-            </a:r>
-            <a:endParaRPr lang="en-US" sz="1100" dirty="0"/>
-          </a:p>
-          <a:p>
-            <a:pPr marL="342900" indent="-342900">
-              <a:lnSpc>
-                <a:spcPts val="2400"/>
-              </a:lnSpc>
-              <a:spcAft>
-                <a:spcPts val="400"/>
-              </a:spcAft>
-              <a:buSzPct val="100000"/>
-              <a:buChar char="•"/>
-            </a:pPr>
-            <a:r>
-              <a:rPr lang="en-US" sz="1100" dirty="0">
-                <a:solidFill>
-                  <a:srgbClr val="4A4A6A"/>
-                </a:solidFill>
-              </a:rPr>
-              <a:t>8T: 3.12s→2.85s    16T: 3.41s→2.98s</a:t>
-            </a:r>
-            <a:endParaRPr lang="en-US" sz="1100" dirty="0"/>
-          </a:p>
-          <a:p>
-            <a:pPr marL="342900" indent="-342900">
-              <a:lnSpc>
-                <a:spcPts val="2400"/>
-              </a:lnSpc>
-              <a:spcAft>
-                <a:spcPts val="400"/>
-              </a:spcAft>
-              <a:buSzPct val="100000"/>
-              <a:buChar char="•"/>
-            </a:pPr>
-            <a:r>
-              <a:rPr lang="en-US" sz="1100" dirty="0">
-                <a:solidFill>
-                  <a:srgbClr val="4A4A6A"/>
-                </a:solidFill>
-              </a:rPr>
-              <a:t>减少持锁时间，多线程有效</a:t>
-            </a:r>
-            <a:endParaRPr lang="en-US" sz="1100" dirty="0"/>
-          </a:p>
-        </p:txBody>
-      </p:sp>
-      <p:sp>
-        <p:nvSpPr>
-          <p:cNvPr id="12" name="Shape 10"/>
-          <p:cNvSpPr/>
-          <p:nvPr/>
-        </p:nvSpPr>
-        <p:spPr>
-          <a:xfrm>
-            <a:off x="274320" y="2971800"/>
-            <a:ext cx="11612880" cy="1554480"/>
-          </a:xfrm>
-          <a:prstGeom prst="roundRect">
-            <a:avLst>
-              <a:gd name="adj" fmla="val 5882"/>
-            </a:avLst>
-          </a:prstGeom>
-          <a:solidFill>
-            <a:srgbClr val="FFFFFF"/>
-          </a:solidFill>
-          <a:ln w="15240">
-            <a:solidFill>
-              <a:srgbClr val="2563EB"/>
-            </a:solidFill>
-            <a:prstDash val="solid"/>
-          </a:ln>
-        </p:spPr>
-      </p:sp>
-      <p:sp>
-        <p:nvSpPr>
-          <p:cNvPr id="13" name="Shape 11"/>
-          <p:cNvSpPr/>
-          <p:nvPr/>
-        </p:nvSpPr>
-        <p:spPr>
-          <a:xfrm>
-            <a:off x="274320" y="2971800"/>
-            <a:ext cx="109728" cy="1554480"/>
-          </a:xfrm>
-          <a:prstGeom prst="rect">
-            <a:avLst/>
-          </a:prstGeom>
-          <a:solidFill>
-            <a:srgbClr val="2563EB"/>
-          </a:solidFill>
-          <a:ln/>
-        </p:spPr>
-      </p:sp>
-      <p:sp>
-        <p:nvSpPr>
-          <p:cNvPr id="14" name="Text 12"/>
-          <p:cNvSpPr/>
-          <p:nvPr/>
-        </p:nvSpPr>
-        <p:spPr>
-          <a:xfrm>
-            <a:off x="594360" y="3154680"/>
-            <a:ext cx="640080" cy="640080"/>
-          </a:xfrm>
-          <a:prstGeom prst="rect">
-            <a:avLst/>
-          </a:prstGeom>
-          <a:noFill/>
-          <a:ln/>
-        </p:spPr>
-        <p:txBody>
-          <a:bodyPr wrap="square" rtlCol="0" anchor="ctr"/>
-          <a:lstStyle/>
-          <a:p>
-            <a:pPr indent="0" marL="0">
-              <a:buNone/>
-            </a:pPr>
-            <a:r>
-              <a:rPr lang="en-US" sz="3000" b="1" dirty="0">
-                <a:solidFill>
-                  <a:srgbClr val="2563EB"/>
-                </a:solidFill>
-                <a:latin typeface="Consolas" pitchFamily="34" charset="0"/>
-                <a:ea typeface="Consolas" pitchFamily="34" charset="-122"/>
-                <a:cs typeface="Consolas" pitchFamily="34" charset="-120"/>
-              </a:rPr>
-              <a:t>02</a:t>
-            </a:r>
-            <a:endParaRPr lang="en-US" sz="3000" dirty="0"/>
-          </a:p>
-        </p:txBody>
-      </p:sp>
-      <p:sp>
-        <p:nvSpPr>
-          <p:cNvPr id="15" name="Text 13"/>
-          <p:cNvSpPr/>
-          <p:nvPr/>
-        </p:nvSpPr>
-        <p:spPr>
-          <a:xfrm>
-            <a:off x="1371600" y="3108960"/>
-            <a:ext cx="5486400" cy="365760"/>
-          </a:xfrm>
-          <a:prstGeom prst="rect">
-            <a:avLst/>
-          </a:prstGeom>
-          <a:noFill/>
-          <a:ln/>
-        </p:spPr>
-        <p:txBody>
-          <a:bodyPr wrap="square" rtlCol="0" anchor="ctr"/>
-          <a:lstStyle/>
-          <a:p>
-            <a:pPr indent="0" marL="0">
-              <a:buNone/>
-            </a:pPr>
-            <a:r>
-              <a:rPr lang="en-US" sz="1500" b="1" dirty="0">
-                <a:solidFill>
-                  <a:srgbClr val="1A1A2E"/>
-                </a:solidFill>
-              </a:rPr>
-              <a:t>Record Fill Outside Writer Mutex</a:t>
-            </a:r>
-            <a:endParaRPr lang="en-US" sz="1500" dirty="0"/>
-          </a:p>
-        </p:txBody>
-      </p:sp>
-      <p:sp>
-        <p:nvSpPr>
-          <p:cNvPr id="16" name="Text 14"/>
-          <p:cNvSpPr/>
-          <p:nvPr/>
-        </p:nvSpPr>
-        <p:spPr>
-          <a:xfrm>
-            <a:off x="1554480" y="3474720"/>
             <a:ext cx="9875520" cy="914400"/>
           </a:xfrm>
           <a:prstGeom prst="rect">
@@ -6793,13 +6586,13 @@
       </p:sp>
       <p:sp>
         <p:nvSpPr>
-          <p:cNvPr id="17" name="Shape 15"/>
+          <p:cNvPr id="12" name="Shape 10"/>
           <p:cNvSpPr/>
           <p:nvPr/>
         </p:nvSpPr>
         <p:spPr>
           <a:xfrm>
-            <a:off x="274320" y="4754880"/>
+            <a:off x="274320" y="2971800"/>
             <a:ext cx="11612880" cy="1554480"/>
           </a:xfrm>
           <a:prstGeom prst="roundRect">
@@ -6820,13 +6613,13 @@
       </p:sp>
       <p:sp>
         <p:nvSpPr>
-          <p:cNvPr id="18" name="Shape 16"/>
+          <p:cNvPr id="13" name="Shape 11"/>
           <p:cNvSpPr/>
           <p:nvPr/>
         </p:nvSpPr>
         <p:spPr>
           <a:xfrm>
-            <a:off x="274320" y="4754880"/>
+            <a:off x="274320" y="2971800"/>
             <a:ext cx="109728" cy="1554480"/>
           </a:xfrm>
           <a:prstGeom prst="rect">
@@ -6840,13 +6633,13 @@
       </p:sp>
       <p:sp>
         <p:nvSpPr>
-          <p:cNvPr id="19" name="Text 17"/>
+          <p:cNvPr id="14" name="Text 12"/>
           <p:cNvSpPr/>
           <p:nvPr/>
         </p:nvSpPr>
         <p:spPr>
           <a:xfrm>
-            <a:off x="594360" y="4937760"/>
+            <a:off x="594360" y="3154680"/>
             <a:ext cx="640080" cy="640080"/>
           </a:xfrm>
           <a:prstGeom prst="rect">
@@ -6871,7 +6664,7 @@
                 <a:ea typeface="Consolas" pitchFamily="34" charset="-122"/>
                 <a:cs typeface="Consolas" pitchFamily="34" charset="-120"/>
               </a:rPr>
-              <a:t>★</a:t>
+              <a:t>02</a:t>
             </a:r>
             <a:endParaRPr lang="en-US" sz="3000" dirty="0"/>
           </a:p>
@@ -6879,13 +6672,13 @@
       </p:sp>
       <p:sp>
         <p:nvSpPr>
-          <p:cNvPr id="20" name="Text 18"/>
+          <p:cNvPr id="15" name="Text 13"/>
           <p:cNvSpPr/>
           <p:nvPr/>
         </p:nvSpPr>
         <p:spPr>
           <a:xfrm>
-            <a:off x="1371600" y="4892040"/>
+            <a:off x="1371600" y="3108960"/>
             <a:ext cx="5486400" cy="365760"/>
           </a:xfrm>
           <a:prstGeom prst="rect">
@@ -6915,13 +6708,13 @@
       </p:sp>
       <p:sp>
         <p:nvSpPr>
-          <p:cNvPr id="21" name="Text 19"/>
+          <p:cNvPr id="16" name="Text 14"/>
           <p:cNvSpPr/>
           <p:nvPr/>
         </p:nvSpPr>
         <p:spPr>
           <a:xfrm>
-            <a:off x="1554480" y="5257800"/>
+            <a:off x="1554480" y="3474720"/>
             <a:ext cx="9875520" cy="914400"/>
           </a:xfrm>
           <a:prstGeom prst="rect">

</xml_diff>

<commit_message>
Fix slide 4 layout: taller cards with more spacing
</commit_message>
<xml_diff>
--- a/presentation/native_hook_progress_2026-06-05.pptx
+++ b/presentation/native_hook_progress_2026-06-05.pptx
@@ -6385,12 +6385,12 @@
         </p:nvSpPr>
         <p:spPr>
           <a:xfrm>
-            <a:off x="274320" y="1188720"/>
-            <a:ext cx="11612880" cy="1554480"/>
+            <a:off x="274320" y="1280160"/>
+            <a:ext cx="11612880" cy="2011680"/>
           </a:xfrm>
           <a:prstGeom prst="roundRect">
             <a:avLst>
-              <a:gd name="adj" fmla="val 5882"/>
+              <a:gd name="adj" fmla="val 4545"/>
             </a:avLst>
           </a:prstGeom>
           <a:solidFill>
@@ -6412,8 +6412,8 @@
         </p:nvSpPr>
         <p:spPr>
           <a:xfrm>
-            <a:off x="274320" y="1188720"/>
-            <a:ext cx="109728" cy="1554480"/>
+            <a:off x="274320" y="1280160"/>
+            <a:ext cx="109728" cy="2011680"/>
           </a:xfrm>
           <a:prstGeom prst="rect">
             <a:avLst/>
@@ -6432,7 +6432,7 @@
         </p:nvSpPr>
         <p:spPr>
           <a:xfrm>
-            <a:off x="594360" y="1371600"/>
+            <a:off x="594360" y="1508760"/>
             <a:ext cx="640080" cy="640080"/>
           </a:xfrm>
           <a:prstGeom prst="rect">
@@ -6471,7 +6471,7 @@
         </p:nvSpPr>
         <p:spPr>
           <a:xfrm>
-            <a:off x="1371600" y="1325880"/>
+            <a:off x="1371600" y="1463040"/>
             <a:ext cx="5486400" cy="365760"/>
           </a:xfrm>
           <a:prstGeom prst="rect">
@@ -6507,8 +6507,8 @@
         </p:nvSpPr>
         <p:spPr>
           <a:xfrm>
-            <a:off x="1554480" y="1691640"/>
-            <a:ext cx="9875520" cy="914400"/>
+            <a:off x="1554480" y="1920240"/>
+            <a:ext cx="9875520" cy="1097280"/>
           </a:xfrm>
           <a:prstGeom prst="rect">
             <a:avLst/>
@@ -6531,14 +6531,14 @@
               <a:buChar char="•"/>
             </a:pPr>
             <a:r>
-              <a:rPr lang="en-US" sz="1100" dirty="0">
+              <a:rPr lang="en-US" sz="1300" dirty="0">
                 <a:solidFill>
                   <a:srgbClr val="4A4A6A"/>
                 </a:solidFill>
               </a:rPr>
               <a:t>record 元数据填充移出锁</a:t>
             </a:r>
-            <a:endParaRPr lang="en-US" sz="1100" dirty="0"/>
+            <a:endParaRPr lang="en-US" sz="1300" dirty="0"/>
           </a:p>
           <a:p>
             <a:pPr marL="342900" indent="-342900">
@@ -6552,14 +6552,14 @@
               <a:buChar char="•"/>
             </a:pPr>
             <a:r>
-              <a:rPr lang="en-US" sz="1100" dirty="0">
+              <a:rPr lang="en-US" sz="1300" dirty="0">
                 <a:solidFill>
                   <a:srgbClr val="4A4A6A"/>
                 </a:solidFill>
               </a:rPr>
               <a:t>4T: 3.51s→2.72s (22.5%)    8T: 3.64s→3.12s (14.3%)</a:t>
             </a:r>
-            <a:endParaRPr lang="en-US" sz="1100" dirty="0"/>
+            <a:endParaRPr lang="en-US" sz="1300" dirty="0"/>
           </a:p>
           <a:p>
             <a:pPr marL="342900" indent="-342900">
@@ -6573,14 +6573,14 @@
               <a:buChar char="•"/>
             </a:pPr>
             <a:r>
-              <a:rPr lang="en-US" sz="1100" dirty="0">
+              <a:rPr lang="en-US" sz="1300" dirty="0">
                 <a:solidFill>
                   <a:srgbClr val="4A4A6A"/>
                 </a:solidFill>
               </a:rPr>
               <a:t>缩短临界区 = 减少竞争窗口</a:t>
             </a:r>
-            <a:endParaRPr lang="en-US" sz="1100" dirty="0"/>
+            <a:endParaRPr lang="en-US" sz="1300" dirty="0"/>
           </a:p>
         </p:txBody>
       </p:sp>
@@ -6592,12 +6592,12 @@
         </p:nvSpPr>
         <p:spPr>
           <a:xfrm>
-            <a:off x="274320" y="2971800"/>
-            <a:ext cx="11612880" cy="1554480"/>
+            <a:off x="274320" y="3749040"/>
+            <a:ext cx="11612880" cy="2011680"/>
           </a:xfrm>
           <a:prstGeom prst="roundRect">
             <a:avLst>
-              <a:gd name="adj" fmla="val 5882"/>
+              <a:gd name="adj" fmla="val 4545"/>
             </a:avLst>
           </a:prstGeom>
           <a:solidFill>
@@ -6619,8 +6619,8 @@
         </p:nvSpPr>
         <p:spPr>
           <a:xfrm>
-            <a:off x="274320" y="2971800"/>
-            <a:ext cx="109728" cy="1554480"/>
+            <a:off x="274320" y="3749040"/>
+            <a:ext cx="109728" cy="2011680"/>
           </a:xfrm>
           <a:prstGeom prst="rect">
             <a:avLst/>
@@ -6639,7 +6639,7 @@
         </p:nvSpPr>
         <p:spPr>
           <a:xfrm>
-            <a:off x="594360" y="3154680"/>
+            <a:off x="594360" y="3977640"/>
             <a:ext cx="640080" cy="640080"/>
           </a:xfrm>
           <a:prstGeom prst="rect">
@@ -6678,7 +6678,7 @@
         </p:nvSpPr>
         <p:spPr>
           <a:xfrm>
-            <a:off x="1371600" y="3108960"/>
+            <a:off x="1371600" y="3931920"/>
             <a:ext cx="5486400" cy="365760"/>
           </a:xfrm>
           <a:prstGeom prst="rect">
@@ -6714,8 +6714,8 @@
         </p:nvSpPr>
         <p:spPr>
           <a:xfrm>
-            <a:off x="1554480" y="3474720"/>
-            <a:ext cx="9875520" cy="914400"/>
+            <a:off x="1554480" y="4389120"/>
+            <a:ext cx="9875520" cy="1097280"/>
           </a:xfrm>
           <a:prstGeom prst="rect">
             <a:avLst/>
@@ -6738,14 +6738,14 @@
               <a:buChar char="•"/>
             </a:pPr>
             <a:r>
-              <a:rPr lang="en-US" sz="1100" dirty="0">
+              <a:rPr lang="en-US" sz="1300" dirty="0">
                 <a:solidFill>
                   <a:srgbClr val="4A4A6A"/>
                 </a:solidFill>
               </a:rPr>
               <a:t>per-thread buffer → 一次拿锁批量写 → 一次 atomic publish → 一次 notify</a:t>
             </a:r>
-            <a:endParaRPr lang="en-US" sz="1100" dirty="0"/>
+            <a:endParaRPr lang="en-US" sz="1300" dirty="0"/>
           </a:p>
           <a:p>
             <a:pPr marL="342900" indent="-342900">
@@ -6759,14 +6759,14 @@
               <a:buChar char="•"/>
             </a:pPr>
             <a:r>
-              <a:rPr lang="en-US" sz="1100" dirty="0">
+              <a:rPr lang="en-US" sz="1300" dirty="0">
                 <a:solidFill>
                   <a:srgbClr val="4A4A6A"/>
                 </a:solidFill>
               </a:rPr>
               <a:t>1T: 1.55s→1.22s    8T: 3.12s→1.28s    16T: 3.41s→1.34s</a:t>
             </a:r>
-            <a:endParaRPr lang="en-US" sz="1100" dirty="0"/>
+            <a:endParaRPr lang="en-US" sz="1300" dirty="0"/>
           </a:p>
           <a:p>
             <a:pPr marL="342900" indent="-342900">
@@ -6780,14 +6780,14 @@
               <a:buChar char="•"/>
             </a:pPr>
             <a:r>
-              <a:rPr lang="en-US" sz="1100" dirty="0">
+              <a:rPr lang="en-US" sz="1300" dirty="0">
                 <a:solidFill>
                   <a:srgbClr val="4A4A6A"/>
                 </a:solidFill>
               </a:rPr>
               <a:t>env gate: LNHV1_STAGE6_BATCH_SIZE = &lt;1..64&gt;</a:t>
             </a:r>
-            <a:endParaRPr lang="en-US" sz="1100" dirty="0"/>
+            <a:endParaRPr lang="en-US" sz="1300" dirty="0"/>
           </a:p>
         </p:txBody>
       </p:sp>

</xml_diff>

<commit_message>
Add detailed implementation info to slide 4 and script
</commit_message>
<xml_diff>
--- a/presentation/native_hook_progress_2026-06-05.pptx
+++ b/presentation/native_hook_progress_2026-06-05.pptx
@@ -7217,11 +7217,11 @@
         <p:spPr>
           <a:xfrm>
             <a:off x="274320" y="1280160"/>
-            <a:ext cx="11612880" cy="2011680"/>
+            <a:ext cx="11612880" cy="2468880"/>
           </a:xfrm>
           <a:prstGeom prst="roundRect">
             <a:avLst>
-              <a:gd name="adj" fmla="val 4545"/>
+              <a:gd name="adj" fmla="val 3704"/>
             </a:avLst>
           </a:prstGeom>
           <a:solidFill>
@@ -7244,7 +7244,7 @@
         <p:spPr>
           <a:xfrm>
             <a:off x="274320" y="1280160"/>
-            <a:ext cx="109728" cy="2011680"/>
+            <a:ext cx="109728" cy="2468880"/>
           </a:xfrm>
           <a:prstGeom prst="rect">
             <a:avLst/>
@@ -7339,7 +7339,7 @@
         <p:spPr>
           <a:xfrm>
             <a:off x="1554480" y="1920240"/>
-            <a:ext cx="9875520" cy="1097280"/>
+            <a:ext cx="9875520" cy="1554480"/>
           </a:xfrm>
           <a:prstGeom prst="rect">
             <a:avLst/>
@@ -7362,14 +7362,14 @@
               <a:buChar char="•"/>
             </a:pPr>
             <a:r>
-              <a:rPr lang="en-US" sz="1300" dirty="0">
+              <a:rPr lang="en-US" sz="1200" dirty="0">
                 <a:solidFill>
                   <a:srgbClr val="4A4A6A"/>
                 </a:solidFill>
               </a:rPr>
-              <a:t>record 元数据填充移出锁</a:t>
+              <a:t>移出锁的操作: pid, tid, timestamp, type, size, addr 填充 + thread-name 更新</a:t>
             </a:r>
-            <a:endParaRPr lang="en-US" sz="1300" dirty="0"/>
+            <a:endParaRPr lang="en-US" sz="1200" dirty="0"/>
           </a:p>
           <a:p>
             <a:pPr marL="342900" indent="-342900">
@@ -7383,14 +7383,14 @@
               <a:buChar char="•"/>
             </a:pPr>
             <a:r>
-              <a:rPr lang="en-US" sz="1300" dirty="0">
+              <a:rPr lang="en-US" sz="1200" dirty="0">
                 <a:solidFill>
                   <a:srgbClr val="4A4A6A"/>
                 </a:solidFill>
               </a:rPr>
-              <a:t>4T: 3.51s→2.72s (22.5%)    8T: 3.64s→3.12s (14.3%)</a:t>
+              <a:t>这些操作不碰共享状态——pid/tid 是 thread-local cache，timestamp 是 clock_gettime</a:t>
             </a:r>
-            <a:endParaRPr lang="en-US" sz="1300" dirty="0"/>
+            <a:endParaRPr lang="en-US" sz="1200" dirty="0"/>
           </a:p>
           <a:p>
             <a:pPr marL="342900" indent="-342900">
@@ -7404,14 +7404,77 @@
               <a:buChar char="•"/>
             </a:pPr>
             <a:r>
-              <a:rPr lang="en-US" sz="1300" dirty="0">
+              <a:rPr lang="en-US" sz="1200" dirty="0">
                 <a:solidFill>
                   <a:srgbClr val="4A4A6A"/>
                 </a:solidFill>
               </a:rPr>
-              <a:t>缩短临界区 = 减少竞争窗口</a:t>
+              <a:t>原来锁内做: lock → fill → write_ring → notify → unlock</a:t>
             </a:r>
-            <a:endParaRPr lang="en-US" sz="1300" dirty="0"/>
+            <a:endParaRPr lang="en-US" sz="1200" dirty="0"/>
+          </a:p>
+          <a:p>
+            <a:pPr marL="342900" indent="-342900">
+              <a:lnSpc>
+                <a:spcPts val="2400"/>
+              </a:lnSpc>
+              <a:spcAft>
+                <a:spcPts val="400"/>
+              </a:spcAft>
+              <a:buSzPct val="100000"/>
+              <a:buChar char="•"/>
+            </a:pPr>
+            <a:r>
+              <a:rPr lang="en-US" sz="1200" dirty="0">
+                <a:solidFill>
+                  <a:srgbClr val="4A4A6A"/>
+                </a:solidFill>
+              </a:rPr>
+              <a:t>优化后: fill → lock → write_ring → notify → unlock</a:t>
+            </a:r>
+            <a:endParaRPr lang="en-US" sz="1200" dirty="0"/>
+          </a:p>
+          <a:p>
+            <a:pPr marL="342900" indent="-342900">
+              <a:lnSpc>
+                <a:spcPts val="2400"/>
+              </a:lnSpc>
+              <a:spcAft>
+                <a:spcPts val="400"/>
+              </a:spcAft>
+              <a:buSzPct val="100000"/>
+              <a:buChar char="•"/>
+            </a:pPr>
+            <a:r>
+              <a:rPr lang="en-US" sz="1200" dirty="0">
+                <a:solidFill>
+                  <a:srgbClr val="4A4A6A"/>
+                </a:solidFill>
+              </a:rPr>
+              <a:t>4T: 3.51s→2.72s (22.5%)    8T: 3.64s→3.12s (14.3%)</a:t>
+            </a:r>
+            <a:endParaRPr lang="en-US" sz="1200" dirty="0"/>
+          </a:p>
+          <a:p>
+            <a:pPr marL="342900" indent="-342900">
+              <a:lnSpc>
+                <a:spcPts val="2400"/>
+              </a:lnSpc>
+              <a:spcAft>
+                <a:spcPts val="400"/>
+              </a:spcAft>
+              <a:buSzPct val="100000"/>
+              <a:buChar char="•"/>
+            </a:pPr>
+            <a:r>
+              <a:rPr lang="en-US" sz="1200" dirty="0">
+                <a:solidFill>
+                  <a:srgbClr val="4A4A6A"/>
+                </a:solidFill>
+              </a:rPr>
+              <a:t>核心收益: 缩短锁内工作量 → 减少其他线程排队等锁时间</a:t>
+            </a:r>
+            <a:endParaRPr lang="en-US" sz="1200" dirty="0"/>
           </a:p>
         </p:txBody>
       </p:sp>
@@ -7424,11 +7487,11 @@
         <p:spPr>
           <a:xfrm>
             <a:off x="274320" y="3749040"/>
-            <a:ext cx="11612880" cy="2011680"/>
+            <a:ext cx="11612880" cy="2468880"/>
           </a:xfrm>
           <a:prstGeom prst="roundRect">
             <a:avLst>
-              <a:gd name="adj" fmla="val 4545"/>
+              <a:gd name="adj" fmla="val 3704"/>
             </a:avLst>
           </a:prstGeom>
           <a:solidFill>
@@ -7451,7 +7514,7 @@
         <p:spPr>
           <a:xfrm>
             <a:off x="274320" y="3749040"/>
-            <a:ext cx="109728" cy="2011680"/>
+            <a:ext cx="109728" cy="2468880"/>
           </a:xfrm>
           <a:prstGeom prst="rect">
             <a:avLst/>
@@ -7546,7 +7609,7 @@
         <p:spPr>
           <a:xfrm>
             <a:off x="1554480" y="4389120"/>
-            <a:ext cx="9875520" cy="1097280"/>
+            <a:ext cx="9875520" cy="1554480"/>
           </a:xfrm>
           <a:prstGeom prst="rect">
             <a:avLst/>
@@ -7569,14 +7632,14 @@
               <a:buChar char="•"/>
             </a:pPr>
             <a:r>
-              <a:rPr lang="en-US" sz="1300" dirty="0">
+              <a:rPr lang="en-US" sz="1200" dirty="0">
                 <a:solidFill>
                   <a:srgbClr val="4A4A6A"/>
                 </a:solidFill>
               </a:rPr>
-              <a:t>per-thread buffer → 一次拿锁批量写 → 一次 atomic publish → 一次 notify</a:t>
+              <a:t>per-thread buffer (array&lt;HookRecord, 65&gt;) + counter, env: LNHV1_STAGE6_BATCH_SIZE=1~64</a:t>
             </a:r>
-            <a:endParaRPr lang="en-US" sz="1300" dirty="0"/>
+            <a:endParaRPr lang="en-US" sz="1200" dirty="0"/>
           </a:p>
           <a:p>
             <a:pPr marL="342900" indent="-342900">
@@ -7590,14 +7653,14 @@
               <a:buChar char="•"/>
             </a:pPr>
             <a:r>
-              <a:rPr lang="en-US" sz="1300" dirty="0">
+              <a:rPr lang="en-US" sz="1200" dirty="0">
                 <a:solidFill>
                   <a:srgbClr val="4A4A6A"/>
                 </a:solidFill>
               </a:rPr>
-              <a:t>1T: 1.55s→1.22s    8T: 3.12s→1.28s    16T: 3.41s→1.34s</a:t>
+              <a:t>BufferStage6Record: 每 record 加到 buffer; count &gt;= batch_size 时触发 FlushStage6Batch</a:t>
             </a:r>
-            <a:endParaRPr lang="en-US" sz="1300" dirty="0"/>
+            <a:endParaRPr lang="en-US" sz="1200" dirty="0"/>
           </a:p>
           <a:p>
             <a:pPr marL="342900" indent="-342900">
@@ -7611,14 +7674,98 @@
               <a:buChar char="•"/>
             </a:pPr>
             <a:r>
-              <a:rPr lang="en-US" sz="1300" dirty="0">
+              <a:rPr lang="en-US" sz="1200" dirty="0">
                 <a:solidFill>
                   <a:srgbClr val="4A4A6A"/>
                 </a:solidFill>
               </a:rPr>
-              <a:t>env gate: LNHV1_STAGE6_BATCH_SIZE = &lt;1..64&gt;</a:t>
+              <a:t>Flush 内: 拿一次 mutex_ → WriteRecordsLocked(批量拷贝到 ring) → 一次 atomic write_index → 一次 PrepareFlush</a:t>
             </a:r>
-            <a:endParaRPr lang="en-US" sz="1300" dirty="0"/>
+            <a:endParaRPr lang="en-US" sz="1200" dirty="0"/>
+          </a:p>
+          <a:p>
+            <a:pPr marL="342900" indent="-342900">
+              <a:lnSpc>
+                <a:spcPts val="2400"/>
+              </a:lnSpc>
+              <a:spcAft>
+                <a:spcPts val="400"/>
+              </a:spcAft>
+              <a:buSzPct val="100000"/>
+              <a:buChar char="•"/>
+            </a:pPr>
+            <a:r>
+              <a:rPr lang="en-US" sz="1200" dirty="0">
+                <a:solidFill>
+                  <a:srgbClr val="4A4A6A"/>
+                </a:solidFill>
+              </a:rPr>
+              <a:t>原来 100万条 = 100万次拿锁 + 100万次 atomic publish + ~5万次 eventfd</a:t>
+            </a:r>
+            <a:endParaRPr lang="en-US" sz="1200" dirty="0"/>
+          </a:p>
+          <a:p>
+            <a:pPr marL="342900" indent="-342900">
+              <a:lnSpc>
+                <a:spcPts val="2400"/>
+              </a:lnSpc>
+              <a:spcAft>
+                <a:spcPts val="400"/>
+              </a:spcAft>
+              <a:buSzPct val="100000"/>
+              <a:buChar char="•"/>
+            </a:pPr>
+            <a:r>
+              <a:rPr lang="en-US" sz="1200" dirty="0">
+                <a:solidFill>
+                  <a:srgbClr val="4A4A6A"/>
+                </a:solidFill>
+              </a:rPr>
+              <a:t>batch64 ↓ = ~1.5万次拿锁 + ~1.5万次 atomic publish + ~780次 eventfd</a:t>
+            </a:r>
+            <a:endParaRPr lang="en-US" sz="1200" dirty="0"/>
+          </a:p>
+          <a:p>
+            <a:pPr marL="342900" indent="-342900">
+              <a:lnSpc>
+                <a:spcPts val="2400"/>
+              </a:lnSpc>
+              <a:spcAft>
+                <a:spcPts val="400"/>
+              </a:spcAft>
+              <a:buSzPct val="100000"/>
+              <a:buChar char="•"/>
+            </a:pPr>
+            <a:r>
+              <a:rPr lang="en-US" sz="1200" dirty="0">
+                <a:solidFill>
+                  <a:srgbClr val="4A4A6A"/>
+                </a:solidFill>
+              </a:rPr>
+              <a:t>1T: 1.55s→1.22s    8T: 3.12s→1.28s    16T: 3.41s→1.34s</a:t>
+            </a:r>
+            <a:endParaRPr lang="en-US" sz="1200" dirty="0"/>
+          </a:p>
+          <a:p>
+            <a:pPr marL="342900" indent="-342900">
+              <a:lnSpc>
+                <a:spcPts val="2400"/>
+              </a:lnSpc>
+              <a:spcAft>
+                <a:spcPts val="400"/>
+              </a:spcAft>
+              <a:buSzPct val="100000"/>
+              <a:buChar char="•"/>
+            </a:pPr>
+            <a:r>
+              <a:rPr lang="en-US" sz="1200" dirty="0">
+                <a:solidFill>
+                  <a:srgbClr val="4A4A6A"/>
+                </a:solidFill>
+              </a:rPr>
+              <a:t>线程退出时 Stage6RecordBatch 析构函数自动 Flush 排空残留</a:t>
+            </a:r>
+            <a:endParaRPr lang="en-US" sz="1200" dirty="0"/>
           </a:p>
         </p:txBody>
       </p:sp>

</xml_diff>

<commit_message>
Move batch detail numbers from slide 4 to visualization slide 5
</commit_message>
<xml_diff>
--- a/presentation/native_hook_progress_2026-06-05.pptx
+++ b/presentation/native_hook_progress_2026-06-05.pptx
@@ -9481,7 +9481,7 @@
                   <a:srgbClr val="4A4A6A"/>
                 </a:solidFill>
               </a:rPr>
-              <a:t>per-thread buffer (array&lt;HookRecord, 65&gt;) + counter, env: LNHV1_STAGE6_BATCH_SIZE=1~64</a:t>
+              <a:t>per-thread buffer (array&lt;HookRecord, 65&gt;) + counter</a:t>
             </a:r>
             <a:endParaRPr lang="en-US" sz="1200" dirty="0"/>
           </a:p>
@@ -9502,7 +9502,7 @@
                   <a:srgbClr val="4A4A6A"/>
                 </a:solidFill>
               </a:rPr>
-              <a:t>BufferStage6Record: 每 record 加到 buffer; count &gt;= batch_size 时触发 FlushStage6Batch</a:t>
+              <a:t>BufferStage6Record 累积 record; count &gt;= batch_size → FlushStage6Batch</a:t>
             </a:r>
             <a:endParaRPr lang="en-US" sz="1200" dirty="0"/>
           </a:p>
@@ -9523,7 +9523,7 @@
                   <a:srgbClr val="4A4A6A"/>
                 </a:solidFill>
               </a:rPr>
-              <a:t>Flush 内: 拿一次 mutex_ → WriteRecordsLocked(批量拷贝到 ring) → 一次 atomic write_index → 一次 PrepareFlush</a:t>
+              <a:t>Flush 内: 拿一次锁 → 批量写 ring → 一次 atomic publish → 一次 notify</a:t>
             </a:r>
             <a:endParaRPr lang="en-US" sz="1200" dirty="0"/>
           </a:p>
@@ -9544,7 +9544,7 @@
                   <a:srgbClr val="4A4A6A"/>
                 </a:solidFill>
               </a:rPr>
-              <a:t>原来 100万条 = 100万次拿锁 + 100万次 atomic publish + ~5万次 eventfd</a:t>
+              <a:t>析构函数在线程退出时自动 Flush 残留</a:t>
             </a:r>
             <a:endParaRPr lang="en-US" sz="1200" dirty="0"/>
           </a:p>
@@ -9565,7 +9565,7 @@
                   <a:srgbClr val="4A4A6A"/>
                 </a:solidFill>
               </a:rPr>
-              <a:t>batch64 ↓ = ~1.5万次拿锁 + ~1.5万次 atomic publish + ~780次 eventfd</a:t>
+              <a:t>env gate: LNHV1_STAGE6_BATCH_SIZE=1~64（默认0=关闭）</a:t>
             </a:r>
             <a:endParaRPr lang="en-US" sz="1200" dirty="0"/>
           </a:p>
@@ -9586,28 +9586,7 @@
                   <a:srgbClr val="4A4A6A"/>
                 </a:solidFill>
               </a:rPr>
-              <a:t>1T: 1.55s→1.22s    8T: 3.12s→1.28s    16T: 3.41s→1.34s</a:t>
-            </a:r>
-            <a:endParaRPr lang="en-US" sz="1200" dirty="0"/>
-          </a:p>
-          <a:p>
-            <a:pPr marL="342900" indent="-342900">
-              <a:lnSpc>
-                <a:spcPts val="2400"/>
-              </a:lnSpc>
-              <a:spcAft>
-                <a:spcPts val="400"/>
-              </a:spcAft>
-              <a:buSzPct val="100000"/>
-              <a:buChar char="•"/>
-            </a:pPr>
-            <a:r>
-              <a:rPr lang="en-US" sz="1200" dirty="0">
-                <a:solidFill>
-                  <a:srgbClr val="4A4A6A"/>
-                </a:solidFill>
-              </a:rPr>
-              <a:t>线程退出时 Stage6RecordBatch 析构函数自动 Flush 排空残留</a:t>
+              <a:t>效果: 1T 1.55s→1.22s    8T 3.12s→1.28s    16T 3.41s→1.34s</a:t>
             </a:r>
             <a:endParaRPr lang="en-US" sz="1200" dirty="0"/>
           </a:p>

</xml_diff>

<commit_message>
Minimize English terms, use Chinese throughout PPT
</commit_message>
<xml_diff>
--- a/presentation/native_hook_progress_2026-06-05.pptx
+++ b/presentation/native_hook_progress_2026-06-05.pptx
@@ -4606,7 +4606,7 @@
                   <a:srgbClr val="1A1A2E"/>
                 </a:solidFill>
               </a:rPr>
-              <a:t>Next Steps</a:t>
+              <a:t>后续计划</a:t>
             </a:r>
             <a:endParaRPr lang="en-US" sz="2400" dirty="0"/>
           </a:p>
@@ -6153,7 +6153,7 @@
                   <a:srgbClr val="1A1A2E"/>
                 </a:solidFill>
               </a:rPr>
-              <a:t>Writer/Ring Impact 拆解实验</a:t>
+              <a:t>写入器/环形缓冲区 逐段拆解实验</a:t>
             </a:r>
             <a:endParaRPr lang="en-US" sz="2400" dirty="0"/>
           </a:p>
@@ -9010,7 +9010,7 @@
                   <a:srgbClr val="1A1A2E"/>
                 </a:solidFill>
               </a:rPr>
-              <a:t>Producer 端两项优化</a:t>
+              <a:t>生产者端 两项优化</a:t>
             </a:r>
             <a:endParaRPr lang="en-US" sz="2400" dirty="0"/>
           </a:p>
@@ -9168,7 +9168,7 @@
                   <a:srgbClr val="1A1A2E"/>
                 </a:solidFill>
               </a:rPr>
-              <a:t>Record Fill Outside Writer Mutex</a:t>
+              <a:t>记录填充移出写入锁</a:t>
             </a:r>
             <a:endParaRPr lang="en-US" sz="1500" dirty="0"/>
           </a:p>
@@ -9211,7 +9211,7 @@
                   <a:srgbClr val="4A4A6A"/>
                 </a:solidFill>
               </a:rPr>
-              <a:t>移出锁的操作: pid, tid, timestamp, type, size, addr 填充 + thread-name 更新</a:t>
+              <a:t>移出锁的操作: 进程ID、线程ID、时间戳、类型、大小、地址 + 线程名更新</a:t>
             </a:r>
             <a:endParaRPr lang="en-US" sz="1200" dirty="0"/>
           </a:p>
@@ -9232,7 +9232,7 @@
                   <a:srgbClr val="4A4A6A"/>
                 </a:solidFill>
               </a:rPr>
-              <a:t>这些操作不碰共享状态——pid/tid 是 thread-local cache，timestamp 是 clock_gettime</a:t>
+              <a:t>这些字段不碰共享状态——进程/线程ID缓存于线程本地，时间戳直接系统调用</a:t>
             </a:r>
             <a:endParaRPr lang="en-US" sz="1200" dirty="0"/>
           </a:p>
@@ -9253,7 +9253,7 @@
                   <a:srgbClr val="4A4A6A"/>
                 </a:solidFill>
               </a:rPr>
-              <a:t>原来锁内做: lock → fill → write_ring → notify → unlock</a:t>
+              <a:t>原来: 拿锁 → 填充字段 → 写共享内存 → 通知 → 放锁</a:t>
             </a:r>
             <a:endParaRPr lang="en-US" sz="1200" dirty="0"/>
           </a:p>
@@ -9274,7 +9274,7 @@
                   <a:srgbClr val="4A4A6A"/>
                 </a:solidFill>
               </a:rPr>
-              <a:t>优化后: fill → lock → write_ring → notify → unlock</a:t>
+              <a:t>优化后: 填充字段 → 拿锁 → 写共享内存 → 通知 → 放锁</a:t>
             </a:r>
             <a:endParaRPr lang="en-US" sz="1200" dirty="0"/>
           </a:p>
@@ -9316,7 +9316,7 @@
                   <a:srgbClr val="4A4A6A"/>
                 </a:solidFill>
               </a:rPr>
-              <a:t>核心收益: 缩短锁内工作量 → 减少其他线程排队等锁时间</a:t>
+              <a:t>核心收益: 缩短临界区 → 减少其他线程等锁时间</a:t>
             </a:r>
             <a:endParaRPr lang="en-US" sz="1200" dirty="0"/>
           </a:p>
@@ -9438,7 +9438,7 @@
                   <a:srgbClr val="1A1A2E"/>
                 </a:solidFill>
               </a:rPr>
-              <a:t>Stage 6  Batch  Publish</a:t>
+              <a:t>Stage 6  批量发布</a:t>
             </a:r>
             <a:endParaRPr lang="en-US" sz="1500" dirty="0"/>
           </a:p>
@@ -9481,7 +9481,7 @@
                   <a:srgbClr val="4A4A6A"/>
                 </a:solidFill>
               </a:rPr>
-              <a:t>per-thread buffer (array&lt;HookRecord, 65&gt;) + counter</a:t>
+              <a:t>线程本地缓冲区 (固定大小数组 + 计数器)</a:t>
             </a:r>
             <a:endParaRPr lang="en-US" sz="1200" dirty="0"/>
           </a:p>
@@ -9502,7 +9502,7 @@
                   <a:srgbClr val="4A4A6A"/>
                 </a:solidFill>
               </a:rPr>
-              <a:t>BufferStage6Record 累积 record; count &gt;= batch_size → FlushStage6Batch</a:t>
+              <a:t>每条记录先进入缓冲区; 攒满批次大小 → 触发批量排空</a:t>
             </a:r>
             <a:endParaRPr lang="en-US" sz="1200" dirty="0"/>
           </a:p>
@@ -9523,7 +9523,7 @@
                   <a:srgbClr val="4A4A6A"/>
                 </a:solidFill>
               </a:rPr>
-              <a:t>Flush 内: 拿一次锁 → 批量写 ring → 一次 atomic publish → 一次 notify</a:t>
+              <a:t>排空时: 拿一次锁 → 批量写共享内存 → 一次原子更新索引 → 一次事件通知</a:t>
             </a:r>
             <a:endParaRPr lang="en-US" sz="1200" dirty="0"/>
           </a:p>
@@ -9544,7 +9544,7 @@
                   <a:srgbClr val="4A4A6A"/>
                 </a:solidFill>
               </a:rPr>
-              <a:t>析构函数在线程退出时自动 Flush 残留</a:t>
+              <a:t>线程退出时析构函数自动排空残留</a:t>
             </a:r>
             <a:endParaRPr lang="en-US" sz="1200" dirty="0"/>
           </a:p>
@@ -9733,7 +9733,7 @@
                   <a:srgbClr val="1A1A2E"/>
                 </a:solidFill>
               </a:rPr>
-              <a:t>Batch Publish — 工作原理</a:t>
+              <a:t>批量发布 — 工作原理</a:t>
             </a:r>
             <a:endParaRPr lang="en-US" sz="2400" dirty="0"/>
           </a:p>
@@ -9769,7 +9769,7 @@
                   <a:srgbClr val="8888A8"/>
                 </a:solidFill>
               </a:rPr>
-              <a:t>Per-Record  vs  Per-Batch</a:t>
+              <a:t>逐记录  vs  逐批次</a:t>
             </a:r>
             <a:endParaRPr lang="en-US" sz="1200" dirty="0"/>
           </a:p>
@@ -9805,7 +9805,7 @@
                   <a:srgbClr val="1A1A2E"/>
                 </a:solidFill>
               </a:rPr>
-              <a:t>Per-Record（优化前）</a:t>
+              <a:t>逐记录模式（优化前）</a:t>
             </a:r>
             <a:endParaRPr lang="en-US" sz="1300" dirty="0"/>
           </a:p>
@@ -10903,7 +10903,7 @@
                   <a:srgbClr val="4A4A6A"/>
                 </a:solidFill>
               </a:rPr>
-              <a:t>record → 每 percord 走一遍拿锁、写ring、通知</a:t>
+              <a:t>record → 每条记录走一遍拿锁、写共享内存、通知</a:t>
             </a:r>
             <a:endParaRPr lang="en-US" sz="900" dirty="0"/>
           </a:p>
@@ -10939,7 +10939,7 @@
                   <a:srgbClr val="1A1A2E"/>
                 </a:solidFill>
               </a:rPr>
-              <a:t>Per-Batch（batch=64 优化后）</a:t>
+              <a:t>逐批次模式（batch=64 优化后）</a:t>
             </a:r>
             <a:endParaRPr lang="en-US" sz="1300" dirty="0"/>
           </a:p>
@@ -12002,7 +12002,7 @@
                   <a:srgbClr val="FFFFFF"/>
                 </a:solidFill>
               </a:rPr>
-              <a:t>即：100万次锁操作 → 1.5万次锁操作    100万次 atomic publish → 1.5万次    ~5万次 eventfd → ~780次</a:t>
+              <a:t>即：100万次锁操作 → 1.5万次锁操作    100万次原子索引发布 → 1.5万次    ~5万次事件通知 → ~780次</a:t>
             </a:r>
             <a:endParaRPr lang="en-US" sz="1300" dirty="0"/>
           </a:p>
@@ -12149,7 +12149,7 @@
                   <a:srgbClr val="1A1A2E"/>
                 </a:solidFill>
               </a:rPr>
-              <a:t>Batch Publish — Pink 验证数据</a:t>
+              <a:t>批量发布 — 服务器验证数据</a:t>
             </a:r>
             <a:endParaRPr lang="en-US" sz="2400" dirty="0"/>
           </a:p>
@@ -16429,7 +16429,7 @@
                   <a:srgbClr val="1A1A2E"/>
                 </a:solidFill>
               </a:rPr>
-              <a:t>StackWriter 模块级瓶颈定位</a:t>
+              <a:t>栈写入器 模块级瓶颈定位</a:t>
             </a:r>
             <a:endParaRPr lang="en-US" sz="2400" dirty="0"/>
           </a:p>
@@ -18224,7 +18224,7 @@
                   <a:srgbClr val="1A1A2E"/>
                 </a:solidFill>
               </a:rPr>
-              <a:t>Prototype  ↔  OpenHarmony  架构对齐</a:t>
+              <a:t>原型  ↔  OpenHarmony  架构对齐</a:t>
             </a:r>
             <a:endParaRPr lang="en-US" sz="2400" dirty="0"/>
           </a:p>

</xml_diff>

<commit_message>
Redesign architecture slide: aligned modules vs remaining gaps
</commit_message>
<xml_diff>
--- a/presentation/native_hook_progress_2026-06-05.pptx
+++ b/presentation/native_hook_progress_2026-06-05.pptx
@@ -18260,9 +18260,72 @@
                   <a:srgbClr val="8888A8"/>
                 </a:solidFill>
               </a:rPr>
-              <a:t>热路径模块映射</a:t>
+              <a:t>已对齐的模块 vs 仍存在的差异</a:t>
             </a:r>
             <a:endParaRPr lang="en-US" sz="1200" dirty="0"/>
+          </a:p>
+        </p:txBody>
+      </p:sp>
+      <p:sp>
+        <p:nvSpPr>
+          <p:cNvPr id="7" name="Shape 5"/>
+          <p:cNvSpPr/>
+          <p:nvPr/>
+        </p:nvSpPr>
+        <p:spPr>
+          <a:xfrm>
+            <a:off x="228600" y="1097280"/>
+            <a:ext cx="5486400" cy="5029200"/>
+          </a:xfrm>
+          <a:prstGeom prst="roundRect">
+            <a:avLst>
+              <a:gd name="adj" fmla="val 1818"/>
+            </a:avLst>
+          </a:prstGeom>
+          <a:solidFill>
+            <a:srgbClr val="ECFDF5"/>
+          </a:solidFill>
+          <a:ln w="15240">
+            <a:solidFill>
+              <a:srgbClr val="059669"/>
+            </a:solidFill>
+            <a:prstDash val="solid"/>
+          </a:ln>
+        </p:spPr>
+      </p:sp>
+      <p:sp>
+        <p:nvSpPr>
+          <p:cNvPr id="8" name="Text 6"/>
+          <p:cNvSpPr/>
+          <p:nvPr/>
+        </p:nvSpPr>
+        <p:spPr>
+          <a:xfrm>
+            <a:off x="457200" y="1188720"/>
+            <a:ext cx="3657600" cy="320040"/>
+          </a:xfrm>
+          <a:prstGeom prst="rect">
+            <a:avLst/>
+          </a:prstGeom>
+          <a:noFill/>
+          <a:ln/>
+        </p:spPr>
+        <p:txBody>
+          <a:bodyPr wrap="square" rtlCol="0" anchor="ctr"/>
+          <a:lstStyle/>
+          <a:p>
+            <a:pPr indent="0" marL="0">
+              <a:buNone/>
+            </a:pPr>
+            <a:r>
+              <a:rPr lang="en-US" sz="1400" b="1" dirty="0">
+                <a:solidFill>
+                  <a:srgbClr val="059669"/>
+                </a:solidFill>
+              </a:rPr>
+              <a:t>✓ 已对齐的模块</a:t>
+            </a:r>
+            <a:endParaRPr lang="en-US" sz="1400" dirty="0"/>
           </a:p>
         </p:txBody>
       </p:sp>
@@ -18281,80 +18344,19 @@
           </p:nvPr>
         </p:nvGraphicFramePr>
         <p:xfrm>
-          <a:off x="274320" y="1188720"/>
-          <a:ext cx="11521440" cy="914400"/>
+          <a:off x="411480" y="1645920"/>
+          <a:ext cx="5120640" cy="914400"/>
         </p:xfrm>
         <a:graphic>
           <a:graphicData uri="http://schemas.openxmlformats.org/drawingml/2006/table">
             <a:tbl>
               <a:tblPr/>
               <a:tblGrid>
-                <a:gridCol w="3840480"/>
-                <a:gridCol w="3840480"/>
-                <a:gridCol w="3840480"/>
+                <a:gridCol w="1645920"/>
+                <a:gridCol w="1828800"/>
+                <a:gridCol w="2011680"/>
               </a:tblGrid>
-              <a:tr h="384048">
-                <a:tc>
-                  <a:txBody>
-                    <a:bodyPr/>
-                    <a:lstStyle/>
-                    <a:p>
-                      <a:pPr algn="l" indent="0" marL="0">
-                        <a:buNone/>
-                      </a:pPr>
-                      <a:r>
-                        <a:rPr lang="en-US" sz="1200" b="1" dirty="0">
-                          <a:solidFill>
-                            <a:srgbClr val="2563EB"/>
-                          </a:solidFill>
-                        </a:rPr>
-                        <a:t>热路径操作</a:t>
-                      </a:r>
-                      <a:endParaRPr lang="en-US" sz="1200" dirty="0"/>
-                    </a:p>
-                  </a:txBody>
-                  <a:tcPr marL="76200" marR="76200" marT="25400" marB="25400">
-                    <a:lnL w="6350" cap="flat" cmpd="sng" algn="ctr">
-                      <a:solidFill>
-                        <a:srgbClr val="E0E4EC"/>
-                      </a:solidFill>
-                      <a:prstDash val="solid"/>
-                      <a:round/>
-                      <a:headEnd type="none" w="med" len="med"/>
-                      <a:tailEnd type="none" w="med" len="med"/>
-                    </a:lnL>
-                    <a:lnR w="6350" cap="flat" cmpd="sng" algn="ctr">
-                      <a:solidFill>
-                        <a:srgbClr val="E0E4EC"/>
-                      </a:solidFill>
-                      <a:prstDash val="solid"/>
-                      <a:round/>
-                      <a:headEnd type="none" w="med" len="med"/>
-                      <a:tailEnd type="none" w="med" len="med"/>
-                    </a:lnR>
-                    <a:lnT w="6350" cap="flat" cmpd="sng" algn="ctr">
-                      <a:solidFill>
-                        <a:srgbClr val="E0E4EC"/>
-                      </a:solidFill>
-                      <a:prstDash val="solid"/>
-                      <a:round/>
-                      <a:headEnd type="none" w="med" len="med"/>
-                      <a:tailEnd type="none" w="med" len="med"/>
-                    </a:lnT>
-                    <a:lnB w="6350" cap="flat" cmpd="sng" algn="ctr">
-                      <a:solidFill>
-                        <a:srgbClr val="E0E4EC"/>
-                      </a:solidFill>
-                      <a:prstDash val="solid"/>
-                      <a:round/>
-                      <a:headEnd type="none" w="med" len="med"/>
-                      <a:tailEnd type="none" w="med" len="med"/>
-                    </a:lnB>
-                    <a:solidFill>
-                      <a:srgbClr val="EEF2FF"/>
-                    </a:solidFill>
-                  </a:tcPr>
-                </a:tc>
+              <a:tr h="457200">
                 <a:tc>
                   <a:txBody>
                     <a:bodyPr/>
@@ -18364,20 +18366,20 @@
                         <a:buNone/>
                       </a:pPr>
                       <a:r>
-                        <a:rPr lang="en-US" sz="1200" b="1" dirty="0">
+                        <a:rPr lang="en-US" sz="900" b="1" dirty="0">
                           <a:solidFill>
-                            <a:srgbClr val="2563EB"/>
+                            <a:srgbClr val="059669"/>
                           </a:solidFill>
                         </a:rPr>
-                        <a:t>Prototype (Plan B)</a:t>
+                        <a:t>操作</a:t>
                       </a:r>
-                      <a:endParaRPr lang="en-US" sz="1200" dirty="0"/>
+                      <a:endParaRPr lang="en-US" sz="900" dirty="0"/>
                     </a:p>
                   </a:txBody>
-                  <a:tcPr marL="76200" marR="76200" marT="25400" marB="25400">
+                  <a:tcPr marL="50800" marR="50800" marT="25400" marB="25400">
                     <a:lnL w="6350" cap="flat" cmpd="sng" algn="ctr">
                       <a:solidFill>
-                        <a:srgbClr val="E0E4EC"/>
+                        <a:srgbClr val="059669"/>
                       </a:solidFill>
                       <a:prstDash val="solid"/>
                       <a:round/>
@@ -18386,7 +18388,7 @@
                     </a:lnL>
                     <a:lnR w="6350" cap="flat" cmpd="sng" algn="ctr">
                       <a:solidFill>
-                        <a:srgbClr val="E0E4EC"/>
+                        <a:srgbClr val="059669"/>
                       </a:solidFill>
                       <a:prstDash val="solid"/>
                       <a:round/>
@@ -18395,7 +18397,7 @@
                     </a:lnR>
                     <a:lnT w="6350" cap="flat" cmpd="sng" algn="ctr">
                       <a:solidFill>
-                        <a:srgbClr val="E0E4EC"/>
+                        <a:srgbClr val="059669"/>
                       </a:solidFill>
                       <a:prstDash val="solid"/>
                       <a:round/>
@@ -18404,131 +18406,7 @@
                     </a:lnT>
                     <a:lnB w="6350" cap="flat" cmpd="sng" algn="ctr">
                       <a:solidFill>
-                        <a:srgbClr val="E0E4EC"/>
-                      </a:solidFill>
-                      <a:prstDash val="solid"/>
-                      <a:round/>
-                      <a:headEnd type="none" w="med" len="med"/>
-                      <a:tailEnd type="none" w="med" len="med"/>
-                    </a:lnB>
-                    <a:solidFill>
-                      <a:srgbClr val="EEF2FF"/>
-                    </a:solidFill>
-                  </a:tcPr>
-                </a:tc>
-                <a:tc>
-                  <a:txBody>
-                    <a:bodyPr/>
-                    <a:lstStyle/>
-                    <a:p>
-                      <a:pPr algn="ctr" indent="0" marL="0">
-                        <a:buNone/>
-                      </a:pPr>
-                      <a:r>
-                        <a:rPr lang="en-US" sz="1200" b="1" dirty="0">
-                          <a:solidFill>
-                            <a:srgbClr val="2563EB"/>
-                          </a:solidFill>
-                        </a:rPr>
-                        <a:t>OpenHarmony (hook_client.cpp)</a:t>
-                      </a:r>
-                      <a:endParaRPr lang="en-US" sz="1200" dirty="0"/>
-                    </a:p>
-                  </a:txBody>
-                  <a:tcPr marL="76200" marR="76200" marT="25400" marB="25400">
-                    <a:lnL w="6350" cap="flat" cmpd="sng" algn="ctr">
-                      <a:solidFill>
-                        <a:srgbClr val="E0E4EC"/>
-                      </a:solidFill>
-                      <a:prstDash val="solid"/>
-                      <a:round/>
-                      <a:headEnd type="none" w="med" len="med"/>
-                      <a:tailEnd type="none" w="med" len="med"/>
-                    </a:lnL>
-                    <a:lnR w="6350" cap="flat" cmpd="sng" algn="ctr">
-                      <a:solidFill>
-                        <a:srgbClr val="E0E4EC"/>
-                      </a:solidFill>
-                      <a:prstDash val="solid"/>
-                      <a:round/>
-                      <a:headEnd type="none" w="med" len="med"/>
-                      <a:tailEnd type="none" w="med" len="med"/>
-                    </a:lnR>
-                    <a:lnT w="6350" cap="flat" cmpd="sng" algn="ctr">
-                      <a:solidFill>
-                        <a:srgbClr val="E0E4EC"/>
-                      </a:solidFill>
-                      <a:prstDash val="solid"/>
-                      <a:round/>
-                      <a:headEnd type="none" w="med" len="med"/>
-                      <a:tailEnd type="none" w="med" len="med"/>
-                    </a:lnT>
-                    <a:lnB w="6350" cap="flat" cmpd="sng" algn="ctr">
-                      <a:solidFill>
-                        <a:srgbClr val="E0E4EC"/>
-                      </a:solidFill>
-                      <a:prstDash val="solid"/>
-                      <a:round/>
-                      <a:headEnd type="none" w="med" len="med"/>
-                      <a:tailEnd type="none" w="med" len="med"/>
-                    </a:lnB>
-                    <a:solidFill>
-                      <a:srgbClr val="EEF2FF"/>
-                    </a:solidFill>
-                  </a:tcPr>
-                </a:tc>
-              </a:tr>
-              <a:tr h="384048">
-                <a:tc>
-                  <a:txBody>
-                    <a:bodyPr/>
-                    <a:lstStyle/>
-                    <a:p>
-                      <a:pPr algn="l" indent="0" marL="0">
-                        <a:buNone/>
-                      </a:pPr>
-                      <a:r>
-                        <a:rPr lang="en-US" sz="1200" dirty="0">
-                          <a:solidFill>
-                            <a:srgbClr val="4A4A6A"/>
-                          </a:solidFill>
-                        </a:rPr>
-                        <a:t>malloc / filter / sample</a:t>
-                      </a:r>
-                      <a:endParaRPr lang="en-US" sz="1200" dirty="0"/>
-                    </a:p>
-                  </a:txBody>
-                  <a:tcPr marL="76200" marR="76200" marT="25400" marB="25400">
-                    <a:lnL w="6350" cap="flat" cmpd="sng" algn="ctr">
-                      <a:solidFill>
-                        <a:srgbClr val="E0E4EC"/>
-                      </a:solidFill>
-                      <a:prstDash val="solid"/>
-                      <a:round/>
-                      <a:headEnd type="none" w="med" len="med"/>
-                      <a:tailEnd type="none" w="med" len="med"/>
-                    </a:lnL>
-                    <a:lnR w="6350" cap="flat" cmpd="sng" algn="ctr">
-                      <a:solidFill>
-                        <a:srgbClr val="E0E4EC"/>
-                      </a:solidFill>
-                      <a:prstDash val="solid"/>
-                      <a:round/>
-                      <a:headEnd type="none" w="med" len="med"/>
-                      <a:tailEnd type="none" w="med" len="med"/>
-                    </a:lnR>
-                    <a:lnT w="6350" cap="flat" cmpd="sng" algn="ctr">
-                      <a:solidFill>
-                        <a:srgbClr val="E0E4EC"/>
-                      </a:solidFill>
-                      <a:prstDash val="solid"/>
-                      <a:round/>
-                      <a:headEnd type="none" w="med" len="med"/>
-                      <a:tailEnd type="none" w="med" len="med"/>
-                    </a:lnT>
-                    <a:lnB w="6350" cap="flat" cmpd="sng" algn="ctr">
-                      <a:solidFill>
-                        <a:srgbClr val="E0E4EC"/>
+                        <a:srgbClr val="059669"/>
                       </a:solidFill>
                       <a:prstDash val="solid"/>
                       <a:round/>
@@ -18549,20 +18427,20 @@
                         <a:buNone/>
                       </a:pPr>
                       <a:r>
-                        <a:rPr lang="en-US" sz="1200" dirty="0">
+                        <a:rPr lang="en-US" sz="900" b="1" dirty="0">
                           <a:solidFill>
-                            <a:srgbClr val="4A4A6A"/>
+                            <a:srgbClr val="059669"/>
                           </a:solidFill>
                         </a:rPr>
-                        <a:t>hook_writer</a:t>
+                        <a:t>原型 (Plan B)</a:t>
                       </a:r>
-                      <a:endParaRPr lang="en-US" sz="1200" dirty="0"/>
+                      <a:endParaRPr lang="en-US" sz="900" dirty="0"/>
                     </a:p>
                   </a:txBody>
-                  <a:tcPr marL="76200" marR="76200" marT="25400" marB="25400">
+                  <a:tcPr marL="50800" marR="50800" marT="25400" marB="25400">
                     <a:lnL w="6350" cap="flat" cmpd="sng" algn="ctr">
                       <a:solidFill>
-                        <a:srgbClr val="E0E4EC"/>
+                        <a:srgbClr val="059669"/>
                       </a:solidFill>
                       <a:prstDash val="solid"/>
                       <a:round/>
@@ -18571,7 +18449,7 @@
                     </a:lnL>
                     <a:lnR w="6350" cap="flat" cmpd="sng" algn="ctr">
                       <a:solidFill>
-                        <a:srgbClr val="E0E4EC"/>
+                        <a:srgbClr val="059669"/>
                       </a:solidFill>
                       <a:prstDash val="solid"/>
                       <a:round/>
@@ -18580,7 +18458,7 @@
                     </a:lnR>
                     <a:lnT w="6350" cap="flat" cmpd="sng" algn="ctr">
                       <a:solidFill>
-                        <a:srgbClr val="E0E4EC"/>
+                        <a:srgbClr val="059669"/>
                       </a:solidFill>
                       <a:prstDash val="solid"/>
                       <a:round/>
@@ -18589,7 +18467,7 @@
                     </a:lnT>
                     <a:lnB w="6350" cap="flat" cmpd="sng" algn="ctr">
                       <a:solidFill>
-                        <a:srgbClr val="E0E4EC"/>
+                        <a:srgbClr val="059669"/>
                       </a:solidFill>
                       <a:prstDash val="solid"/>
                       <a:round/>
@@ -18610,20 +18488,20 @@
                         <a:buNone/>
                       </a:pPr>
                       <a:r>
-                        <a:rPr lang="en-US" sz="1200" dirty="0">
+                        <a:rPr lang="en-US" sz="900" b="1" dirty="0">
                           <a:solidFill>
                             <a:srgbClr val="059669"/>
                           </a:solidFill>
                         </a:rPr>
-                        <a:t>hook_malloc</a:t>
+                        <a:t>真实代码</a:t>
                       </a:r>
-                      <a:endParaRPr lang="en-US" sz="1200" dirty="0"/>
+                      <a:endParaRPr lang="en-US" sz="900" dirty="0"/>
                     </a:p>
                   </a:txBody>
-                  <a:tcPr marL="76200" marR="76200" marT="25400" marB="25400">
+                  <a:tcPr marL="50800" marR="50800" marT="25400" marB="25400">
                     <a:lnL w="6350" cap="flat" cmpd="sng" algn="ctr">
                       <a:solidFill>
-                        <a:srgbClr val="E0E4EC"/>
+                        <a:srgbClr val="059669"/>
                       </a:solidFill>
                       <a:prstDash val="solid"/>
                       <a:round/>
@@ -18632,7 +18510,7 @@
                     </a:lnL>
                     <a:lnR w="6350" cap="flat" cmpd="sng" algn="ctr">
                       <a:solidFill>
-                        <a:srgbClr val="E0E4EC"/>
+                        <a:srgbClr val="059669"/>
                       </a:solidFill>
                       <a:prstDash val="solid"/>
                       <a:round/>
@@ -18641,7 +18519,7 @@
                     </a:lnR>
                     <a:lnT w="6350" cap="flat" cmpd="sng" algn="ctr">
                       <a:solidFill>
-                        <a:srgbClr val="E0E4EC"/>
+                        <a:srgbClr val="059669"/>
                       </a:solidFill>
                       <a:prstDash val="solid"/>
                       <a:round/>
@@ -18650,7 +18528,7 @@
                     </a:lnT>
                     <a:lnB w="6350" cap="flat" cmpd="sng" algn="ctr">
                       <a:solidFill>
-                        <a:srgbClr val="E0E4EC"/>
+                        <a:srgbClr val="059669"/>
                       </a:solidFill>
                       <a:prstDash val="solid"/>
                       <a:round/>
@@ -18663,30 +18541,30 @@
                   </a:tcPr>
                 </a:tc>
               </a:tr>
-              <a:tr h="384048">
+              <a:tr h="457200">
                 <a:tc>
                   <a:txBody>
                     <a:bodyPr/>
                     <a:lstStyle/>
                     <a:p>
-                      <a:pPr algn="l" indent="0" marL="0">
+                      <a:pPr algn="ctr" indent="0" marL="0">
                         <a:buNone/>
                       </a:pPr>
                       <a:r>
-                        <a:rPr lang="en-US" sz="1200" dirty="0">
+                        <a:rPr lang="en-US" sz="900" dirty="0">
                           <a:solidFill>
-                            <a:srgbClr val="4A4A6A"/>
+                            <a:srgbClr val="1A1A2E"/>
                           </a:solidFill>
                         </a:rPr>
-                        <a:t>re-entry guard</a:t>
+                        <a:t>malloc入口</a:t>
                       </a:r>
-                      <a:endParaRPr lang="en-US" sz="1200" dirty="0"/>
+                      <a:endParaRPr lang="en-US" sz="900" dirty="0"/>
                     </a:p>
                   </a:txBody>
-                  <a:tcPr marL="76200" marR="76200" marT="25400" marB="25400">
+                  <a:tcPr marL="50800" marR="50800" marT="25400" marB="25400">
                     <a:lnL w="6350" cap="flat" cmpd="sng" algn="ctr">
                       <a:solidFill>
-                        <a:srgbClr val="E0E4EC"/>
+                        <a:srgbClr val="059669"/>
                       </a:solidFill>
                       <a:prstDash val="solid"/>
                       <a:round/>
@@ -18695,7 +18573,7 @@
                     </a:lnL>
                     <a:lnR w="6350" cap="flat" cmpd="sng" algn="ctr">
                       <a:solidFill>
-                        <a:srgbClr val="E0E4EC"/>
+                        <a:srgbClr val="059669"/>
                       </a:solidFill>
                       <a:prstDash val="solid"/>
                       <a:round/>
@@ -18704,7 +18582,7 @@
                     </a:lnR>
                     <a:lnT w="6350" cap="flat" cmpd="sng" algn="ctr">
                       <a:solidFill>
-                        <a:srgbClr val="E0E4EC"/>
+                        <a:srgbClr val="059669"/>
                       </a:solidFill>
                       <a:prstDash val="solid"/>
                       <a:round/>
@@ -18713,7 +18591,7 @@
                     </a:lnT>
                     <a:lnB w="6350" cap="flat" cmpd="sng" algn="ctr">
                       <a:solidFill>
-                        <a:srgbClr val="E0E4EC"/>
+                        <a:srgbClr val="059669"/>
                       </a:solidFill>
                       <a:prstDash val="solid"/>
                       <a:round/>
@@ -18721,7 +18599,7 @@
                       <a:tailEnd type="none" w="med" len="med"/>
                     </a:lnB>
                     <a:solidFill>
-                      <a:srgbClr val="F4F6FB"/>
+                      <a:srgbClr val="ECFDF5"/>
                     </a:solidFill>
                   </a:tcPr>
                 </a:tc>
@@ -18734,20 +18612,20 @@
                         <a:buNone/>
                       </a:pPr>
                       <a:r>
-                        <a:rPr lang="en-US" sz="1200" dirty="0">
+                        <a:rPr lang="en-US" sz="900" dirty="0">
                           <a:solidFill>
-                            <a:srgbClr val="4A4A6A"/>
+                            <a:srgbClr val="1A1A2E"/>
                           </a:solidFill>
                         </a:rPr>
-                        <a:t>HookReentryGuard</a:t>
+                        <a:t>hook_writer</a:t>
                       </a:r>
-                      <a:endParaRPr lang="en-US" sz="1200" dirty="0"/>
+                      <a:endParaRPr lang="en-US" sz="900" dirty="0"/>
                     </a:p>
                   </a:txBody>
-                  <a:tcPr marL="76200" marR="76200" marT="25400" marB="25400">
+                  <a:tcPr marL="50800" marR="50800" marT="25400" marB="25400">
                     <a:lnL w="6350" cap="flat" cmpd="sng" algn="ctr">
                       <a:solidFill>
-                        <a:srgbClr val="E0E4EC"/>
+                        <a:srgbClr val="059669"/>
                       </a:solidFill>
                       <a:prstDash val="solid"/>
                       <a:round/>
@@ -18756,7 +18634,7 @@
                     </a:lnL>
                     <a:lnR w="6350" cap="flat" cmpd="sng" algn="ctr">
                       <a:solidFill>
-                        <a:srgbClr val="E0E4EC"/>
+                        <a:srgbClr val="059669"/>
                       </a:solidFill>
                       <a:prstDash val="solid"/>
                       <a:round/>
@@ -18765,7 +18643,7 @@
                     </a:lnR>
                     <a:lnT w="6350" cap="flat" cmpd="sng" algn="ctr">
                       <a:solidFill>
-                        <a:srgbClr val="E0E4EC"/>
+                        <a:srgbClr val="059669"/>
                       </a:solidFill>
                       <a:prstDash val="solid"/>
                       <a:round/>
@@ -18774,7 +18652,7 @@
                     </a:lnT>
                     <a:lnB w="6350" cap="flat" cmpd="sng" algn="ctr">
                       <a:solidFill>
-                        <a:srgbClr val="E0E4EC"/>
+                        <a:srgbClr val="059669"/>
                       </a:solidFill>
                       <a:prstDash val="solid"/>
                       <a:round/>
@@ -18782,7 +18660,7 @@
                       <a:tailEnd type="none" w="med" len="med"/>
                     </a:lnB>
                     <a:solidFill>
-                      <a:srgbClr val="F4F6FB"/>
+                      <a:srgbClr val="ECFDF5"/>
                     </a:solidFill>
                   </a:tcPr>
                 </a:tc>
@@ -18795,20 +18673,20 @@
                         <a:buNone/>
                       </a:pPr>
                       <a:r>
-                        <a:rPr lang="en-US" sz="1200" dirty="0">
+                        <a:rPr lang="en-US" sz="900" dirty="0">
                           <a:solidFill>
-                            <a:srgbClr val="059669"/>
+                            <a:srgbClr val="1A1A2E"/>
                           </a:solidFill>
                         </a:rPr>
-                        <a:t>__set_hook_flag</a:t>
+                        <a:t>hook_malloc</a:t>
                       </a:r>
-                      <a:endParaRPr lang="en-US" sz="1200" dirty="0"/>
+                      <a:endParaRPr lang="en-US" sz="900" dirty="0"/>
                     </a:p>
                   </a:txBody>
-                  <a:tcPr marL="76200" marR="76200" marT="25400" marB="25400">
+                  <a:tcPr marL="50800" marR="50800" marT="25400" marB="25400">
                     <a:lnL w="6350" cap="flat" cmpd="sng" algn="ctr">
                       <a:solidFill>
-                        <a:srgbClr val="E0E4EC"/>
+                        <a:srgbClr val="059669"/>
                       </a:solidFill>
                       <a:prstDash val="solid"/>
                       <a:round/>
@@ -18817,7 +18695,7 @@
                     </a:lnL>
                     <a:lnR w="6350" cap="flat" cmpd="sng" algn="ctr">
                       <a:solidFill>
-                        <a:srgbClr val="E0E4EC"/>
+                        <a:srgbClr val="059669"/>
                       </a:solidFill>
                       <a:prstDash val="solid"/>
                       <a:round/>
@@ -18826,7 +18704,7 @@
                     </a:lnR>
                     <a:lnT w="6350" cap="flat" cmpd="sng" algn="ctr">
                       <a:solidFill>
-                        <a:srgbClr val="E0E4EC"/>
+                        <a:srgbClr val="059669"/>
                       </a:solidFill>
                       <a:prstDash val="solid"/>
                       <a:round/>
@@ -18835,7 +18713,7 @@
                     </a:lnT>
                     <a:lnB w="6350" cap="flat" cmpd="sng" algn="ctr">
                       <a:solidFill>
-                        <a:srgbClr val="E0E4EC"/>
+                        <a:srgbClr val="059669"/>
                       </a:solidFill>
                       <a:prstDash val="solid"/>
                       <a:round/>
@@ -18843,35 +18721,35 @@
                       <a:tailEnd type="none" w="med" len="med"/>
                     </a:lnB>
                     <a:solidFill>
-                      <a:srgbClr val="F4F6FB"/>
+                      <a:srgbClr val="ECFDF5"/>
                     </a:solidFill>
                   </a:tcPr>
                 </a:tc>
               </a:tr>
-              <a:tr h="384048">
+              <a:tr h="457200">
                 <a:tc>
                   <a:txBody>
                     <a:bodyPr/>
                     <a:lstStyle/>
                     <a:p>
-                      <a:pPr algn="l" indent="0" marL="0">
+                      <a:pPr algn="ctr" indent="0" marL="0">
                         <a:buNone/>
                       </a:pPr>
                       <a:r>
-                        <a:rPr lang="en-US" sz="1200" dirty="0">
+                        <a:rPr lang="en-US" sz="900" dirty="0">
                           <a:solidFill>
-                            <a:srgbClr val="4A4A6A"/>
+                            <a:srgbClr val="1A1A2E"/>
                           </a:solidFill>
                         </a:rPr>
-                        <a:t>StackRawData fill</a:t>
+                        <a:t>重入保护</a:t>
                       </a:r>
-                      <a:endParaRPr lang="en-US" sz="1200" dirty="0"/>
+                      <a:endParaRPr lang="en-US" sz="900" dirty="0"/>
                     </a:p>
                   </a:txBody>
-                  <a:tcPr marL="76200" marR="76200" marT="25400" marB="25400">
+                  <a:tcPr marL="50800" marR="50800" marT="25400" marB="25400">
                     <a:lnL w="6350" cap="flat" cmpd="sng" algn="ctr">
                       <a:solidFill>
-                        <a:srgbClr val="E0E4EC"/>
+                        <a:srgbClr val="059669"/>
                       </a:solidFill>
                       <a:prstDash val="solid"/>
                       <a:round/>
@@ -18880,7 +18758,7 @@
                     </a:lnL>
                     <a:lnR w="6350" cap="flat" cmpd="sng" algn="ctr">
                       <a:solidFill>
-                        <a:srgbClr val="E0E4EC"/>
+                        <a:srgbClr val="059669"/>
                       </a:solidFill>
                       <a:prstDash val="solid"/>
                       <a:round/>
@@ -18889,7 +18767,7 @@
                     </a:lnR>
                     <a:lnT w="6350" cap="flat" cmpd="sng" algn="ctr">
                       <a:solidFill>
-                        <a:srgbClr val="E0E4EC"/>
+                        <a:srgbClr val="059669"/>
                       </a:solidFill>
                       <a:prstDash val="solid"/>
                       <a:round/>
@@ -18898,7 +18776,7 @@
                     </a:lnT>
                     <a:lnB w="6350" cap="flat" cmpd="sng" algn="ctr">
                       <a:solidFill>
-                        <a:srgbClr val="E0E4EC"/>
+                        <a:srgbClr val="059669"/>
                       </a:solidFill>
                       <a:prstDash val="solid"/>
                       <a:round/>
@@ -18919,20 +18797,20 @@
                         <a:buNone/>
                       </a:pPr>
                       <a:r>
-                        <a:rPr lang="en-US" sz="1200" dirty="0">
+                        <a:rPr lang="en-US" sz="900" dirty="0">
                           <a:solidFill>
-                            <a:srgbClr val="4A4A6A"/>
+                            <a:srgbClr val="1A1A2E"/>
                           </a:solidFill>
                         </a:rPr>
-                        <a:t>simplified</a:t>
+                        <a:t>HookReentryGuard</a:t>
                       </a:r>
-                      <a:endParaRPr lang="en-US" sz="1200" dirty="0"/>
+                      <a:endParaRPr lang="en-US" sz="900" dirty="0"/>
                     </a:p>
                   </a:txBody>
-                  <a:tcPr marL="76200" marR="76200" marT="25400" marB="25400">
+                  <a:tcPr marL="50800" marR="50800" marT="25400" marB="25400">
                     <a:lnL w="6350" cap="flat" cmpd="sng" algn="ctr">
                       <a:solidFill>
-                        <a:srgbClr val="E0E4EC"/>
+                        <a:srgbClr val="059669"/>
                       </a:solidFill>
                       <a:prstDash val="solid"/>
                       <a:round/>
@@ -18941,7 +18819,7 @@
                     </a:lnL>
                     <a:lnR w="6350" cap="flat" cmpd="sng" algn="ctr">
                       <a:solidFill>
-                        <a:srgbClr val="E0E4EC"/>
+                        <a:srgbClr val="059669"/>
                       </a:solidFill>
                       <a:prstDash val="solid"/>
                       <a:round/>
@@ -18950,7 +18828,7 @@
                     </a:lnR>
                     <a:lnT w="6350" cap="flat" cmpd="sng" algn="ctr">
                       <a:solidFill>
-                        <a:srgbClr val="E0E4EC"/>
+                        <a:srgbClr val="059669"/>
                       </a:solidFill>
                       <a:prstDash val="solid"/>
                       <a:round/>
@@ -18959,7 +18837,7 @@
                     </a:lnT>
                     <a:lnB w="6350" cap="flat" cmpd="sng" algn="ctr">
                       <a:solidFill>
-                        <a:srgbClr val="E0E4EC"/>
+                        <a:srgbClr val="059669"/>
                       </a:solidFill>
                       <a:prstDash val="solid"/>
                       <a:round/>
@@ -18980,20 +18858,20 @@
                         <a:buNone/>
                       </a:pPr>
                       <a:r>
-                        <a:rPr lang="en-US" sz="1200" dirty="0">
+                        <a:rPr lang="en-US" sz="900" dirty="0">
                           <a:solidFill>
-                            <a:srgbClr val="059669"/>
+                            <a:srgbClr val="1A1A2E"/>
                           </a:solidFill>
                         </a:rPr>
-                        <a:t>rawdata.{pid, tid, size, addr, ts}</a:t>
+                        <a:t>__set_hook_flag</a:t>
                       </a:r>
-                      <a:endParaRPr lang="en-US" sz="1200" dirty="0"/>
+                      <a:endParaRPr lang="en-US" sz="900" dirty="0"/>
                     </a:p>
                   </a:txBody>
-                  <a:tcPr marL="76200" marR="76200" marT="25400" marB="25400">
+                  <a:tcPr marL="50800" marR="50800" marT="25400" marB="25400">
                     <a:lnL w="6350" cap="flat" cmpd="sng" algn="ctr">
                       <a:solidFill>
-                        <a:srgbClr val="E0E4EC"/>
+                        <a:srgbClr val="059669"/>
                       </a:solidFill>
                       <a:prstDash val="solid"/>
                       <a:round/>
@@ -19002,7 +18880,7 @@
                     </a:lnL>
                     <a:lnR w="6350" cap="flat" cmpd="sng" algn="ctr">
                       <a:solidFill>
-                        <a:srgbClr val="E0E4EC"/>
+                        <a:srgbClr val="059669"/>
                       </a:solidFill>
                       <a:prstDash val="solid"/>
                       <a:round/>
@@ -19011,7 +18889,7 @@
                     </a:lnR>
                     <a:lnT w="6350" cap="flat" cmpd="sng" algn="ctr">
                       <a:solidFill>
-                        <a:srgbClr val="E0E4EC"/>
+                        <a:srgbClr val="059669"/>
                       </a:solidFill>
                       <a:prstDash val="solid"/>
                       <a:round/>
@@ -19020,7 +18898,7 @@
                     </a:lnT>
                     <a:lnB w="6350" cap="flat" cmpd="sng" algn="ctr">
                       <a:solidFill>
-                        <a:srgbClr val="E0E4EC"/>
+                        <a:srgbClr val="059669"/>
                       </a:solidFill>
                       <a:prstDash val="solid"/>
                       <a:round/>
@@ -19033,30 +18911,30 @@
                   </a:tcPr>
                 </a:tc>
               </a:tr>
-              <a:tr h="384048">
+              <a:tr h="457200">
                 <a:tc>
                   <a:txBody>
                     <a:bodyPr/>
                     <a:lstStyle/>
                     <a:p>
-                      <a:pPr algn="l" indent="0" marL="0">
+                      <a:pPr algn="ctr" indent="0" marL="0">
                         <a:buNone/>
                       </a:pPr>
                       <a:r>
-                        <a:rPr lang="en-US" sz="1200" dirty="0">
+                        <a:rPr lang="en-US" sz="900" dirty="0">
                           <a:solidFill>
-                            <a:srgbClr val="4A4A6A"/>
+                            <a:srgbClr val="1A1A2E"/>
                           </a:solidFill>
                         </a:rPr>
-                        <a:t>AddressHandler</a:t>
+                        <a:t>地址追踪</a:t>
                       </a:r>
-                      <a:endParaRPr lang="en-US" sz="1200" dirty="0"/>
+                      <a:endParaRPr lang="en-US" sz="900" dirty="0"/>
                     </a:p>
                   </a:txBody>
-                  <a:tcPr marL="76200" marR="76200" marT="25400" marB="25400">
+                  <a:tcPr marL="50800" marR="50800" marT="25400" marB="25400">
                     <a:lnL w="6350" cap="flat" cmpd="sng" algn="ctr">
                       <a:solidFill>
-                        <a:srgbClr val="E0E4EC"/>
+                        <a:srgbClr val="059669"/>
                       </a:solidFill>
                       <a:prstDash val="solid"/>
                       <a:round/>
@@ -19065,7 +18943,7 @@
                     </a:lnL>
                     <a:lnR w="6350" cap="flat" cmpd="sng" algn="ctr">
                       <a:solidFill>
-                        <a:srgbClr val="E0E4EC"/>
+                        <a:srgbClr val="059669"/>
                       </a:solidFill>
                       <a:prstDash val="solid"/>
                       <a:round/>
@@ -19074,7 +18952,7 @@
                     </a:lnR>
                     <a:lnT w="6350" cap="flat" cmpd="sng" algn="ctr">
                       <a:solidFill>
-                        <a:srgbClr val="E0E4EC"/>
+                        <a:srgbClr val="059669"/>
                       </a:solidFill>
                       <a:prstDash val="solid"/>
                       <a:round/>
@@ -19083,7 +18961,7 @@
                     </a:lnT>
                     <a:lnB w="6350" cap="flat" cmpd="sng" algn="ctr">
                       <a:solidFill>
-                        <a:srgbClr val="E0E4EC"/>
+                        <a:srgbClr val="059669"/>
                       </a:solidFill>
                       <a:prstDash val="solid"/>
                       <a:round/>
@@ -19091,7 +18969,7 @@
                       <a:tailEnd type="none" w="med" len="med"/>
                     </a:lnB>
                     <a:solidFill>
-                      <a:srgbClr val="F4F6FB"/>
+                      <a:srgbClr val="ECFDF5"/>
                     </a:solidFill>
                   </a:tcPr>
                 </a:tc>
@@ -19104,20 +18982,20 @@
                         <a:buNone/>
                       </a:pPr>
                       <a:r>
-                        <a:rPr lang="en-US" sz="1200" dirty="0">
+                        <a:rPr lang="en-US" sz="900" dirty="0">
                           <a:solidFill>
-                            <a:srgbClr val="4A4A6A"/>
+                            <a:srgbClr val="1A1A2E"/>
                           </a:solidFill>
                         </a:rPr>
-                        <a:t>address_handler.h  [NEW]</a:t>
+                        <a:t>address_handler.h</a:t>
                       </a:r>
-                      <a:endParaRPr lang="en-US" sz="1200" dirty="0"/>
+                      <a:endParaRPr lang="en-US" sz="900" dirty="0"/>
                     </a:p>
                   </a:txBody>
-                  <a:tcPr marL="76200" marR="76200" marT="25400" marB="25400">
+                  <a:tcPr marL="50800" marR="50800" marT="25400" marB="25400">
                     <a:lnL w="6350" cap="flat" cmpd="sng" algn="ctr">
                       <a:solidFill>
-                        <a:srgbClr val="E0E4EC"/>
+                        <a:srgbClr val="059669"/>
                       </a:solidFill>
                       <a:prstDash val="solid"/>
                       <a:round/>
@@ -19126,7 +19004,7 @@
                     </a:lnL>
                     <a:lnR w="6350" cap="flat" cmpd="sng" algn="ctr">
                       <a:solidFill>
-                        <a:srgbClr val="E0E4EC"/>
+                        <a:srgbClr val="059669"/>
                       </a:solidFill>
                       <a:prstDash val="solid"/>
                       <a:round/>
@@ -19135,7 +19013,7 @@
                     </a:lnR>
                     <a:lnT w="6350" cap="flat" cmpd="sng" algn="ctr">
                       <a:solidFill>
-                        <a:srgbClr val="E0E4EC"/>
+                        <a:srgbClr val="059669"/>
                       </a:solidFill>
                       <a:prstDash val="solid"/>
                       <a:round/>
@@ -19144,7 +19022,7 @@
                     </a:lnT>
                     <a:lnB w="6350" cap="flat" cmpd="sng" algn="ctr">
                       <a:solidFill>
-                        <a:srgbClr val="E0E4EC"/>
+                        <a:srgbClr val="059669"/>
                       </a:solidFill>
                       <a:prstDash val="solid"/>
                       <a:round/>
@@ -19152,7 +19030,7 @@
                       <a:tailEnd type="none" w="med" len="med"/>
                     </a:lnB>
                     <a:solidFill>
-                      <a:srgbClr val="F4F6FB"/>
+                      <a:srgbClr val="ECFDF5"/>
                     </a:solidFill>
                   </a:tcPr>
                 </a:tc>
@@ -19165,20 +19043,20 @@
                         <a:buNone/>
                       </a:pPr>
                       <a:r>
-                        <a:rPr lang="en-US" sz="1200" dirty="0">
+                        <a:rPr lang="en-US" sz="900" dirty="0">
                           <a:solidFill>
-                            <a:srgbClr val="059669"/>
+                            <a:srgbClr val="1A1A2E"/>
                           </a:solidFill>
                         </a:rPr>
                         <a:t>AddAllocAddr()</a:t>
                       </a:r>
-                      <a:endParaRPr lang="en-US" sz="1200" dirty="0"/>
+                      <a:endParaRPr lang="en-US" sz="900" dirty="0"/>
                     </a:p>
                   </a:txBody>
-                  <a:tcPr marL="76200" marR="76200" marT="25400" marB="25400">
+                  <a:tcPr marL="50800" marR="50800" marT="25400" marB="25400">
                     <a:lnL w="6350" cap="flat" cmpd="sng" algn="ctr">
                       <a:solidFill>
-                        <a:srgbClr val="E0E4EC"/>
+                        <a:srgbClr val="059669"/>
                       </a:solidFill>
                       <a:prstDash val="solid"/>
                       <a:round/>
@@ -19187,7 +19065,7 @@
                     </a:lnL>
                     <a:lnR w="6350" cap="flat" cmpd="sng" algn="ctr">
                       <a:solidFill>
-                        <a:srgbClr val="E0E4EC"/>
+                        <a:srgbClr val="059669"/>
                       </a:solidFill>
                       <a:prstDash val="solid"/>
                       <a:round/>
@@ -19196,7 +19074,7 @@
                     </a:lnR>
                     <a:lnT w="6350" cap="flat" cmpd="sng" algn="ctr">
                       <a:solidFill>
-                        <a:srgbClr val="E0E4EC"/>
+                        <a:srgbClr val="059669"/>
                       </a:solidFill>
                       <a:prstDash val="solid"/>
                       <a:round/>
@@ -19205,7 +19083,7 @@
                     </a:lnT>
                     <a:lnB w="6350" cap="flat" cmpd="sng" algn="ctr">
                       <a:solidFill>
-                        <a:srgbClr val="E0E4EC"/>
+                        <a:srgbClr val="059669"/>
                       </a:solidFill>
                       <a:prstDash val="solid"/>
                       <a:round/>
@@ -19213,35 +19091,35 @@
                       <a:tailEnd type="none" w="med" len="med"/>
                     </a:lnB>
                     <a:solidFill>
-                      <a:srgbClr val="F4F6FB"/>
+                      <a:srgbClr val="ECFDF5"/>
                     </a:solidFill>
                   </a:tcPr>
                 </a:tc>
               </a:tr>
-              <a:tr h="384048">
+              <a:tr h="457200">
                 <a:tc>
                   <a:txBody>
                     <a:bodyPr/>
                     <a:lstStyle/>
                     <a:p>
-                      <a:pPr algn="l" indent="0" marL="0">
+                      <a:pPr algn="ctr" indent="0" marL="0">
                         <a:buNone/>
                       </a:pPr>
                       <a:r>
-                        <a:rPr lang="en-US" sz="1200" dirty="0">
+                        <a:rPr lang="en-US" sz="900" dirty="0">
                           <a:solidFill>
-                            <a:srgbClr val="4A4A6A"/>
+                            <a:srgbClr val="1A1A2E"/>
                           </a:solidFill>
                         </a:rPr>
-                        <a:t>StackWriter write</a:t>
+                        <a:t>写共享内存</a:t>
                       </a:r>
-                      <a:endParaRPr lang="en-US" sz="1200" dirty="0"/>
+                      <a:endParaRPr lang="en-US" sz="900" dirty="0"/>
                     </a:p>
                   </a:txBody>
-                  <a:tcPr marL="76200" marR="76200" marT="25400" marB="25400">
+                  <a:tcPr marL="50800" marR="50800" marT="25400" marB="25400">
                     <a:lnL w="6350" cap="flat" cmpd="sng" algn="ctr">
                       <a:solidFill>
-                        <a:srgbClr val="E0E4EC"/>
+                        <a:srgbClr val="059669"/>
                       </a:solidFill>
                       <a:prstDash val="solid"/>
                       <a:round/>
@@ -19250,7 +19128,7 @@
                     </a:lnL>
                     <a:lnR w="6350" cap="flat" cmpd="sng" algn="ctr">
                       <a:solidFill>
-                        <a:srgbClr val="E0E4EC"/>
+                        <a:srgbClr val="059669"/>
                       </a:solidFill>
                       <a:prstDash val="solid"/>
                       <a:round/>
@@ -19259,7 +19137,7 @@
                     </a:lnR>
                     <a:lnT w="6350" cap="flat" cmpd="sng" algn="ctr">
                       <a:solidFill>
-                        <a:srgbClr val="E0E4EC"/>
+                        <a:srgbClr val="059669"/>
                       </a:solidFill>
                       <a:prstDash val="solid"/>
                       <a:round/>
@@ -19268,7 +19146,7 @@
                     </a:lnT>
                     <a:lnB w="6350" cap="flat" cmpd="sng" algn="ctr">
                       <a:solidFill>
-                        <a:srgbClr val="E0E4EC"/>
+                        <a:srgbClr val="059669"/>
                       </a:solidFill>
                       <a:prstDash val="solid"/>
                       <a:round/>
@@ -19289,20 +19167,20 @@
                         <a:buNone/>
                       </a:pPr>
                       <a:r>
-                        <a:rPr lang="en-US" sz="1200" dirty="0">
+                        <a:rPr lang="en-US" sz="900" dirty="0">
                           <a:solidFill>
-                            <a:srgbClr val="4A4A6A"/>
+                            <a:srgbClr val="1A1A2E"/>
                           </a:solidFill>
                         </a:rPr>
-                        <a:t>stack_writer.cpp  [NEW]</a:t>
+                        <a:t>stack_writer.cpp</a:t>
                       </a:r>
-                      <a:endParaRPr lang="en-US" sz="1200" dirty="0"/>
+                      <a:endParaRPr lang="en-US" sz="900" dirty="0"/>
                     </a:p>
                   </a:txBody>
-                  <a:tcPr marL="76200" marR="76200" marT="25400" marB="25400">
+                  <a:tcPr marL="50800" marR="50800" marT="25400" marB="25400">
                     <a:lnL w="6350" cap="flat" cmpd="sng" algn="ctr">
                       <a:solidFill>
-                        <a:srgbClr val="E0E4EC"/>
+                        <a:srgbClr val="059669"/>
                       </a:solidFill>
                       <a:prstDash val="solid"/>
                       <a:round/>
@@ -19311,7 +19189,7 @@
                     </a:lnL>
                     <a:lnR w="6350" cap="flat" cmpd="sng" algn="ctr">
                       <a:solidFill>
-                        <a:srgbClr val="E0E4EC"/>
+                        <a:srgbClr val="059669"/>
                       </a:solidFill>
                       <a:prstDash val="solid"/>
                       <a:round/>
@@ -19320,7 +19198,7 @@
                     </a:lnR>
                     <a:lnT w="6350" cap="flat" cmpd="sng" algn="ctr">
                       <a:solidFill>
-                        <a:srgbClr val="E0E4EC"/>
+                        <a:srgbClr val="059669"/>
                       </a:solidFill>
                       <a:prstDash val="solid"/>
                       <a:round/>
@@ -19329,7 +19207,7 @@
                     </a:lnT>
                     <a:lnB w="6350" cap="flat" cmpd="sng" algn="ctr">
                       <a:solidFill>
-                        <a:srgbClr val="E0E4EC"/>
+                        <a:srgbClr val="059669"/>
                       </a:solidFill>
                       <a:prstDash val="solid"/>
                       <a:round/>
@@ -19350,20 +19228,20 @@
                         <a:buNone/>
                       </a:pPr>
                       <a:r>
-                        <a:rPr lang="en-US" sz="1200" dirty="0">
+                        <a:rPr lang="en-US" sz="900" dirty="0">
                           <a:solidFill>
-                            <a:srgbClr val="059669"/>
+                            <a:srgbClr val="1A1A2E"/>
                           </a:solidFill>
                         </a:rPr>
                         <a:t>WriteWithPayloadTimeout</a:t>
                       </a:r>
-                      <a:endParaRPr lang="en-US" sz="1200" dirty="0"/>
+                      <a:endParaRPr lang="en-US" sz="900" dirty="0"/>
                     </a:p>
                   </a:txBody>
-                  <a:tcPr marL="76200" marR="76200" marT="25400" marB="25400">
+                  <a:tcPr marL="50800" marR="50800" marT="25400" marB="25400">
                     <a:lnL w="6350" cap="flat" cmpd="sng" algn="ctr">
                       <a:solidFill>
-                        <a:srgbClr val="E0E4EC"/>
+                        <a:srgbClr val="059669"/>
                       </a:solidFill>
                       <a:prstDash val="solid"/>
                       <a:round/>
@@ -19372,7 +19250,7 @@
                     </a:lnL>
                     <a:lnR w="6350" cap="flat" cmpd="sng" algn="ctr">
                       <a:solidFill>
-                        <a:srgbClr val="E0E4EC"/>
+                        <a:srgbClr val="059669"/>
                       </a:solidFill>
                       <a:prstDash val="solid"/>
                       <a:round/>
@@ -19381,7 +19259,7 @@
                     </a:lnR>
                     <a:lnT w="6350" cap="flat" cmpd="sng" algn="ctr">
                       <a:solidFill>
-                        <a:srgbClr val="E0E4EC"/>
+                        <a:srgbClr val="059669"/>
                       </a:solidFill>
                       <a:prstDash val="solid"/>
                       <a:round/>
@@ -19390,7 +19268,7 @@
                     </a:lnT>
                     <a:lnB w="6350" cap="flat" cmpd="sng" algn="ctr">
                       <a:solidFill>
-                        <a:srgbClr val="E0E4EC"/>
+                        <a:srgbClr val="059669"/>
                       </a:solidFill>
                       <a:prstDash val="solid"/>
                       <a:round/>
@@ -19403,30 +19281,30 @@
                   </a:tcPr>
                 </a:tc>
               </a:tr>
-              <a:tr h="384048">
+              <a:tr h="457200">
                 <a:tc>
                   <a:txBody>
                     <a:bodyPr/>
                     <a:lstStyle/>
                     <a:p>
-                      <a:pPr algn="l" indent="0" marL="0">
+                      <a:pPr algn="ctr" indent="0" marL="0">
                         <a:buNone/>
                       </a:pPr>
                       <a:r>
-                        <a:rPr lang="en-US" sz="1200" dirty="0">
+                        <a:rPr lang="en-US" sz="900" dirty="0">
                           <a:solidFill>
-                            <a:srgbClr val="4A4A6A"/>
+                            <a:srgbClr val="1A1A2E"/>
                           </a:solidFill>
                         </a:rPr>
-                        <a:t>StackWriter flush</a:t>
+                        <a:t>通知消费者</a:t>
                       </a:r>
-                      <a:endParaRPr lang="en-US" sz="1200" dirty="0"/>
+                      <a:endParaRPr lang="en-US" sz="900" dirty="0"/>
                     </a:p>
                   </a:txBody>
-                  <a:tcPr marL="76200" marR="76200" marT="25400" marB="25400">
+                  <a:tcPr marL="50800" marR="50800" marT="25400" marB="25400">
                     <a:lnL w="6350" cap="flat" cmpd="sng" algn="ctr">
                       <a:solidFill>
-                        <a:srgbClr val="E0E4EC"/>
+                        <a:srgbClr val="059669"/>
                       </a:solidFill>
                       <a:prstDash val="solid"/>
                       <a:round/>
@@ -19435,7 +19313,7 @@
                     </a:lnL>
                     <a:lnR w="6350" cap="flat" cmpd="sng" algn="ctr">
                       <a:solidFill>
-                        <a:srgbClr val="E0E4EC"/>
+                        <a:srgbClr val="059669"/>
                       </a:solidFill>
                       <a:prstDash val="solid"/>
                       <a:round/>
@@ -19444,7 +19322,7 @@
                     </a:lnR>
                     <a:lnT w="6350" cap="flat" cmpd="sng" algn="ctr">
                       <a:solidFill>
-                        <a:srgbClr val="E0E4EC"/>
+                        <a:srgbClr val="059669"/>
                       </a:solidFill>
                       <a:prstDash val="solid"/>
                       <a:round/>
@@ -19453,7 +19331,7 @@
                     </a:lnT>
                     <a:lnB w="6350" cap="flat" cmpd="sng" algn="ctr">
                       <a:solidFill>
-                        <a:srgbClr val="E0E4EC"/>
+                        <a:srgbClr val="059669"/>
                       </a:solidFill>
                       <a:prstDash val="solid"/>
                       <a:round/>
@@ -19461,7 +19339,7 @@
                       <a:tailEnd type="none" w="med" len="med"/>
                     </a:lnB>
                     <a:solidFill>
-                      <a:srgbClr val="F4F6FB"/>
+                      <a:srgbClr val="ECFDF5"/>
                     </a:solidFill>
                   </a:tcPr>
                 </a:tc>
@@ -19474,20 +19352,20 @@
                         <a:buNone/>
                       </a:pPr>
                       <a:r>
-                        <a:rPr lang="en-US" sz="1200" dirty="0">
+                        <a:rPr lang="en-US" sz="900" dirty="0">
                           <a:solidFill>
-                            <a:srgbClr val="4A4A6A"/>
+                            <a:srgbClr val="1A1A2E"/>
                           </a:solidFill>
                         </a:rPr>
-                        <a:t>Flush / FlushEventFd  [NEW]</a:t>
+                        <a:t>stack_writer::Flush</a:t>
                       </a:r>
-                      <a:endParaRPr lang="en-US" sz="1200" dirty="0"/>
+                      <a:endParaRPr lang="en-US" sz="900" dirty="0"/>
                     </a:p>
                   </a:txBody>
-                  <a:tcPr marL="76200" marR="76200" marT="25400" marB="25400">
+                  <a:tcPr marL="50800" marR="50800" marT="25400" marB="25400">
                     <a:lnL w="6350" cap="flat" cmpd="sng" algn="ctr">
                       <a:solidFill>
-                        <a:srgbClr val="E0E4EC"/>
+                        <a:srgbClr val="059669"/>
                       </a:solidFill>
                       <a:prstDash val="solid"/>
                       <a:round/>
@@ -19496,7 +19374,7 @@
                     </a:lnL>
                     <a:lnR w="6350" cap="flat" cmpd="sng" algn="ctr">
                       <a:solidFill>
-                        <a:srgbClr val="E0E4EC"/>
+                        <a:srgbClr val="059669"/>
                       </a:solidFill>
                       <a:prstDash val="solid"/>
                       <a:round/>
@@ -19505,7 +19383,7 @@
                     </a:lnR>
                     <a:lnT w="6350" cap="flat" cmpd="sng" algn="ctr">
                       <a:solidFill>
-                        <a:srgbClr val="E0E4EC"/>
+                        <a:srgbClr val="059669"/>
                       </a:solidFill>
                       <a:prstDash val="solid"/>
                       <a:round/>
@@ -19514,7 +19392,7 @@
                     </a:lnT>
                     <a:lnB w="6350" cap="flat" cmpd="sng" algn="ctr">
                       <a:solidFill>
-                        <a:srgbClr val="E0E4EC"/>
+                        <a:srgbClr val="059669"/>
                       </a:solidFill>
                       <a:prstDash val="solid"/>
                       <a:round/>
@@ -19522,7 +19400,7 @@
                       <a:tailEnd type="none" w="med" len="med"/>
                     </a:lnB>
                     <a:solidFill>
-                      <a:srgbClr val="F4F6FB"/>
+                      <a:srgbClr val="ECFDF5"/>
                     </a:solidFill>
                   </a:tcPr>
                 </a:tc>
@@ -19535,20 +19413,20 @@
                         <a:buNone/>
                       </a:pPr>
                       <a:r>
-                        <a:rPr lang="en-US" sz="1200" dirty="0">
+                        <a:rPr lang="en-US" sz="900" dirty="0">
                           <a:solidFill>
-                            <a:srgbClr val="059669"/>
+                            <a:srgbClr val="1A1A2E"/>
                           </a:solidFill>
                         </a:rPr>
-                        <a:t>Flush → EventNotifier::Post</a:t>
+                        <a:t>Flush→EventNotifier::Post</a:t>
                       </a:r>
-                      <a:endParaRPr lang="en-US" sz="1200" dirty="0"/>
+                      <a:endParaRPr lang="en-US" sz="900" dirty="0"/>
                     </a:p>
                   </a:txBody>
-                  <a:tcPr marL="76200" marR="76200" marT="25400" marB="25400">
+                  <a:tcPr marL="50800" marR="50800" marT="25400" marB="25400">
                     <a:lnL w="6350" cap="flat" cmpd="sng" algn="ctr">
                       <a:solidFill>
-                        <a:srgbClr val="E0E4EC"/>
+                        <a:srgbClr val="059669"/>
                       </a:solidFill>
                       <a:prstDash val="solid"/>
                       <a:round/>
@@ -19557,7 +19435,7 @@
                     </a:lnL>
                     <a:lnR w="6350" cap="flat" cmpd="sng" algn="ctr">
                       <a:solidFill>
-                        <a:srgbClr val="E0E4EC"/>
+                        <a:srgbClr val="059669"/>
                       </a:solidFill>
                       <a:prstDash val="solid"/>
                       <a:round/>
@@ -19566,7 +19444,7 @@
                     </a:lnR>
                     <a:lnT w="6350" cap="flat" cmpd="sng" algn="ctr">
                       <a:solidFill>
-                        <a:srgbClr val="E0E4EC"/>
+                        <a:srgbClr val="059669"/>
                       </a:solidFill>
                       <a:prstDash val="solid"/>
                       <a:round/>
@@ -19575,7 +19453,7 @@
                     </a:lnT>
                     <a:lnB w="6350" cap="flat" cmpd="sng" algn="ctr">
                       <a:solidFill>
-                        <a:srgbClr val="E0E4EC"/>
+                        <a:srgbClr val="059669"/>
                       </a:solidFill>
                       <a:prstDash val="solid"/>
                       <a:round/>
@@ -19583,7 +19461,7 @@
                       <a:tailEnd type="none" w="med" len="med"/>
                     </a:lnB>
                     <a:solidFill>
-                      <a:srgbClr val="F4F6FB"/>
+                      <a:srgbClr val="ECFDF5"/>
                     </a:solidFill>
                   </a:tcPr>
                 </a:tc>
@@ -19592,6 +19470,238 @@
           </a:graphicData>
         </a:graphic>
       </p:graphicFrame>
+      <p:sp>
+        <p:nvSpPr>
+          <p:cNvPr id="10" name="Shape 7"/>
+          <p:cNvSpPr/>
+          <p:nvPr/>
+        </p:nvSpPr>
+        <p:spPr>
+          <a:xfrm>
+            <a:off x="5989320" y="1097280"/>
+            <a:ext cx="5943600" cy="5029200"/>
+          </a:xfrm>
+          <a:prstGeom prst="roundRect">
+            <a:avLst>
+              <a:gd name="adj" fmla="val 1818"/>
+            </a:avLst>
+          </a:prstGeom>
+          <a:solidFill>
+            <a:srgbClr val="FDF2F8"/>
+          </a:solidFill>
+          <a:ln w="15240">
+            <a:solidFill>
+              <a:srgbClr val="DB2777"/>
+            </a:solidFill>
+            <a:prstDash val="solid"/>
+          </a:ln>
+        </p:spPr>
+      </p:sp>
+      <p:sp>
+        <p:nvSpPr>
+          <p:cNvPr id="11" name="Text 8"/>
+          <p:cNvSpPr/>
+          <p:nvPr/>
+        </p:nvSpPr>
+        <p:spPr>
+          <a:xfrm>
+            <a:off x="6217920" y="1188720"/>
+            <a:ext cx="3657600" cy="320040"/>
+          </a:xfrm>
+          <a:prstGeom prst="rect">
+            <a:avLst/>
+          </a:prstGeom>
+          <a:noFill/>
+          <a:ln/>
+        </p:spPr>
+        <p:txBody>
+          <a:bodyPr wrap="square" rtlCol="0" anchor="ctr"/>
+          <a:lstStyle/>
+          <a:p>
+            <a:pPr indent="0" marL="0">
+              <a:buNone/>
+            </a:pPr>
+            <a:r>
+              <a:rPr lang="en-US" sz="1400" b="1" dirty="0">
+                <a:solidFill>
+                  <a:srgbClr val="DB2777"/>
+                </a:solidFill>
+              </a:rPr>
+              <a:t>✗ 仍存在的差异</a:t>
+            </a:r>
+            <a:endParaRPr lang="en-US" sz="1400" dirty="0"/>
+          </a:p>
+        </p:txBody>
+      </p:sp>
+      <p:sp>
+        <p:nvSpPr>
+          <p:cNvPr id="12" name="Text 9"/>
+          <p:cNvSpPr/>
+          <p:nvPr/>
+        </p:nvSpPr>
+        <p:spPr>
+          <a:xfrm>
+            <a:off x="6309360" y="1691640"/>
+            <a:ext cx="5486400" cy="4114800"/>
+          </a:xfrm>
+          <a:prstGeom prst="rect">
+            <a:avLst/>
+          </a:prstGeom>
+          <a:noFill/>
+          <a:ln/>
+        </p:spPr>
+        <p:txBody>
+          <a:bodyPr wrap="square" rtlCol="0" anchor="t"/>
+          <a:lstStyle/>
+          <a:p>
+            <a:pPr marL="342900" indent="-342900">
+              <a:lnSpc>
+                <a:spcPts val="2400"/>
+              </a:lnSpc>
+              <a:spcAft>
+                <a:spcPts val="400"/>
+              </a:spcAft>
+              <a:buSzPct val="100000"/>
+              <a:buChar char="•"/>
+            </a:pPr>
+            <a:r>
+              <a:rPr lang="en-US" sz="1100" dirty="0">
+                <a:solidFill>
+                  <a:srgbClr val="4A4A6A"/>
+                </a:solidFill>
+              </a:rPr>
+              <a:t>FpUnwind 栈回溯: aarch64 专用指令，原型跑 x86 无法实现</a:t>
+            </a:r>
+            <a:endParaRPr lang="en-US" sz="1100" dirty="0"/>
+          </a:p>
+          <a:p>
+            <a:pPr marL="342900" indent="-342900">
+              <a:lnSpc>
+                <a:spcPts val="2400"/>
+              </a:lnSpc>
+              <a:spcAft>
+                <a:spcPts val="400"/>
+              </a:spcAft>
+              <a:buSzPct val="100000"/>
+              <a:buChar char="•"/>
+            </a:pPr>
+            <a:r>
+              <a:rPr lang="en-US" sz="1100" dirty="0">
+                <a:solidFill>
+                  <a:srgbClr val="4A4A6A"/>
+                </a:solidFill>
+              </a:rPr>
+              <a:t>StackRawData 格式: 原型简化版字段 vs 真实代码含 ip[] 数组 + jsChainId</a:t>
+            </a:r>
+            <a:endParaRPr lang="en-US" sz="1100" dirty="0"/>
+          </a:p>
+          <a:p>
+            <a:pPr marL="342900" indent="-342900">
+              <a:lnSpc>
+                <a:spcPts val="2400"/>
+              </a:lnSpc>
+              <a:spcAft>
+                <a:spcPts val="400"/>
+              </a:spcAft>
+              <a:buSzPct val="100000"/>
+              <a:buChar char="•"/>
+            </a:pPr>
+            <a:r>
+              <a:rPr lang="en-US" sz="1100" dirty="0">
+                <a:solidFill>
+                  <a:srgbClr val="4A4A6A"/>
+                </a:solidFill>
+              </a:rPr>
+              <a:t>record 大小计算: 原型固定 sizeof(HookRecord)，真实代码根据 fpunwind 模式动态计算</a:t>
+            </a:r>
+            <a:endParaRPr lang="en-US" sz="1100" dirty="0"/>
+          </a:p>
+          <a:p>
+            <a:pPr marL="342900" indent="-342900">
+              <a:lnSpc>
+                <a:spcPts val="2400"/>
+              </a:lnSpc>
+              <a:spcAft>
+                <a:spcPts val="400"/>
+              </a:spcAft>
+              <a:buSzPct val="100000"/>
+              <a:buChar char="•"/>
+            </a:pPr>
+            <a:r>
+              <a:rPr lang="en-US" sz="1100" dirty="0">
+                <a:solidFill>
+                  <a:srgbClr val="4A4A6A"/>
+                </a:solidFill>
+              </a:rPr>
+              <a:t>构建系统: 原型用 CMake，真实代码用 GN + OpenHarmony SDK</a:t>
+            </a:r>
+            <a:endParaRPr lang="en-US" sz="1100" dirty="0"/>
+          </a:p>
+          <a:p>
+            <a:pPr marL="342900" indent="-342900">
+              <a:lnSpc>
+                <a:spcPts val="2400"/>
+              </a:lnSpc>
+              <a:spcAft>
+                <a:spcPts val="400"/>
+              </a:spcAft>
+              <a:buSzPct val="100000"/>
+              <a:buChar char="•"/>
+            </a:pPr>
+            <a:r>
+              <a:rPr lang="en-US" sz="1100" dirty="0">
+                <a:solidFill>
+                  <a:srgbClr val="4A4A6A"/>
+                </a:solidFill>
+              </a:rPr>
+              <a:t>共享内存层: 原型直接操作 ring，真实代码多一层 ShareMemoryBlock 封装</a:t>
+            </a:r>
+            <a:endParaRPr lang="en-US" sz="1100" dirty="0"/>
+          </a:p>
+          <a:p>
+            <a:pPr marL="342900" indent="-342900">
+              <a:lnSpc>
+                <a:spcPts val="2400"/>
+              </a:lnSpc>
+              <a:spcAft>
+                <a:spcPts val="400"/>
+              </a:spcAft>
+              <a:buSzPct val="100000"/>
+              <a:buChar char="•"/>
+            </a:pPr>
+            <a:r>
+              <a:rPr lang="en-US" sz="1100" dirty="0">
+                <a:solidFill>
+                  <a:srgbClr val="4A4A6A"/>
+                </a:solidFill>
+              </a:rPr>
+              <a:t>consumer 交互: 原型简单 eventfd，真实代码多了一层 EventNotifier + 心跳检测</a:t>
+            </a:r>
+            <a:endParaRPr lang="en-US" sz="1100" dirty="0"/>
+          </a:p>
+          <a:p>
+            <a:pPr marL="342900" indent="-342900">
+              <a:lnSpc>
+                <a:spcPts val="2400"/>
+              </a:lnSpc>
+              <a:spcAft>
+                <a:spcPts val="400"/>
+              </a:spcAft>
+              <a:buSzPct val="100000"/>
+              <a:buChar char="•"/>
+            </a:pPr>
+            <a:r>
+              <a:rPr lang="en-US" sz="1100" dirty="0">
+                <a:solidFill>
+                  <a:srgbClr val="4A4A6A"/>
+                </a:solidFill>
+              </a:rPr>
+              <a:t>编译验证: 原型可本地编译测试，真实代码待 OH SDK 环境</a:t>
+            </a:r>
+            <a:endParaRPr lang="en-US" sz="1100" dirty="0"/>
+          </a:p>
+        </p:txBody>
+      </p:sp>
     </p:spTree>
   </p:cSld>
   <p:clrMapOvr>

</xml_diff>

<commit_message>
Mark new modules on arch slide, fix visualization text contrast
</commit_message>
<xml_diff>
--- a/presentation/native_hook_progress_2026-06-05.pptx
+++ b/presentation/native_hook_progress_2026-06-05.pptx
@@ -11999,7 +11999,7 @@
             <a:r>
               <a:rPr lang="en-US" sz="1300" b="1" dirty="0">
                 <a:solidFill>
-                  <a:srgbClr val="FFFFFF"/>
+                  <a:srgbClr val="1A1A2E"/>
                 </a:solidFill>
               </a:rPr>
               <a:t>即：100万次锁操作 → 1.5万次锁操作    100万次原子索引发布 → 1.5万次    ~5万次事件通知 → ~780次</a:t>
@@ -18987,7 +18987,7 @@
                             <a:srgbClr val="1A1A2E"/>
                           </a:solidFill>
                         </a:rPr>
-                        <a:t>address_handler.h</a:t>
+                        <a:t>address_handler.h  [新增]</a:t>
                       </a:r>
                       <a:endParaRPr lang="en-US" sz="900" dirty="0"/>
                     </a:p>
@@ -19172,7 +19172,7 @@
                             <a:srgbClr val="1A1A2E"/>
                           </a:solidFill>
                         </a:rPr>
-                        <a:t>stack_writer.cpp</a:t>
+                        <a:t>stack_writer.cpp  [新增]</a:t>
                       </a:r>
                       <a:endParaRPr lang="en-US" sz="900" dirty="0"/>
                     </a:p>
@@ -19357,7 +19357,7 @@
                             <a:srgbClr val="1A1A2E"/>
                           </a:solidFill>
                         </a:rPr>
-                        <a:t>stack_writer::Flush</a:t>
+                        <a:t>stack_writer::Flush  [新增]</a:t>
                       </a:r>
                       <a:endParaRPr lang="en-US" sz="900" dirty="0"/>
                     </a:p>

</xml_diff>

<commit_message>
Trim slide 4 text, increase card height, reduce font
</commit_message>
<xml_diff>
--- a/presentation/native_hook_progress_2026-06-05.pptx
+++ b/presentation/native_hook_progress_2026-06-05.pptx
@@ -9061,11 +9061,11 @@
         <p:spPr>
           <a:xfrm>
             <a:off x="274320" y="1280160"/>
-            <a:ext cx="11612880" cy="2468880"/>
+            <a:ext cx="11612880" cy="2743200"/>
           </a:xfrm>
           <a:prstGeom prst="roundRect">
             <a:avLst>
-              <a:gd name="adj" fmla="val 3704"/>
+              <a:gd name="adj" fmla="val 3333"/>
             </a:avLst>
           </a:prstGeom>
           <a:solidFill>
@@ -9088,7 +9088,7 @@
         <p:spPr>
           <a:xfrm>
             <a:off x="274320" y="1280160"/>
-            <a:ext cx="109728" cy="2468880"/>
+            <a:ext cx="109728" cy="2743200"/>
           </a:xfrm>
           <a:prstGeom prst="rect">
             <a:avLst/>
@@ -9183,7 +9183,7 @@
         <p:spPr>
           <a:xfrm>
             <a:off x="1554480" y="1920240"/>
-            <a:ext cx="9875520" cy="1554480"/>
+            <a:ext cx="9875520" cy="1645920"/>
           </a:xfrm>
           <a:prstGeom prst="rect">
             <a:avLst/>
@@ -9206,14 +9206,14 @@
               <a:buChar char="•"/>
             </a:pPr>
             <a:r>
-              <a:rPr lang="en-US" sz="1200" dirty="0">
+              <a:rPr lang="en-US" sz="1100" dirty="0">
                 <a:solidFill>
                   <a:srgbClr val="4A4A6A"/>
                 </a:solidFill>
               </a:rPr>
-              <a:t>移出锁的操作: 进程ID、线程ID、时间戳、类型、大小、地址 + 线程名更新</a:t>
+              <a:t>移出锁的操作: 进程/线程ID、时间戳、类型、大小、地址 + 线程名更新</a:t>
             </a:r>
-            <a:endParaRPr lang="en-US" sz="1200" dirty="0"/>
+            <a:endParaRPr lang="en-US" sz="1100" dirty="0"/>
           </a:p>
           <a:p>
             <a:pPr marL="342900" indent="-342900">
@@ -9227,14 +9227,14 @@
               <a:buChar char="•"/>
             </a:pPr>
             <a:r>
-              <a:rPr lang="en-US" sz="1200" dirty="0">
+              <a:rPr lang="en-US" sz="1100" dirty="0">
                 <a:solidFill>
                   <a:srgbClr val="4A4A6A"/>
                 </a:solidFill>
               </a:rPr>
-              <a:t>这些字段不碰共享状态——进程/线程ID缓存于线程本地，时间戳直接系统调用</a:t>
+              <a:t>这些字段不碰共享状态 — 进程/线程ID本地缓存，时间戳直接系统调用</a:t>
             </a:r>
-            <a:endParaRPr lang="en-US" sz="1200" dirty="0"/>
+            <a:endParaRPr lang="en-US" sz="1100" dirty="0"/>
           </a:p>
           <a:p>
             <a:pPr marL="342900" indent="-342900">
@@ -9248,14 +9248,14 @@
               <a:buChar char="•"/>
             </a:pPr>
             <a:r>
-              <a:rPr lang="en-US" sz="1200" dirty="0">
+              <a:rPr lang="en-US" sz="1100" dirty="0">
                 <a:solidFill>
                   <a:srgbClr val="4A4A6A"/>
                 </a:solidFill>
               </a:rPr>
               <a:t>原来: 拿锁 → 填充字段 → 写共享内存 → 通知 → 放锁</a:t>
             </a:r>
-            <a:endParaRPr lang="en-US" sz="1200" dirty="0"/>
+            <a:endParaRPr lang="en-US" sz="1100" dirty="0"/>
           </a:p>
           <a:p>
             <a:pPr marL="342900" indent="-342900">
@@ -9269,14 +9269,14 @@
               <a:buChar char="•"/>
             </a:pPr>
             <a:r>
-              <a:rPr lang="en-US" sz="1200" dirty="0">
+              <a:rPr lang="en-US" sz="1100" dirty="0">
                 <a:solidFill>
                   <a:srgbClr val="4A4A6A"/>
                 </a:solidFill>
               </a:rPr>
               <a:t>优化后: 填充字段 → 拿锁 → 写共享内存 → 通知 → 放锁</a:t>
             </a:r>
-            <a:endParaRPr lang="en-US" sz="1200" dirty="0"/>
+            <a:endParaRPr lang="en-US" sz="1100" dirty="0"/>
           </a:p>
           <a:p>
             <a:pPr marL="342900" indent="-342900">
@@ -9290,14 +9290,14 @@
               <a:buChar char="•"/>
             </a:pPr>
             <a:r>
-              <a:rPr lang="en-US" sz="1200" dirty="0">
+              <a:rPr lang="en-US" sz="1100" dirty="0">
                 <a:solidFill>
                   <a:srgbClr val="4A4A6A"/>
                 </a:solidFill>
               </a:rPr>
-              <a:t>4T: 3.51s→2.72s (22.5%)    8T: 3.64s→3.12s (14.3%)</a:t>
+              <a:t>4T: 3.51→2.72s (22.5%)    8T: 3.64→3.12s (14.3%)</a:t>
             </a:r>
-            <a:endParaRPr lang="en-US" sz="1200" dirty="0"/>
+            <a:endParaRPr lang="en-US" sz="1100" dirty="0"/>
           </a:p>
           <a:p>
             <a:pPr marL="342900" indent="-342900">
@@ -9311,14 +9311,14 @@
               <a:buChar char="•"/>
             </a:pPr>
             <a:r>
-              <a:rPr lang="en-US" sz="1200" dirty="0">
+              <a:rPr lang="en-US" sz="1100" dirty="0">
                 <a:solidFill>
                   <a:srgbClr val="4A4A6A"/>
                 </a:solidFill>
               </a:rPr>
-              <a:t>核心收益: 缩短临界区 → 减少其他线程等锁时间</a:t>
+              <a:t>核心收益: 缩短临界区 → 减少等锁时间</a:t>
             </a:r>
-            <a:endParaRPr lang="en-US" sz="1200" dirty="0"/>
+            <a:endParaRPr lang="en-US" sz="1100" dirty="0"/>
           </a:p>
         </p:txBody>
       </p:sp>
@@ -9331,11 +9331,11 @@
         <p:spPr>
           <a:xfrm>
             <a:off x="274320" y="3749040"/>
-            <a:ext cx="11612880" cy="2468880"/>
+            <a:ext cx="11612880" cy="2743200"/>
           </a:xfrm>
           <a:prstGeom prst="roundRect">
             <a:avLst>
-              <a:gd name="adj" fmla="val 3704"/>
+              <a:gd name="adj" fmla="val 3333"/>
             </a:avLst>
           </a:prstGeom>
           <a:solidFill>
@@ -9358,7 +9358,7 @@
         <p:spPr>
           <a:xfrm>
             <a:off x="274320" y="3749040"/>
-            <a:ext cx="109728" cy="2468880"/>
+            <a:ext cx="109728" cy="2743200"/>
           </a:xfrm>
           <a:prstGeom prst="rect">
             <a:avLst/>
@@ -9453,7 +9453,7 @@
         <p:spPr>
           <a:xfrm>
             <a:off x="1554480" y="4389120"/>
-            <a:ext cx="9875520" cy="1554480"/>
+            <a:ext cx="9875520" cy="1645920"/>
           </a:xfrm>
           <a:prstGeom prst="rect">
             <a:avLst/>
@@ -9476,14 +9476,14 @@
               <a:buChar char="•"/>
             </a:pPr>
             <a:r>
-              <a:rPr lang="en-US" sz="1200" dirty="0">
+              <a:rPr lang="en-US" sz="1100" dirty="0">
                 <a:solidFill>
                   <a:srgbClr val="4A4A6A"/>
                 </a:solidFill>
               </a:rPr>
-              <a:t>线程本地缓冲区 (固定大小数组 + 计数器)</a:t>
+              <a:t>线程本地缓冲区 (固定数组 + 计数器)</a:t>
             </a:r>
-            <a:endParaRPr lang="en-US" sz="1200" dirty="0"/>
+            <a:endParaRPr lang="en-US" sz="1100" dirty="0"/>
           </a:p>
           <a:p>
             <a:pPr marL="342900" indent="-342900">
@@ -9497,14 +9497,14 @@
               <a:buChar char="•"/>
             </a:pPr>
             <a:r>
-              <a:rPr lang="en-US" sz="1200" dirty="0">
+              <a:rPr lang="en-US" sz="1100" dirty="0">
                 <a:solidFill>
                   <a:srgbClr val="4A4A6A"/>
                 </a:solidFill>
               </a:rPr>
-              <a:t>每条记录先进入缓冲区; 攒满批次大小 → 触发批量排空</a:t>
+              <a:t>记录先进缓冲区; 攒满批次大小 → 触发批量排空</a:t>
             </a:r>
-            <a:endParaRPr lang="en-US" sz="1200" dirty="0"/>
+            <a:endParaRPr lang="en-US" sz="1100" dirty="0"/>
           </a:p>
           <a:p>
             <a:pPr marL="342900" indent="-342900">
@@ -9518,14 +9518,14 @@
               <a:buChar char="•"/>
             </a:pPr>
             <a:r>
-              <a:rPr lang="en-US" sz="1200" dirty="0">
+              <a:rPr lang="en-US" sz="1100" dirty="0">
                 <a:solidFill>
                   <a:srgbClr val="4A4A6A"/>
                 </a:solidFill>
               </a:rPr>
-              <a:t>排空时: 拿一次锁 → 批量写共享内存 → 一次原子更新索引 → 一次事件通知</a:t>
+              <a:t>排空: 一次拿锁 → 批量写 → 一次原子发布索引 → 一次事件通知</a:t>
             </a:r>
-            <a:endParaRPr lang="en-US" sz="1200" dirty="0"/>
+            <a:endParaRPr lang="en-US" sz="1100" dirty="0"/>
           </a:p>
           <a:p>
             <a:pPr marL="342900" indent="-342900">
@@ -9539,14 +9539,14 @@
               <a:buChar char="•"/>
             </a:pPr>
             <a:r>
-              <a:rPr lang="en-US" sz="1200" dirty="0">
+              <a:rPr lang="en-US" sz="1100" dirty="0">
                 <a:solidFill>
                   <a:srgbClr val="4A4A6A"/>
                 </a:solidFill>
               </a:rPr>
               <a:t>线程退出时析构函数自动排空残留</a:t>
             </a:r>
-            <a:endParaRPr lang="en-US" sz="1200" dirty="0"/>
+            <a:endParaRPr lang="en-US" sz="1100" dirty="0"/>
           </a:p>
           <a:p>
             <a:pPr marL="342900" indent="-342900">
@@ -9560,14 +9560,14 @@
               <a:buChar char="•"/>
             </a:pPr>
             <a:r>
-              <a:rPr lang="en-US" sz="1200" dirty="0">
+              <a:rPr lang="en-US" sz="1100" dirty="0">
                 <a:solidFill>
                   <a:srgbClr val="4A4A6A"/>
                 </a:solidFill>
               </a:rPr>
-              <a:t>env gate: LNHV1_STAGE6_BATCH_SIZE=1~64（默认0=关闭）</a:t>
+              <a:t>控制: LNHV1_STAGE6_BATCH_SIZE=1~64（默认0=关闭）</a:t>
             </a:r>
-            <a:endParaRPr lang="en-US" sz="1200" dirty="0"/>
+            <a:endParaRPr lang="en-US" sz="1100" dirty="0"/>
           </a:p>
           <a:p>
             <a:pPr marL="342900" indent="-342900">
@@ -9581,14 +9581,14 @@
               <a:buChar char="•"/>
             </a:pPr>
             <a:r>
-              <a:rPr lang="en-US" sz="1200" dirty="0">
+              <a:rPr lang="en-US" sz="1100" dirty="0">
                 <a:solidFill>
                   <a:srgbClr val="4A4A6A"/>
                 </a:solidFill>
               </a:rPr>
-              <a:t>效果: 1T 1.55s→1.22s    8T 3.12s→1.28s    16T 3.41s→1.34s</a:t>
+              <a:t>效果: 1T 1.55→1.22s    8T 3.12→1.28s    16T 3.41→1.34s</a:t>
             </a:r>
-            <a:endParaRPr lang="en-US" sz="1200" dirty="0"/>
+            <a:endParaRPr lang="en-US" sz="1100" dirty="0"/>
           </a:p>
         </p:txBody>
       </p:sp>

</xml_diff>

<commit_message>
Add English 'Batch Publish' to batch-related slide titles
</commit_message>
<xml_diff>
--- a/presentation/native_hook_progress_2026-06-05.pptx
+++ b/presentation/native_hook_progress_2026-06-05.pptx
@@ -9438,7 +9438,7 @@
                   <a:srgbClr val="1A1A2E"/>
                 </a:solidFill>
               </a:rPr>
-              <a:t>Stage 6  批量发布</a:t>
+              <a:t>批量发布 (Batch Publish)</a:t>
             </a:r>
             <a:endParaRPr lang="en-US" sz="1500" dirty="0"/>
           </a:p>
@@ -9733,7 +9733,7 @@
                   <a:srgbClr val="1A1A2E"/>
                 </a:solidFill>
               </a:rPr>
-              <a:t>批量发布 — 工作原理</a:t>
+              <a:t>批量发布 — 工作原理 (Batch Publish)</a:t>
             </a:r>
             <a:endParaRPr lang="en-US" sz="2400" dirty="0"/>
           </a:p>
@@ -12149,7 +12149,7 @@
                   <a:srgbClr val="1A1A2E"/>
                 </a:solidFill>
               </a:rPr>
-              <a:t>批量发布 — 服务器验证数据</a:t>
+              <a:t>批量发布 — 服务器验证数据 (Batch Publish)</a:t>
             </a:r>
             <a:endParaRPr lang="en-US" sz="2400" dirty="0"/>
           </a:p>

</xml_diff>

<commit_message>
Swap Next Steps 2<->3, remove AGENTS.md ref from slide 11
</commit_message>
<xml_diff>
--- a/presentation/native_hook_progress_2026-06-05.pptx
+++ b/presentation/native_hook_progress_2026-06-05.pptx
@@ -4222,7 +4222,7 @@
                   <a:srgbClr val="059669"/>
                 </a:solidFill>
               </a:rPr>
-              <a:t>三步预检法  [AGENTS.md]</a:t>
+              <a:t>三步预检法</a:t>
             </a:r>
             <a:endParaRPr lang="en-US" sz="1600" dirty="0"/>
           </a:p>
@@ -4791,164 +4791,6 @@
           </a:solidFill>
           <a:ln w="19050">
             <a:solidFill>
-              <a:srgbClr val="059669"/>
-            </a:solidFill>
-            <a:prstDash val="solid"/>
-          </a:ln>
-        </p:spPr>
-      </p:sp>
-      <p:sp>
-        <p:nvSpPr>
-          <p:cNvPr id="12" name="Shape 10"/>
-          <p:cNvSpPr/>
-          <p:nvPr/>
-        </p:nvSpPr>
-        <p:spPr>
-          <a:xfrm>
-            <a:off x="914400" y="3063240"/>
-            <a:ext cx="109728" cy="1371600"/>
-          </a:xfrm>
-          <a:prstGeom prst="rect">
-            <a:avLst/>
-          </a:prstGeom>
-          <a:solidFill>
-            <a:srgbClr val="059669"/>
-          </a:solidFill>
-          <a:ln/>
-        </p:spPr>
-      </p:sp>
-      <p:sp>
-        <p:nvSpPr>
-          <p:cNvPr id="13" name="Text 11"/>
-          <p:cNvSpPr/>
-          <p:nvPr/>
-        </p:nvSpPr>
-        <p:spPr>
-          <a:xfrm>
-            <a:off x="1234440" y="3200400"/>
-            <a:ext cx="731520" cy="731520"/>
-          </a:xfrm>
-          <a:prstGeom prst="rect">
-            <a:avLst/>
-          </a:prstGeom>
-          <a:noFill/>
-          <a:ln/>
-        </p:spPr>
-        <p:txBody>
-          <a:bodyPr wrap="square" rtlCol="0" anchor="ctr"/>
-          <a:lstStyle/>
-          <a:p>
-            <a:pPr indent="0" marL="0">
-              <a:buNone/>
-            </a:pPr>
-            <a:r>
-              <a:rPr lang="en-US" sz="3400" b="1" dirty="0">
-                <a:solidFill>
-                  <a:srgbClr val="059669"/>
-                </a:solidFill>
-                <a:latin typeface="Consolas" pitchFamily="34" charset="0"/>
-                <a:ea typeface="Consolas" pitchFamily="34" charset="-122"/>
-                <a:cs typeface="Consolas" pitchFamily="34" charset="-120"/>
-              </a:rPr>
-              <a:t>02</a:t>
-            </a:r>
-            <a:endParaRPr lang="en-US" sz="3400" dirty="0"/>
-          </a:p>
-        </p:txBody>
-      </p:sp>
-      <p:sp>
-        <p:nvSpPr>
-          <p:cNvPr id="14" name="Text 12"/>
-          <p:cNvSpPr/>
-          <p:nvPr/>
-        </p:nvSpPr>
-        <p:spPr>
-          <a:xfrm>
-            <a:off x="2103120" y="3246120"/>
-            <a:ext cx="4572000" cy="365760"/>
-          </a:xfrm>
-          <a:prstGeom prst="rect">
-            <a:avLst/>
-          </a:prstGeom>
-          <a:noFill/>
-          <a:ln/>
-        </p:spPr>
-        <p:txBody>
-          <a:bodyPr wrap="square" rtlCol="0" anchor="ctr"/>
-          <a:lstStyle/>
-          <a:p>
-            <a:pPr indent="0" marL="0">
-              <a:buNone/>
-            </a:pPr>
-            <a:r>
-              <a:rPr lang="en-US" sz="1600" b="1" dirty="0">
-                <a:solidFill>
-                  <a:srgbClr val="1A1A2E"/>
-                </a:solidFill>
-              </a:rPr>
-              <a:t>真实代码验证</a:t>
-            </a:r>
-            <a:endParaRPr lang="en-US" sz="1600" dirty="0"/>
-          </a:p>
-        </p:txBody>
-      </p:sp>
-      <p:sp>
-        <p:nvSpPr>
-          <p:cNvPr id="15" name="Text 13"/>
-          <p:cNvSpPr/>
-          <p:nvPr/>
-        </p:nvSpPr>
-        <p:spPr>
-          <a:xfrm>
-            <a:off x="2103120" y="3703320"/>
-            <a:ext cx="8229600" cy="457200"/>
-          </a:xfrm>
-          <a:prstGeom prst="rect">
-            <a:avLst/>
-          </a:prstGeom>
-          <a:noFill/>
-          <a:ln/>
-        </p:spPr>
-        <p:txBody>
-          <a:bodyPr wrap="square" rtlCol="0" anchor="ctr"/>
-          <a:lstStyle/>
-          <a:p>
-            <a:pPr indent="0" marL="0">
-              <a:buNone/>
-            </a:pPr>
-            <a:r>
-              <a:rPr lang="en-US" sz="1300" dirty="0">
-                <a:solidFill>
-                  <a:srgbClr val="4A4A6A"/>
-                </a:solidFill>
-              </a:rPr>
-              <a:t>等待 OpenHarmony 编译环境 → GitLab fork benchmark → 合 master</a:t>
-            </a:r>
-            <a:endParaRPr lang="en-US" sz="1300" dirty="0"/>
-          </a:p>
-        </p:txBody>
-      </p:sp>
-      <p:sp>
-        <p:nvSpPr>
-          <p:cNvPr id="16" name="Shape 14"/>
-          <p:cNvSpPr/>
-          <p:nvPr/>
-        </p:nvSpPr>
-        <p:spPr>
-          <a:xfrm>
-            <a:off x="914400" y="4754880"/>
-            <a:ext cx="10332720" cy="1371600"/>
-          </a:xfrm>
-          <a:prstGeom prst="roundRect">
-            <a:avLst>
-              <a:gd name="adj" fmla="val 6667"/>
-            </a:avLst>
-          </a:prstGeom>
-          <a:solidFill>
-            <a:srgbClr val="FFFFFF"/>
-          </a:solidFill>
-          <a:ln w="19050">
-            <a:solidFill>
               <a:srgbClr val="7C3AED"/>
             </a:solidFill>
             <a:prstDash val="solid"/>
@@ -4957,13 +4799,13 @@
       </p:sp>
       <p:sp>
         <p:nvSpPr>
-          <p:cNvPr id="17" name="Shape 15"/>
+          <p:cNvPr id="12" name="Shape 10"/>
           <p:cNvSpPr/>
           <p:nvPr/>
         </p:nvSpPr>
         <p:spPr>
           <a:xfrm>
-            <a:off x="914400" y="4754880"/>
+            <a:off x="914400" y="3063240"/>
             <a:ext cx="109728" cy="1371600"/>
           </a:xfrm>
           <a:prstGeom prst="rect">
@@ -4977,13 +4819,13 @@
       </p:sp>
       <p:sp>
         <p:nvSpPr>
-          <p:cNvPr id="18" name="Text 16"/>
+          <p:cNvPr id="13" name="Text 11"/>
           <p:cNvSpPr/>
           <p:nvPr/>
         </p:nvSpPr>
         <p:spPr>
           <a:xfrm>
-            <a:off x="1234440" y="4892040"/>
+            <a:off x="1234440" y="3200400"/>
             <a:ext cx="731520" cy="731520"/>
           </a:xfrm>
           <a:prstGeom prst="rect">
@@ -5008,7 +4850,7 @@
                 <a:ea typeface="Consolas" pitchFamily="34" charset="-122"/>
                 <a:cs typeface="Consolas" pitchFamily="34" charset="-120"/>
               </a:rPr>
-              <a:t>03</a:t>
+              <a:t>02</a:t>
             </a:r>
             <a:endParaRPr lang="en-US" sz="3400" dirty="0"/>
           </a:p>
@@ -5016,13 +4858,13 @@
       </p:sp>
       <p:sp>
         <p:nvSpPr>
-          <p:cNvPr id="19" name="Text 17"/>
+          <p:cNvPr id="14" name="Text 12"/>
           <p:cNvSpPr/>
           <p:nvPr/>
         </p:nvSpPr>
         <p:spPr>
           <a:xfrm>
-            <a:off x="2103120" y="4937760"/>
+            <a:off x="2103120" y="3246120"/>
             <a:ext cx="4572000" cy="365760"/>
           </a:xfrm>
           <a:prstGeom prst="rect">
@@ -5052,13 +4894,13 @@
       </p:sp>
       <p:sp>
         <p:nvSpPr>
-          <p:cNvPr id="20" name="Text 18"/>
+          <p:cNvPr id="15" name="Text 13"/>
           <p:cNvSpPr/>
           <p:nvPr/>
         </p:nvSpPr>
         <p:spPr>
           <a:xfrm>
-            <a:off x="2103120" y="5394960"/>
+            <a:off x="2103120" y="3703320"/>
             <a:ext cx="8229600" cy="457200"/>
           </a:xfrm>
           <a:prstGeom prst="rect">
@@ -5095,6 +4937,164 @@
                 </a:solidFill>
               </a:rPr>
               <a:t>如需进一步：评估 producer 端 eBPF 替代方案</a:t>
+            </a:r>
+            <a:endParaRPr lang="en-US" sz="1300" dirty="0"/>
+          </a:p>
+        </p:txBody>
+      </p:sp>
+      <p:sp>
+        <p:nvSpPr>
+          <p:cNvPr id="16" name="Shape 14"/>
+          <p:cNvSpPr/>
+          <p:nvPr/>
+        </p:nvSpPr>
+        <p:spPr>
+          <a:xfrm>
+            <a:off x="914400" y="4754880"/>
+            <a:ext cx="10332720" cy="1371600"/>
+          </a:xfrm>
+          <a:prstGeom prst="roundRect">
+            <a:avLst>
+              <a:gd name="adj" fmla="val 6667"/>
+            </a:avLst>
+          </a:prstGeom>
+          <a:solidFill>
+            <a:srgbClr val="FFFFFF"/>
+          </a:solidFill>
+          <a:ln w="19050">
+            <a:solidFill>
+              <a:srgbClr val="059669"/>
+            </a:solidFill>
+            <a:prstDash val="solid"/>
+          </a:ln>
+        </p:spPr>
+      </p:sp>
+      <p:sp>
+        <p:nvSpPr>
+          <p:cNvPr id="17" name="Shape 15"/>
+          <p:cNvSpPr/>
+          <p:nvPr/>
+        </p:nvSpPr>
+        <p:spPr>
+          <a:xfrm>
+            <a:off x="914400" y="4754880"/>
+            <a:ext cx="109728" cy="1371600"/>
+          </a:xfrm>
+          <a:prstGeom prst="rect">
+            <a:avLst/>
+          </a:prstGeom>
+          <a:solidFill>
+            <a:srgbClr val="059669"/>
+          </a:solidFill>
+          <a:ln/>
+        </p:spPr>
+      </p:sp>
+      <p:sp>
+        <p:nvSpPr>
+          <p:cNvPr id="18" name="Text 16"/>
+          <p:cNvSpPr/>
+          <p:nvPr/>
+        </p:nvSpPr>
+        <p:spPr>
+          <a:xfrm>
+            <a:off x="1234440" y="4892040"/>
+            <a:ext cx="731520" cy="731520"/>
+          </a:xfrm>
+          <a:prstGeom prst="rect">
+            <a:avLst/>
+          </a:prstGeom>
+          <a:noFill/>
+          <a:ln/>
+        </p:spPr>
+        <p:txBody>
+          <a:bodyPr wrap="square" rtlCol="0" anchor="ctr"/>
+          <a:lstStyle/>
+          <a:p>
+            <a:pPr indent="0" marL="0">
+              <a:buNone/>
+            </a:pPr>
+            <a:r>
+              <a:rPr lang="en-US" sz="3400" b="1" dirty="0">
+                <a:solidFill>
+                  <a:srgbClr val="059669"/>
+                </a:solidFill>
+                <a:latin typeface="Consolas" pitchFamily="34" charset="0"/>
+                <a:ea typeface="Consolas" pitchFamily="34" charset="-122"/>
+                <a:cs typeface="Consolas" pitchFamily="34" charset="-120"/>
+              </a:rPr>
+              <a:t>03</a:t>
+            </a:r>
+            <a:endParaRPr lang="en-US" sz="3400" dirty="0"/>
+          </a:p>
+        </p:txBody>
+      </p:sp>
+      <p:sp>
+        <p:nvSpPr>
+          <p:cNvPr id="19" name="Text 17"/>
+          <p:cNvSpPr/>
+          <p:nvPr/>
+        </p:nvSpPr>
+        <p:spPr>
+          <a:xfrm>
+            <a:off x="2103120" y="4937760"/>
+            <a:ext cx="4572000" cy="365760"/>
+          </a:xfrm>
+          <a:prstGeom prst="rect">
+            <a:avLst/>
+          </a:prstGeom>
+          <a:noFill/>
+          <a:ln/>
+        </p:spPr>
+        <p:txBody>
+          <a:bodyPr wrap="square" rtlCol="0" anchor="ctr"/>
+          <a:lstStyle/>
+          <a:p>
+            <a:pPr indent="0" marL="0">
+              <a:buNone/>
+            </a:pPr>
+            <a:r>
+              <a:rPr lang="en-US" sz="1600" b="1" dirty="0">
+                <a:solidFill>
+                  <a:srgbClr val="1A1A2E"/>
+                </a:solidFill>
+              </a:rPr>
+              <a:t>真实代码验证</a:t>
+            </a:r>
+            <a:endParaRPr lang="en-US" sz="1600" dirty="0"/>
+          </a:p>
+        </p:txBody>
+      </p:sp>
+      <p:sp>
+        <p:nvSpPr>
+          <p:cNvPr id="20" name="Text 18"/>
+          <p:cNvSpPr/>
+          <p:nvPr/>
+        </p:nvSpPr>
+        <p:spPr>
+          <a:xfrm>
+            <a:off x="2103120" y="5394960"/>
+            <a:ext cx="8229600" cy="457200"/>
+          </a:xfrm>
+          <a:prstGeom prst="rect">
+            <a:avLst/>
+          </a:prstGeom>
+          <a:noFill/>
+          <a:ln/>
+        </p:spPr>
+        <p:txBody>
+          <a:bodyPr wrap="square" rtlCol="0" anchor="ctr"/>
+          <a:lstStyle/>
+          <a:p>
+            <a:pPr indent="0" marL="0">
+              <a:buNone/>
+            </a:pPr>
+            <a:r>
+              <a:rPr lang="en-US" sz="1300" dirty="0">
+                <a:solidFill>
+                  <a:srgbClr val="4A4A6A"/>
+                </a:solidFill>
+              </a:rPr>
+              <a:t>等待 OpenHarmony 编译环境 → GitLab fork benchmark → 合 master</a:t>
             </a:r>
             <a:endParaRPr lang="en-US" sz="1300" dirty="0"/>
           </a:p>

</xml_diff>

<commit_message>
Move fork to memory_leak/yt_nativehook, update all references
</commit_message>
<xml_diff>
--- a/presentation/native_hook_progress_2026-06-05.pptx
+++ b/presentation/native_hook_progress_2026-06-05.pptx
@@ -2159,7 +2159,7 @@
                   <a:srgbClr val="8888A8"/>
                 </a:solidFill>
               </a:rPr>
-              <a:t>gitlab.youtune.tech/cychi/cyc_nativehook</a:t>
+              <a:t>gitlab.youtune.tech/memory_leak/yt_nativehook</a:t>
             </a:r>
             <a:endParaRPr lang="en-US" sz="1200" dirty="0"/>
           </a:p>
@@ -5811,7 +5811,7 @@
                   <a:srgbClr val="4A4A6A"/>
                 </a:solidFill>
               </a:rPr>
-              <a:t>→ gitlab.youtune.tech/cychi/cyc_nativehook</a:t>
+              <a:t>→ gitlab.youtune.tech/memory_leak/yt_nativehook</a:t>
             </a:r>
             <a:endParaRPr lang="en-US" sz="1200" dirty="0"/>
           </a:p>

</xml_diff>